<commit_message>
Restyle deck with 3D depth: gradients, shadowed cards, sphere badges, 3D charts
Co-Authored-By: Claude Opus 5.5 <noreply@anthropic.com>
Claude-Session: https://claude.ai/code/session_01D1yfgr7znJrRSehnJ7HGe8
</commit_message>
<xml_diff>
--- a/ai-water-deck.pptx
+++ b/ai-water-deck.pptx
@@ -146,11 +146,17 @@
       <c:overlay val="0"/>
     </c:title>
     <c:autoTitleDeleted val="0"/>
+    <c:view3D>
+      <c:rotX val="12"/>
+      <c:rotY val="18"/>
+      <c:rAngAx val="0"/>
+      <c:perspective val="20"/>
+    </c:view3D>
     <c:plotArea>
       <c:layout/>
-      <c:barChart>
+      <c:bar3DChart>
         <c:barDir val="col"/>
-        <c:grouping val="clustered"/>
+        <c:grouping val="standard"/>
         <c:varyColors val="0"/>
         <c:ser>
           <c:idx val="0"/>
@@ -184,7 +190,7 @@
                     <a:solidFill>
                       <a:srgbClr val="0B2239"/>
                     </a:solidFill>
-                    <a:latin typeface="Arial"/>
+                    <a:latin typeface="Calibri"/>
                   </a:defRPr>
                 </a:pPr>
               </a:p>
@@ -246,7 +252,7 @@
                   <a:solidFill>
                     <a:srgbClr val="0B2239"/>
                   </a:solidFill>
-                  <a:latin typeface="Arial"/>
+                  <a:latin typeface="Calibri"/>
                 </a:defRPr>
               </a:pPr>
             </a:p>
@@ -259,12 +265,13 @@
           <c:showBubbleSize val="0"/>
           <c:showLeaderLines val="0"/>
         </c:dLbls>
-        <c:gapWidth val="55"/>
-        <c:overlap val="0"/>
+        <c:gapWidth val="60"/>
+        <c:gapDepth val="150"/>
+        <c:shape val="box"/>
         <c:axId val="2094734554"/>
         <c:axId val="2094734552"/>
         <c:axId val="2094734556"/>
-      </c:barChart>
+      </c:bar3DChart>
       <c:catAx>
         <c:axId val="2094734554"/>
         <c:scaling>
@@ -310,7 +317,7 @@
         <c:axId val="2094734552"/>
         <c:scaling>
           <c:orientation val="minMax"/>
-          <c:max val="48"/>
+          <c:max val="46"/>
           <c:min val="0"/>
         </c:scaling>
         <c:delete val="1"/>
@@ -347,6 +354,44 @@
         <c:crosses val="autoZero"/>
         <c:crossBetween val="between"/>
       </c:valAx>
+      <c:serAx>
+        <c:axId val="2094734556"/>
+        <c:scaling>
+          <c:orientation val="minMax"/>
+        </c:scaling>
+        <c:delete val="1"/>
+        <c:axPos val="b"/>
+        <c:numFmt formatCode="General" sourceLinked="0"/>
+        <c:majorTickMark val="out"/>
+        <c:minorTickMark val="none"/>
+        <c:tickLblPos val="low"/>
+        <c:spPr>
+          <a:ln w="12700" cap="flat">
+            <a:solidFill>
+              <a:srgbClr val="888888"/>
+            </a:solidFill>
+            <a:prstDash val="solid"/>
+            <a:round/>
+          </a:ln>
+        </c:spPr>
+        <c:txPr>
+          <a:bodyPr/>
+          <a:lstStyle/>
+          <a:p>
+            <a:pPr>
+              <a:defRPr sz="1200" b="0" i="0" u="none" strike="noStrike">
+                <a:solidFill>
+                  <a:srgbClr val="000000"/>
+                </a:solidFill>
+                <a:latin typeface="Arial"/>
+              </a:defRPr>
+            </a:pPr>
+            <a:endParaRPr lang="en-US"/>
+          </a:p>
+        </c:txPr>
+        <c:crossAx val="2094734552"/>
+        <c:crosses val="autoZero"/>
+      </c:serAx>
       <c:spPr>
         <a:noFill/>
         <a:ln>
@@ -406,11 +451,17 @@
       <c:overlay val="0"/>
     </c:title>
     <c:autoTitleDeleted val="0"/>
+    <c:view3D>
+      <c:rotX val="12"/>
+      <c:rotY val="18"/>
+      <c:rAngAx val="0"/>
+      <c:perspective val="20"/>
+    </c:view3D>
     <c:plotArea>
       <c:layout/>
-      <c:barChart>
+      <c:bar3DChart>
         <c:barDir val="col"/>
-        <c:grouping val="clustered"/>
+        <c:grouping val="standard"/>
         <c:varyColors val="0"/>
         <c:ser>
           <c:idx val="0"/>
@@ -444,7 +495,7 @@
                     <a:solidFill>
                       <a:srgbClr val="0B2239"/>
                     </a:solidFill>
-                    <a:latin typeface="Arial"/>
+                    <a:latin typeface="Calibri"/>
                   </a:defRPr>
                 </a:pPr>
               </a:p>
@@ -500,7 +551,7 @@
                   <a:solidFill>
                     <a:srgbClr val="0B2239"/>
                   </a:solidFill>
-                  <a:latin typeface="Arial"/>
+                  <a:latin typeface="Calibri"/>
                 </a:defRPr>
               </a:pPr>
             </a:p>
@@ -513,12 +564,13 @@
           <c:showBubbleSize val="0"/>
           <c:showLeaderLines val="0"/>
         </c:dLbls>
-        <c:gapWidth val="45"/>
-        <c:overlap val="0"/>
+        <c:gapWidth val="60"/>
+        <c:gapDepth val="150"/>
+        <c:shape val="box"/>
         <c:axId val="2094734554"/>
         <c:axId val="2094734552"/>
         <c:axId val="2094734556"/>
-      </c:barChart>
+      </c:bar3DChart>
       <c:catAx>
         <c:axId val="2094734554"/>
         <c:scaling>
@@ -564,7 +616,7 @@
         <c:axId val="2094734552"/>
         <c:scaling>
           <c:orientation val="minMax"/>
-          <c:max val="31000"/>
+          <c:max val="30000"/>
           <c:min val="0"/>
         </c:scaling>
         <c:delete val="1"/>
@@ -601,10 +653,46 @@
         <c:crosses val="autoZero"/>
         <c:crossBetween val="between"/>
       </c:valAx>
+      <c:serAx>
+        <c:axId val="2094734556"/>
+        <c:scaling>
+          <c:orientation val="minMax"/>
+        </c:scaling>
+        <c:delete val="1"/>
+        <c:axPos val="b"/>
+        <c:numFmt formatCode="General" sourceLinked="0"/>
+        <c:majorTickMark val="out"/>
+        <c:minorTickMark val="none"/>
+        <c:tickLblPos val="low"/>
+        <c:spPr>
+          <a:ln w="12700" cap="flat">
+            <a:solidFill>
+              <a:srgbClr val="888888"/>
+            </a:solidFill>
+            <a:prstDash val="solid"/>
+            <a:round/>
+          </a:ln>
+        </c:spPr>
+        <c:txPr>
+          <a:bodyPr/>
+          <a:lstStyle/>
+          <a:p>
+            <a:pPr>
+              <a:defRPr sz="1200" b="0" i="0" u="none" strike="noStrike">
+                <a:solidFill>
+                  <a:srgbClr val="000000"/>
+                </a:solidFill>
+                <a:latin typeface="Arial"/>
+              </a:defRPr>
+            </a:pPr>
+            <a:endParaRPr lang="en-US"/>
+          </a:p>
+        </c:txPr>
+        <c:crossAx val="2094734552"/>
+        <c:crosses val="autoZero"/>
+      </c:serAx>
       <c:spPr>
-        <a:solidFill>
-          <a:srgbClr val="EAF4F7"/>
-        </a:solidFill>
+        <a:noFill/>
         <a:ln>
           <a:noFill/>
         </a:ln>
@@ -1755,9 +1843,16 @@
   <p:cSld name="Slide 1">
     <p:bg>
       <p:bgPr>
-        <a:solidFill>
-          <a:srgbClr val="0B2239"/>
-        </a:solidFill>
+        <a:blipFill dpi="0" rotWithShape="1">
+          <a:blip r:embed="rId1">
+            <a:lum/>
+          </a:blip>
+          <a:srcRect/>
+          <a:stretch>
+            <a:fillRect/>
+          </a:stretch>
+        </a:blipFill>
+        <a:effectLst/>
       </p:bgPr>
     </p:bg>
     <p:spTree>
@@ -1776,13 +1871,91 @@
       </p:grpSpPr>
       <p:sp>
         <p:nvSpPr>
-          <p:cNvPr id="2" name="title"/>
+          <p:cNvPr id="2" name="caption-tag"/>
           <p:cNvSpPr txBox="1"/>
           <p:nvPr/>
         </p:nvSpPr>
         <p:spPr>
           <a:xfrm>
-            <a:off x="548640" y="411480"/>
+            <a:off x="548640" y="347472"/>
+            <a:ext cx="7315200" cy="320040"/>
+          </a:xfrm>
+          <a:prstGeom prst="rect">
+            <a:avLst/>
+          </a:prstGeom>
+          <a:noFill/>
+          <a:ln/>
+        </p:spPr>
+        <p:txBody>
+          <a:bodyPr wrap="square" lIns="0" tIns="0" rIns="0" bIns="0" rtlCol="0" anchor="ctr"/>
+          <a:lstStyle/>
+          <a:p>
+            <a:pPr indent="0" marL="0">
+              <a:buNone/>
+            </a:pPr>
+            <a:r>
+              <a:rPr lang="en-US" sz="1400" b="1" spc="300" kern="0" dirty="0">
+                <a:solidFill>
+                  <a:srgbClr val="F2A33A"/>
+                </a:solidFill>
+                <a:latin typeface="Calibri" pitchFamily="34" charset="0"/>
+                <a:ea typeface="Calibri" pitchFamily="34" charset="-122"/>
+                <a:cs typeface="Calibri" pitchFamily="34" charset="-120"/>
+              </a:rPr>
+              <a:t>01  ·  GLOBAL PICTURE</a:t>
+            </a:r>
+            <a:endParaRPr lang="en-US" sz="1400" dirty="0"/>
+          </a:p>
+        </p:txBody>
+      </p:sp>
+      <p:sp>
+        <p:nvSpPr>
+          <p:cNvPr id="3" name="caption-page"/>
+          <p:cNvSpPr txBox="1"/>
+          <p:nvPr/>
+        </p:nvSpPr>
+        <p:spPr>
+          <a:xfrm>
+            <a:off x="10725912" y="6291072"/>
+            <a:ext cx="914400" cy="365760"/>
+          </a:xfrm>
+          <a:prstGeom prst="rect">
+            <a:avLst/>
+          </a:prstGeom>
+          <a:noFill/>
+          <a:ln/>
+        </p:spPr>
+        <p:txBody>
+          <a:bodyPr wrap="square" lIns="0" tIns="0" rIns="0" bIns="0" rtlCol="0" anchor="ctr"/>
+          <a:lstStyle/>
+          <a:p>
+            <a:pPr algn="r" indent="0" marL="0">
+              <a:buNone/>
+            </a:pPr>
+            <a:r>
+              <a:rPr lang="en-US" sz="1100" dirty="0">
+                <a:solidFill>
+                  <a:srgbClr val="B8C7D3"/>
+                </a:solidFill>
+                <a:latin typeface="Calibri" pitchFamily="34" charset="0"/>
+                <a:ea typeface="Calibri" pitchFamily="34" charset="-122"/>
+                <a:cs typeface="Calibri" pitchFamily="34" charset="-120"/>
+              </a:rPr>
+              <a:t>1 / 5</a:t>
+            </a:r>
+            <a:endParaRPr lang="en-US" sz="1100" dirty="0"/>
+          </a:p>
+        </p:txBody>
+      </p:sp>
+      <p:sp>
+        <p:nvSpPr>
+          <p:cNvPr id="4" name="title"/>
+          <p:cNvSpPr txBox="1"/>
+          <p:nvPr/>
+        </p:nvSpPr>
+        <p:spPr>
+          <a:xfrm>
+            <a:off x="548640" y="658368"/>
             <a:ext cx="11064240" cy="731520"/>
           </a:xfrm>
           <a:prstGeom prst="rect">
@@ -1815,13 +1988,13 @@
       </p:sp>
       <p:sp>
         <p:nvSpPr>
-          <p:cNvPr id="3" name="kicker"/>
+          <p:cNvPr id="5" name="kicker"/>
           <p:cNvSpPr txBox="1"/>
           <p:nvPr/>
         </p:nvSpPr>
         <p:spPr>
           <a:xfrm>
-            <a:off x="548640" y="1143000"/>
+            <a:off x="548640" y="1389888"/>
             <a:ext cx="11064240" cy="457200"/>
           </a:xfrm>
           <a:prstGeom prst="rect">
@@ -1852,150 +2025,9 @@
           </a:p>
         </p:txBody>
       </p:sp>
-      <p:sp>
-        <p:nvSpPr>
-          <p:cNvPr id="4" name="Shape 2"/>
-          <p:cNvSpPr/>
-          <p:nvPr/>
-        </p:nvSpPr>
-        <p:spPr>
-          <a:xfrm>
-            <a:off x="548640" y="1874520"/>
-            <a:ext cx="475488" cy="475488"/>
-          </a:xfrm>
-          <a:prstGeom prst="ellipse">
-            <a:avLst/>
-          </a:prstGeom>
-          <a:solidFill>
-            <a:srgbClr val="137C94"/>
-          </a:solidFill>
-          <a:ln w="12700">
-            <a:solidFill>
-              <a:srgbClr val="137C94"/>
-            </a:solidFill>
-            <a:prstDash val="solid"/>
-          </a:ln>
-        </p:spPr>
-      </p:sp>
       <p:pic>
         <p:nvPicPr>
-          <p:cNvPr id="5" name="Image 0" descr="preencoded.png">    </p:cNvPr>
-          <p:cNvPicPr>
-            <a:picLocks noChangeAspect="1"/>
-          </p:cNvPicPr>
-          <p:nvPr/>
-        </p:nvPicPr>
-        <p:blipFill>
-          <a:blip r:embed="rId1"/>
-          <a:stretch>
-            <a:fillRect/>
-          </a:stretch>
-        </p:blipFill>
-        <p:spPr>
-          <a:xfrm>
-            <a:off x="658368" y="1984248"/>
-            <a:ext cx="256032" cy="256032"/>
-          </a:xfrm>
-          <a:prstGeom prst="rect">
-            <a:avLst/>
-          </a:prstGeom>
-        </p:spPr>
-      </p:pic>
-      <p:sp>
-        <p:nvSpPr>
-          <p:cNvPr id="6" name="body"/>
-          <p:cNvSpPr txBox="1"/>
-          <p:nvPr/>
-        </p:nvSpPr>
-        <p:spPr>
-          <a:xfrm>
-            <a:off x="1207008" y="1819656"/>
-            <a:ext cx="5394960" cy="585216"/>
-          </a:xfrm>
-          <a:prstGeom prst="rect">
-            <a:avLst/>
-          </a:prstGeom>
-          <a:noFill/>
-          <a:ln/>
-        </p:spPr>
-        <p:txBody>
-          <a:bodyPr wrap="square" lIns="0" tIns="0" rIns="0" bIns="0" rtlCol="0" anchor="ctr"/>
-          <a:lstStyle/>
-          <a:p>
-            <a:pPr indent="0" marL="0">
-              <a:buNone/>
-            </a:pPr>
-            <a:r>
-              <a:rPr lang="en-US" sz="2100" dirty="0">
-                <a:solidFill>
-                  <a:srgbClr val="FFFFFF"/>
-                </a:solidFill>
-                <a:latin typeface="Calibri" pitchFamily="34" charset="0"/>
-                <a:ea typeface="Calibri" pitchFamily="34" charset="-122"/>
-                <a:cs typeface="Calibri" pitchFamily="34" charset="-120"/>
-              </a:rPr>
-              <a:t>AI data centers run on water </a:t>
-            </a:r>
-            <a:pPr indent="0" marL="0">
-              <a:buNone/>
-            </a:pPr>
-            <a:r>
-              <a:rPr lang="en-US" sz="2100" b="1" dirty="0">
-                <a:solidFill>
-                  <a:srgbClr val="F2A33A"/>
-                </a:solidFill>
-                <a:latin typeface="Calibri" pitchFamily="34" charset="0"/>
-                <a:ea typeface="Calibri" pitchFamily="34" charset="-122"/>
-                <a:cs typeface="Calibri" pitchFamily="34" charset="-120"/>
-              </a:rPr>
-              <a:t>and</a:t>
-            </a:r>
-            <a:pPr indent="0" marL="0">
-              <a:buNone/>
-            </a:pPr>
-            <a:r>
-              <a:rPr lang="en-US" sz="2100" dirty="0">
-                <a:solidFill>
-                  <a:srgbClr val="FFFFFF"/>
-                </a:solidFill>
-                <a:latin typeface="Calibri" pitchFamily="34" charset="0"/>
-                <a:ea typeface="Calibri" pitchFamily="34" charset="-122"/>
-                <a:cs typeface="Calibri" pitchFamily="34" charset="-120"/>
-              </a:rPr>
-              <a:t> power</a:t>
-            </a:r>
-            <a:endParaRPr lang="en-US" sz="2100" dirty="0"/>
-          </a:p>
-        </p:txBody>
-      </p:sp>
-      <p:sp>
-        <p:nvSpPr>
-          <p:cNvPr id="7" name="Shape 4"/>
-          <p:cNvSpPr/>
-          <p:nvPr/>
-        </p:nvSpPr>
-        <p:spPr>
-          <a:xfrm>
-            <a:off x="548640" y="2551176"/>
-            <a:ext cx="475488" cy="475488"/>
-          </a:xfrm>
-          <a:prstGeom prst="ellipse">
-            <a:avLst/>
-          </a:prstGeom>
-          <a:solidFill>
-            <a:srgbClr val="137C94"/>
-          </a:solidFill>
-          <a:ln w="12700">
-            <a:solidFill>
-              <a:srgbClr val="137C94"/>
-            </a:solidFill>
-            <a:prstDash val="solid"/>
-          </a:ln>
-        </p:spPr>
-      </p:sp>
-      <p:pic>
-        <p:nvPicPr>
-          <p:cNvPr id="8" name="Image 1" descr="preencoded.png">    </p:cNvPr>
+          <p:cNvPr id="6" name="Image 0" descr="preencoded.png">    </p:cNvPr>
           <p:cNvPicPr>
             <a:picLocks noChangeAspect="1"/>
           </p:cNvPicPr>
@@ -2009,8 +2041,8 @@
         </p:blipFill>
         <p:spPr>
           <a:xfrm>
-            <a:off x="658368" y="2660904"/>
-            <a:ext cx="256032" cy="256032"/>
+            <a:off x="502920" y="2121408"/>
+            <a:ext cx="603504" cy="603504"/>
           </a:xfrm>
           <a:prstGeom prst="rect">
             <a:avLst/>
@@ -2019,14 +2051,14 @@
       </p:pic>
       <p:sp>
         <p:nvSpPr>
-          <p:cNvPr id="9" name="body"/>
+          <p:cNvPr id="7" name="body"/>
           <p:cNvSpPr txBox="1"/>
           <p:nvPr/>
         </p:nvSpPr>
         <p:spPr>
           <a:xfrm>
-            <a:off x="1207008" y="2496312"/>
-            <a:ext cx="5394960" cy="585216"/>
+            <a:off x="1280160" y="2103120"/>
+            <a:ext cx="5349240" cy="585216"/>
           </a:xfrm>
           <a:prstGeom prst="rect">
             <a:avLst/>
@@ -2042,6 +2074,20 @@
               <a:buNone/>
             </a:pPr>
             <a:r>
+              <a:rPr lang="en-US" sz="2100" dirty="0">
+                <a:solidFill>
+                  <a:srgbClr val="FFFFFF"/>
+                </a:solidFill>
+                <a:latin typeface="Calibri" pitchFamily="34" charset="0"/>
+                <a:ea typeface="Calibri" pitchFamily="34" charset="-122"/>
+                <a:cs typeface="Calibri" pitchFamily="34" charset="-120"/>
+              </a:rPr>
+              <a:t>AI data centers run on water </a:t>
+            </a:r>
+            <a:pPr indent="0" marL="0">
+              <a:buNone/>
+            </a:pPr>
+            <a:r>
               <a:rPr lang="en-US" sz="2100" b="1" dirty="0">
                 <a:solidFill>
                   <a:srgbClr val="F2A33A"/>
@@ -2050,7 +2096,7 @@
                 <a:ea typeface="Calibri" pitchFamily="34" charset="-122"/>
                 <a:cs typeface="Calibri" pitchFamily="34" charset="-120"/>
               </a:rPr>
-              <a:t>On-site: </a:t>
+              <a:t>and</a:t>
             </a:r>
             <a:pPr indent="0" marL="0">
               <a:buNone/>
@@ -2064,40 +2110,15 @@
                 <a:ea typeface="Calibri" pitchFamily="34" charset="-122"/>
                 <a:cs typeface="Calibri" pitchFamily="34" charset="-120"/>
               </a:rPr>
-              <a:t>water evaporates to cool servers</a:t>
+              <a:t> power</a:t>
             </a:r>
             <a:endParaRPr lang="en-US" sz="2100" dirty="0"/>
           </a:p>
         </p:txBody>
-      </p:sp>
-      <p:sp>
-        <p:nvSpPr>
-          <p:cNvPr id="10" name="Shape 6"/>
-          <p:cNvSpPr/>
-          <p:nvPr/>
-        </p:nvSpPr>
-        <p:spPr>
-          <a:xfrm>
-            <a:off x="548640" y="3227832"/>
-            <a:ext cx="475488" cy="475488"/>
-          </a:xfrm>
-          <a:prstGeom prst="ellipse">
-            <a:avLst/>
-          </a:prstGeom>
-          <a:solidFill>
-            <a:srgbClr val="F2A33A"/>
-          </a:solidFill>
-          <a:ln w="12700">
-            <a:solidFill>
-              <a:srgbClr val="F2A33A"/>
-            </a:solidFill>
-            <a:prstDash val="solid"/>
-          </a:ln>
-        </p:spPr>
       </p:sp>
       <p:pic>
         <p:nvPicPr>
-          <p:cNvPr id="11" name="Image 2" descr="preencoded.png">    </p:cNvPr>
+          <p:cNvPr id="8" name="Image 1" descr="preencoded.png">    </p:cNvPr>
           <p:cNvPicPr>
             <a:picLocks noChangeAspect="1"/>
           </p:cNvPicPr>
@@ -2111,8 +2132,8 @@
         </p:blipFill>
         <p:spPr>
           <a:xfrm>
-            <a:off x="658368" y="3337560"/>
-            <a:ext cx="256032" cy="256032"/>
+            <a:off x="502920" y="2788920"/>
+            <a:ext cx="603504" cy="603504"/>
           </a:xfrm>
           <a:prstGeom prst="rect">
             <a:avLst/>
@@ -2121,14 +2142,14 @@
       </p:pic>
       <p:sp>
         <p:nvSpPr>
-          <p:cNvPr id="12" name="body"/>
+          <p:cNvPr id="9" name="body"/>
           <p:cNvSpPr txBox="1"/>
           <p:nvPr/>
         </p:nvSpPr>
         <p:spPr>
           <a:xfrm>
-            <a:off x="1207008" y="3172968"/>
-            <a:ext cx="5394960" cy="585216"/>
+            <a:off x="1280160" y="2770632"/>
+            <a:ext cx="5349240" cy="585216"/>
           </a:xfrm>
           <a:prstGeom prst="rect">
             <a:avLst/>
@@ -2152,7 +2173,7 @@
                 <a:ea typeface="Calibri" pitchFamily="34" charset="-122"/>
                 <a:cs typeface="Calibri" pitchFamily="34" charset="-120"/>
               </a:rPr>
-              <a:t>Off-site: </a:t>
+              <a:t>On-site: </a:t>
             </a:r>
             <a:pPr indent="0" marL="0">
               <a:buNone/>
@@ -2166,54 +2187,15 @@
                 <a:ea typeface="Calibri" pitchFamily="34" charset="-122"/>
                 <a:cs typeface="Calibri" pitchFamily="34" charset="-120"/>
               </a:rPr>
-              <a:t>US power plants use about </a:t>
-            </a:r>
-            <a:pPr indent="0" marL="0">
-              <a:buNone/>
-            </a:pPr>
-            <a:r>
-              <a:rPr lang="en-US" sz="2100" b="1" dirty="0">
-                <a:solidFill>
-                  <a:srgbClr val="F2A33A"/>
-                </a:solidFill>
-                <a:latin typeface="Calibri" pitchFamily="34" charset="0"/>
-                <a:ea typeface="Calibri" pitchFamily="34" charset="-122"/>
-                <a:cs typeface="Calibri" pitchFamily="34" charset="-120"/>
-              </a:rPr>
-              <a:t>12× more</a:t>
+              <a:t>water evaporates to cool servers</a:t>
             </a:r>
             <a:endParaRPr lang="en-US" sz="2100" dirty="0"/>
           </a:p>
         </p:txBody>
-      </p:sp>
-      <p:sp>
-        <p:nvSpPr>
-          <p:cNvPr id="13" name="Shape 8"/>
-          <p:cNvSpPr/>
-          <p:nvPr/>
-        </p:nvSpPr>
-        <p:spPr>
-          <a:xfrm>
-            <a:off x="548640" y="3904488"/>
-            <a:ext cx="475488" cy="475488"/>
-          </a:xfrm>
-          <a:prstGeom prst="ellipse">
-            <a:avLst/>
-          </a:prstGeom>
-          <a:solidFill>
-            <a:srgbClr val="137C94"/>
-          </a:solidFill>
-          <a:ln w="12700">
-            <a:solidFill>
-              <a:srgbClr val="137C94"/>
-            </a:solidFill>
-            <a:prstDash val="solid"/>
-          </a:ln>
-        </p:spPr>
       </p:sp>
       <p:pic>
         <p:nvPicPr>
-          <p:cNvPr id="14" name="Image 3" descr="preencoded.png">    </p:cNvPr>
+          <p:cNvPr id="10" name="Image 2" descr="preencoded.png">    </p:cNvPr>
           <p:cNvPicPr>
             <a:picLocks noChangeAspect="1"/>
           </p:cNvPicPr>
@@ -2227,8 +2209,8 @@
         </p:blipFill>
         <p:spPr>
           <a:xfrm>
-            <a:off x="658368" y="4014216"/>
-            <a:ext cx="256032" cy="256032"/>
+            <a:off x="502920" y="3456432"/>
+            <a:ext cx="603504" cy="603504"/>
           </a:xfrm>
           <a:prstGeom prst="rect">
             <a:avLst/>
@@ -2237,14 +2219,14 @@
       </p:pic>
       <p:sp>
         <p:nvSpPr>
-          <p:cNvPr id="15" name="body"/>
+          <p:cNvPr id="11" name="body"/>
           <p:cNvSpPr txBox="1"/>
           <p:nvPr/>
         </p:nvSpPr>
         <p:spPr>
           <a:xfrm>
-            <a:off x="1207008" y="3849624"/>
-            <a:ext cx="5394960" cy="585216"/>
+            <a:off x="1280160" y="3438144"/>
+            <a:ext cx="5349240" cy="585216"/>
           </a:xfrm>
           <a:prstGeom prst="rect">
             <a:avLst/>
@@ -2260,6 +2242,20 @@
               <a:buNone/>
             </a:pPr>
             <a:r>
+              <a:rPr lang="en-US" sz="2100" b="1" dirty="0">
+                <a:solidFill>
+                  <a:srgbClr val="F2A33A"/>
+                </a:solidFill>
+                <a:latin typeface="Calibri" pitchFamily="34" charset="0"/>
+                <a:ea typeface="Calibri" pitchFamily="34" charset="-122"/>
+                <a:cs typeface="Calibri" pitchFamily="34" charset="-120"/>
+              </a:rPr>
+              <a:t>Off-site: </a:t>
+            </a:r>
+            <a:pPr indent="0" marL="0">
+              <a:buNone/>
+            </a:pPr>
+            <a:r>
               <a:rPr lang="en-US" sz="2100" dirty="0">
                 <a:solidFill>
                   <a:srgbClr val="FFFFFF"/>
@@ -2268,7 +2264,7 @@
                 <a:ea typeface="Calibri" pitchFamily="34" charset="-122"/>
                 <a:cs typeface="Calibri" pitchFamily="34" charset="-120"/>
               </a:rPr>
-              <a:t>Google’s water use: </a:t>
+              <a:t>US power plants use about </a:t>
             </a:r>
             <a:pPr indent="0" marL="0">
               <a:buNone/>
@@ -2282,54 +2278,15 @@
                 <a:ea typeface="Calibri" pitchFamily="34" charset="-122"/>
                 <a:cs typeface="Calibri" pitchFamily="34" charset="-120"/>
               </a:rPr>
-              <a:t>up 70%</a:t>
-            </a:r>
-            <a:pPr indent="0" marL="0">
-              <a:buNone/>
-            </a:pPr>
-            <a:r>
-              <a:rPr lang="en-US" sz="2100" dirty="0">
-                <a:solidFill>
-                  <a:srgbClr val="FFFFFF"/>
-                </a:solidFill>
-                <a:latin typeface="Calibri" pitchFamily="34" charset="0"/>
-                <a:ea typeface="Calibri" pitchFamily="34" charset="-122"/>
-                <a:cs typeface="Calibri" pitchFamily="34" charset="-120"/>
-              </a:rPr>
-              <a:t> in two years</a:t>
+              <a:t>12× more</a:t>
             </a:r>
             <a:endParaRPr lang="en-US" sz="2100" dirty="0"/>
           </a:p>
         </p:txBody>
-      </p:sp>
-      <p:sp>
-        <p:nvSpPr>
-          <p:cNvPr id="16" name="Shape 10"/>
-          <p:cNvSpPr/>
-          <p:nvPr/>
-        </p:nvSpPr>
-        <p:spPr>
-          <a:xfrm>
-            <a:off x="548640" y="4581144"/>
-            <a:ext cx="475488" cy="475488"/>
-          </a:xfrm>
-          <a:prstGeom prst="ellipse">
-            <a:avLst/>
-          </a:prstGeom>
-          <a:solidFill>
-            <a:srgbClr val="137C94"/>
-          </a:solidFill>
-          <a:ln w="12700">
-            <a:solidFill>
-              <a:srgbClr val="137C94"/>
-            </a:solidFill>
-            <a:prstDash val="solid"/>
-          </a:ln>
-        </p:spPr>
       </p:sp>
       <p:pic>
         <p:nvPicPr>
-          <p:cNvPr id="17" name="Image 4" descr="preencoded.png">    </p:cNvPr>
+          <p:cNvPr id="12" name="Image 3" descr="preencoded.png">    </p:cNvPr>
           <p:cNvPicPr>
             <a:picLocks noChangeAspect="1"/>
           </p:cNvPicPr>
@@ -2343,8 +2300,8 @@
         </p:blipFill>
         <p:spPr>
           <a:xfrm>
-            <a:off x="658368" y="4690872"/>
-            <a:ext cx="256032" cy="256032"/>
+            <a:off x="502920" y="4123944"/>
+            <a:ext cx="603504" cy="603504"/>
           </a:xfrm>
           <a:prstGeom prst="rect">
             <a:avLst/>
@@ -2353,14 +2310,14 @@
       </p:pic>
       <p:sp>
         <p:nvSpPr>
-          <p:cNvPr id="18" name="body"/>
+          <p:cNvPr id="13" name="body"/>
           <p:cNvSpPr txBox="1"/>
           <p:nvPr/>
         </p:nvSpPr>
         <p:spPr>
           <a:xfrm>
-            <a:off x="1207008" y="4526280"/>
-            <a:ext cx="5394960" cy="585216"/>
+            <a:off x="1280160" y="4105656"/>
+            <a:ext cx="5349240" cy="585216"/>
           </a:xfrm>
           <a:prstGeom prst="rect">
             <a:avLst/>
@@ -2376,6 +2333,20 @@
               <a:buNone/>
             </a:pPr>
             <a:r>
+              <a:rPr lang="en-US" sz="2100" dirty="0">
+                <a:solidFill>
+                  <a:srgbClr val="FFFFFF"/>
+                </a:solidFill>
+                <a:latin typeface="Calibri" pitchFamily="34" charset="0"/>
+                <a:ea typeface="Calibri" pitchFamily="34" charset="-122"/>
+                <a:cs typeface="Calibri" pitchFamily="34" charset="-120"/>
+              </a:rPr>
+              <a:t>Google’s water use: </a:t>
+            </a:r>
+            <a:pPr indent="0" marL="0">
+              <a:buNone/>
+            </a:pPr>
+            <a:r>
               <a:rPr lang="en-US" sz="2100" b="1" dirty="0">
                 <a:solidFill>
                   <a:srgbClr val="F2A33A"/>
@@ -2384,7 +2355,7 @@
                 <a:ea typeface="Calibri" pitchFamily="34" charset="-122"/>
                 <a:cs typeface="Calibri" pitchFamily="34" charset="-120"/>
               </a:rPr>
-              <a:t>Uruguay 2023: </a:t>
+              <a:t>up 70%</a:t>
             </a:r>
             <a:pPr indent="0" marL="0">
               <a:buNone/>
@@ -2398,40 +2369,15 @@
                 <a:ea typeface="Calibri" pitchFamily="34" charset="-122"/>
                 <a:cs typeface="Calibri" pitchFamily="34" charset="-120"/>
               </a:rPr>
-              <a:t>drought, salty tap water, protests</a:t>
+              <a:t> in two years</a:t>
             </a:r>
             <a:endParaRPr lang="en-US" sz="2100" dirty="0"/>
           </a:p>
         </p:txBody>
-      </p:sp>
-      <p:sp>
-        <p:nvSpPr>
-          <p:cNvPr id="19" name="Shape 12"/>
-          <p:cNvSpPr/>
-          <p:nvPr/>
-        </p:nvSpPr>
-        <p:spPr>
-          <a:xfrm>
-            <a:off x="548640" y="5257800"/>
-            <a:ext cx="475488" cy="475488"/>
-          </a:xfrm>
-          <a:prstGeom prst="ellipse">
-            <a:avLst/>
-          </a:prstGeom>
-          <a:solidFill>
-            <a:srgbClr val="137C94"/>
-          </a:solidFill>
-          <a:ln w="12700">
-            <a:solidFill>
-              <a:srgbClr val="137C94"/>
-            </a:solidFill>
-            <a:prstDash val="solid"/>
-          </a:ln>
-        </p:spPr>
       </p:sp>
       <p:pic>
         <p:nvPicPr>
-          <p:cNvPr id="20" name="Image 5" descr="preencoded.png">    </p:cNvPr>
+          <p:cNvPr id="14" name="Image 4" descr="preencoded.png">    </p:cNvPr>
           <p:cNvPicPr>
             <a:picLocks noChangeAspect="1"/>
           </p:cNvPicPr>
@@ -2445,8 +2391,8 @@
         </p:blipFill>
         <p:spPr>
           <a:xfrm>
-            <a:off x="658368" y="5367528"/>
-            <a:ext cx="256032" cy="256032"/>
+            <a:off x="502920" y="4791456"/>
+            <a:ext cx="603504" cy="603504"/>
           </a:xfrm>
           <a:prstGeom prst="rect">
             <a:avLst/>
@@ -2455,14 +2401,14 @@
       </p:pic>
       <p:sp>
         <p:nvSpPr>
-          <p:cNvPr id="21" name="body"/>
+          <p:cNvPr id="15" name="body"/>
           <p:cNvSpPr txBox="1"/>
           <p:nvPr/>
         </p:nvSpPr>
         <p:spPr>
           <a:xfrm>
-            <a:off x="1207008" y="5202936"/>
-            <a:ext cx="5394960" cy="585216"/>
+            <a:off x="1280160" y="4773168"/>
+            <a:ext cx="5349240" cy="585216"/>
           </a:xfrm>
           <a:prstGeom prst="rect">
             <a:avLst/>
@@ -2478,6 +2424,20 @@
               <a:buNone/>
             </a:pPr>
             <a:r>
+              <a:rPr lang="en-US" sz="2100" b="1" dirty="0">
+                <a:solidFill>
+                  <a:srgbClr val="F2A33A"/>
+                </a:solidFill>
+                <a:latin typeface="Calibri" pitchFamily="34" charset="0"/>
+                <a:ea typeface="Calibri" pitchFamily="34" charset="-122"/>
+                <a:cs typeface="Calibri" pitchFamily="34" charset="-120"/>
+              </a:rPr>
+              <a:t>Uruguay 2023: </a:t>
+            </a:r>
+            <a:pPr indent="0" marL="0">
+              <a:buNone/>
+            </a:pPr>
+            <a:r>
               <a:rPr lang="en-US" sz="2100" dirty="0">
                 <a:solidFill>
                   <a:srgbClr val="FFFFFF"/>
@@ -2486,6 +2446,69 @@
                 <a:ea typeface="Calibri" pitchFamily="34" charset="-122"/>
                 <a:cs typeface="Calibri" pitchFamily="34" charset="-120"/>
               </a:rPr>
+              <a:t>drought, salty tap water, protests</a:t>
+            </a:r>
+            <a:endParaRPr lang="en-US" sz="2100" dirty="0"/>
+          </a:p>
+        </p:txBody>
+      </p:sp>
+      <p:pic>
+        <p:nvPicPr>
+          <p:cNvPr id="16" name="Image 5" descr="preencoded.png">    </p:cNvPr>
+          <p:cNvPicPr>
+            <a:picLocks noChangeAspect="1"/>
+          </p:cNvPicPr>
+          <p:nvPr/>
+        </p:nvPicPr>
+        <p:blipFill>
+          <a:blip r:embed="rId7"/>
+          <a:stretch>
+            <a:fillRect/>
+          </a:stretch>
+        </p:blipFill>
+        <p:spPr>
+          <a:xfrm>
+            <a:off x="502920" y="5458968"/>
+            <a:ext cx="603504" cy="603504"/>
+          </a:xfrm>
+          <a:prstGeom prst="rect">
+            <a:avLst/>
+          </a:prstGeom>
+        </p:spPr>
+      </p:pic>
+      <p:sp>
+        <p:nvSpPr>
+          <p:cNvPr id="17" name="body"/>
+          <p:cNvSpPr txBox="1"/>
+          <p:nvPr/>
+        </p:nvSpPr>
+        <p:spPr>
+          <a:xfrm>
+            <a:off x="1280160" y="5440680"/>
+            <a:ext cx="5349240" cy="585216"/>
+          </a:xfrm>
+          <a:prstGeom prst="rect">
+            <a:avLst/>
+          </a:prstGeom>
+          <a:noFill/>
+          <a:ln/>
+        </p:spPr>
+        <p:txBody>
+          <a:bodyPr wrap="square" lIns="0" tIns="0" rIns="0" bIns="0" rtlCol="0" anchor="ctr"/>
+          <a:lstStyle/>
+          <a:p>
+            <a:pPr indent="0" marL="0">
+              <a:buNone/>
+            </a:pPr>
+            <a:r>
+              <a:rPr lang="en-US" sz="2100" dirty="0">
+                <a:solidFill>
+                  <a:srgbClr val="FFFFFF"/>
+                </a:solidFill>
+                <a:latin typeface="Calibri" pitchFamily="34" charset="0"/>
+                <a:ea typeface="Calibri" pitchFamily="34" charset="-122"/>
+                <a:cs typeface="Calibri" pitchFamily="34" charset="-120"/>
+              </a:rPr>
               <a:t>Result: Google switched its plan to air cooling</a:t>
             </a:r>
             <a:endParaRPr lang="en-US" sz="2100" dirty="0"/>
@@ -2494,18 +2517,18 @@
       </p:sp>
       <p:sp>
         <p:nvSpPr>
-          <p:cNvPr id="22" name="Shape 14"/>
+          <p:cNvPr id="18" name="Shape 10"/>
           <p:cNvSpPr/>
           <p:nvPr/>
         </p:nvSpPr>
         <p:spPr>
           <a:xfrm>
-            <a:off x="6949440" y="1828800"/>
-            <a:ext cx="4690872" cy="4160520"/>
+            <a:off x="6949440" y="2103120"/>
+            <a:ext cx="4690872" cy="3931920"/>
           </a:xfrm>
           <a:prstGeom prst="roundRect">
             <a:avLst>
-              <a:gd name="adj" fmla="val 3956"/>
+              <a:gd name="adj" fmla="val 4651"/>
             </a:avLst>
           </a:prstGeom>
           <a:solidFill>
@@ -2517,34 +2540,41 @@
             </a:solidFill>
             <a:prstDash val="solid"/>
           </a:ln>
+          <a:effectLst>
+            <a:outerShdw sx="100000" sy="100000" kx="0" ky="0" algn="bl" rotWithShape="0" blurRad="279400" dist="101600" dir="5400000">
+              <a:srgbClr val="000000">
+                <a:alpha val="45000"/>
+              </a:srgbClr>
+            </a:outerShdw>
+          </a:effectLst>
         </p:spPr>
       </p:sp>
       <p:graphicFrame>
         <p:nvGraphicFramePr>
-          <p:cNvPr id="23" name="Chart 0" descr=""/>
+          <p:cNvPr id="19" name="Chart 0" descr=""/>
           <p:cNvGraphicFramePr/>
           <p:nvPr/>
         </p:nvGraphicFramePr>
         <p:xfrm>
-          <a:off x="7132320" y="1920240"/>
-          <a:ext cx="4325112" cy="3520440"/>
+          <a:off x="7086600" y="2194560"/>
+          <a:ext cx="4416552" cy="3383280"/>
         </p:xfrm>
         <a:graphic xmlns:a="http://schemas.openxmlformats.org/drawingml/2006/main">
           <a:graphicData uri="http://schemas.openxmlformats.org/drawingml/2006/chart">
-            <c:chart xmlns:c="http://schemas.openxmlformats.org/drawingml/2006/chart" r:id="rId7"/>
+            <c:chart xmlns:c="http://schemas.openxmlformats.org/drawingml/2006/chart" r:id="rId8"/>
           </a:graphicData>
         </a:graphic>
       </p:graphicFrame>
       <p:sp>
         <p:nvSpPr>
-          <p:cNvPr id="24" name="caption-chart"/>
+          <p:cNvPr id="20" name="caption-chart"/>
           <p:cNvSpPr txBox="1"/>
           <p:nvPr/>
         </p:nvSpPr>
         <p:spPr>
           <a:xfrm>
-            <a:off x="7132320" y="5468112"/>
-            <a:ext cx="4325112" cy="365760"/>
+            <a:off x="7086600" y="5577840"/>
+            <a:ext cx="4416552" cy="320040"/>
           </a:xfrm>
           <a:prstGeom prst="rect">
             <a:avLst/>
@@ -2576,14 +2606,14 @@
       </p:sp>
       <p:sp>
         <p:nvSpPr>
-          <p:cNvPr id="25" name="caption-sources"/>
+          <p:cNvPr id="21" name="caption-sources"/>
           <p:cNvSpPr txBox="1"/>
           <p:nvPr/>
         </p:nvSpPr>
         <p:spPr>
           <a:xfrm>
             <a:off x="548640" y="6291072"/>
-            <a:ext cx="11064240" cy="365760"/>
+            <a:ext cx="10058400" cy="365760"/>
           </a:xfrm>
           <a:prstGeom prst="rect">
             <a:avLst/>
@@ -2626,9 +2656,16 @@
   <p:cSld name="Slide 2">
     <p:bg>
       <p:bgPr>
-        <a:solidFill>
-          <a:srgbClr val="FFFFFF"/>
-        </a:solidFill>
+        <a:blipFill dpi="0" rotWithShape="1">
+          <a:blip r:embed="rId1">
+            <a:lum/>
+          </a:blip>
+          <a:srcRect/>
+          <a:stretch>
+            <a:fillRect/>
+          </a:stretch>
+        </a:blipFill>
+        <a:effectLst/>
       </p:bgPr>
     </p:bg>
     <p:spTree>
@@ -2647,13 +2684,91 @@
       </p:grpSpPr>
       <p:sp>
         <p:nvSpPr>
-          <p:cNvPr id="2" name="title"/>
+          <p:cNvPr id="2" name="caption-tag"/>
           <p:cNvSpPr txBox="1"/>
           <p:nvPr/>
         </p:nvSpPr>
         <p:spPr>
           <a:xfrm>
-            <a:off x="548640" y="411480"/>
+            <a:off x="548640" y="347472"/>
+            <a:ext cx="7315200" cy="320040"/>
+          </a:xfrm>
+          <a:prstGeom prst="rect">
+            <a:avLst/>
+          </a:prstGeom>
+          <a:noFill/>
+          <a:ln/>
+        </p:spPr>
+        <p:txBody>
+          <a:bodyPr wrap="square" lIns="0" tIns="0" rIns="0" bIns="0" rtlCol="0" anchor="ctr"/>
+          <a:lstStyle/>
+          <a:p>
+            <a:pPr indent="0" marL="0">
+              <a:buNone/>
+            </a:pPr>
+            <a:r>
+              <a:rPr lang="en-US" sz="1400" b="1" spc="300" kern="0" dirty="0">
+                <a:solidFill>
+                  <a:srgbClr val="137C94"/>
+                </a:solidFill>
+                <a:latin typeface="Calibri" pitchFamily="34" charset="0"/>
+                <a:ea typeface="Calibri" pitchFamily="34" charset="-122"/>
+                <a:cs typeface="Calibri" pitchFamily="34" charset="-120"/>
+              </a:rPr>
+              <a:t>02  ·  ISRAEL &amp; LEV HASHARON</a:t>
+            </a:r>
+            <a:endParaRPr lang="en-US" sz="1400" dirty="0"/>
+          </a:p>
+        </p:txBody>
+      </p:sp>
+      <p:sp>
+        <p:nvSpPr>
+          <p:cNvPr id="3" name="caption-page"/>
+          <p:cNvSpPr txBox="1"/>
+          <p:nvPr/>
+        </p:nvSpPr>
+        <p:spPr>
+          <a:xfrm>
+            <a:off x="10725912" y="6291072"/>
+            <a:ext cx="914400" cy="365760"/>
+          </a:xfrm>
+          <a:prstGeom prst="rect">
+            <a:avLst/>
+          </a:prstGeom>
+          <a:noFill/>
+          <a:ln/>
+        </p:spPr>
+        <p:txBody>
+          <a:bodyPr wrap="square" lIns="0" tIns="0" rIns="0" bIns="0" rtlCol="0" anchor="ctr"/>
+          <a:lstStyle/>
+          <a:p>
+            <a:pPr algn="r" indent="0" marL="0">
+              <a:buNone/>
+            </a:pPr>
+            <a:r>
+              <a:rPr lang="en-US" sz="1100" dirty="0">
+                <a:solidFill>
+                  <a:srgbClr val="4A5A68"/>
+                </a:solidFill>
+                <a:latin typeface="Calibri" pitchFamily="34" charset="0"/>
+                <a:ea typeface="Calibri" pitchFamily="34" charset="-122"/>
+                <a:cs typeface="Calibri" pitchFamily="34" charset="-120"/>
+              </a:rPr>
+              <a:t>2 / 5</a:t>
+            </a:r>
+            <a:endParaRPr lang="en-US" sz="1100" dirty="0"/>
+          </a:p>
+        </p:txBody>
+      </p:sp>
+      <p:sp>
+        <p:nvSpPr>
+          <p:cNvPr id="4" name="title"/>
+          <p:cNvSpPr txBox="1"/>
+          <p:nvPr/>
+        </p:nvSpPr>
+        <p:spPr>
+          <a:xfrm>
+            <a:off x="548640" y="685800"/>
             <a:ext cx="11064240" cy="731520"/>
           </a:xfrm>
           <a:prstGeom prst="rect">
@@ -2684,136 +2799,9 @@
           </a:p>
         </p:txBody>
       </p:sp>
-      <p:sp>
-        <p:nvSpPr>
-          <p:cNvPr id="3" name="Shape 1"/>
-          <p:cNvSpPr/>
-          <p:nvPr/>
-        </p:nvSpPr>
-        <p:spPr>
-          <a:xfrm>
-            <a:off x="548640" y="1463040"/>
-            <a:ext cx="475488" cy="475488"/>
-          </a:xfrm>
-          <a:prstGeom prst="ellipse">
-            <a:avLst/>
-          </a:prstGeom>
-          <a:solidFill>
-            <a:srgbClr val="137C94"/>
-          </a:solidFill>
-          <a:ln w="12700">
-            <a:solidFill>
-              <a:srgbClr val="137C94"/>
-            </a:solidFill>
-            <a:prstDash val="solid"/>
-          </a:ln>
-        </p:spPr>
-      </p:sp>
       <p:pic>
         <p:nvPicPr>
-          <p:cNvPr id="4" name="Image 0" descr="preencoded.png">    </p:cNvPr>
-          <p:cNvPicPr>
-            <a:picLocks noChangeAspect="1"/>
-          </p:cNvPicPr>
-          <p:nvPr/>
-        </p:nvPicPr>
-        <p:blipFill>
-          <a:blip r:embed="rId1"/>
-          <a:stretch>
-            <a:fillRect/>
-          </a:stretch>
-        </p:blipFill>
-        <p:spPr>
-          <a:xfrm>
-            <a:off x="658368" y="1572768"/>
-            <a:ext cx="256032" cy="256032"/>
-          </a:xfrm>
-          <a:prstGeom prst="rect">
-            <a:avLst/>
-          </a:prstGeom>
-        </p:spPr>
-      </p:pic>
-      <p:sp>
-        <p:nvSpPr>
-          <p:cNvPr id="5" name="body"/>
-          <p:cNvSpPr txBox="1"/>
-          <p:nvPr/>
-        </p:nvSpPr>
-        <p:spPr>
-          <a:xfrm>
-            <a:off x="1207008" y="1408176"/>
-            <a:ext cx="5669280" cy="585216"/>
-          </a:xfrm>
-          <a:prstGeom prst="rect">
-            <a:avLst/>
-          </a:prstGeom>
-          <a:noFill/>
-          <a:ln/>
-        </p:spPr>
-        <p:txBody>
-          <a:bodyPr wrap="square" lIns="0" tIns="0" rIns="0" bIns="0" rtlCol="0" anchor="ctr"/>
-          <a:lstStyle/>
-          <a:p>
-            <a:pPr indent="0" marL="0">
-              <a:buNone/>
-            </a:pPr>
-            <a:r>
-              <a:rPr lang="en-US" sz="2200" dirty="0">
-                <a:solidFill>
-                  <a:srgbClr val="0B2239"/>
-                </a:solidFill>
-                <a:latin typeface="Calibri" pitchFamily="34" charset="0"/>
-                <a:ea typeface="Calibri" pitchFamily="34" charset="-122"/>
-                <a:cs typeface="Calibri" pitchFamily="34" charset="-120"/>
-              </a:rPr>
-              <a:t>Most of our tap water is </a:t>
-            </a:r>
-            <a:pPr indent="0" marL="0">
-              <a:buNone/>
-            </a:pPr>
-            <a:r>
-              <a:rPr lang="en-US" sz="2200" b="1" dirty="0">
-                <a:solidFill>
-                  <a:srgbClr val="137C94"/>
-                </a:solidFill>
-                <a:latin typeface="Calibri" pitchFamily="34" charset="0"/>
-                <a:ea typeface="Calibri" pitchFamily="34" charset="-122"/>
-                <a:cs typeface="Calibri" pitchFamily="34" charset="-120"/>
-              </a:rPr>
-              <a:t>desalinated</a:t>
-            </a:r>
-            <a:endParaRPr lang="en-US" sz="2200" dirty="0"/>
-          </a:p>
-        </p:txBody>
-      </p:sp>
-      <p:sp>
-        <p:nvSpPr>
-          <p:cNvPr id="6" name="Shape 3"/>
-          <p:cNvSpPr/>
-          <p:nvPr/>
-        </p:nvSpPr>
-        <p:spPr>
-          <a:xfrm>
-            <a:off x="548640" y="2194560"/>
-            <a:ext cx="475488" cy="475488"/>
-          </a:xfrm>
-          <a:prstGeom prst="ellipse">
-            <a:avLst/>
-          </a:prstGeom>
-          <a:solidFill>
-            <a:srgbClr val="F2A33A"/>
-          </a:solidFill>
-          <a:ln w="12700">
-            <a:solidFill>
-              <a:srgbClr val="F2A33A"/>
-            </a:solidFill>
-            <a:prstDash val="solid"/>
-          </a:ln>
-        </p:spPr>
-      </p:sp>
-      <p:pic>
-        <p:nvPicPr>
-          <p:cNvPr id="7" name="Image 1" descr="preencoded.png">    </p:cNvPr>
+          <p:cNvPr id="5" name="Image 0" descr="preencoded.png">    </p:cNvPr>
           <p:cNvPicPr>
             <a:picLocks noChangeAspect="1"/>
           </p:cNvPicPr>
@@ -2827,8 +2815,8 @@
         </p:blipFill>
         <p:spPr>
           <a:xfrm>
-            <a:off x="658368" y="2304288"/>
-            <a:ext cx="256032" cy="256032"/>
+            <a:off x="502920" y="1682496"/>
+            <a:ext cx="603504" cy="603504"/>
           </a:xfrm>
           <a:prstGeom prst="rect">
             <a:avLst/>
@@ -2837,14 +2825,14 @@
       </p:pic>
       <p:sp>
         <p:nvSpPr>
-          <p:cNvPr id="8" name="body"/>
+          <p:cNvPr id="6" name="body"/>
           <p:cNvSpPr txBox="1"/>
           <p:nvPr/>
         </p:nvSpPr>
         <p:spPr>
           <a:xfrm>
-            <a:off x="1207008" y="2139696"/>
-            <a:ext cx="5669280" cy="585216"/>
+            <a:off x="1280160" y="1664208"/>
+            <a:ext cx="5715000" cy="585216"/>
           </a:xfrm>
           <a:prstGeom prst="rect">
             <a:avLst/>
@@ -2860,7 +2848,7 @@
               <a:buNone/>
             </a:pPr>
             <a:r>
-              <a:rPr lang="en-US" sz="2200" dirty="0">
+              <a:rPr lang="en-US" sz="2100" dirty="0">
                 <a:solidFill>
                   <a:srgbClr val="0B2239"/>
                 </a:solidFill>
@@ -2868,54 +2856,29 @@
                 <a:ea typeface="Calibri" pitchFamily="34" charset="-122"/>
                 <a:cs typeface="Calibri" pitchFamily="34" charset="-120"/>
               </a:rPr>
-              <a:t>Desalination needs </a:t>
-            </a:r>
-            <a:pPr indent="0" marL="0">
-              <a:buNone/>
-            </a:pPr>
-            <a:r>
-              <a:rPr lang="en-US" sz="2200" b="1" dirty="0">
-                <a:solidFill>
-                  <a:srgbClr val="0B2239"/>
-                </a:solidFill>
-                <a:latin typeface="Calibri" pitchFamily="34" charset="0"/>
-                <a:ea typeface="Calibri" pitchFamily="34" charset="-122"/>
-                <a:cs typeface="Calibri" pitchFamily="34" charset="-120"/>
-              </a:rPr>
-              <a:t>a lot of electricity</a:t>
-            </a:r>
-            <a:endParaRPr lang="en-US" sz="2200" dirty="0"/>
-          </a:p>
-        </p:txBody>
-      </p:sp>
-      <p:sp>
-        <p:nvSpPr>
-          <p:cNvPr id="9" name="Shape 5"/>
-          <p:cNvSpPr/>
-          <p:nvPr/>
-        </p:nvSpPr>
-        <p:spPr>
-          <a:xfrm>
-            <a:off x="548640" y="2926080"/>
-            <a:ext cx="475488" cy="475488"/>
-          </a:xfrm>
-          <a:prstGeom prst="ellipse">
-            <a:avLst/>
-          </a:prstGeom>
-          <a:solidFill>
-            <a:srgbClr val="F2A33A"/>
-          </a:solidFill>
-          <a:ln w="12700">
-            <a:solidFill>
-              <a:srgbClr val="F2A33A"/>
-            </a:solidFill>
-            <a:prstDash val="solid"/>
-          </a:ln>
-        </p:spPr>
+              <a:t>Most of our tap water is </a:t>
+            </a:r>
+            <a:pPr indent="0" marL="0">
+              <a:buNone/>
+            </a:pPr>
+            <a:r>
+              <a:rPr lang="en-US" sz="2100" b="1" dirty="0">
+                <a:solidFill>
+                  <a:srgbClr val="137C94"/>
+                </a:solidFill>
+                <a:latin typeface="Calibri" pitchFamily="34" charset="0"/>
+                <a:ea typeface="Calibri" pitchFamily="34" charset="-122"/>
+                <a:cs typeface="Calibri" pitchFamily="34" charset="-120"/>
+              </a:rPr>
+              <a:t>desalinated</a:t>
+            </a:r>
+            <a:endParaRPr lang="en-US" sz="2100" dirty="0"/>
+          </a:p>
+        </p:txBody>
       </p:sp>
       <p:pic>
         <p:nvPicPr>
-          <p:cNvPr id="10" name="Image 2" descr="preencoded.png">    </p:cNvPr>
+          <p:cNvPr id="7" name="Image 1" descr="preencoded.png">    </p:cNvPr>
           <p:cNvPicPr>
             <a:picLocks noChangeAspect="1"/>
           </p:cNvPicPr>
@@ -2929,8 +2892,8 @@
         </p:blipFill>
         <p:spPr>
           <a:xfrm>
-            <a:off x="658368" y="3035808"/>
-            <a:ext cx="256032" cy="256032"/>
+            <a:off x="502920" y="2395728"/>
+            <a:ext cx="603504" cy="603504"/>
           </a:xfrm>
           <a:prstGeom prst="rect">
             <a:avLst/>
@@ -2939,14 +2902,14 @@
       </p:pic>
       <p:sp>
         <p:nvSpPr>
-          <p:cNvPr id="11" name="body"/>
+          <p:cNvPr id="8" name="body"/>
           <p:cNvSpPr txBox="1"/>
           <p:nvPr/>
         </p:nvSpPr>
         <p:spPr>
           <a:xfrm>
-            <a:off x="1207008" y="2871216"/>
-            <a:ext cx="5669280" cy="585216"/>
+            <a:off x="1280160" y="2377440"/>
+            <a:ext cx="5715000" cy="585216"/>
           </a:xfrm>
           <a:prstGeom prst="rect">
             <a:avLst/>
@@ -2962,7 +2925,7 @@
               <a:buNone/>
             </a:pPr>
             <a:r>
-              <a:rPr lang="en-US" sz="2200" dirty="0">
+              <a:rPr lang="en-US" sz="2100" dirty="0">
                 <a:solidFill>
                   <a:srgbClr val="0B2239"/>
                 </a:solidFill>
@@ -2970,13 +2933,13 @@
                 <a:ea typeface="Calibri" pitchFamily="34" charset="-122"/>
                 <a:cs typeface="Calibri" pitchFamily="34" charset="-120"/>
               </a:rPr>
-              <a:t>Data centers requested </a:t>
-            </a:r>
-            <a:pPr indent="0" marL="0">
-              <a:buNone/>
-            </a:pPr>
-            <a:r>
-              <a:rPr lang="en-US" sz="2200" b="1" dirty="0">
+              <a:t>Desalination needs </a:t>
+            </a:r>
+            <a:pPr indent="0" marL="0">
+              <a:buNone/>
+            </a:pPr>
+            <a:r>
+              <a:rPr lang="en-US" sz="2100" b="1" dirty="0">
                 <a:solidFill>
                   <a:srgbClr val="0B2239"/>
                 </a:solidFill>
@@ -2984,54 +2947,15 @@
                 <a:ea typeface="Calibri" pitchFamily="34" charset="-122"/>
                 <a:cs typeface="Calibri" pitchFamily="34" charset="-120"/>
               </a:rPr>
-              <a:t>27,000 MW</a:t>
-            </a:r>
-            <a:pPr indent="0" marL="0">
-              <a:buNone/>
-            </a:pPr>
-            <a:r>
-              <a:rPr lang="en-US" sz="2200" dirty="0">
-                <a:solidFill>
-                  <a:srgbClr val="0B2239"/>
-                </a:solidFill>
-                <a:latin typeface="Calibri" pitchFamily="34" charset="0"/>
-                <a:ea typeface="Calibri" pitchFamily="34" charset="-122"/>
-                <a:cs typeface="Calibri" pitchFamily="34" charset="-120"/>
-              </a:rPr>
-              <a:t> (≈3× average)</a:t>
-            </a:r>
-            <a:endParaRPr lang="en-US" sz="2200" dirty="0"/>
-          </a:p>
-        </p:txBody>
-      </p:sp>
-      <p:sp>
-        <p:nvSpPr>
-          <p:cNvPr id="12" name="Shape 7"/>
-          <p:cNvSpPr/>
-          <p:nvPr/>
-        </p:nvSpPr>
-        <p:spPr>
-          <a:xfrm>
-            <a:off x="548640" y="3657600"/>
-            <a:ext cx="475488" cy="475488"/>
-          </a:xfrm>
-          <a:prstGeom prst="ellipse">
-            <a:avLst/>
-          </a:prstGeom>
-          <a:solidFill>
-            <a:srgbClr val="137C94"/>
-          </a:solidFill>
-          <a:ln w="12700">
-            <a:solidFill>
-              <a:srgbClr val="137C94"/>
-            </a:solidFill>
-            <a:prstDash val="solid"/>
-          </a:ln>
-        </p:spPr>
+              <a:t>a lot of electricity</a:t>
+            </a:r>
+            <a:endParaRPr lang="en-US" sz="2100" dirty="0"/>
+          </a:p>
+        </p:txBody>
       </p:sp>
       <p:pic>
         <p:nvPicPr>
-          <p:cNvPr id="13" name="Image 3" descr="preencoded.png">    </p:cNvPr>
+          <p:cNvPr id="9" name="Image 2" descr="preencoded.png">    </p:cNvPr>
           <p:cNvPicPr>
             <a:picLocks noChangeAspect="1"/>
           </p:cNvPicPr>
@@ -3045,8 +2969,8 @@
         </p:blipFill>
         <p:spPr>
           <a:xfrm>
-            <a:off x="658368" y="3767328"/>
-            <a:ext cx="256032" cy="256032"/>
+            <a:off x="502920" y="3108960"/>
+            <a:ext cx="603504" cy="603504"/>
           </a:xfrm>
           <a:prstGeom prst="rect">
             <a:avLst/>
@@ -3055,14 +2979,14 @@
       </p:pic>
       <p:sp>
         <p:nvSpPr>
-          <p:cNvPr id="14" name="body"/>
+          <p:cNvPr id="10" name="body"/>
           <p:cNvSpPr txBox="1"/>
           <p:nvPr/>
         </p:nvSpPr>
         <p:spPr>
           <a:xfrm>
-            <a:off x="1207008" y="3602736"/>
-            <a:ext cx="5669280" cy="585216"/>
+            <a:off x="1280160" y="3090672"/>
+            <a:ext cx="5715000" cy="585216"/>
           </a:xfrm>
           <a:prstGeom prst="rect">
             <a:avLst/>
@@ -3078,21 +3002,7 @@
               <a:buNone/>
             </a:pPr>
             <a:r>
-              <a:rPr lang="en-US" sz="2200" b="1" dirty="0">
-                <a:solidFill>
-                  <a:srgbClr val="137C94"/>
-                </a:solidFill>
-                <a:latin typeface="Calibri" pitchFamily="34" charset="0"/>
-                <a:ea typeface="Calibri" pitchFamily="34" charset="-122"/>
-                <a:cs typeface="Calibri" pitchFamily="34" charset="-120"/>
-              </a:rPr>
-              <a:t>July 2026: </a:t>
-            </a:r>
-            <a:pPr indent="0" marL="0">
-              <a:buNone/>
-            </a:pPr>
-            <a:r>
-              <a:rPr lang="en-US" sz="2200" dirty="0">
+              <a:rPr lang="en-US" sz="2100" dirty="0">
                 <a:solidFill>
                   <a:srgbClr val="0B2239"/>
                 </a:solidFill>
@@ -3100,40 +3010,43 @@
                 <a:ea typeface="Calibri" pitchFamily="34" charset="-122"/>
                 <a:cs typeface="Calibri" pitchFamily="34" charset="-120"/>
               </a:rPr>
-              <a:t>regulator froze new connections</a:t>
-            </a:r>
-            <a:endParaRPr lang="en-US" sz="2200" dirty="0"/>
-          </a:p>
-        </p:txBody>
-      </p:sp>
-      <p:sp>
-        <p:nvSpPr>
-          <p:cNvPr id="15" name="Shape 9"/>
-          <p:cNvSpPr/>
-          <p:nvPr/>
-        </p:nvSpPr>
-        <p:spPr>
-          <a:xfrm>
-            <a:off x="548640" y="4389120"/>
-            <a:ext cx="475488" cy="475488"/>
-          </a:xfrm>
-          <a:prstGeom prst="ellipse">
-            <a:avLst/>
-          </a:prstGeom>
-          <a:solidFill>
-            <a:srgbClr val="137C94"/>
-          </a:solidFill>
-          <a:ln w="12700">
-            <a:solidFill>
-              <a:srgbClr val="137C94"/>
-            </a:solidFill>
-            <a:prstDash val="solid"/>
-          </a:ln>
-        </p:spPr>
+              <a:t>Data centers requested </a:t>
+            </a:r>
+            <a:pPr indent="0" marL="0">
+              <a:buNone/>
+            </a:pPr>
+            <a:r>
+              <a:rPr lang="en-US" sz="2100" b="1" dirty="0">
+                <a:solidFill>
+                  <a:srgbClr val="0B2239"/>
+                </a:solidFill>
+                <a:latin typeface="Calibri" pitchFamily="34" charset="0"/>
+                <a:ea typeface="Calibri" pitchFamily="34" charset="-122"/>
+                <a:cs typeface="Calibri" pitchFamily="34" charset="-120"/>
+              </a:rPr>
+              <a:t>27,000 MW</a:t>
+            </a:r>
+            <a:pPr indent="0" marL="0">
+              <a:buNone/>
+            </a:pPr>
+            <a:r>
+              <a:rPr lang="en-US" sz="2100" dirty="0">
+                <a:solidFill>
+                  <a:srgbClr val="0B2239"/>
+                </a:solidFill>
+                <a:latin typeface="Calibri" pitchFamily="34" charset="0"/>
+                <a:ea typeface="Calibri" pitchFamily="34" charset="-122"/>
+                <a:cs typeface="Calibri" pitchFamily="34" charset="-120"/>
+              </a:rPr>
+              <a:t> (≈3× average)</a:t>
+            </a:r>
+            <a:endParaRPr lang="en-US" sz="2100" dirty="0"/>
+          </a:p>
+        </p:txBody>
       </p:sp>
       <p:pic>
         <p:nvPicPr>
-          <p:cNvPr id="16" name="Image 4" descr="preencoded.png">    </p:cNvPr>
+          <p:cNvPr id="11" name="Image 3" descr="preencoded.png">    </p:cNvPr>
           <p:cNvPicPr>
             <a:picLocks noChangeAspect="1"/>
           </p:cNvPicPr>
@@ -3147,8 +3060,8 @@
         </p:blipFill>
         <p:spPr>
           <a:xfrm>
-            <a:off x="658368" y="4498848"/>
-            <a:ext cx="256032" cy="256032"/>
+            <a:off x="502920" y="3822192"/>
+            <a:ext cx="603504" cy="603504"/>
           </a:xfrm>
           <a:prstGeom prst="rect">
             <a:avLst/>
@@ -3157,14 +3070,14 @@
       </p:pic>
       <p:sp>
         <p:nvSpPr>
-          <p:cNvPr id="17" name="body"/>
+          <p:cNvPr id="12" name="body"/>
           <p:cNvSpPr txBox="1"/>
           <p:nvPr/>
         </p:nvSpPr>
         <p:spPr>
           <a:xfrm>
-            <a:off x="1207008" y="4334256"/>
-            <a:ext cx="5669280" cy="585216"/>
+            <a:off x="1280160" y="3803904"/>
+            <a:ext cx="5715000" cy="585216"/>
           </a:xfrm>
           <a:prstGeom prst="rect">
             <a:avLst/>
@@ -3180,7 +3093,7 @@
               <a:buNone/>
             </a:pPr>
             <a:r>
-              <a:rPr lang="en-US" sz="2200" b="1" dirty="0">
+              <a:rPr lang="en-US" sz="2100" b="1" dirty="0">
                 <a:solidFill>
                   <a:srgbClr val="137C94"/>
                 </a:solidFill>
@@ -3188,13 +3101,13 @@
                 <a:ea typeface="Calibri" pitchFamily="34" charset="-122"/>
                 <a:cs typeface="Calibri" pitchFamily="34" charset="-120"/>
               </a:rPr>
-              <a:t>Near us: </a:t>
-            </a:r>
-            <a:pPr indent="0" marL="0">
-              <a:buNone/>
-            </a:pPr>
-            <a:r>
-              <a:rPr lang="en-US" sz="2200" dirty="0">
+              <a:t>July 2026: </a:t>
+            </a:r>
+            <a:pPr indent="0" marL="0">
+              <a:buNone/>
+            </a:pPr>
+            <a:r>
+              <a:rPr lang="en-US" sz="2100" dirty="0">
                 <a:solidFill>
                   <a:srgbClr val="0B2239"/>
                 </a:solidFill>
@@ -3202,40 +3115,15 @@
                 <a:ea typeface="Calibri" pitchFamily="34" charset="-122"/>
                 <a:cs typeface="Calibri" pitchFamily="34" charset="-120"/>
               </a:rPr>
-              <a:t>Kfar Yona, Netanya, Hadera projects</a:t>
-            </a:r>
-            <a:endParaRPr lang="en-US" sz="2200" dirty="0"/>
-          </a:p>
-        </p:txBody>
-      </p:sp>
-      <p:sp>
-        <p:nvSpPr>
-          <p:cNvPr id="18" name="Shape 11"/>
-          <p:cNvSpPr/>
-          <p:nvPr/>
-        </p:nvSpPr>
-        <p:spPr>
-          <a:xfrm>
-            <a:off x="548640" y="5120640"/>
-            <a:ext cx="475488" cy="475488"/>
-          </a:xfrm>
-          <a:prstGeom prst="ellipse">
-            <a:avLst/>
-          </a:prstGeom>
-          <a:solidFill>
-            <a:srgbClr val="137C94"/>
-          </a:solidFill>
-          <a:ln w="12700">
-            <a:solidFill>
-              <a:srgbClr val="137C94"/>
-            </a:solidFill>
-            <a:prstDash val="solid"/>
-          </a:ln>
-        </p:spPr>
+              <a:t>regulator froze new connections</a:t>
+            </a:r>
+            <a:endParaRPr lang="en-US" sz="2100" dirty="0"/>
+          </a:p>
+        </p:txBody>
       </p:sp>
       <p:pic>
         <p:nvPicPr>
-          <p:cNvPr id="19" name="Image 5" descr="preencoded.png">    </p:cNvPr>
+          <p:cNvPr id="13" name="Image 4" descr="preencoded.png">    </p:cNvPr>
           <p:cNvPicPr>
             <a:picLocks noChangeAspect="1"/>
           </p:cNvPicPr>
@@ -3249,8 +3137,8 @@
         </p:blipFill>
         <p:spPr>
           <a:xfrm>
-            <a:off x="658368" y="5230368"/>
-            <a:ext cx="256032" cy="256032"/>
+            <a:off x="502920" y="4535424"/>
+            <a:ext cx="603504" cy="603504"/>
           </a:xfrm>
           <a:prstGeom prst="rect">
             <a:avLst/>
@@ -3259,14 +3147,14 @@
       </p:pic>
       <p:sp>
         <p:nvSpPr>
-          <p:cNvPr id="20" name="body"/>
+          <p:cNvPr id="14" name="body"/>
           <p:cNvSpPr txBox="1"/>
           <p:nvPr/>
         </p:nvSpPr>
         <p:spPr>
           <a:xfrm>
-            <a:off x="1207008" y="5065776"/>
-            <a:ext cx="5669280" cy="585216"/>
+            <a:off x="1280160" y="4517136"/>
+            <a:ext cx="5715000" cy="585216"/>
           </a:xfrm>
           <a:prstGeom prst="rect">
             <a:avLst/>
@@ -3282,7 +3170,7 @@
               <a:buNone/>
             </a:pPr>
             <a:r>
-              <a:rPr lang="en-US" sz="2200" b="1" dirty="0">
+              <a:rPr lang="en-US" sz="2100" b="1" dirty="0">
                 <a:solidFill>
                   <a:srgbClr val="137C94"/>
                 </a:solidFill>
@@ -3290,13 +3178,90 @@
                 <a:ea typeface="Calibri" pitchFamily="34" charset="-122"/>
                 <a:cs typeface="Calibri" pitchFamily="34" charset="-120"/>
               </a:rPr>
+              <a:t>Near us: </a:t>
+            </a:r>
+            <a:pPr indent="0" marL="0">
+              <a:buNone/>
+            </a:pPr>
+            <a:r>
+              <a:rPr lang="en-US" sz="2100" dirty="0">
+                <a:solidFill>
+                  <a:srgbClr val="0B2239"/>
+                </a:solidFill>
+                <a:latin typeface="Calibri" pitchFamily="34" charset="0"/>
+                <a:ea typeface="Calibri" pitchFamily="34" charset="-122"/>
+                <a:cs typeface="Calibri" pitchFamily="34" charset="-120"/>
+              </a:rPr>
+              <a:t>Kfar Yona, Netanya, Hadera projects</a:t>
+            </a:r>
+            <a:endParaRPr lang="en-US" sz="2100" dirty="0"/>
+          </a:p>
+        </p:txBody>
+      </p:sp>
+      <p:pic>
+        <p:nvPicPr>
+          <p:cNvPr id="15" name="Image 5" descr="preencoded.png">    </p:cNvPr>
+          <p:cNvPicPr>
+            <a:picLocks noChangeAspect="1"/>
+          </p:cNvPicPr>
+          <p:nvPr/>
+        </p:nvPicPr>
+        <p:blipFill>
+          <a:blip r:embed="rId7"/>
+          <a:stretch>
+            <a:fillRect/>
+          </a:stretch>
+        </p:blipFill>
+        <p:spPr>
+          <a:xfrm>
+            <a:off x="502920" y="5248656"/>
+            <a:ext cx="603504" cy="603504"/>
+          </a:xfrm>
+          <a:prstGeom prst="rect">
+            <a:avLst/>
+          </a:prstGeom>
+        </p:spPr>
+      </p:pic>
+      <p:sp>
+        <p:nvSpPr>
+          <p:cNvPr id="16" name="body"/>
+          <p:cNvSpPr txBox="1"/>
+          <p:nvPr/>
+        </p:nvSpPr>
+        <p:spPr>
+          <a:xfrm>
+            <a:off x="1280160" y="5230368"/>
+            <a:ext cx="5715000" cy="585216"/>
+          </a:xfrm>
+          <a:prstGeom prst="rect">
+            <a:avLst/>
+          </a:prstGeom>
+          <a:noFill/>
+          <a:ln/>
+        </p:spPr>
+        <p:txBody>
+          <a:bodyPr wrap="square" lIns="0" tIns="0" rIns="0" bIns="0" rtlCol="0" anchor="ctr"/>
+          <a:lstStyle/>
+          <a:p>
+            <a:pPr indent="0" marL="0">
+              <a:buNone/>
+            </a:pPr>
+            <a:r>
+              <a:rPr lang="en-US" sz="2100" b="1" dirty="0">
+                <a:solidFill>
+                  <a:srgbClr val="137C94"/>
+                </a:solidFill>
+                <a:latin typeface="Calibri" pitchFamily="34" charset="0"/>
+                <a:ea typeface="Calibri" pitchFamily="34" charset="-122"/>
+                <a:cs typeface="Calibri" pitchFamily="34" charset="-120"/>
+              </a:rPr>
               <a:t>2026 water shortage: </a:t>
             </a:r>
             <a:pPr indent="0" marL="0">
               <a:buNone/>
             </a:pPr>
             <a:r>
-              <a:rPr lang="en-US" sz="2200" dirty="0">
+              <a:rPr lang="en-US" sz="2100" dirty="0">
                 <a:solidFill>
                   <a:srgbClr val="0B2239"/>
                 </a:solidFill>
@@ -3306,63 +3271,70 @@
               </a:rPr>
               <a:t>farms were cut first</a:t>
             </a:r>
-            <a:endParaRPr lang="en-US" sz="2200" dirty="0"/>
-          </a:p>
-        </p:txBody>
-      </p:sp>
-      <p:sp>
-        <p:nvSpPr>
-          <p:cNvPr id="21" name="Shape 13"/>
+            <a:endParaRPr lang="en-US" sz="2100" dirty="0"/>
+          </a:p>
+        </p:txBody>
+      </p:sp>
+      <p:sp>
+        <p:nvSpPr>
+          <p:cNvPr id="17" name="Shape 9"/>
           <p:cNvSpPr/>
           <p:nvPr/>
         </p:nvSpPr>
         <p:spPr>
           <a:xfrm>
-            <a:off x="7178040" y="1417320"/>
-            <a:ext cx="4462272" cy="4526280"/>
+            <a:off x="7178040" y="1645920"/>
+            <a:ext cx="4462272" cy="4389120"/>
           </a:xfrm>
           <a:prstGeom prst="roundRect">
             <a:avLst>
-              <a:gd name="adj" fmla="val 3689"/>
+              <a:gd name="adj" fmla="val 4167"/>
             </a:avLst>
           </a:prstGeom>
           <a:solidFill>
-            <a:srgbClr val="EAF4F7"/>
+            <a:srgbClr val="FFFFFF"/>
           </a:solidFill>
           <a:ln w="12700">
             <a:solidFill>
-              <a:srgbClr val="EAF4F7"/>
+              <a:srgbClr val="FFFFFF"/>
             </a:solidFill>
             <a:prstDash val="solid"/>
           </a:ln>
+          <a:effectLst>
+            <a:outerShdw sx="100000" sy="100000" kx="0" ky="0" algn="bl" rotWithShape="0" blurRad="203200" dist="76200" dir="5400000">
+              <a:srgbClr val="000000">
+                <a:alpha val="18000"/>
+              </a:srgbClr>
+            </a:outerShdw>
+          </a:effectLst>
         </p:spPr>
       </p:sp>
       <p:graphicFrame>
         <p:nvGraphicFramePr>
-          <p:cNvPr id="22" name="Chart 0" descr=""/>
+          <p:cNvPr id="18" name="Chart 0" descr=""/>
           <p:cNvGraphicFramePr/>
           <p:nvPr/>
         </p:nvGraphicFramePr>
         <p:xfrm>
-          <a:off x="7315200" y="1554480"/>
-          <a:ext cx="4187952" cy="3749040"/>
+          <a:off x="7315200" y="1737360"/>
+          <a:ext cx="4187952" cy="3657600"/>
         </p:xfrm>
         <a:graphic xmlns:a="http://schemas.openxmlformats.org/drawingml/2006/main">
           <a:graphicData uri="http://schemas.openxmlformats.org/drawingml/2006/chart">
-            <c:chart xmlns:c="http://schemas.openxmlformats.org/drawingml/2006/chart" r:id="rId7"/>
+            <c:chart xmlns:c="http://schemas.openxmlformats.org/drawingml/2006/chart" r:id="rId8"/>
           </a:graphicData>
         </a:graphic>
       </p:graphicFrame>
       <p:sp>
         <p:nvSpPr>
-          <p:cNvPr id="23" name="caption-chart"/>
+          <p:cNvPr id="19" name="caption-chart"/>
           <p:cNvSpPr txBox="1"/>
           <p:nvPr/>
         </p:nvSpPr>
         <p:spPr>
           <a:xfrm>
-            <a:off x="7315200" y="5303520"/>
-            <a:ext cx="4187952" cy="548640"/>
+            <a:off x="7360920" y="5394960"/>
+            <a:ext cx="4096512" cy="548640"/>
           </a:xfrm>
           <a:prstGeom prst="rect">
             <a:avLst/>
@@ -3394,14 +3366,14 @@
       </p:sp>
       <p:sp>
         <p:nvSpPr>
-          <p:cNvPr id="24" name="caption-sources"/>
+          <p:cNvPr id="20" name="caption-sources"/>
           <p:cNvSpPr txBox="1"/>
           <p:nvPr/>
         </p:nvSpPr>
         <p:spPr>
           <a:xfrm>
             <a:off x="548640" y="6291072"/>
-            <a:ext cx="11064240" cy="365760"/>
+            <a:ext cx="10058400" cy="365760"/>
           </a:xfrm>
           <a:prstGeom prst="rect">
             <a:avLst/>
@@ -3444,9 +3416,16 @@
   <p:cSld name="Slide 3">
     <p:bg>
       <p:bgPr>
-        <a:solidFill>
-          <a:srgbClr val="FFFFFF"/>
-        </a:solidFill>
+        <a:blipFill dpi="0" rotWithShape="1">
+          <a:blip r:embed="rId1">
+            <a:lum/>
+          </a:blip>
+          <a:srcRect/>
+          <a:stretch>
+            <a:fillRect/>
+          </a:stretch>
+        </a:blipFill>
+        <a:effectLst/>
       </p:bgPr>
     </p:bg>
     <p:spTree>
@@ -3465,13 +3444,91 @@
       </p:grpSpPr>
       <p:sp>
         <p:nvSpPr>
-          <p:cNvPr id="2" name="title"/>
+          <p:cNvPr id="2" name="caption-tag"/>
           <p:cNvSpPr txBox="1"/>
           <p:nvPr/>
         </p:nvSpPr>
         <p:spPr>
           <a:xfrm>
-            <a:off x="548640" y="411480"/>
+            <a:off x="548640" y="347472"/>
+            <a:ext cx="7315200" cy="320040"/>
+          </a:xfrm>
+          <a:prstGeom prst="rect">
+            <a:avLst/>
+          </a:prstGeom>
+          <a:noFill/>
+          <a:ln/>
+        </p:spPr>
+        <p:txBody>
+          <a:bodyPr wrap="square" lIns="0" tIns="0" rIns="0" bIns="0" rtlCol="0" anchor="ctr"/>
+          <a:lstStyle/>
+          <a:p>
+            <a:pPr indent="0" marL="0">
+              <a:buNone/>
+            </a:pPr>
+            <a:r>
+              <a:rPr lang="en-US" sz="1400" b="1" spc="300" kern="0" dirty="0">
+                <a:solidFill>
+                  <a:srgbClr val="137C94"/>
+                </a:solidFill>
+                <a:latin typeface="Calibri" pitchFamily="34" charset="0"/>
+                <a:ea typeface="Calibri" pitchFamily="34" charset="-122"/>
+                <a:cs typeface="Calibri" pitchFamily="34" charset="-120"/>
+              </a:rPr>
+              <a:t>03  ·  ORGANIZATIONS &amp; LAWS</a:t>
+            </a:r>
+            <a:endParaRPr lang="en-US" sz="1400" dirty="0"/>
+          </a:p>
+        </p:txBody>
+      </p:sp>
+      <p:sp>
+        <p:nvSpPr>
+          <p:cNvPr id="3" name="caption-page"/>
+          <p:cNvSpPr txBox="1"/>
+          <p:nvPr/>
+        </p:nvSpPr>
+        <p:spPr>
+          <a:xfrm>
+            <a:off x="10725912" y="6291072"/>
+            <a:ext cx="914400" cy="365760"/>
+          </a:xfrm>
+          <a:prstGeom prst="rect">
+            <a:avLst/>
+          </a:prstGeom>
+          <a:noFill/>
+          <a:ln/>
+        </p:spPr>
+        <p:txBody>
+          <a:bodyPr wrap="square" lIns="0" tIns="0" rIns="0" bIns="0" rtlCol="0" anchor="ctr"/>
+          <a:lstStyle/>
+          <a:p>
+            <a:pPr algn="r" indent="0" marL="0">
+              <a:buNone/>
+            </a:pPr>
+            <a:r>
+              <a:rPr lang="en-US" sz="1100" dirty="0">
+                <a:solidFill>
+                  <a:srgbClr val="4A5A68"/>
+                </a:solidFill>
+                <a:latin typeface="Calibri" pitchFamily="34" charset="0"/>
+                <a:ea typeface="Calibri" pitchFamily="34" charset="-122"/>
+                <a:cs typeface="Calibri" pitchFamily="34" charset="-120"/>
+              </a:rPr>
+              <a:t>3 / 5</a:t>
+            </a:r>
+            <a:endParaRPr lang="en-US" sz="1100" dirty="0"/>
+          </a:p>
+        </p:txBody>
+      </p:sp>
+      <p:sp>
+        <p:nvSpPr>
+          <p:cNvPr id="4" name="title"/>
+          <p:cNvSpPr txBox="1"/>
+          <p:nvPr/>
+        </p:nvSpPr>
+        <p:spPr>
+          <a:xfrm>
+            <a:off x="548640" y="685800"/>
             <a:ext cx="11064240" cy="731520"/>
           </a:xfrm>
           <a:prstGeom prst="rect">
@@ -3504,255 +3561,41 @@
       </p:sp>
       <p:sp>
         <p:nvSpPr>
-          <p:cNvPr id="3" name="Shape 1"/>
+          <p:cNvPr id="5" name="Shape 3"/>
           <p:cNvSpPr/>
           <p:nvPr/>
         </p:nvSpPr>
         <p:spPr>
           <a:xfrm>
-            <a:off x="548640" y="1417320"/>
-            <a:ext cx="7086600" cy="2103120"/>
+            <a:off x="548640" y="1645920"/>
+            <a:ext cx="7086600" cy="2011680"/>
           </a:xfrm>
           <a:prstGeom prst="roundRect">
             <a:avLst>
-              <a:gd name="adj" fmla="val 6522"/>
+              <a:gd name="adj" fmla="val 9091"/>
             </a:avLst>
           </a:prstGeom>
           <a:solidFill>
-            <a:srgbClr val="EAF4F7"/>
+            <a:srgbClr val="FFFFFF"/>
           </a:solidFill>
           <a:ln w="12700">
             <a:solidFill>
-              <a:srgbClr val="EAF4F7"/>
+              <a:srgbClr val="FFFFFF"/>
             </a:solidFill>
             <a:prstDash val="solid"/>
           </a:ln>
-        </p:spPr>
-      </p:sp>
-      <p:sp>
-        <p:nvSpPr>
-          <p:cNvPr id="4" name="Shape 2"/>
-          <p:cNvSpPr/>
-          <p:nvPr/>
-        </p:nvSpPr>
-        <p:spPr>
-          <a:xfrm>
-            <a:off x="777240" y="1645920"/>
-            <a:ext cx="566928" cy="566928"/>
-          </a:xfrm>
-          <a:prstGeom prst="ellipse">
-            <a:avLst/>
-          </a:prstGeom>
-          <a:solidFill>
-            <a:srgbClr val="137C94"/>
-          </a:solidFill>
-          <a:ln w="12700">
-            <a:solidFill>
-              <a:srgbClr val="137C94"/>
-            </a:solidFill>
-            <a:prstDash val="solid"/>
-          </a:ln>
+          <a:effectLst>
+            <a:outerShdw sx="100000" sy="100000" kx="0" ky="0" algn="bl" rotWithShape="0" blurRad="203200" dist="76200" dir="5400000">
+              <a:srgbClr val="000000">
+                <a:alpha val="18000"/>
+              </a:srgbClr>
+            </a:outerShdw>
+          </a:effectLst>
         </p:spPr>
       </p:sp>
       <p:pic>
         <p:nvPicPr>
-          <p:cNvPr id="5" name="Image 0" descr="preencoded.png">    </p:cNvPr>
-          <p:cNvPicPr>
-            <a:picLocks noChangeAspect="1"/>
-          </p:cNvPicPr>
-          <p:nvPr/>
-        </p:nvPicPr>
-        <p:blipFill>
-          <a:blip r:embed="rId1"/>
-          <a:stretch>
-            <a:fillRect/>
-          </a:stretch>
-        </p:blipFill>
-        <p:spPr>
-          <a:xfrm>
-            <a:off x="914400" y="1783080"/>
-            <a:ext cx="292608" cy="292608"/>
-          </a:xfrm>
-          <a:prstGeom prst="rect">
-            <a:avLst/>
-          </a:prstGeom>
-        </p:spPr>
-      </p:pic>
-      <p:sp>
-        <p:nvSpPr>
-          <p:cNvPr id="6" name="header"/>
-          <p:cNvSpPr txBox="1"/>
-          <p:nvPr/>
-        </p:nvSpPr>
-        <p:spPr>
-          <a:xfrm>
-            <a:off x="1554480" y="1572768"/>
-            <a:ext cx="5852160" cy="731520"/>
-          </a:xfrm>
-          <a:prstGeom prst="rect">
-            <a:avLst/>
-          </a:prstGeom>
-          <a:noFill/>
-          <a:ln/>
-        </p:spPr>
-        <p:txBody>
-          <a:bodyPr wrap="square" lIns="0" tIns="0" rIns="0" bIns="0" rtlCol="0" anchor="ctr"/>
-          <a:lstStyle/>
-          <a:p>
-            <a:pPr indent="0" marL="0">
-              <a:buNone/>
-            </a:pPr>
-            <a:r>
-              <a:rPr lang="en-US" sz="2400" b="1" dirty="0">
-                <a:solidFill>
-                  <a:srgbClr val="0B2239"/>
-                </a:solidFill>
-                <a:latin typeface="Cambria" pitchFamily="34" charset="0"/>
-                <a:ea typeface="Cambria" pitchFamily="34" charset="-122"/>
-                <a:cs typeface="Cambria" pitchFamily="34" charset="-120"/>
-              </a:rPr>
-              <a:t>NGO: SPNI</a:t>
-            </a:r>
-            <a:endParaRPr lang="en-US" sz="2400" dirty="0"/>
-          </a:p>
-          <a:p>
-            <a:pPr indent="0" marL="0">
-              <a:buNone/>
-            </a:pPr>
-            <a:r>
-              <a:rPr lang="en-US" sz="1400" dirty="0">
-                <a:solidFill>
-                  <a:srgbClr val="4A5A68"/>
-                </a:solidFill>
-                <a:latin typeface="Calibri" pitchFamily="34" charset="0"/>
-                <a:ea typeface="Calibri" pitchFamily="34" charset="-122"/>
-                <a:cs typeface="Calibri" pitchFamily="34" charset="-120"/>
-              </a:rPr>
-              <a:t>Society for the Protection of Nature in Israel</a:t>
-            </a:r>
-            <a:endParaRPr lang="en-US" sz="2400" dirty="0"/>
-          </a:p>
-        </p:txBody>
-      </p:sp>
-      <p:sp>
-        <p:nvSpPr>
-          <p:cNvPr id="7" name="body"/>
-          <p:cNvSpPr txBox="1"/>
-          <p:nvPr/>
-        </p:nvSpPr>
-        <p:spPr>
-          <a:xfrm>
-            <a:off x="868680" y="2423160"/>
-            <a:ext cx="6583680" cy="960120"/>
-          </a:xfrm>
-          <a:prstGeom prst="rect">
-            <a:avLst/>
-          </a:prstGeom>
-          <a:noFill/>
-          <a:ln/>
-        </p:spPr>
-        <p:txBody>
-          <a:bodyPr wrap="square" lIns="0" tIns="0" rIns="0" bIns="0" rtlCol="0" anchor="t"/>
-          <a:lstStyle/>
-          <a:p>
-            <a:pPr marL="342900" indent="-342900">
-              <a:spcAft>
-                <a:spcPts val="600"/>
-              </a:spcAft>
-              <a:buSzPct val="100000"/>
-              <a:buChar char="•"/>
-            </a:pPr>
-            <a:r>
-              <a:rPr lang="en-US" sz="2000" dirty="0">
-                <a:solidFill>
-                  <a:srgbClr val="0B2239"/>
-                </a:solidFill>
-                <a:latin typeface="Calibri" pitchFamily="34" charset="0"/>
-                <a:ea typeface="Calibri" pitchFamily="34" charset="-122"/>
-                <a:cs typeface="Calibri" pitchFamily="34" charset="-120"/>
-              </a:rPr>
-              <a:t>Advocacy against the AI server-farm fast-track bill</a:t>
-            </a:r>
-            <a:endParaRPr lang="en-US" sz="2000" dirty="0"/>
-          </a:p>
-          <a:p>
-            <a:pPr marL="342900" indent="-342900">
-              <a:spcAft>
-                <a:spcPts val="600"/>
-              </a:spcAft>
-              <a:buSzPct val="100000"/>
-              <a:buChar char="•"/>
-            </a:pPr>
-            <a:r>
-              <a:rPr lang="en-US" sz="2000" dirty="0">
-                <a:solidFill>
-                  <a:srgbClr val="0B2239"/>
-                </a:solidFill>
-                <a:latin typeface="Calibri" pitchFamily="34" charset="0"/>
-                <a:ea typeface="Calibri" pitchFamily="34" charset="-122"/>
-                <a:cs typeface="Calibri" pitchFamily="34" charset="-120"/>
-              </a:rPr>
-              <a:t>The bill lets big farms skip local committees</a:t>
-            </a:r>
-            <a:endParaRPr lang="en-US" sz="2000" dirty="0"/>
-          </a:p>
-        </p:txBody>
-      </p:sp>
-      <p:sp>
-        <p:nvSpPr>
-          <p:cNvPr id="8" name="Shape 5"/>
-          <p:cNvSpPr/>
-          <p:nvPr/>
-        </p:nvSpPr>
-        <p:spPr>
-          <a:xfrm>
-            <a:off x="548640" y="3703320"/>
-            <a:ext cx="7086600" cy="2331720"/>
-          </a:xfrm>
-          <a:prstGeom prst="roundRect">
-            <a:avLst>
-              <a:gd name="adj" fmla="val 5882"/>
-            </a:avLst>
-          </a:prstGeom>
-          <a:solidFill>
-            <a:srgbClr val="FDF1DF"/>
-          </a:solidFill>
-          <a:ln w="12700">
-            <a:solidFill>
-              <a:srgbClr val="FDF1DF"/>
-            </a:solidFill>
-            <a:prstDash val="solid"/>
-          </a:ln>
-        </p:spPr>
-      </p:sp>
-      <p:sp>
-        <p:nvSpPr>
-          <p:cNvPr id="9" name="Shape 6"/>
-          <p:cNvSpPr/>
-          <p:nvPr/>
-        </p:nvSpPr>
-        <p:spPr>
-          <a:xfrm>
-            <a:off x="777240" y="3913632"/>
-            <a:ext cx="566928" cy="566928"/>
-          </a:xfrm>
-          <a:prstGeom prst="ellipse">
-            <a:avLst/>
-          </a:prstGeom>
-          <a:solidFill>
-            <a:srgbClr val="F2A33A"/>
-          </a:solidFill>
-          <a:ln w="12700">
-            <a:solidFill>
-              <a:srgbClr val="F2A33A"/>
-            </a:solidFill>
-            <a:prstDash val="solid"/>
-          </a:ln>
-        </p:spPr>
-      </p:sp>
-      <p:pic>
-        <p:nvPicPr>
-          <p:cNvPr id="10" name="Image 1" descr="preencoded.png">    </p:cNvPr>
+          <p:cNvPr id="6" name="Image 0" descr="preencoded.png">    </p:cNvPr>
           <p:cNvPicPr>
             <a:picLocks noChangeAspect="1"/>
           </p:cNvPicPr>
@@ -3766,8 +3609,8 @@
         </p:blipFill>
         <p:spPr>
           <a:xfrm>
-            <a:off x="914400" y="4050792"/>
-            <a:ext cx="292608" cy="292608"/>
+            <a:off x="777240" y="1810512"/>
+            <a:ext cx="713232" cy="713232"/>
           </a:xfrm>
           <a:prstGeom prst="rect">
             <a:avLst/>
@@ -3776,14 +3619,14 @@
       </p:pic>
       <p:sp>
         <p:nvSpPr>
-          <p:cNvPr id="11" name="header"/>
+          <p:cNvPr id="7" name="header"/>
           <p:cNvSpPr txBox="1"/>
           <p:nvPr/>
         </p:nvSpPr>
         <p:spPr>
           <a:xfrm>
-            <a:off x="1554480" y="3913632"/>
-            <a:ext cx="5852160" cy="566928"/>
+            <a:off x="1645920" y="1810512"/>
+            <a:ext cx="5760720" cy="713232"/>
           </a:xfrm>
           <a:prstGeom prst="rect">
             <a:avLst/>
@@ -3807,22 +3650,39 @@
                 <a:ea typeface="Cambria" pitchFamily="34" charset="-122"/>
                 <a:cs typeface="Cambria" pitchFamily="34" charset="-120"/>
               </a:rPr>
-              <a:t>Legislation &amp; regulation</a:t>
+              <a:t>NGO: SPNI</a:t>
             </a:r>
             <a:endParaRPr lang="en-US" sz="2400" dirty="0"/>
           </a:p>
-        </p:txBody>
-      </p:sp>
-      <p:sp>
-        <p:nvSpPr>
-          <p:cNvPr id="12" name="body"/>
+          <a:p>
+            <a:pPr indent="0" marL="0">
+              <a:buNone/>
+            </a:pPr>
+            <a:r>
+              <a:rPr lang="en-US" sz="1400" dirty="0">
+                <a:solidFill>
+                  <a:srgbClr val="4A5A68"/>
+                </a:solidFill>
+                <a:latin typeface="Calibri" pitchFamily="34" charset="0"/>
+                <a:ea typeface="Calibri" pitchFamily="34" charset="-122"/>
+                <a:cs typeface="Calibri" pitchFamily="34" charset="-120"/>
+              </a:rPr>
+              <a:t>Society for the Protection of Nature in Israel</a:t>
+            </a:r>
+            <a:endParaRPr lang="en-US" sz="2400" dirty="0"/>
+          </a:p>
+        </p:txBody>
+      </p:sp>
+      <p:sp>
+        <p:nvSpPr>
+          <p:cNvPr id="8" name="body"/>
           <p:cNvSpPr txBox="1"/>
           <p:nvPr/>
         </p:nvSpPr>
         <p:spPr>
           <a:xfrm>
-            <a:off x="868680" y="4617720"/>
-            <a:ext cx="6583680" cy="1325880"/>
+            <a:off x="868680" y="2651760"/>
+            <a:ext cx="6583680" cy="914400"/>
           </a:xfrm>
           <a:prstGeom prst="rect">
             <a:avLst/>
@@ -3850,7 +3710,7 @@
                 <a:ea typeface="Calibri" pitchFamily="34" charset="-122"/>
                 <a:cs typeface="Calibri" pitchFamily="34" charset="-120"/>
               </a:rPr>
-              <a:t>EU (2023): data centers must report water use</a:t>
+              <a:t>Advocacy against the AI server-farm fast-track bill</a:t>
             </a:r>
             <a:endParaRPr lang="en-US" sz="2000" dirty="0"/>
           </a:p>
@@ -3871,63 +3731,49 @@
                 <a:ea typeface="Calibri" pitchFamily="34" charset="-122"/>
                 <a:cs typeface="Calibri" pitchFamily="34" charset="-120"/>
               </a:rPr>
-              <a:t>Israel’s Water Law (1959): water is public</a:t>
+              <a:t>The bill lets big farms skip local committees</a:t>
             </a:r>
             <a:endParaRPr lang="en-US" sz="2000" dirty="0"/>
           </a:p>
-          <a:p>
-            <a:pPr marL="342900" indent="-342900">
-              <a:spcAft>
-                <a:spcPts val="600"/>
-              </a:spcAft>
-              <a:buSzPct val="100000"/>
-              <a:buChar char="•"/>
-            </a:pPr>
-            <a:r>
-              <a:rPr lang="en-US" sz="2000" dirty="0">
-                <a:solidFill>
-                  <a:srgbClr val="0B2239"/>
-                </a:solidFill>
-                <a:latin typeface="Calibri" pitchFamily="34" charset="0"/>
-                <a:ea typeface="Calibri" pitchFamily="34" charset="-122"/>
-                <a:cs typeface="Calibri" pitchFamily="34" charset="-120"/>
-              </a:rPr>
-              <a:t>Israel: no disclosure rule found</a:t>
-            </a:r>
-            <a:endParaRPr lang="en-US" sz="2000" dirty="0"/>
-          </a:p>
-        </p:txBody>
-      </p:sp>
-      <p:sp>
-        <p:nvSpPr>
-          <p:cNvPr id="13" name="photo-frame"/>
+        </p:txBody>
+      </p:sp>
+      <p:sp>
+        <p:nvSpPr>
+          <p:cNvPr id="9" name="Shape 6"/>
           <p:cNvSpPr/>
           <p:nvPr/>
         </p:nvSpPr>
         <p:spPr>
           <a:xfrm>
-            <a:off x="8001000" y="1417320"/>
-            <a:ext cx="3639312" cy="4617720"/>
+            <a:off x="548640" y="3840480"/>
+            <a:ext cx="7086600" cy="2240280"/>
           </a:xfrm>
           <a:prstGeom prst="roundRect">
             <a:avLst>
-              <a:gd name="adj" fmla="val 4523"/>
+              <a:gd name="adj" fmla="val 8163"/>
             </a:avLst>
           </a:prstGeom>
           <a:solidFill>
-            <a:srgbClr val="EAF4F7"/>
+            <a:srgbClr val="FFFFFF"/>
           </a:solidFill>
-          <a:ln w="25400">
+          <a:ln w="12700">
             <a:solidFill>
-              <a:srgbClr val="137C94"/>
+              <a:srgbClr val="FFFFFF"/>
             </a:solidFill>
-            <a:prstDash val="dash"/>
+            <a:prstDash val="solid"/>
           </a:ln>
+          <a:effectLst>
+            <a:outerShdw sx="100000" sy="100000" kx="0" ky="0" algn="bl" rotWithShape="0" blurRad="203200" dist="76200" dir="5400000">
+              <a:srgbClr val="000000">
+                <a:alpha val="18000"/>
+              </a:srgbClr>
+            </a:outerShdw>
+          </a:effectLst>
         </p:spPr>
       </p:sp>
       <p:pic>
         <p:nvPicPr>
-          <p:cNvPr id="14" name="Image 2" descr="preencoded.png">    </p:cNvPr>
+          <p:cNvPr id="10" name="Image 1" descr="preencoded.png">    </p:cNvPr>
           <p:cNvPicPr>
             <a:picLocks noChangeAspect="1"/>
           </p:cNvPicPr>
@@ -3941,8 +3787,8 @@
         </p:blipFill>
         <p:spPr>
           <a:xfrm>
-            <a:off x="9500616" y="2766060"/>
-            <a:ext cx="640080" cy="640080"/>
+            <a:off x="777240" y="3986784"/>
+            <a:ext cx="713232" cy="713232"/>
           </a:xfrm>
           <a:prstGeom prst="rect">
             <a:avLst/>
@@ -3951,14 +3797,14 @@
       </p:pic>
       <p:sp>
         <p:nvSpPr>
-          <p:cNvPr id="15" name="caption-photo"/>
+          <p:cNvPr id="11" name="header"/>
           <p:cNvSpPr txBox="1"/>
           <p:nvPr/>
         </p:nvSpPr>
         <p:spPr>
           <a:xfrm>
-            <a:off x="8183880" y="3543300"/>
-            <a:ext cx="3273552" cy="1005840"/>
+            <a:off x="1645920" y="4023360"/>
+            <a:ext cx="5760720" cy="603504"/>
           </a:xfrm>
           <a:prstGeom prst="rect">
             <a:avLst/>
@@ -3967,14 +3813,223 @@
           <a:ln/>
         </p:spPr>
         <p:txBody>
+          <a:bodyPr wrap="square" lIns="0" tIns="0" rIns="0" bIns="0" rtlCol="0" anchor="ctr"/>
+          <a:lstStyle/>
+          <a:p>
+            <a:pPr indent="0" marL="0">
+              <a:buNone/>
+            </a:pPr>
+            <a:r>
+              <a:rPr lang="en-US" sz="2400" b="1" dirty="0">
+                <a:solidFill>
+                  <a:srgbClr val="0B2239"/>
+                </a:solidFill>
+                <a:latin typeface="Cambria" pitchFamily="34" charset="0"/>
+                <a:ea typeface="Cambria" pitchFamily="34" charset="-122"/>
+                <a:cs typeface="Cambria" pitchFamily="34" charset="-120"/>
+              </a:rPr>
+              <a:t>Legislation &amp; regulation</a:t>
+            </a:r>
+            <a:endParaRPr lang="en-US" sz="2400" dirty="0"/>
+          </a:p>
+        </p:txBody>
+      </p:sp>
+      <p:sp>
+        <p:nvSpPr>
+          <p:cNvPr id="12" name="body"/>
+          <p:cNvSpPr txBox="1"/>
+          <p:nvPr/>
+        </p:nvSpPr>
+        <p:spPr>
+          <a:xfrm>
+            <a:off x="868680" y="4754880"/>
+            <a:ext cx="6583680" cy="1234440"/>
+          </a:xfrm>
+          <a:prstGeom prst="rect">
+            <a:avLst/>
+          </a:prstGeom>
+          <a:noFill/>
+          <a:ln/>
+        </p:spPr>
+        <p:txBody>
           <a:bodyPr wrap="square" lIns="0" tIns="0" rIns="0" bIns="0" rtlCol="0" anchor="t"/>
           <a:lstStyle/>
           <a:p>
+            <a:pPr marL="342900" indent="-342900">
+              <a:spcAft>
+                <a:spcPts val="500"/>
+              </a:spcAft>
+              <a:buSzPct val="100000"/>
+              <a:buChar char="•"/>
+            </a:pPr>
+            <a:r>
+              <a:rPr lang="en-US" sz="2000" dirty="0">
+                <a:solidFill>
+                  <a:srgbClr val="0B2239"/>
+                </a:solidFill>
+                <a:latin typeface="Calibri" pitchFamily="34" charset="0"/>
+                <a:ea typeface="Calibri" pitchFamily="34" charset="-122"/>
+                <a:cs typeface="Calibri" pitchFamily="34" charset="-120"/>
+              </a:rPr>
+              <a:t>EU (2023): data centers must report water use</a:t>
+            </a:r>
+            <a:endParaRPr lang="en-US" sz="2000" dirty="0"/>
+          </a:p>
+          <a:p>
+            <a:pPr marL="342900" indent="-342900">
+              <a:spcAft>
+                <a:spcPts val="500"/>
+              </a:spcAft>
+              <a:buSzPct val="100000"/>
+              <a:buChar char="•"/>
+            </a:pPr>
+            <a:r>
+              <a:rPr lang="en-US" sz="2000" dirty="0">
+                <a:solidFill>
+                  <a:srgbClr val="0B2239"/>
+                </a:solidFill>
+                <a:latin typeface="Calibri" pitchFamily="34" charset="0"/>
+                <a:ea typeface="Calibri" pitchFamily="34" charset="-122"/>
+                <a:cs typeface="Calibri" pitchFamily="34" charset="-120"/>
+              </a:rPr>
+              <a:t>Israel’s Water Law (1959): water is public</a:t>
+            </a:r>
+            <a:endParaRPr lang="en-US" sz="2000" dirty="0"/>
+          </a:p>
+          <a:p>
+            <a:pPr marL="342900" indent="-342900">
+              <a:spcAft>
+                <a:spcPts val="500"/>
+              </a:spcAft>
+              <a:buSzPct val="100000"/>
+              <a:buChar char="•"/>
+            </a:pPr>
+            <a:r>
+              <a:rPr lang="en-US" sz="2000" dirty="0">
+                <a:solidFill>
+                  <a:srgbClr val="0B2239"/>
+                </a:solidFill>
+                <a:latin typeface="Calibri" pitchFamily="34" charset="0"/>
+                <a:ea typeface="Calibri" pitchFamily="34" charset="-122"/>
+                <a:cs typeface="Calibri" pitchFamily="34" charset="-120"/>
+              </a:rPr>
+              <a:t>Israel: no disclosure rule found</a:t>
+            </a:r>
+            <a:endParaRPr lang="en-US" sz="2000" dirty="0"/>
+          </a:p>
+        </p:txBody>
+      </p:sp>
+      <p:sp>
+        <p:nvSpPr>
+          <p:cNvPr id="13" name="Shape 9"/>
+          <p:cNvSpPr/>
+          <p:nvPr/>
+        </p:nvSpPr>
+        <p:spPr>
+          <a:xfrm>
+            <a:off x="8001000" y="1645920"/>
+            <a:ext cx="3639312" cy="4434840"/>
+          </a:xfrm>
+          <a:prstGeom prst="roundRect">
+            <a:avLst>
+              <a:gd name="adj" fmla="val 5025"/>
+            </a:avLst>
+          </a:prstGeom>
+          <a:solidFill>
+            <a:srgbClr val="FFFFFF"/>
+          </a:solidFill>
+          <a:ln w="12700">
+            <a:solidFill>
+              <a:srgbClr val="FFFFFF"/>
+            </a:solidFill>
+            <a:prstDash val="solid"/>
+          </a:ln>
+          <a:effectLst>
+            <a:outerShdw sx="100000" sy="100000" kx="0" ky="0" algn="bl" rotWithShape="0" blurRad="203200" dist="76200" dir="5400000">
+              <a:srgbClr val="000000">
+                <a:alpha val="18000"/>
+              </a:srgbClr>
+            </a:outerShdw>
+          </a:effectLst>
+        </p:spPr>
+      </p:sp>
+      <p:sp>
+        <p:nvSpPr>
+          <p:cNvPr id="14" name="photo-frame"/>
+          <p:cNvSpPr/>
+          <p:nvPr/>
+        </p:nvSpPr>
+        <p:spPr>
+          <a:xfrm>
+            <a:off x="8165592" y="1810512"/>
+            <a:ext cx="3310128" cy="4105656"/>
+          </a:xfrm>
+          <a:prstGeom prst="roundRect">
+            <a:avLst>
+              <a:gd name="adj" fmla="val 3867"/>
+            </a:avLst>
+          </a:prstGeom>
+          <a:solidFill>
+            <a:srgbClr val="EAF4F7"/>
+          </a:solidFill>
+          <a:ln w="19050">
+            <a:solidFill>
+              <a:srgbClr val="137C94"/>
+            </a:solidFill>
+            <a:prstDash val="dash"/>
+          </a:ln>
+        </p:spPr>
+      </p:sp>
+      <p:pic>
+        <p:nvPicPr>
+          <p:cNvPr id="15" name="Image 2" descr="preencoded.png">    </p:cNvPr>
+          <p:cNvPicPr>
+            <a:picLocks noChangeAspect="1"/>
+          </p:cNvPicPr>
+          <p:nvPr/>
+        </p:nvPicPr>
+        <p:blipFill>
+          <a:blip r:embed="rId4"/>
+          <a:stretch>
+            <a:fillRect/>
+          </a:stretch>
+        </p:blipFill>
+        <p:spPr>
+          <a:xfrm>
+            <a:off x="9409176" y="2766060"/>
+            <a:ext cx="822960" cy="822960"/>
+          </a:xfrm>
+          <a:prstGeom prst="rect">
+            <a:avLst/>
+          </a:prstGeom>
+        </p:spPr>
+      </p:pic>
+      <p:sp>
+        <p:nvSpPr>
+          <p:cNvPr id="16" name="caption-photo"/>
+          <p:cNvSpPr txBox="1"/>
+          <p:nvPr/>
+        </p:nvSpPr>
+        <p:spPr>
+          <a:xfrm>
+            <a:off x="8275320" y="3753612"/>
+            <a:ext cx="3090672" cy="1005840"/>
+          </a:xfrm>
+          <a:prstGeom prst="rect">
+            <a:avLst/>
+          </a:prstGeom>
+          <a:noFill/>
+          <a:ln/>
+        </p:spPr>
+        <p:txBody>
+          <a:bodyPr wrap="square" lIns="0" tIns="0" rIns="0" bIns="0" rtlCol="0" anchor="t"/>
+          <a:lstStyle/>
+          <a:p>
             <a:pPr algn="ctr" indent="0" marL="0">
               <a:buNone/>
             </a:pPr>
             <a:r>
-              <a:rPr lang="en-US" sz="1600" b="1" dirty="0">
+              <a:rPr lang="en-US" sz="1600" b="1" spc="200" kern="0" dirty="0">
                 <a:solidFill>
                   <a:srgbClr val="4A5A68"/>
                 </a:solidFill>
@@ -4024,14 +4079,14 @@
       </p:sp>
       <p:sp>
         <p:nvSpPr>
-          <p:cNvPr id="16" name="caption-sources"/>
+          <p:cNvPr id="17" name="caption-sources"/>
           <p:cNvSpPr txBox="1"/>
           <p:nvPr/>
         </p:nvSpPr>
         <p:spPr>
           <a:xfrm>
             <a:off x="548640" y="6291072"/>
-            <a:ext cx="11064240" cy="365760"/>
+            <a:ext cx="10058400" cy="365760"/>
           </a:xfrm>
           <a:prstGeom prst="rect">
             <a:avLst/>
@@ -4074,9 +4129,16 @@
   <p:cSld name="Slide 4">
     <p:bg>
       <p:bgPr>
-        <a:solidFill>
-          <a:srgbClr val="FFFFFF"/>
-        </a:solidFill>
+        <a:blipFill dpi="0" rotWithShape="1">
+          <a:blip r:embed="rId1">
+            <a:lum/>
+          </a:blip>
+          <a:srcRect/>
+          <a:stretch>
+            <a:fillRect/>
+          </a:stretch>
+        </a:blipFill>
+        <a:effectLst/>
       </p:bgPr>
     </p:bg>
     <p:spTree>
@@ -4095,13 +4157,91 @@
       </p:grpSpPr>
       <p:sp>
         <p:nvSpPr>
-          <p:cNvPr id="2" name="title"/>
+          <p:cNvPr id="2" name="caption-tag"/>
           <p:cNvSpPr txBox="1"/>
           <p:nvPr/>
         </p:nvSpPr>
         <p:spPr>
           <a:xfrm>
-            <a:off x="548640" y="411480"/>
+            <a:off x="548640" y="347472"/>
+            <a:ext cx="7315200" cy="320040"/>
+          </a:xfrm>
+          <a:prstGeom prst="rect">
+            <a:avLst/>
+          </a:prstGeom>
+          <a:noFill/>
+          <a:ln/>
+        </p:spPr>
+        <p:txBody>
+          <a:bodyPr wrap="square" lIns="0" tIns="0" rIns="0" bIns="0" rtlCol="0" anchor="ctr"/>
+          <a:lstStyle/>
+          <a:p>
+            <a:pPr indent="0" marL="0">
+              <a:buNone/>
+            </a:pPr>
+            <a:r>
+              <a:rPr lang="en-US" sz="1400" b="1" spc="300" kern="0" dirty="0">
+                <a:solidFill>
+                  <a:srgbClr val="137C94"/>
+                </a:solidFill>
+                <a:latin typeface="Calibri" pitchFamily="34" charset="0"/>
+                <a:ea typeface="Calibri" pitchFamily="34" charset="-122"/>
+                <a:cs typeface="Calibri" pitchFamily="34" charset="-120"/>
+              </a:rPr>
+              <a:t>04  ·  OUR PROPOSAL</a:t>
+            </a:r>
+            <a:endParaRPr lang="en-US" sz="1400" dirty="0"/>
+          </a:p>
+        </p:txBody>
+      </p:sp>
+      <p:sp>
+        <p:nvSpPr>
+          <p:cNvPr id="3" name="caption-page"/>
+          <p:cNvSpPr txBox="1"/>
+          <p:nvPr/>
+        </p:nvSpPr>
+        <p:spPr>
+          <a:xfrm>
+            <a:off x="10725912" y="6291072"/>
+            <a:ext cx="914400" cy="365760"/>
+          </a:xfrm>
+          <a:prstGeom prst="rect">
+            <a:avLst/>
+          </a:prstGeom>
+          <a:noFill/>
+          <a:ln/>
+        </p:spPr>
+        <p:txBody>
+          <a:bodyPr wrap="square" lIns="0" tIns="0" rIns="0" bIns="0" rtlCol="0" anchor="ctr"/>
+          <a:lstStyle/>
+          <a:p>
+            <a:pPr algn="r" indent="0" marL="0">
+              <a:buNone/>
+            </a:pPr>
+            <a:r>
+              <a:rPr lang="en-US" sz="1100" dirty="0">
+                <a:solidFill>
+                  <a:srgbClr val="4A5A68"/>
+                </a:solidFill>
+                <a:latin typeface="Calibri" pitchFamily="34" charset="0"/>
+                <a:ea typeface="Calibri" pitchFamily="34" charset="-122"/>
+                <a:cs typeface="Calibri" pitchFamily="34" charset="-120"/>
+              </a:rPr>
+              <a:t>4 / 5</a:t>
+            </a:r>
+            <a:endParaRPr lang="en-US" sz="1100" dirty="0"/>
+          </a:p>
+        </p:txBody>
+      </p:sp>
+      <p:sp>
+        <p:nvSpPr>
+          <p:cNvPr id="4" name="title"/>
+          <p:cNvSpPr txBox="1"/>
+          <p:nvPr/>
+        </p:nvSpPr>
+        <p:spPr>
+          <a:xfrm>
+            <a:off x="548640" y="685800"/>
             <a:ext cx="11064240" cy="731520"/>
           </a:xfrm>
           <a:prstGeom prst="rect">
@@ -4134,40 +4274,47 @@
       </p:sp>
       <p:sp>
         <p:nvSpPr>
-          <p:cNvPr id="3" name="Shape 1"/>
+          <p:cNvPr id="5" name="Shape 3"/>
           <p:cNvSpPr/>
           <p:nvPr/>
         </p:nvSpPr>
         <p:spPr>
           <a:xfrm>
-            <a:off x="548640" y="1417320"/>
-            <a:ext cx="7086600" cy="3063240"/>
+            <a:off x="548640" y="1645920"/>
+            <a:ext cx="7086600" cy="2926080"/>
           </a:xfrm>
           <a:prstGeom prst="roundRect">
             <a:avLst>
-              <a:gd name="adj" fmla="val 4478"/>
+              <a:gd name="adj" fmla="val 6250"/>
             </a:avLst>
           </a:prstGeom>
           <a:solidFill>
-            <a:srgbClr val="EAF4F7"/>
+            <a:srgbClr val="FFFFFF"/>
           </a:solidFill>
           <a:ln w="12700">
             <a:solidFill>
-              <a:srgbClr val="EAF4F7"/>
+              <a:srgbClr val="FFFFFF"/>
             </a:solidFill>
             <a:prstDash val="solid"/>
           </a:ln>
-        </p:spPr>
-      </p:sp>
-      <p:sp>
-        <p:nvSpPr>
-          <p:cNvPr id="4" name="header"/>
+          <a:effectLst>
+            <a:outerShdw sx="100000" sy="100000" kx="0" ky="0" algn="bl" rotWithShape="0" blurRad="203200" dist="76200" dir="5400000">
+              <a:srgbClr val="000000">
+                <a:alpha val="18000"/>
+              </a:srgbClr>
+            </a:outerShdw>
+          </a:effectLst>
+        </p:spPr>
+      </p:sp>
+      <p:sp>
+        <p:nvSpPr>
+          <p:cNvPr id="6" name="header"/>
           <p:cNvSpPr txBox="1"/>
           <p:nvPr/>
         </p:nvSpPr>
         <p:spPr>
           <a:xfrm>
-            <a:off x="822960" y="1554480"/>
+            <a:off x="822960" y="1783080"/>
             <a:ext cx="6583680" cy="548640"/>
           </a:xfrm>
           <a:prstGeom prst="rect">
@@ -4198,516 +4345,9 @@
           </a:p>
         </p:txBody>
       </p:sp>
-      <p:sp>
-        <p:nvSpPr>
-          <p:cNvPr id="5" name="Shape 3"/>
-          <p:cNvSpPr/>
-          <p:nvPr/>
-        </p:nvSpPr>
-        <p:spPr>
-          <a:xfrm>
-            <a:off x="822960" y="2240280"/>
-            <a:ext cx="457200" cy="457200"/>
-          </a:xfrm>
-          <a:prstGeom prst="ellipse">
-            <a:avLst/>
-          </a:prstGeom>
-          <a:solidFill>
-            <a:srgbClr val="137C94"/>
-          </a:solidFill>
-          <a:ln w="12700">
-            <a:solidFill>
-              <a:srgbClr val="137C94"/>
-            </a:solidFill>
-            <a:prstDash val="solid"/>
-          </a:ln>
-        </p:spPr>
-      </p:sp>
-      <p:sp>
-        <p:nvSpPr>
-          <p:cNvPr id="6" name="number"/>
-          <p:cNvSpPr txBox="1"/>
-          <p:nvPr/>
-        </p:nvSpPr>
-        <p:spPr>
-          <a:xfrm>
-            <a:off x="822960" y="2240280"/>
-            <a:ext cx="457200" cy="457200"/>
-          </a:xfrm>
-          <a:prstGeom prst="rect">
-            <a:avLst/>
-          </a:prstGeom>
-          <a:noFill/>
-          <a:ln/>
-        </p:spPr>
-        <p:txBody>
-          <a:bodyPr wrap="square" lIns="0" tIns="0" rIns="0" bIns="0" rtlCol="0" anchor="ctr"/>
-          <a:lstStyle/>
-          <a:p>
-            <a:pPr algn="ctr" indent="0" marL="0">
-              <a:buNone/>
-            </a:pPr>
-            <a:r>
-              <a:rPr lang="en-US" sz="2000" b="1" dirty="0">
-                <a:solidFill>
-                  <a:srgbClr val="FFFFFF"/>
-                </a:solidFill>
-                <a:latin typeface="Calibri" pitchFamily="34" charset="0"/>
-                <a:ea typeface="Calibri" pitchFamily="34" charset="-122"/>
-                <a:cs typeface="Calibri" pitchFamily="34" charset="-120"/>
-              </a:rPr>
-              <a:t>1</a:t>
-            </a:r>
-            <a:endParaRPr lang="en-US" sz="2000" dirty="0"/>
-          </a:p>
-        </p:txBody>
-      </p:sp>
-      <p:sp>
-        <p:nvSpPr>
-          <p:cNvPr id="7" name="body"/>
-          <p:cNvSpPr txBox="1"/>
-          <p:nvPr/>
-        </p:nvSpPr>
-        <p:spPr>
-          <a:xfrm>
-            <a:off x="1463040" y="2194560"/>
-            <a:ext cx="5989320" cy="548640"/>
-          </a:xfrm>
-          <a:prstGeom prst="rect">
-            <a:avLst/>
-          </a:prstGeom>
-          <a:noFill/>
-          <a:ln/>
-        </p:spPr>
-        <p:txBody>
-          <a:bodyPr wrap="square" lIns="0" tIns="0" rIns="0" bIns="0" rtlCol="0" anchor="ctr"/>
-          <a:lstStyle/>
-          <a:p>
-            <a:pPr indent="0" marL="0">
-              <a:buNone/>
-            </a:pPr>
-            <a:r>
-              <a:rPr lang="en-US" sz="2100" dirty="0">
-                <a:solidFill>
-                  <a:srgbClr val="0B2239"/>
-                </a:solidFill>
-                <a:latin typeface="Calibri" pitchFamily="34" charset="0"/>
-                <a:ea typeface="Calibri" pitchFamily="34" charset="-122"/>
-                <a:cs typeface="Calibri" pitchFamily="34" charset="-120"/>
-              </a:rPr>
-              <a:t>Data centers publish yearly water and power use</a:t>
-            </a:r>
-            <a:endParaRPr lang="en-US" sz="2100" dirty="0"/>
-          </a:p>
-        </p:txBody>
-      </p:sp>
-      <p:sp>
-        <p:nvSpPr>
-          <p:cNvPr id="8" name="Shape 6"/>
-          <p:cNvSpPr/>
-          <p:nvPr/>
-        </p:nvSpPr>
-        <p:spPr>
-          <a:xfrm>
-            <a:off x="822960" y="2834640"/>
-            <a:ext cx="457200" cy="457200"/>
-          </a:xfrm>
-          <a:prstGeom prst="ellipse">
-            <a:avLst/>
-          </a:prstGeom>
-          <a:solidFill>
-            <a:srgbClr val="137C94"/>
-          </a:solidFill>
-          <a:ln w="12700">
-            <a:solidFill>
-              <a:srgbClr val="137C94"/>
-            </a:solidFill>
-            <a:prstDash val="solid"/>
-          </a:ln>
-        </p:spPr>
-      </p:sp>
-      <p:sp>
-        <p:nvSpPr>
-          <p:cNvPr id="9" name="number"/>
-          <p:cNvSpPr txBox="1"/>
-          <p:nvPr/>
-        </p:nvSpPr>
-        <p:spPr>
-          <a:xfrm>
-            <a:off x="822960" y="2834640"/>
-            <a:ext cx="457200" cy="457200"/>
-          </a:xfrm>
-          <a:prstGeom prst="rect">
-            <a:avLst/>
-          </a:prstGeom>
-          <a:noFill/>
-          <a:ln/>
-        </p:spPr>
-        <p:txBody>
-          <a:bodyPr wrap="square" lIns="0" tIns="0" rIns="0" bIns="0" rtlCol="0" anchor="ctr"/>
-          <a:lstStyle/>
-          <a:p>
-            <a:pPr algn="ctr" indent="0" marL="0">
-              <a:buNone/>
-            </a:pPr>
-            <a:r>
-              <a:rPr lang="en-US" sz="2000" b="1" dirty="0">
-                <a:solidFill>
-                  <a:srgbClr val="FFFFFF"/>
-                </a:solidFill>
-                <a:latin typeface="Calibri" pitchFamily="34" charset="0"/>
-                <a:ea typeface="Calibri" pitchFamily="34" charset="-122"/>
-                <a:cs typeface="Calibri" pitchFamily="34" charset="-120"/>
-              </a:rPr>
-              <a:t>2</a:t>
-            </a:r>
-            <a:endParaRPr lang="en-US" sz="2000" dirty="0"/>
-          </a:p>
-        </p:txBody>
-      </p:sp>
-      <p:sp>
-        <p:nvSpPr>
-          <p:cNvPr id="10" name="body"/>
-          <p:cNvSpPr txBox="1"/>
-          <p:nvPr/>
-        </p:nvSpPr>
-        <p:spPr>
-          <a:xfrm>
-            <a:off x="1463040" y="2788920"/>
-            <a:ext cx="5989320" cy="548640"/>
-          </a:xfrm>
-          <a:prstGeom prst="rect">
-            <a:avLst/>
-          </a:prstGeom>
-          <a:noFill/>
-          <a:ln/>
-        </p:spPr>
-        <p:txBody>
-          <a:bodyPr wrap="square" lIns="0" tIns="0" rIns="0" bIns="0" rtlCol="0" anchor="ctr"/>
-          <a:lstStyle/>
-          <a:p>
-            <a:pPr indent="0" marL="0">
-              <a:buNone/>
-            </a:pPr>
-            <a:r>
-              <a:rPr lang="en-US" sz="2100" dirty="0">
-                <a:solidFill>
-                  <a:srgbClr val="0B2239"/>
-                </a:solidFill>
-                <a:latin typeface="Calibri" pitchFamily="34" charset="0"/>
-                <a:ea typeface="Calibri" pitchFamily="34" charset="-122"/>
-                <a:cs typeface="Calibri" pitchFamily="34" charset="-120"/>
-              </a:rPr>
-              <a:t>Local hearings stay, even on the fast track</a:t>
-            </a:r>
-            <a:endParaRPr lang="en-US" sz="2100" dirty="0"/>
-          </a:p>
-        </p:txBody>
-      </p:sp>
-      <p:sp>
-        <p:nvSpPr>
-          <p:cNvPr id="11" name="Shape 9"/>
-          <p:cNvSpPr/>
-          <p:nvPr/>
-        </p:nvSpPr>
-        <p:spPr>
-          <a:xfrm>
-            <a:off x="822960" y="3429000"/>
-            <a:ext cx="457200" cy="457200"/>
-          </a:xfrm>
-          <a:prstGeom prst="ellipse">
-            <a:avLst/>
-          </a:prstGeom>
-          <a:solidFill>
-            <a:srgbClr val="137C94"/>
-          </a:solidFill>
-          <a:ln w="12700">
-            <a:solidFill>
-              <a:srgbClr val="137C94"/>
-            </a:solidFill>
-            <a:prstDash val="solid"/>
-          </a:ln>
-        </p:spPr>
-      </p:sp>
-      <p:sp>
-        <p:nvSpPr>
-          <p:cNvPr id="12" name="number"/>
-          <p:cNvSpPr txBox="1"/>
-          <p:nvPr/>
-        </p:nvSpPr>
-        <p:spPr>
-          <a:xfrm>
-            <a:off x="822960" y="3429000"/>
-            <a:ext cx="457200" cy="457200"/>
-          </a:xfrm>
-          <a:prstGeom prst="rect">
-            <a:avLst/>
-          </a:prstGeom>
-          <a:noFill/>
-          <a:ln/>
-        </p:spPr>
-        <p:txBody>
-          <a:bodyPr wrap="square" lIns="0" tIns="0" rIns="0" bIns="0" rtlCol="0" anchor="ctr"/>
-          <a:lstStyle/>
-          <a:p>
-            <a:pPr algn="ctr" indent="0" marL="0">
-              <a:buNone/>
-            </a:pPr>
-            <a:r>
-              <a:rPr lang="en-US" sz="2000" b="1" dirty="0">
-                <a:solidFill>
-                  <a:srgbClr val="FFFFFF"/>
-                </a:solidFill>
-                <a:latin typeface="Calibri" pitchFamily="34" charset="0"/>
-                <a:ea typeface="Calibri" pitchFamily="34" charset="-122"/>
-                <a:cs typeface="Calibri" pitchFamily="34" charset="-120"/>
-              </a:rPr>
-              <a:t>3</a:t>
-            </a:r>
-            <a:endParaRPr lang="en-US" sz="2000" dirty="0"/>
-          </a:p>
-        </p:txBody>
-      </p:sp>
-      <p:sp>
-        <p:nvSpPr>
-          <p:cNvPr id="13" name="body"/>
-          <p:cNvSpPr txBox="1"/>
-          <p:nvPr/>
-        </p:nvSpPr>
-        <p:spPr>
-          <a:xfrm>
-            <a:off x="1463040" y="3383280"/>
-            <a:ext cx="5989320" cy="548640"/>
-          </a:xfrm>
-          <a:prstGeom prst="rect">
-            <a:avLst/>
-          </a:prstGeom>
-          <a:noFill/>
-          <a:ln/>
-        </p:spPr>
-        <p:txBody>
-          <a:bodyPr wrap="square" lIns="0" tIns="0" rIns="0" bIns="0" rtlCol="0" anchor="ctr"/>
-          <a:lstStyle/>
-          <a:p>
-            <a:pPr indent="0" marL="0">
-              <a:buNone/>
-            </a:pPr>
-            <a:r>
-              <a:rPr lang="en-US" sz="2100" dirty="0">
-                <a:solidFill>
-                  <a:srgbClr val="0B2239"/>
-                </a:solidFill>
-                <a:latin typeface="Calibri" pitchFamily="34" charset="0"/>
-                <a:ea typeface="Calibri" pitchFamily="34" charset="-122"/>
-                <a:cs typeface="Calibri" pitchFamily="34" charset="-120"/>
-              </a:rPr>
-              <a:t>In shortages: homes and farms before servers</a:t>
-            </a:r>
-            <a:endParaRPr lang="en-US" sz="2100" dirty="0"/>
-          </a:p>
-        </p:txBody>
-      </p:sp>
-      <p:sp>
-        <p:nvSpPr>
-          <p:cNvPr id="14" name="body"/>
-          <p:cNvSpPr txBox="1"/>
-          <p:nvPr/>
-        </p:nvSpPr>
-        <p:spPr>
-          <a:xfrm>
-            <a:off x="822960" y="4023360"/>
-            <a:ext cx="6583680" cy="365760"/>
-          </a:xfrm>
-          <a:prstGeom prst="rect">
-            <a:avLst/>
-          </a:prstGeom>
-          <a:noFill/>
-          <a:ln/>
-        </p:spPr>
-        <p:txBody>
-          <a:bodyPr wrap="square" lIns="0" tIns="0" rIns="0" bIns="0" rtlCol="0" anchor="ctr"/>
-          <a:lstStyle/>
-          <a:p>
-            <a:pPr indent="0" marL="0">
-              <a:buNone/>
-            </a:pPr>
-            <a:r>
-              <a:rPr lang="en-US" sz="2000" b="1" i="1" dirty="0">
-                <a:solidFill>
-                  <a:srgbClr val="137C94"/>
-                </a:solidFill>
-                <a:latin typeface="Calibri" pitchFamily="34" charset="0"/>
-                <a:ea typeface="Calibri" pitchFamily="34" charset="-122"/>
-                <a:cs typeface="Calibri" pitchFamily="34" charset="-120"/>
-              </a:rPr>
-              <a:t>Aim: fair siting, no discrimination</a:t>
-            </a:r>
-            <a:endParaRPr lang="en-US" sz="2000" dirty="0"/>
-          </a:p>
-        </p:txBody>
-      </p:sp>
-      <p:sp>
-        <p:nvSpPr>
-          <p:cNvPr id="15" name="Shape 13"/>
-          <p:cNvSpPr/>
-          <p:nvPr/>
-        </p:nvSpPr>
-        <p:spPr>
-          <a:xfrm>
-            <a:off x="548640" y="4663440"/>
-            <a:ext cx="7086600" cy="1371600"/>
-          </a:xfrm>
-          <a:prstGeom prst="roundRect">
-            <a:avLst>
-              <a:gd name="adj" fmla="val 10000"/>
-            </a:avLst>
-          </a:prstGeom>
-          <a:solidFill>
-            <a:srgbClr val="FDF1DF"/>
-          </a:solidFill>
-          <a:ln w="12700">
-            <a:solidFill>
-              <a:srgbClr val="FDF1DF"/>
-            </a:solidFill>
-            <a:prstDash val="solid"/>
-          </a:ln>
-        </p:spPr>
-      </p:sp>
-      <p:sp>
-        <p:nvSpPr>
-          <p:cNvPr id="16" name="Shape 14"/>
-          <p:cNvSpPr/>
-          <p:nvPr/>
-        </p:nvSpPr>
-        <p:spPr>
-          <a:xfrm>
-            <a:off x="777240" y="5065776"/>
-            <a:ext cx="566928" cy="566928"/>
-          </a:xfrm>
-          <a:prstGeom prst="ellipse">
-            <a:avLst/>
-          </a:prstGeom>
-          <a:solidFill>
-            <a:srgbClr val="F2A33A"/>
-          </a:solidFill>
-          <a:ln w="12700">
-            <a:solidFill>
-              <a:srgbClr val="F2A33A"/>
-            </a:solidFill>
-            <a:prstDash val="solid"/>
-          </a:ln>
-        </p:spPr>
-      </p:sp>
       <p:pic>
         <p:nvPicPr>
-          <p:cNvPr id="17" name="Image 0" descr="preencoded.png">    </p:cNvPr>
-          <p:cNvPicPr>
-            <a:picLocks noChangeAspect="1"/>
-          </p:cNvPicPr>
-          <p:nvPr/>
-        </p:nvPicPr>
-        <p:blipFill>
-          <a:blip r:embed="rId1"/>
-          <a:stretch>
-            <a:fillRect/>
-          </a:stretch>
-        </p:blipFill>
-        <p:spPr>
-          <a:xfrm>
-            <a:off x="914400" y="5202936"/>
-            <a:ext cx="292608" cy="292608"/>
-          </a:xfrm>
-          <a:prstGeom prst="rect">
-            <a:avLst/>
-          </a:prstGeom>
-        </p:spPr>
-      </p:pic>
-      <p:sp>
-        <p:nvSpPr>
-          <p:cNvPr id="18" name="body"/>
-          <p:cNvSpPr txBox="1"/>
-          <p:nvPr/>
-        </p:nvSpPr>
-        <p:spPr>
-          <a:xfrm>
-            <a:off x="1554480" y="4754880"/>
-            <a:ext cx="5943600" cy="1188720"/>
-          </a:xfrm>
-          <a:prstGeom prst="rect">
-            <a:avLst/>
-          </a:prstGeom>
-          <a:noFill/>
-          <a:ln/>
-        </p:spPr>
-        <p:txBody>
-          <a:bodyPr wrap="square" lIns="0" tIns="0" rIns="0" bIns="0" rtlCol="0" anchor="ctr"/>
-          <a:lstStyle/>
-          <a:p>
-            <a:pPr indent="0" marL="0">
-              <a:buNone/>
-            </a:pPr>
-            <a:r>
-              <a:rPr lang="en-US" sz="2200" b="1" dirty="0">
-                <a:solidFill>
-                  <a:srgbClr val="0B2239"/>
-                </a:solidFill>
-                <a:latin typeface="Cambria" pitchFamily="34" charset="0"/>
-                <a:ea typeface="Cambria" pitchFamily="34" charset="-122"/>
-                <a:cs typeface="Cambria" pitchFamily="34" charset="-120"/>
-              </a:rPr>
-              <a:t>Awareness idea: an “AI nutrition label”</a:t>
-            </a:r>
-            <a:endParaRPr lang="en-US" sz="2200" dirty="0"/>
-          </a:p>
-          <a:p>
-            <a:pPr indent="0" marL="0">
-              <a:buNone/>
-            </a:pPr>
-            <a:r>
-              <a:rPr lang="en-US" sz="2000" dirty="0">
-                <a:solidFill>
-                  <a:srgbClr val="0B2239"/>
-                </a:solidFill>
-                <a:latin typeface="Calibri" pitchFamily="34" charset="0"/>
-                <a:ea typeface="Calibri" pitchFamily="34" charset="-122"/>
-                <a:cs typeface="Calibri" pitchFamily="34" charset="-120"/>
-              </a:rPr>
-              <a:t>Posters showing each AI tool’s water and power</a:t>
-            </a:r>
-            <a:endParaRPr lang="en-US" sz="2200" dirty="0"/>
-          </a:p>
-        </p:txBody>
-      </p:sp>
-      <p:sp>
-        <p:nvSpPr>
-          <p:cNvPr id="19" name="photo-frame"/>
-          <p:cNvSpPr/>
-          <p:nvPr/>
-        </p:nvSpPr>
-        <p:spPr>
-          <a:xfrm>
-            <a:off x="8001000" y="1417320"/>
-            <a:ext cx="3639312" cy="4617720"/>
-          </a:xfrm>
-          <a:prstGeom prst="roundRect">
-            <a:avLst>
-              <a:gd name="adj" fmla="val 4523"/>
-            </a:avLst>
-          </a:prstGeom>
-          <a:solidFill>
-            <a:srgbClr val="EAF4F7"/>
-          </a:solidFill>
-          <a:ln w="25400">
-            <a:solidFill>
-              <a:srgbClr val="137C94"/>
-            </a:solidFill>
-            <a:prstDash val="dash"/>
-          </a:ln>
-        </p:spPr>
-      </p:sp>
-      <p:pic>
-        <p:nvPicPr>
-          <p:cNvPr id="20" name="Image 1" descr="preencoded.png">    </p:cNvPr>
+          <p:cNvPr id="7" name="Image 0" descr="preencoded.png">    </p:cNvPr>
           <p:cNvPicPr>
             <a:picLocks noChangeAspect="1"/>
           </p:cNvPicPr>
@@ -4721,8 +4361,8 @@
         </p:blipFill>
         <p:spPr>
           <a:xfrm>
-            <a:off x="9500616" y="2766060"/>
-            <a:ext cx="640080" cy="640080"/>
+            <a:off x="786384" y="2404872"/>
+            <a:ext cx="548640" cy="548640"/>
           </a:xfrm>
           <a:prstGeom prst="rect">
             <a:avLst/>
@@ -4731,14 +4371,14 @@
       </p:pic>
       <p:sp>
         <p:nvSpPr>
-          <p:cNvPr id="21" name="caption-photo"/>
+          <p:cNvPr id="8" name="number"/>
           <p:cNvSpPr txBox="1"/>
           <p:nvPr/>
         </p:nvSpPr>
         <p:spPr>
           <a:xfrm>
-            <a:off x="8183880" y="3543300"/>
-            <a:ext cx="3273552" cy="1005840"/>
+            <a:off x="786384" y="2395728"/>
+            <a:ext cx="548640" cy="457200"/>
           </a:xfrm>
           <a:prstGeom prst="rect">
             <a:avLst/>
@@ -4747,6 +4387,526 @@
           <a:ln/>
         </p:spPr>
         <p:txBody>
+          <a:bodyPr wrap="square" lIns="0" tIns="0" rIns="0" bIns="0" rtlCol="0" anchor="ctr"/>
+          <a:lstStyle/>
+          <a:p>
+            <a:pPr algn="ctr" indent="0" marL="0">
+              <a:buNone/>
+            </a:pPr>
+            <a:r>
+              <a:rPr lang="en-US" sz="2000" b="1" dirty="0">
+                <a:solidFill>
+                  <a:srgbClr val="FFFFFF"/>
+                </a:solidFill>
+                <a:latin typeface="Calibri" pitchFamily="34" charset="0"/>
+                <a:ea typeface="Calibri" pitchFamily="34" charset="-122"/>
+                <a:cs typeface="Calibri" pitchFamily="34" charset="-120"/>
+              </a:rPr>
+              <a:t>1</a:t>
+            </a:r>
+            <a:endParaRPr lang="en-US" sz="2000" dirty="0"/>
+          </a:p>
+        </p:txBody>
+      </p:sp>
+      <p:sp>
+        <p:nvSpPr>
+          <p:cNvPr id="9" name="body"/>
+          <p:cNvSpPr txBox="1"/>
+          <p:nvPr/>
+        </p:nvSpPr>
+        <p:spPr>
+          <a:xfrm>
+            <a:off x="1481328" y="2386584"/>
+            <a:ext cx="5989320" cy="512064"/>
+          </a:xfrm>
+          <a:prstGeom prst="rect">
+            <a:avLst/>
+          </a:prstGeom>
+          <a:noFill/>
+          <a:ln/>
+        </p:spPr>
+        <p:txBody>
+          <a:bodyPr wrap="square" lIns="0" tIns="0" rIns="0" bIns="0" rtlCol="0" anchor="ctr"/>
+          <a:lstStyle/>
+          <a:p>
+            <a:pPr indent="0" marL="0">
+              <a:buNone/>
+            </a:pPr>
+            <a:r>
+              <a:rPr lang="en-US" sz="2100" dirty="0">
+                <a:solidFill>
+                  <a:srgbClr val="0B2239"/>
+                </a:solidFill>
+                <a:latin typeface="Calibri" pitchFamily="34" charset="0"/>
+                <a:ea typeface="Calibri" pitchFamily="34" charset="-122"/>
+                <a:cs typeface="Calibri" pitchFamily="34" charset="-120"/>
+              </a:rPr>
+              <a:t>Data centers publish yearly water and power use</a:t>
+            </a:r>
+            <a:endParaRPr lang="en-US" sz="2100" dirty="0"/>
+          </a:p>
+        </p:txBody>
+      </p:sp>
+      <p:pic>
+        <p:nvPicPr>
+          <p:cNvPr id="10" name="Image 1" descr="preencoded.png">    </p:cNvPr>
+          <p:cNvPicPr>
+            <a:picLocks noChangeAspect="1"/>
+          </p:cNvPicPr>
+          <p:nvPr/>
+        </p:nvPicPr>
+        <p:blipFill>
+          <a:blip r:embed="rId3"/>
+          <a:stretch>
+            <a:fillRect/>
+          </a:stretch>
+        </p:blipFill>
+        <p:spPr>
+          <a:xfrm>
+            <a:off x="786384" y="2971800"/>
+            <a:ext cx="548640" cy="548640"/>
+          </a:xfrm>
+          <a:prstGeom prst="rect">
+            <a:avLst/>
+          </a:prstGeom>
+        </p:spPr>
+      </p:pic>
+      <p:sp>
+        <p:nvSpPr>
+          <p:cNvPr id="11" name="number"/>
+          <p:cNvSpPr txBox="1"/>
+          <p:nvPr/>
+        </p:nvSpPr>
+        <p:spPr>
+          <a:xfrm>
+            <a:off x="786384" y="2962656"/>
+            <a:ext cx="548640" cy="457200"/>
+          </a:xfrm>
+          <a:prstGeom prst="rect">
+            <a:avLst/>
+          </a:prstGeom>
+          <a:noFill/>
+          <a:ln/>
+        </p:spPr>
+        <p:txBody>
+          <a:bodyPr wrap="square" lIns="0" tIns="0" rIns="0" bIns="0" rtlCol="0" anchor="ctr"/>
+          <a:lstStyle/>
+          <a:p>
+            <a:pPr algn="ctr" indent="0" marL="0">
+              <a:buNone/>
+            </a:pPr>
+            <a:r>
+              <a:rPr lang="en-US" sz="2000" b="1" dirty="0">
+                <a:solidFill>
+                  <a:srgbClr val="FFFFFF"/>
+                </a:solidFill>
+                <a:latin typeface="Calibri" pitchFamily="34" charset="0"/>
+                <a:ea typeface="Calibri" pitchFamily="34" charset="-122"/>
+                <a:cs typeface="Calibri" pitchFamily="34" charset="-120"/>
+              </a:rPr>
+              <a:t>2</a:t>
+            </a:r>
+            <a:endParaRPr lang="en-US" sz="2000" dirty="0"/>
+          </a:p>
+        </p:txBody>
+      </p:sp>
+      <p:sp>
+        <p:nvSpPr>
+          <p:cNvPr id="12" name="body"/>
+          <p:cNvSpPr txBox="1"/>
+          <p:nvPr/>
+        </p:nvSpPr>
+        <p:spPr>
+          <a:xfrm>
+            <a:off x="1481328" y="2953512"/>
+            <a:ext cx="5989320" cy="512064"/>
+          </a:xfrm>
+          <a:prstGeom prst="rect">
+            <a:avLst/>
+          </a:prstGeom>
+          <a:noFill/>
+          <a:ln/>
+        </p:spPr>
+        <p:txBody>
+          <a:bodyPr wrap="square" lIns="0" tIns="0" rIns="0" bIns="0" rtlCol="0" anchor="ctr"/>
+          <a:lstStyle/>
+          <a:p>
+            <a:pPr indent="0" marL="0">
+              <a:buNone/>
+            </a:pPr>
+            <a:r>
+              <a:rPr lang="en-US" sz="2100" dirty="0">
+                <a:solidFill>
+                  <a:srgbClr val="0B2239"/>
+                </a:solidFill>
+                <a:latin typeface="Calibri" pitchFamily="34" charset="0"/>
+                <a:ea typeface="Calibri" pitchFamily="34" charset="-122"/>
+                <a:cs typeface="Calibri" pitchFamily="34" charset="-120"/>
+              </a:rPr>
+              <a:t>Local hearings stay, even on the fast track</a:t>
+            </a:r>
+            <a:endParaRPr lang="en-US" sz="2100" dirty="0"/>
+          </a:p>
+        </p:txBody>
+      </p:sp>
+      <p:pic>
+        <p:nvPicPr>
+          <p:cNvPr id="13" name="Image 2" descr="preencoded.png">    </p:cNvPr>
+          <p:cNvPicPr>
+            <a:picLocks noChangeAspect="1"/>
+          </p:cNvPicPr>
+          <p:nvPr/>
+        </p:nvPicPr>
+        <p:blipFill>
+          <a:blip r:embed="rId4"/>
+          <a:stretch>
+            <a:fillRect/>
+          </a:stretch>
+        </p:blipFill>
+        <p:spPr>
+          <a:xfrm>
+            <a:off x="786384" y="3538728"/>
+            <a:ext cx="548640" cy="548640"/>
+          </a:xfrm>
+          <a:prstGeom prst="rect">
+            <a:avLst/>
+          </a:prstGeom>
+        </p:spPr>
+      </p:pic>
+      <p:sp>
+        <p:nvSpPr>
+          <p:cNvPr id="14" name="number"/>
+          <p:cNvSpPr txBox="1"/>
+          <p:nvPr/>
+        </p:nvSpPr>
+        <p:spPr>
+          <a:xfrm>
+            <a:off x="786384" y="3529584"/>
+            <a:ext cx="548640" cy="457200"/>
+          </a:xfrm>
+          <a:prstGeom prst="rect">
+            <a:avLst/>
+          </a:prstGeom>
+          <a:noFill/>
+          <a:ln/>
+        </p:spPr>
+        <p:txBody>
+          <a:bodyPr wrap="square" lIns="0" tIns="0" rIns="0" bIns="0" rtlCol="0" anchor="ctr"/>
+          <a:lstStyle/>
+          <a:p>
+            <a:pPr algn="ctr" indent="0" marL="0">
+              <a:buNone/>
+            </a:pPr>
+            <a:r>
+              <a:rPr lang="en-US" sz="2000" b="1" dirty="0">
+                <a:solidFill>
+                  <a:srgbClr val="FFFFFF"/>
+                </a:solidFill>
+                <a:latin typeface="Calibri" pitchFamily="34" charset="0"/>
+                <a:ea typeface="Calibri" pitchFamily="34" charset="-122"/>
+                <a:cs typeface="Calibri" pitchFamily="34" charset="-120"/>
+              </a:rPr>
+              <a:t>3</a:t>
+            </a:r>
+            <a:endParaRPr lang="en-US" sz="2000" dirty="0"/>
+          </a:p>
+        </p:txBody>
+      </p:sp>
+      <p:sp>
+        <p:nvSpPr>
+          <p:cNvPr id="15" name="body"/>
+          <p:cNvSpPr txBox="1"/>
+          <p:nvPr/>
+        </p:nvSpPr>
+        <p:spPr>
+          <a:xfrm>
+            <a:off x="1481328" y="3520440"/>
+            <a:ext cx="5989320" cy="512064"/>
+          </a:xfrm>
+          <a:prstGeom prst="rect">
+            <a:avLst/>
+          </a:prstGeom>
+          <a:noFill/>
+          <a:ln/>
+        </p:spPr>
+        <p:txBody>
+          <a:bodyPr wrap="square" lIns="0" tIns="0" rIns="0" bIns="0" rtlCol="0" anchor="ctr"/>
+          <a:lstStyle/>
+          <a:p>
+            <a:pPr indent="0" marL="0">
+              <a:buNone/>
+            </a:pPr>
+            <a:r>
+              <a:rPr lang="en-US" sz="2100" dirty="0">
+                <a:solidFill>
+                  <a:srgbClr val="0B2239"/>
+                </a:solidFill>
+                <a:latin typeface="Calibri" pitchFamily="34" charset="0"/>
+                <a:ea typeface="Calibri" pitchFamily="34" charset="-122"/>
+                <a:cs typeface="Calibri" pitchFamily="34" charset="-120"/>
+              </a:rPr>
+              <a:t>In shortages: homes and farms before servers</a:t>
+            </a:r>
+            <a:endParaRPr lang="en-US" sz="2100" dirty="0"/>
+          </a:p>
+        </p:txBody>
+      </p:sp>
+      <p:sp>
+        <p:nvSpPr>
+          <p:cNvPr id="16" name="body"/>
+          <p:cNvSpPr txBox="1"/>
+          <p:nvPr/>
+        </p:nvSpPr>
+        <p:spPr>
+          <a:xfrm>
+            <a:off x="822960" y="4114800"/>
+            <a:ext cx="6583680" cy="365760"/>
+          </a:xfrm>
+          <a:prstGeom prst="rect">
+            <a:avLst/>
+          </a:prstGeom>
+          <a:noFill/>
+          <a:ln/>
+        </p:spPr>
+        <p:txBody>
+          <a:bodyPr wrap="square" lIns="0" tIns="0" rIns="0" bIns="0" rtlCol="0" anchor="ctr"/>
+          <a:lstStyle/>
+          <a:p>
+            <a:pPr indent="0" marL="0">
+              <a:buNone/>
+            </a:pPr>
+            <a:r>
+              <a:rPr lang="en-US" sz="2000" b="1" i="1" dirty="0">
+                <a:solidFill>
+                  <a:srgbClr val="137C94"/>
+                </a:solidFill>
+                <a:latin typeface="Calibri" pitchFamily="34" charset="0"/>
+                <a:ea typeface="Calibri" pitchFamily="34" charset="-122"/>
+                <a:cs typeface="Calibri" pitchFamily="34" charset="-120"/>
+              </a:rPr>
+              <a:t>Aim: fair siting, no discrimination</a:t>
+            </a:r>
+            <a:endParaRPr lang="en-US" sz="2000" dirty="0"/>
+          </a:p>
+        </p:txBody>
+      </p:sp>
+      <p:sp>
+        <p:nvSpPr>
+          <p:cNvPr id="17" name="Shape 12"/>
+          <p:cNvSpPr/>
+          <p:nvPr/>
+        </p:nvSpPr>
+        <p:spPr>
+          <a:xfrm>
+            <a:off x="548640" y="4754880"/>
+            <a:ext cx="7086600" cy="1325880"/>
+          </a:xfrm>
+          <a:prstGeom prst="roundRect">
+            <a:avLst>
+              <a:gd name="adj" fmla="val 13793"/>
+            </a:avLst>
+          </a:prstGeom>
+          <a:solidFill>
+            <a:srgbClr val="FFFFFF"/>
+          </a:solidFill>
+          <a:ln w="12700">
+            <a:solidFill>
+              <a:srgbClr val="FFFFFF"/>
+            </a:solidFill>
+            <a:prstDash val="solid"/>
+          </a:ln>
+          <a:effectLst>
+            <a:outerShdw sx="100000" sy="100000" kx="0" ky="0" algn="bl" rotWithShape="0" blurRad="203200" dist="76200" dir="5400000">
+              <a:srgbClr val="000000">
+                <a:alpha val="18000"/>
+              </a:srgbClr>
+            </a:outerShdw>
+          </a:effectLst>
+        </p:spPr>
+      </p:sp>
+      <p:pic>
+        <p:nvPicPr>
+          <p:cNvPr id="18" name="Image 3" descr="preencoded.png">    </p:cNvPr>
+          <p:cNvPicPr>
+            <a:picLocks noChangeAspect="1"/>
+          </p:cNvPicPr>
+          <p:nvPr/>
+        </p:nvPicPr>
+        <p:blipFill>
+          <a:blip r:embed="rId5"/>
+          <a:stretch>
+            <a:fillRect/>
+          </a:stretch>
+        </p:blipFill>
+        <p:spPr>
+          <a:xfrm>
+            <a:off x="777240" y="5047488"/>
+            <a:ext cx="713232" cy="713232"/>
+          </a:xfrm>
+          <a:prstGeom prst="rect">
+            <a:avLst/>
+          </a:prstGeom>
+        </p:spPr>
+      </p:pic>
+      <p:sp>
+        <p:nvSpPr>
+          <p:cNvPr id="19" name="body"/>
+          <p:cNvSpPr txBox="1"/>
+          <p:nvPr/>
+        </p:nvSpPr>
+        <p:spPr>
+          <a:xfrm>
+            <a:off x="1645920" y="4828032"/>
+            <a:ext cx="5852160" cy="1188720"/>
+          </a:xfrm>
+          <a:prstGeom prst="rect">
+            <a:avLst/>
+          </a:prstGeom>
+          <a:noFill/>
+          <a:ln/>
+        </p:spPr>
+        <p:txBody>
+          <a:bodyPr wrap="square" lIns="0" tIns="0" rIns="0" bIns="0" rtlCol="0" anchor="ctr"/>
+          <a:lstStyle/>
+          <a:p>
+            <a:pPr indent="0" marL="0">
+              <a:buNone/>
+            </a:pPr>
+            <a:r>
+              <a:rPr lang="en-US" sz="2200" b="1" dirty="0">
+                <a:solidFill>
+                  <a:srgbClr val="0B2239"/>
+                </a:solidFill>
+                <a:latin typeface="Cambria" pitchFamily="34" charset="0"/>
+                <a:ea typeface="Cambria" pitchFamily="34" charset="-122"/>
+                <a:cs typeface="Cambria" pitchFamily="34" charset="-120"/>
+              </a:rPr>
+              <a:t>Awareness idea: an “AI nutrition label”</a:t>
+            </a:r>
+            <a:endParaRPr lang="en-US" sz="2200" dirty="0"/>
+          </a:p>
+          <a:p>
+            <a:pPr indent="0" marL="0">
+              <a:buNone/>
+            </a:pPr>
+            <a:r>
+              <a:rPr lang="en-US" sz="2000" dirty="0">
+                <a:solidFill>
+                  <a:srgbClr val="0B2239"/>
+                </a:solidFill>
+                <a:latin typeface="Calibri" pitchFamily="34" charset="0"/>
+                <a:ea typeface="Calibri" pitchFamily="34" charset="-122"/>
+                <a:cs typeface="Calibri" pitchFamily="34" charset="-120"/>
+              </a:rPr>
+              <a:t>Posters showing each AI tool’s water and power</a:t>
+            </a:r>
+            <a:endParaRPr lang="en-US" sz="2200" dirty="0"/>
+          </a:p>
+        </p:txBody>
+      </p:sp>
+      <p:sp>
+        <p:nvSpPr>
+          <p:cNvPr id="20" name="Shape 14"/>
+          <p:cNvSpPr/>
+          <p:nvPr/>
+        </p:nvSpPr>
+        <p:spPr>
+          <a:xfrm>
+            <a:off x="8001000" y="1645920"/>
+            <a:ext cx="3639312" cy="4434840"/>
+          </a:xfrm>
+          <a:prstGeom prst="roundRect">
+            <a:avLst>
+              <a:gd name="adj" fmla="val 5025"/>
+            </a:avLst>
+          </a:prstGeom>
+          <a:solidFill>
+            <a:srgbClr val="FFFFFF"/>
+          </a:solidFill>
+          <a:ln w="12700">
+            <a:solidFill>
+              <a:srgbClr val="FFFFFF"/>
+            </a:solidFill>
+            <a:prstDash val="solid"/>
+          </a:ln>
+          <a:effectLst>
+            <a:outerShdw sx="100000" sy="100000" kx="0" ky="0" algn="bl" rotWithShape="0" blurRad="203200" dist="76200" dir="5400000">
+              <a:srgbClr val="000000">
+                <a:alpha val="18000"/>
+              </a:srgbClr>
+            </a:outerShdw>
+          </a:effectLst>
+        </p:spPr>
+      </p:sp>
+      <p:sp>
+        <p:nvSpPr>
+          <p:cNvPr id="21" name="photo-frame"/>
+          <p:cNvSpPr/>
+          <p:nvPr/>
+        </p:nvSpPr>
+        <p:spPr>
+          <a:xfrm>
+            <a:off x="8165592" y="1810512"/>
+            <a:ext cx="3310128" cy="4105656"/>
+          </a:xfrm>
+          <a:prstGeom prst="roundRect">
+            <a:avLst>
+              <a:gd name="adj" fmla="val 3867"/>
+            </a:avLst>
+          </a:prstGeom>
+          <a:solidFill>
+            <a:srgbClr val="EAF4F7"/>
+          </a:solidFill>
+          <a:ln w="19050">
+            <a:solidFill>
+              <a:srgbClr val="137C94"/>
+            </a:solidFill>
+            <a:prstDash val="dash"/>
+          </a:ln>
+        </p:spPr>
+      </p:sp>
+      <p:pic>
+        <p:nvPicPr>
+          <p:cNvPr id="22" name="Image 4" descr="preencoded.png">    </p:cNvPr>
+          <p:cNvPicPr>
+            <a:picLocks noChangeAspect="1"/>
+          </p:cNvPicPr>
+          <p:nvPr/>
+        </p:nvPicPr>
+        <p:blipFill>
+          <a:blip r:embed="rId6"/>
+          <a:stretch>
+            <a:fillRect/>
+          </a:stretch>
+        </p:blipFill>
+        <p:spPr>
+          <a:xfrm>
+            <a:off x="9409176" y="2766060"/>
+            <a:ext cx="822960" cy="822960"/>
+          </a:xfrm>
+          <a:prstGeom prst="rect">
+            <a:avLst/>
+          </a:prstGeom>
+        </p:spPr>
+      </p:pic>
+      <p:sp>
+        <p:nvSpPr>
+          <p:cNvPr id="23" name="caption-photo"/>
+          <p:cNvSpPr txBox="1"/>
+          <p:nvPr/>
+        </p:nvSpPr>
+        <p:spPr>
+          <a:xfrm>
+            <a:off x="8275320" y="3753612"/>
+            <a:ext cx="3090672" cy="1005840"/>
+          </a:xfrm>
+          <a:prstGeom prst="rect">
+            <a:avLst/>
+          </a:prstGeom>
+          <a:noFill/>
+          <a:ln/>
+        </p:spPr>
+        <p:txBody>
           <a:bodyPr wrap="square" lIns="0" tIns="0" rIns="0" bIns="0" rtlCol="0" anchor="t"/>
           <a:lstStyle/>
           <a:p>
@@ -4754,7 +4914,7 @@
               <a:buNone/>
             </a:pPr>
             <a:r>
-              <a:rPr lang="en-US" sz="1600" b="1" dirty="0">
+              <a:rPr lang="en-US" sz="1600" b="1" spc="200" kern="0" dirty="0">
                 <a:solidFill>
                   <a:srgbClr val="4A5A68"/>
                 </a:solidFill>
@@ -4804,14 +4964,14 @@
       </p:sp>
       <p:sp>
         <p:nvSpPr>
-          <p:cNvPr id="22" name="caption-sources"/>
+          <p:cNvPr id="24" name="caption-sources"/>
           <p:cNvSpPr txBox="1"/>
           <p:nvPr/>
         </p:nvSpPr>
         <p:spPr>
           <a:xfrm>
             <a:off x="548640" y="6291072"/>
-            <a:ext cx="11064240" cy="365760"/>
+            <a:ext cx="10058400" cy="365760"/>
           </a:xfrm>
           <a:prstGeom prst="rect">
             <a:avLst/>
@@ -4854,9 +5014,16 @@
   <p:cSld name="Slide 5">
     <p:bg>
       <p:bgPr>
-        <a:solidFill>
-          <a:srgbClr val="0B2239"/>
-        </a:solidFill>
+        <a:blipFill dpi="0" rotWithShape="1">
+          <a:blip r:embed="rId1">
+            <a:lum/>
+          </a:blip>
+          <a:srcRect/>
+          <a:stretch>
+            <a:fillRect/>
+          </a:stretch>
+        </a:blipFill>
+        <a:effectLst/>
       </p:bgPr>
     </p:bg>
     <p:spTree>
@@ -4875,14 +5042,92 @@
       </p:grpSpPr>
       <p:sp>
         <p:nvSpPr>
-          <p:cNvPr id="2" name="title"/>
+          <p:cNvPr id="2" name="caption-tag"/>
           <p:cNvSpPr txBox="1"/>
           <p:nvPr/>
         </p:nvSpPr>
         <p:spPr>
           <a:xfrm>
-            <a:off x="548640" y="1234440"/>
-            <a:ext cx="6858000" cy="914400"/>
+            <a:off x="548640" y="347472"/>
+            <a:ext cx="7315200" cy="320040"/>
+          </a:xfrm>
+          <a:prstGeom prst="rect">
+            <a:avLst/>
+          </a:prstGeom>
+          <a:noFill/>
+          <a:ln/>
+        </p:spPr>
+        <p:txBody>
+          <a:bodyPr wrap="square" lIns="0" tIns="0" rIns="0" bIns="0" rtlCol="0" anchor="ctr"/>
+          <a:lstStyle/>
+          <a:p>
+            <a:pPr indent="0" marL="0">
+              <a:buNone/>
+            </a:pPr>
+            <a:r>
+              <a:rPr lang="en-US" sz="1400" b="1" spc="300" kern="0" dirty="0">
+                <a:solidFill>
+                  <a:srgbClr val="F2A33A"/>
+                </a:solidFill>
+                <a:latin typeface="Calibri" pitchFamily="34" charset="0"/>
+                <a:ea typeface="Calibri" pitchFamily="34" charset="-122"/>
+                <a:cs typeface="Calibri" pitchFamily="34" charset="-120"/>
+              </a:rPr>
+              <a:t>05  ·  CLOSING</a:t>
+            </a:r>
+            <a:endParaRPr lang="en-US" sz="1400" dirty="0"/>
+          </a:p>
+        </p:txBody>
+      </p:sp>
+      <p:sp>
+        <p:nvSpPr>
+          <p:cNvPr id="3" name="caption-page"/>
+          <p:cNvSpPr txBox="1"/>
+          <p:nvPr/>
+        </p:nvSpPr>
+        <p:spPr>
+          <a:xfrm>
+            <a:off x="10725912" y="6291072"/>
+            <a:ext cx="914400" cy="365760"/>
+          </a:xfrm>
+          <a:prstGeom prst="rect">
+            <a:avLst/>
+          </a:prstGeom>
+          <a:noFill/>
+          <a:ln/>
+        </p:spPr>
+        <p:txBody>
+          <a:bodyPr wrap="square" lIns="0" tIns="0" rIns="0" bIns="0" rtlCol="0" anchor="ctr"/>
+          <a:lstStyle/>
+          <a:p>
+            <a:pPr algn="r" indent="0" marL="0">
+              <a:buNone/>
+            </a:pPr>
+            <a:r>
+              <a:rPr lang="en-US" sz="1100" dirty="0">
+                <a:solidFill>
+                  <a:srgbClr val="B8C7D3"/>
+                </a:solidFill>
+                <a:latin typeface="Calibri" pitchFamily="34" charset="0"/>
+                <a:ea typeface="Calibri" pitchFamily="34" charset="-122"/>
+                <a:cs typeface="Calibri" pitchFamily="34" charset="-120"/>
+              </a:rPr>
+              <a:t>5 / 5</a:t>
+            </a:r>
+            <a:endParaRPr lang="en-US" sz="1100" dirty="0"/>
+          </a:p>
+        </p:txBody>
+      </p:sp>
+      <p:sp>
+        <p:nvSpPr>
+          <p:cNvPr id="4" name="title"/>
+          <p:cNvSpPr txBox="1"/>
+          <p:nvPr/>
+        </p:nvSpPr>
+        <p:spPr>
+          <a:xfrm>
+            <a:off x="548640" y="1417320"/>
+            <a:ext cx="6949440" cy="914400"/>
           </a:xfrm>
           <a:prstGeom prst="rect">
             <a:avLst/>
@@ -4914,14 +5159,14 @@
       </p:sp>
       <p:sp>
         <p:nvSpPr>
-          <p:cNvPr id="3" name="title"/>
+          <p:cNvPr id="5" name="title"/>
           <p:cNvSpPr txBox="1"/>
           <p:nvPr/>
         </p:nvSpPr>
         <p:spPr>
           <a:xfrm>
-            <a:off x="548640" y="2148840"/>
-            <a:ext cx="6858000" cy="731520"/>
+            <a:off x="548640" y="2331720"/>
+            <a:ext cx="6949440" cy="731520"/>
           </a:xfrm>
           <a:prstGeom prst="rect">
             <a:avLst/>
@@ -4951,136 +5196,9 @@
           </a:p>
         </p:txBody>
       </p:sp>
-      <p:sp>
-        <p:nvSpPr>
-          <p:cNvPr id="4" name="Shape 2"/>
-          <p:cNvSpPr/>
-          <p:nvPr/>
-        </p:nvSpPr>
-        <p:spPr>
-          <a:xfrm>
-            <a:off x="548640" y="3429000"/>
-            <a:ext cx="475488" cy="475488"/>
-          </a:xfrm>
-          <a:prstGeom prst="ellipse">
-            <a:avLst/>
-          </a:prstGeom>
-          <a:solidFill>
-            <a:srgbClr val="F2A33A"/>
-          </a:solidFill>
-          <a:ln w="12700">
-            <a:solidFill>
-              <a:srgbClr val="F2A33A"/>
-            </a:solidFill>
-            <a:prstDash val="solid"/>
-          </a:ln>
-        </p:spPr>
-      </p:sp>
       <p:pic>
         <p:nvPicPr>
-          <p:cNvPr id="5" name="Image 0" descr="preencoded.png">    </p:cNvPr>
-          <p:cNvPicPr>
-            <a:picLocks noChangeAspect="1"/>
-          </p:cNvPicPr>
-          <p:nvPr/>
-        </p:nvPicPr>
-        <p:blipFill>
-          <a:blip r:embed="rId1"/>
-          <a:stretch>
-            <a:fillRect/>
-          </a:stretch>
-        </p:blipFill>
-        <p:spPr>
-          <a:xfrm>
-            <a:off x="658368" y="3538728"/>
-            <a:ext cx="256032" cy="256032"/>
-          </a:xfrm>
-          <a:prstGeom prst="rect">
-            <a:avLst/>
-          </a:prstGeom>
-        </p:spPr>
-      </p:pic>
-      <p:sp>
-        <p:nvSpPr>
-          <p:cNvPr id="6" name="body"/>
-          <p:cNvSpPr txBox="1"/>
-          <p:nvPr/>
-        </p:nvSpPr>
-        <p:spPr>
-          <a:xfrm>
-            <a:off x="1207008" y="3374136"/>
-            <a:ext cx="6217920" cy="585216"/>
-          </a:xfrm>
-          <a:prstGeom prst="rect">
-            <a:avLst/>
-          </a:prstGeom>
-          <a:noFill/>
-          <a:ln/>
-        </p:spPr>
-        <p:txBody>
-          <a:bodyPr wrap="square" lIns="0" tIns="0" rIns="0" bIns="0" rtlCol="0" anchor="ctr"/>
-          <a:lstStyle/>
-          <a:p>
-            <a:pPr indent="0" marL="0">
-              <a:buNone/>
-            </a:pPr>
-            <a:r>
-              <a:rPr lang="en-US" sz="2400" dirty="0">
-                <a:solidFill>
-                  <a:srgbClr val="FFFFFF"/>
-                </a:solidFill>
-                <a:latin typeface="Calibri" pitchFamily="34" charset="0"/>
-                <a:ea typeface="Calibri" pitchFamily="34" charset="-122"/>
-                <a:cs typeface="Calibri" pitchFamily="34" charset="-120"/>
-              </a:rPr>
-              <a:t>Ask two questions: </a:t>
-            </a:r>
-            <a:pPr indent="0" marL="0">
-              <a:buNone/>
-            </a:pPr>
-            <a:r>
-              <a:rPr lang="en-US" sz="2400" b="1" dirty="0">
-                <a:solidFill>
-                  <a:srgbClr val="F2A33A"/>
-                </a:solidFill>
-                <a:latin typeface="Calibri" pitchFamily="34" charset="0"/>
-                <a:ea typeface="Calibri" pitchFamily="34" charset="-122"/>
-                <a:cs typeface="Calibri" pitchFamily="34" charset="-120"/>
-              </a:rPr>
-              <a:t>Who decides? Who pays?</a:t>
-            </a:r>
-            <a:endParaRPr lang="en-US" sz="2400" dirty="0"/>
-          </a:p>
-        </p:txBody>
-      </p:sp>
-      <p:sp>
-        <p:nvSpPr>
-          <p:cNvPr id="7" name="Shape 4"/>
-          <p:cNvSpPr/>
-          <p:nvPr/>
-        </p:nvSpPr>
-        <p:spPr>
-          <a:xfrm>
-            <a:off x="548640" y="4251960"/>
-            <a:ext cx="475488" cy="475488"/>
-          </a:xfrm>
-          <a:prstGeom prst="ellipse">
-            <a:avLst/>
-          </a:prstGeom>
-          <a:solidFill>
-            <a:srgbClr val="137C94"/>
-          </a:solidFill>
-          <a:ln w="12700">
-            <a:solidFill>
-              <a:srgbClr val="137C94"/>
-            </a:solidFill>
-            <a:prstDash val="solid"/>
-          </a:ln>
-        </p:spPr>
-      </p:sp>
-      <p:pic>
-        <p:nvPicPr>
-          <p:cNvPr id="8" name="Image 1" descr="preencoded.png">    </p:cNvPr>
+          <p:cNvPr id="6" name="Image 0" descr="preencoded.png">    </p:cNvPr>
           <p:cNvPicPr>
             <a:picLocks noChangeAspect="1"/>
           </p:cNvPicPr>
@@ -5094,8 +5212,8 @@
         </p:blipFill>
         <p:spPr>
           <a:xfrm>
-            <a:off x="658368" y="4361688"/>
-            <a:ext cx="256032" cy="256032"/>
+            <a:off x="502920" y="3557016"/>
+            <a:ext cx="603504" cy="603504"/>
           </a:xfrm>
           <a:prstGeom prst="rect">
             <a:avLst/>
@@ -5104,13 +5222,13 @@
       </p:pic>
       <p:sp>
         <p:nvSpPr>
-          <p:cNvPr id="9" name="body"/>
+          <p:cNvPr id="7" name="body"/>
           <p:cNvSpPr txBox="1"/>
           <p:nvPr/>
         </p:nvSpPr>
         <p:spPr>
           <a:xfrm>
-            <a:off x="1207008" y="4197096"/>
+            <a:off x="1280160" y="3538728"/>
             <a:ext cx="6217920" cy="585216"/>
           </a:xfrm>
           <a:prstGeom prst="rect">
@@ -5135,7 +5253,7 @@
                 <a:ea typeface="Calibri" pitchFamily="34" charset="-122"/>
                 <a:cs typeface="Calibri" pitchFamily="34" charset="-120"/>
               </a:rPr>
-              <a:t>Real </a:t>
+              <a:t>Ask two questions: </a:t>
             </a:r>
             <a:pPr indent="0" marL="0">
               <a:buNone/>
@@ -5149,109 +5267,15 @@
                 <a:ea typeface="Calibri" pitchFamily="34" charset="-122"/>
                 <a:cs typeface="Calibri" pitchFamily="34" charset="-120"/>
               </a:rPr>
-              <a:t>sustainability</a:t>
-            </a:r>
-            <a:pPr indent="0" marL="0">
-              <a:buNone/>
-            </a:pPr>
-            <a:r>
-              <a:rPr lang="en-US" sz="2400" dirty="0">
-                <a:solidFill>
-                  <a:srgbClr val="FFFFFF"/>
-                </a:solidFill>
-                <a:latin typeface="Calibri" pitchFamily="34" charset="0"/>
-                <a:ea typeface="Calibri" pitchFamily="34" charset="-122"/>
-                <a:cs typeface="Calibri" pitchFamily="34" charset="-120"/>
-              </a:rPr>
-              <a:t> includes </a:t>
-            </a:r>
-            <a:pPr indent="0" marL="0">
-              <a:buNone/>
-            </a:pPr>
-            <a:r>
-              <a:rPr lang="en-US" sz="2400" b="1" dirty="0">
-                <a:solidFill>
-                  <a:srgbClr val="F2A33A"/>
-                </a:solidFill>
-                <a:latin typeface="Calibri" pitchFamily="34" charset="0"/>
-                <a:ea typeface="Calibri" pitchFamily="34" charset="-122"/>
-                <a:cs typeface="Calibri" pitchFamily="34" charset="-120"/>
-              </a:rPr>
-              <a:t>social justice</a:t>
+              <a:t>Who decides? Who pays?</a:t>
             </a:r>
             <a:endParaRPr lang="en-US" sz="2400" dirty="0"/>
           </a:p>
         </p:txBody>
-      </p:sp>
-      <p:sp>
-        <p:nvSpPr>
-          <p:cNvPr id="10" name="body"/>
-          <p:cNvSpPr txBox="1"/>
-          <p:nvPr/>
-        </p:nvSpPr>
-        <p:spPr>
-          <a:xfrm>
-            <a:off x="548640" y="5349240"/>
-            <a:ext cx="6400800" cy="548640"/>
-          </a:xfrm>
-          <a:prstGeom prst="rect">
-            <a:avLst/>
-          </a:prstGeom>
-          <a:noFill/>
-          <a:ln/>
-        </p:spPr>
-        <p:txBody>
-          <a:bodyPr wrap="square" lIns="0" tIns="0" rIns="0" bIns="0" rtlCol="0" anchor="ctr"/>
-          <a:lstStyle/>
-          <a:p>
-            <a:pPr indent="0" marL="0">
-              <a:buNone/>
-            </a:pPr>
-            <a:r>
-              <a:rPr lang="en-US" sz="2200" b="1" dirty="0">
-                <a:solidFill>
-                  <a:srgbClr val="B8C7D3"/>
-                </a:solidFill>
-                <a:latin typeface="Calibri" pitchFamily="34" charset="0"/>
-                <a:ea typeface="Calibri" pitchFamily="34" charset="-122"/>
-                <a:cs typeface="Calibri" pitchFamily="34" charset="-120"/>
-              </a:rPr>
-              <a:t>Thank you! Questions?</a:t>
-            </a:r>
-            <a:endParaRPr lang="en-US" sz="2200" dirty="0"/>
-          </a:p>
-        </p:txBody>
-      </p:sp>
-      <p:sp>
-        <p:nvSpPr>
-          <p:cNvPr id="11" name="photo-frame"/>
-          <p:cNvSpPr/>
-          <p:nvPr/>
-        </p:nvSpPr>
-        <p:spPr>
-          <a:xfrm>
-            <a:off x="8001000" y="1097280"/>
-            <a:ext cx="3639312" cy="4846320"/>
-          </a:xfrm>
-          <a:prstGeom prst="roundRect">
-            <a:avLst>
-              <a:gd name="adj" fmla="val 4523"/>
-            </a:avLst>
-          </a:prstGeom>
-          <a:solidFill>
-            <a:srgbClr val="173A57"/>
-          </a:solidFill>
-          <a:ln w="25400">
-            <a:solidFill>
-              <a:srgbClr val="137C94"/>
-            </a:solidFill>
-            <a:prstDash val="dash"/>
-          </a:ln>
-        </p:spPr>
       </p:sp>
       <p:pic>
         <p:nvPicPr>
-          <p:cNvPr id="12" name="Image 2" descr="preencoded.png">    </p:cNvPr>
+          <p:cNvPr id="8" name="Image 1" descr="preencoded.png">    </p:cNvPr>
           <p:cNvPicPr>
             <a:picLocks noChangeAspect="1"/>
           </p:cNvPicPr>
@@ -5265,8 +5289,8 @@
         </p:blipFill>
         <p:spPr>
           <a:xfrm>
-            <a:off x="9500616" y="2560320"/>
-            <a:ext cx="640080" cy="640080"/>
+            <a:off x="502920" y="4379976"/>
+            <a:ext cx="603504" cy="603504"/>
           </a:xfrm>
           <a:prstGeom prst="rect">
             <a:avLst/>
@@ -5275,14 +5299,14 @@
       </p:pic>
       <p:sp>
         <p:nvSpPr>
-          <p:cNvPr id="13" name="caption-photo"/>
+          <p:cNvPr id="9" name="body"/>
           <p:cNvSpPr txBox="1"/>
           <p:nvPr/>
         </p:nvSpPr>
         <p:spPr>
           <a:xfrm>
-            <a:off x="8183880" y="3337560"/>
-            <a:ext cx="3273552" cy="1005840"/>
+            <a:off x="1280160" y="4361688"/>
+            <a:ext cx="6217920" cy="585216"/>
           </a:xfrm>
           <a:prstGeom prst="rect">
             <a:avLst/>
@@ -5291,6 +5315,211 @@
           <a:ln/>
         </p:spPr>
         <p:txBody>
+          <a:bodyPr wrap="square" lIns="0" tIns="0" rIns="0" bIns="0" rtlCol="0" anchor="ctr"/>
+          <a:lstStyle/>
+          <a:p>
+            <a:pPr indent="0" marL="0">
+              <a:buNone/>
+            </a:pPr>
+            <a:r>
+              <a:rPr lang="en-US" sz="2400" dirty="0">
+                <a:solidFill>
+                  <a:srgbClr val="FFFFFF"/>
+                </a:solidFill>
+                <a:latin typeface="Calibri" pitchFamily="34" charset="0"/>
+                <a:ea typeface="Calibri" pitchFamily="34" charset="-122"/>
+                <a:cs typeface="Calibri" pitchFamily="34" charset="-120"/>
+              </a:rPr>
+              <a:t>Real </a:t>
+            </a:r>
+            <a:pPr indent="0" marL="0">
+              <a:buNone/>
+            </a:pPr>
+            <a:r>
+              <a:rPr lang="en-US" sz="2400" b="1" dirty="0">
+                <a:solidFill>
+                  <a:srgbClr val="F2A33A"/>
+                </a:solidFill>
+                <a:latin typeface="Calibri" pitchFamily="34" charset="0"/>
+                <a:ea typeface="Calibri" pitchFamily="34" charset="-122"/>
+                <a:cs typeface="Calibri" pitchFamily="34" charset="-120"/>
+              </a:rPr>
+              <a:t>sustainability</a:t>
+            </a:r>
+            <a:pPr indent="0" marL="0">
+              <a:buNone/>
+            </a:pPr>
+            <a:r>
+              <a:rPr lang="en-US" sz="2400" dirty="0">
+                <a:solidFill>
+                  <a:srgbClr val="FFFFFF"/>
+                </a:solidFill>
+                <a:latin typeface="Calibri" pitchFamily="34" charset="0"/>
+                <a:ea typeface="Calibri" pitchFamily="34" charset="-122"/>
+                <a:cs typeface="Calibri" pitchFamily="34" charset="-120"/>
+              </a:rPr>
+              <a:t> includes </a:t>
+            </a:r>
+            <a:pPr indent="0" marL="0">
+              <a:buNone/>
+            </a:pPr>
+            <a:r>
+              <a:rPr lang="en-US" sz="2400" b="1" dirty="0">
+                <a:solidFill>
+                  <a:srgbClr val="F2A33A"/>
+                </a:solidFill>
+                <a:latin typeface="Calibri" pitchFamily="34" charset="0"/>
+                <a:ea typeface="Calibri" pitchFamily="34" charset="-122"/>
+                <a:cs typeface="Calibri" pitchFamily="34" charset="-120"/>
+              </a:rPr>
+              <a:t>social justice</a:t>
+            </a:r>
+            <a:endParaRPr lang="en-US" sz="2400" dirty="0"/>
+          </a:p>
+        </p:txBody>
+      </p:sp>
+      <p:sp>
+        <p:nvSpPr>
+          <p:cNvPr id="10" name="body"/>
+          <p:cNvSpPr txBox="1"/>
+          <p:nvPr/>
+        </p:nvSpPr>
+        <p:spPr>
+          <a:xfrm>
+            <a:off x="548640" y="5440680"/>
+            <a:ext cx="6400800" cy="548640"/>
+          </a:xfrm>
+          <a:prstGeom prst="rect">
+            <a:avLst/>
+          </a:prstGeom>
+          <a:noFill/>
+          <a:ln/>
+        </p:spPr>
+        <p:txBody>
+          <a:bodyPr wrap="square" lIns="0" tIns="0" rIns="0" bIns="0" rtlCol="0" anchor="ctr"/>
+          <a:lstStyle/>
+          <a:p>
+            <a:pPr indent="0" marL="0">
+              <a:buNone/>
+            </a:pPr>
+            <a:r>
+              <a:rPr lang="en-US" sz="2200" b="1" dirty="0">
+                <a:solidFill>
+                  <a:srgbClr val="B8C7D3"/>
+                </a:solidFill>
+                <a:latin typeface="Calibri" pitchFamily="34" charset="0"/>
+                <a:ea typeface="Calibri" pitchFamily="34" charset="-122"/>
+                <a:cs typeface="Calibri" pitchFamily="34" charset="-120"/>
+              </a:rPr>
+              <a:t>Thank you! Questions?</a:t>
+            </a:r>
+            <a:endParaRPr lang="en-US" sz="2200" dirty="0"/>
+          </a:p>
+        </p:txBody>
+      </p:sp>
+      <p:sp>
+        <p:nvSpPr>
+          <p:cNvPr id="11" name="Shape 7"/>
+          <p:cNvSpPr/>
+          <p:nvPr/>
+        </p:nvSpPr>
+        <p:spPr>
+          <a:xfrm>
+            <a:off x="8001000" y="1188720"/>
+            <a:ext cx="3639312" cy="4846320"/>
+          </a:xfrm>
+          <a:prstGeom prst="roundRect">
+            <a:avLst>
+              <a:gd name="adj" fmla="val 5025"/>
+            </a:avLst>
+          </a:prstGeom>
+          <a:solidFill>
+            <a:srgbClr val="163A58"/>
+          </a:solidFill>
+          <a:ln w="12700">
+            <a:solidFill>
+              <a:srgbClr val="163A58"/>
+            </a:solidFill>
+            <a:prstDash val="solid"/>
+          </a:ln>
+          <a:effectLst>
+            <a:outerShdw sx="100000" sy="100000" kx="0" ky="0" algn="bl" rotWithShape="0" blurRad="279400" dist="101600" dir="5400000">
+              <a:srgbClr val="000000">
+                <a:alpha val="45000"/>
+              </a:srgbClr>
+            </a:outerShdw>
+          </a:effectLst>
+        </p:spPr>
+      </p:sp>
+      <p:sp>
+        <p:nvSpPr>
+          <p:cNvPr id="12" name="photo-frame"/>
+          <p:cNvSpPr/>
+          <p:nvPr/>
+        </p:nvSpPr>
+        <p:spPr>
+          <a:xfrm>
+            <a:off x="8165592" y="1353312"/>
+            <a:ext cx="3310128" cy="4517136"/>
+          </a:xfrm>
+          <a:prstGeom prst="roundRect">
+            <a:avLst>
+              <a:gd name="adj" fmla="val 3867"/>
+            </a:avLst>
+          </a:prstGeom>
+          <a:solidFill>
+            <a:srgbClr val="1D4668"/>
+          </a:solidFill>
+          <a:ln w="19050">
+            <a:solidFill>
+              <a:srgbClr val="137C94"/>
+            </a:solidFill>
+            <a:prstDash val="dash"/>
+          </a:ln>
+        </p:spPr>
+      </p:sp>
+      <p:pic>
+        <p:nvPicPr>
+          <p:cNvPr id="13" name="Image 2" descr="preencoded.png">    </p:cNvPr>
+          <p:cNvPicPr>
+            <a:picLocks noChangeAspect="1"/>
+          </p:cNvPicPr>
+          <p:nvPr/>
+        </p:nvPicPr>
+        <p:blipFill>
+          <a:blip r:embed="rId4"/>
+          <a:stretch>
+            <a:fillRect/>
+          </a:stretch>
+        </p:blipFill>
+        <p:spPr>
+          <a:xfrm>
+            <a:off x="9409176" y="2514600"/>
+            <a:ext cx="822960" cy="822960"/>
+          </a:xfrm>
+          <a:prstGeom prst="rect">
+            <a:avLst/>
+          </a:prstGeom>
+        </p:spPr>
+      </p:pic>
+      <p:sp>
+        <p:nvSpPr>
+          <p:cNvPr id="14" name="caption-photo"/>
+          <p:cNvSpPr txBox="1"/>
+          <p:nvPr/>
+        </p:nvSpPr>
+        <p:spPr>
+          <a:xfrm>
+            <a:off x="8275320" y="3502152"/>
+            <a:ext cx="3090672" cy="1005840"/>
+          </a:xfrm>
+          <a:prstGeom prst="rect">
+            <a:avLst/>
+          </a:prstGeom>
+          <a:noFill/>
+          <a:ln/>
+        </p:spPr>
+        <p:txBody>
           <a:bodyPr wrap="square" lIns="0" tIns="0" rIns="0" bIns="0" rtlCol="0" anchor="t"/>
           <a:lstStyle/>
           <a:p>
@@ -5298,7 +5527,7 @@
               <a:buNone/>
             </a:pPr>
             <a:r>
-              <a:rPr lang="en-US" sz="1600" b="1" dirty="0">
+              <a:rPr lang="en-US" sz="1600" b="1" spc="200" kern="0" dirty="0">
                 <a:solidFill>
                   <a:srgbClr val="B8C7D3"/>
                 </a:solidFill>

</xml_diff>

<commit_message>
Rebuild deck on 3D-rendered topic scenes; add Run AI Locally slides
Each slide's background is now a 3D scene of its topic (data-center hall,
Israel's coast at dusk, protest at a data center, laptop running a local
model, efficient AI chip). Slides 4-5 carry the team's new Run AI Locally
idea and plan, condensed to the 6-line rule with the full wording in the
speaker notes. Adds sources S29-S32 and an images note.

Co-Authored-By: Claude Opus 5.5 <noreply@anthropic.com>
Claude-Session: https://claude.ai/code/session_01D1yfgr7znJrRSehnJ7HGe8
</commit_message>
<xml_diff>
--- a/ai-water-deck.pptx
+++ b/ai-water-deck.pptx
@@ -145,7 +145,7 @@
           </c:tx>
           <c:spPr>
             <a:solidFill>
-              <a:srgbClr val="1A9BB8"/>
+              <a:srgbClr val="0F6E84"/>
             </a:solidFill>
             <a:effectLst/>
           </c:spPr>
@@ -159,7 +159,7 @@
                 <a:pPr>
                   <a:defRPr b="1" i="0" strike="noStrike" sz="1800" u="none">
                     <a:solidFill>
-                      <a:srgbClr val="FFFFFF"/>
+                      <a:srgbClr val="0E1B2A"/>
                     </a:solidFill>
                     <a:latin typeface="Calibri"/>
                   </a:defRPr>
@@ -221,7 +221,7 @@
               <a:pPr>
                 <a:defRPr b="1" i="0" strike="noStrike" sz="1800" u="none">
                   <a:solidFill>
-                    <a:srgbClr val="FFFFFF"/>
+                    <a:srgbClr val="0E1B2A"/>
                   </a:solidFill>
                   <a:latin typeface="Calibri"/>
                 </a:defRPr>
@@ -268,7 +268,7 @@
             <a:pPr>
               <a:defRPr sz="1600" b="0" i="0" u="none" strike="noStrike">
                 <a:solidFill>
-                  <a:srgbClr val="FFFFFF"/>
+                  <a:srgbClr val="0E1B2A"/>
                 </a:solidFill>
                 <a:latin typeface="Calibri"/>
               </a:defRPr>
@@ -419,7 +419,7 @@
           </c:tx>
           <c:spPr>
             <a:solidFill>
-              <a:srgbClr val="F2A33A"/>
+              <a:srgbClr val="E8942A"/>
             </a:solidFill>
             <a:effectLst/>
           </c:spPr>
@@ -431,7 +431,7 @@
               <a:lstStyle/>
               <a:p>
                 <a:pPr>
-                  <a:defRPr b="1" i="0" strike="noStrike" sz="1800" u="none">
+                  <a:defRPr b="1" i="0" strike="noStrike" sz="1600" u="none">
                     <a:solidFill>
                       <a:srgbClr val="0E1B2A"/>
                     </a:solidFill>
@@ -487,7 +487,7 @@
             <a:lstStyle/>
             <a:p>
               <a:pPr>
-                <a:defRPr b="1" i="0" strike="noStrike" sz="1800" u="none">
+                <a:defRPr b="1" i="0" strike="noStrike" sz="1600" u="none">
                   <a:solidFill>
                     <a:srgbClr val="0E1B2A"/>
                   </a:solidFill>
@@ -534,7 +534,7 @@
           <a:lstStyle/>
           <a:p>
             <a:pPr>
-              <a:defRPr sz="1500" b="0" i="0" u="none" strike="noStrike">
+              <a:defRPr sz="1300" b="0" i="0" u="none" strike="noStrike">
                 <a:solidFill>
                   <a:srgbClr val="0E1B2A"/>
                 </a:solidFill>
@@ -554,7 +554,7 @@
         <c:axId val="2094734552"/>
         <c:scaling>
           <c:orientation val="minMax"/>
-          <c:max val="30000"/>
+          <c:max val="33000"/>
           <c:min val="0"/>
         </c:scaling>
         <c:delete val="1"/>
@@ -1049,6 +1049,7 @@
             <a:r>
               <a:rPr lang="en-US" dirty="0"/>
               <a:t>SLIDE 1 – talking points and sources (full script: speaker-notes.md)
+- Background: a 3D illustration of the inside of a data center (rows of server racks, cooling pipes).
 - Data centers need water for cooling and electricity to run.
 - ON-SITE vs OFF-SITE [S1 LBNL 2024]: US data centers used 66 billion litres on-site in 2023 and about 800 billion litres off-site (water used by the power plants). 800 / 66 ≈ 12.
 - Google +70% [S6 Google Environmental Reports]: 6.4B gal = 24.2B L (2023); 8.1B gal = 30.7B L (2024); 10.9B gal = 41.3B L (2025). 41.3 / 24.2 = 1.71. Company-reported, all operations.
@@ -1142,9 +1143,11 @@
             <a:r>
               <a:rPr lang="en-US" dirty="0"/>
               <a:t>SLIDE 2 – talking points and sources
+- Background: a 3D illustration of Israel's coast at dusk. Sea, then a desalination plant, then power lines going inland to a lit data-center campus next to Sharon farm fields. It is an illustration, not a map.
+- Chart: data-center grid demand in Israel, megawatts (2026). 1,500 MW already committed; 27,000 MW pending. 27,000 / 1,500 = 18.
 - Desalination share [S17]: sources disagree (State Comptroller 2024: 'about half'; Times of Israel 2026: over 80%). Say 'most', not a single number.
 - Desalination needs electricity [S16]: the State Comptroller (2024) names desalination AND data centers as drivers of 2030 electricity demand.
-- 27,000 MW [S14, S15]: pending data-center requests to Noga, about 3 times Israel's average electricity use. 1,500 MW already committed uses up the planned new supply to 2035 (Ctech). 27,000 / 1,500 = 18.
+- 27,000 MW [S14, S15]: pending data-center requests to Noga, about 3 times Israel's average electricity use. 1,500 MW already committed uses up the planned new supply to 2035 (Ctech).
 - July 2026 freeze [S14]: the Electricity Authority stopped new data-center applications of 8 MW or more for 140 days from 21 July 2026 (until about early December).
 - Near us [S21, S22, S15]: MedOne, two underground data centers in Kfar Yona (next to Lev HaSharon, not inside it), first opens 2026. NED Alpha Campus in Netanya, 42 MW, early 2027. Mega Or asked for 1,111 MW at the old Alliance factory in Hadera.
 - Farms first [S18]: end of Aug 2026, algae shut 5 of 6 big desalination plants. The Water Authority told councils to cut farm and park irrigation. Ramat HaNegev farms lost fresh water completely. NOT caused by data centers. It shows who is cut first.
@@ -1237,12 +1240,13 @@
             <a:r>
               <a:rPr lang="en-US" dirty="0"/>
               <a:t>SLIDE 3 – talking points and sources
+- Background: a 3D illustration (not a real event) of residents protesting at the gate of a data center, seen from a drone.
 - SPNI [S25]: publicly opposed the bill that makes AI server farms 'national infrastructure'. Warned of a 'destructive domino effect' on open land and energy security. Wants the status only for security, intelligence and academic use. Also active: Greenpeace Israel, Green Course.
 - The bill [S24]: Planning and Building Law amendment. AI server farms of 50 MW or more become 'national infrastructure'. They go to the National Infrastructure Committee and skip local and district committees and their objections. Passed first reading on 1 June 2026. FINAL PASSAGE UNVERIFIED: check before presenting.
+- Discrimination (required word): when big projects skip local committees, the people who live next door lose their voice. Critics say this is unfair and can become discrimination against small communities. We did not find proof that Israel targets poor areas on purpose.
 - EU law [S28]: Energy Efficiency Directive (EU) 2023/1791, Article 12. Data centers with 500 kW or more of IT power must report energy and water use every year to an EU database.
 - Water Law [S27]: Water Law 5719-1959, section 1. Water sources in Israel are public property, controlled by the State, for the needs of the residents and the development of the country.
-- Gap: we found no Israeli rule that makes data centers publish their water or power use. Say 'we found no', not 'there is no'.
-- Photo idea: real protest or public meeting photo (e.g. Tucson council, Uruguay protest), or a Knesset photo.</a:t>
+- Gap: we found no Israeli rule that makes data centers publish their water or power use. Say 'we found no', not 'there is no'.</a:t>
             </a:r>
             <a:endParaRPr lang="en-US" dirty="0"/>
           </a:p>
@@ -1330,13 +1334,17 @@
           <a:p>
             <a:r>
               <a:rPr lang="en-US" dirty="0"/>
-              <a:t>SLIDE 4 – talking points
-- This is OUR proposal, not an existing law. It is a policy reform with three parts:
-  1) Disclosure: every data center in Israel above 5 MW publishes its yearly water and electricity use, like the EU rule [S28] (EU threshold: 500 kW). The 5 MW threshold is our choice.
-  2) Local voice: even on the national fast track [S24], the local council and residents still get a public hearing before approval.
-  3) Priority: in a water or power shortage, homes and farms come before servers. In the 2026 shortage, farms were cut first [S18].
-- 'Discrimination': we use it carefully. We did NOT find proof that Israel puts data centers in poor areas on purpose. Our point: when locals lose their say, some communities can be treated unfairly. Fair siting rules prevent that.
-- Awareness idea: an 'AI nutrition label' poster, like a food label. It shows on-site water, off-site water and electricity, with the source and year.</a:t>
+              <a:t>SLIDE 4 – our idea (Speaker C). Full original wording:
+Run AI Locally. Our idea is simple: Make LLMs able to run on normal PCs and laptops.
+- AI companies should optimize their models so they can run locally.
+- People could download an LLM instead of always connecting to a data center.
+- Companies should make models smaller and more efficient.
+- We can use: better optimization, quantization, smaller models, better computer chips.
+- As chips become more powerful, more AI could run locally.
+Instead of only building bigger data centers, make AI more efficient.
+Sources: [S29] Microsoft Phi-3 report (Apr 2024): a 3.8B model, about 1.8 GB at 4 bits, runs on an iPhone 14. [S30] Meta Llama 3.2 1B/3B (Sep 2024): built for phones and edge devices. [S31] QLoRA (2023): 4-bit quantization makes models much smaller. [S32] Copilot+ PCs (May 2024) have an AI chip (NPU) of 40+ TOPS to run AI locally.
+Background: a 3D illustration of a laptop running a small AI model offline.
+Be honest if asked: a laptop's electricity also comes from power plants. The big saving comes from smaller, optimized models doing less work (Google cut energy per prompt 33x in one year by optimizing [S4]).</a:t>
             </a:r>
             <a:endParaRPr lang="en-US" dirty="0"/>
           </a:p>
@@ -1424,10 +1432,19 @@
           <a:p>
             <a:r>
               <a:rPr lang="en-US" dirty="0"/>
-              <a:t>SLIDE 5 – closing
-- Takeaway: AI is not magic in the sky. It uses real water and real electricity, in real places, like Kfar Yona, Netanya and Hadera.
-- Call to action: when a new data center is planned, ask who decides and who pays.
-- Sustainability without social justice is not enough.</a:t>
+              <a:t>SLIDE 5 – our plan and message (Speaker C). Full original wording:
+What Would We Do? Our plan:
+1. AI companies should make local versions of their LLMs.
+2. These models should work on normal PCs and laptops whenever possible.
+3. Companies should focus on optimization instead of just making models bigger.
+4. New chips can gradually make local AI more powerful.
+5. Data centers can still be used for extremely large models and training.
+Possible benefits: less need for new data centers; less land used for AI infrastructure; potentially less water needed for cooling; more AI can run directly on people's computers; more privacy and control for users.
+Our message: Don't just build bigger data centers. Make AI smarter and more efficient.
+Background: a 3D illustration of a small, efficient AI chip in focus, with a big data center blurred behind it.
+Awareness idea: an 'AI label' (like a food label) showing how much water and electricity an AI tool uses, with the source and year.
+Likely question: 'How do you make companies do this?' Answer: public pressure and awareness, plus reporting laws like the EU rule [S28], which make water and power use visible.
+Be honest: training still needs data centers, and local AI still uses electricity. The benefit comes from smaller, more efficient models.</a:t>
             </a:r>
             <a:endParaRPr lang="en-US" dirty="0"/>
           </a:p>
@@ -1781,9 +1798,16 @@
   <p:cSld name="Slide 1">
     <p:bg>
       <p:bgPr>
-        <a:solidFill>
-          <a:srgbClr val="0B2239"/>
-        </a:solidFill>
+        <a:blipFill dpi="0" rotWithShape="1">
+          <a:blip r:embed="rId1">
+            <a:lum/>
+          </a:blip>
+          <a:srcRect/>
+          <a:stretch>
+            <a:fillRect/>
+          </a:stretch>
+        </a:blipFill>
+        <a:effectLst/>
       </p:bgPr>
     </p:bg>
     <p:spTree>
@@ -1808,7 +1832,7 @@
         </p:nvSpPr>
         <p:spPr>
           <a:xfrm>
-            <a:off x="548640" y="502920"/>
+            <a:off x="548640" y="411480"/>
             <a:ext cx="11064240" cy="868680"/>
           </a:xfrm>
           <a:prstGeom prst="rect">
@@ -1825,7 +1849,7 @@
               <a:buNone/>
             </a:pPr>
             <a:r>
-              <a:rPr lang="en-US" sz="4600" dirty="0">
+              <a:rPr lang="en-US" sz="4600" b="1" dirty="0">
                 <a:solidFill>
                   <a:srgbClr val="FFFFFF"/>
                 </a:solidFill>
@@ -1847,7 +1871,7 @@
         </p:nvSpPr>
         <p:spPr>
           <a:xfrm>
-            <a:off x="548640" y="1371600"/>
+            <a:off x="548640" y="1298448"/>
             <a:ext cx="11064240" cy="457200"/>
           </a:xfrm>
           <a:prstGeom prst="rect">
@@ -1864,9 +1888,9 @@
               <a:buNone/>
             </a:pPr>
             <a:r>
-              <a:rPr lang="en-US" sz="2200" dirty="0">
-                <a:solidFill>
-                  <a:srgbClr val="8FA6B8"/>
+              <a:rPr lang="en-US" sz="2200" i="1" dirty="0">
+                <a:solidFill>
+                  <a:srgbClr val="F2A33A"/>
                 </a:solidFill>
                 <a:latin typeface="Calibri" pitchFamily="34" charset="0"/>
                 <a:ea typeface="Calibri" pitchFamily="34" charset="-122"/>
@@ -1886,8 +1910,8 @@
         </p:nvSpPr>
         <p:spPr>
           <a:xfrm>
-            <a:off x="548640" y="2240280"/>
-            <a:ext cx="5897880" cy="3749040"/>
+            <a:off x="548640" y="2148840"/>
+            <a:ext cx="6035040" cy="3931920"/>
           </a:xfrm>
           <a:prstGeom prst="rect">
             <a:avLst/>
@@ -1909,7 +1933,7 @@
             <a:r>
               <a:rPr lang="en-US" sz="2200" dirty="0">
                 <a:solidFill>
-                  <a:srgbClr val="D3DEE6"/>
+                  <a:srgbClr val="E3EBF1"/>
                 </a:solidFill>
                 <a:latin typeface="Calibri" pitchFamily="34" charset="0"/>
                 <a:ea typeface="Calibri" pitchFamily="34" charset="-122"/>
@@ -1931,7 +1955,7 @@
             <a:r>
               <a:rPr lang="en-US" sz="2200" dirty="0">
                 <a:solidFill>
-                  <a:srgbClr val="D3DEE6"/>
+                  <a:srgbClr val="E3EBF1"/>
                 </a:solidFill>
                 <a:latin typeface="Calibri" pitchFamily="34" charset="0"/>
                 <a:ea typeface="Calibri" pitchFamily="34" charset="-122"/>
@@ -1963,7 +1987,7 @@
             <a:r>
               <a:rPr lang="en-US" sz="2200" dirty="0">
                 <a:solidFill>
-                  <a:srgbClr val="D3DEE6"/>
+                  <a:srgbClr val="E3EBF1"/>
                 </a:solidFill>
                 <a:latin typeface="Calibri" pitchFamily="34" charset="0"/>
                 <a:ea typeface="Calibri" pitchFamily="34" charset="-122"/>
@@ -1995,7 +2019,7 @@
             <a:r>
               <a:rPr lang="en-US" sz="2200" dirty="0">
                 <a:solidFill>
-                  <a:srgbClr val="D3DEE6"/>
+                  <a:srgbClr val="E3EBF1"/>
                 </a:solidFill>
                 <a:latin typeface="Calibri" pitchFamily="34" charset="0"/>
                 <a:ea typeface="Calibri" pitchFamily="34" charset="-122"/>
@@ -2038,7 +2062,7 @@
             <a:r>
               <a:rPr lang="en-US" sz="2200" dirty="0">
                 <a:solidFill>
-                  <a:srgbClr val="D3DEE6"/>
+                  <a:srgbClr val="E3EBF1"/>
                 </a:solidFill>
                 <a:latin typeface="Calibri" pitchFamily="34" charset="0"/>
                 <a:ea typeface="Calibri" pitchFamily="34" charset="-122"/>
@@ -2070,7 +2094,7 @@
             <a:r>
               <a:rPr lang="en-US" sz="2200" dirty="0">
                 <a:solidFill>
-                  <a:srgbClr val="D3DEE6"/>
+                  <a:srgbClr val="E3EBF1"/>
                 </a:solidFill>
                 <a:latin typeface="Calibri" pitchFamily="34" charset="0"/>
                 <a:ea typeface="Calibri" pitchFamily="34" charset="-122"/>
@@ -2084,14 +2108,45 @@
       </p:sp>
       <p:sp>
         <p:nvSpPr>
-          <p:cNvPr id="5" name="chart-title"/>
+          <p:cNvPr id="5" name="Shape 3"/>
+          <p:cNvSpPr/>
+          <p:nvPr/>
+        </p:nvSpPr>
+        <p:spPr>
+          <a:xfrm>
+            <a:off x="7543800" y="2011680"/>
+            <a:ext cx="4206240" cy="4069080"/>
+          </a:xfrm>
+          <a:prstGeom prst="roundRect">
+            <a:avLst>
+              <a:gd name="adj" fmla="val 2697"/>
+            </a:avLst>
+          </a:prstGeom>
+          <a:solidFill>
+            <a:srgbClr val="FFFFFF">
+              <a:alpha val="92000"/>
+            </a:srgbClr>
+          </a:solidFill>
+          <a:ln w="12700">
+            <a:solidFill>
+              <a:srgbClr val="FFFFFF">
+                <a:alpha val="0"/>
+              </a:srgbClr>
+            </a:solidFill>
+            <a:prstDash val="solid"/>
+          </a:ln>
+        </p:spPr>
+      </p:sp>
+      <p:sp>
+        <p:nvSpPr>
+          <p:cNvPr id="6" name="chart-title"/>
           <p:cNvSpPr txBox="1"/>
           <p:nvPr/>
         </p:nvSpPr>
         <p:spPr>
           <a:xfrm>
-            <a:off x="6903720" y="2194560"/>
-            <a:ext cx="4754880" cy="777240"/>
+            <a:off x="7772400" y="2148840"/>
+            <a:ext cx="3749040" cy="777240"/>
           </a:xfrm>
           <a:prstGeom prst="rect">
             <a:avLst/>
@@ -2107,9 +2162,9 @@
               <a:buNone/>
             </a:pPr>
             <a:r>
-              <a:rPr lang="en-US" sz="2200" b="1" dirty="0">
-                <a:solidFill>
-                  <a:srgbClr val="FFFFFF"/>
+              <a:rPr lang="en-US" sz="2100" b="1" dirty="0">
+                <a:solidFill>
+                  <a:srgbClr val="0E1B2A"/>
                 </a:solidFill>
                 <a:latin typeface="Calibri" pitchFamily="34" charset="0"/>
                 <a:ea typeface="Calibri" pitchFamily="34" charset="-122"/>
@@ -2117,16 +2172,16 @@
               </a:rPr>
               <a:t>Google’s water use rose 70%</a:t>
             </a:r>
-            <a:endParaRPr lang="en-US" sz="2200" dirty="0"/>
+            <a:endParaRPr lang="en-US" sz="2100" dirty="0"/>
           </a:p>
           <a:p>
             <a:pPr indent="0" marL="0">
               <a:buNone/>
             </a:pPr>
             <a:r>
-              <a:rPr lang="en-US" sz="2200" b="1" dirty="0">
-                <a:solidFill>
-                  <a:srgbClr val="FFFFFF"/>
+              <a:rPr lang="en-US" sz="2100" b="1" dirty="0">
+                <a:solidFill>
+                  <a:srgbClr val="0E1B2A"/>
                 </a:solidFill>
                 <a:latin typeface="Calibri" pitchFamily="34" charset="0"/>
                 <a:ea typeface="Calibri" pitchFamily="34" charset="-122"/>
@@ -2134,20 +2189,20 @@
               </a:rPr>
               <a:t>in two years</a:t>
             </a:r>
-            <a:endParaRPr lang="en-US" sz="2200" dirty="0"/>
+            <a:endParaRPr lang="en-US" sz="2100" dirty="0"/>
           </a:p>
         </p:txBody>
       </p:sp>
       <p:sp>
         <p:nvSpPr>
-          <p:cNvPr id="6" name="caption-chart"/>
+          <p:cNvPr id="7" name="caption-chart"/>
           <p:cNvSpPr txBox="1"/>
           <p:nvPr/>
         </p:nvSpPr>
         <p:spPr>
           <a:xfrm>
-            <a:off x="6903720" y="2971800"/>
-            <a:ext cx="4754880" cy="274320"/>
+            <a:off x="7772400" y="2926080"/>
+            <a:ext cx="3749040" cy="274320"/>
           </a:xfrm>
           <a:prstGeom prst="rect">
             <a:avLst/>
@@ -2163,9 +2218,9 @@
               <a:buNone/>
             </a:pPr>
             <a:r>
-              <a:rPr lang="en-US" sz="1200" dirty="0">
-                <a:solidFill>
-                  <a:srgbClr val="8FA6B8"/>
+              <a:rPr lang="en-US" sz="1100" dirty="0">
+                <a:solidFill>
+                  <a:srgbClr val="4A5A68"/>
                 </a:solidFill>
                 <a:latin typeface="Calibri" pitchFamily="34" charset="0"/>
                 <a:ea typeface="Calibri" pitchFamily="34" charset="-122"/>
@@ -2173,36 +2228,36 @@
               </a:rPr>
               <a:t>Billion litres · all Google operations · company-reported</a:t>
             </a:r>
-            <a:endParaRPr lang="en-US" sz="1200" dirty="0"/>
+            <a:endParaRPr lang="en-US" sz="1100" dirty="0"/>
           </a:p>
         </p:txBody>
       </p:sp>
       <p:graphicFrame>
         <p:nvGraphicFramePr>
-          <p:cNvPr id="7" name="Chart 0" descr=""/>
+          <p:cNvPr id="8" name="Chart 0" descr=""/>
           <p:cNvGraphicFramePr/>
           <p:nvPr/>
         </p:nvGraphicFramePr>
         <p:xfrm>
-          <a:off x="6720840" y="3246120"/>
-          <a:ext cx="5029200" cy="2880360"/>
+          <a:off x="7635240" y="3154680"/>
+          <a:ext cx="4023360" cy="2834640"/>
         </p:xfrm>
         <a:graphic xmlns:a="http://schemas.openxmlformats.org/drawingml/2006/main">
           <a:graphicData uri="http://schemas.openxmlformats.org/drawingml/2006/chart">
-            <c:chart xmlns:c="http://schemas.openxmlformats.org/drawingml/2006/chart" r:id="rId1"/>
+            <c:chart xmlns:c="http://schemas.openxmlformats.org/drawingml/2006/chart" r:id="rId2"/>
           </a:graphicData>
         </a:graphic>
       </p:graphicFrame>
       <p:sp>
         <p:nvSpPr>
-          <p:cNvPr id="8" name="caption-sources"/>
+          <p:cNvPr id="9" name="caption-sources"/>
           <p:cNvSpPr txBox="1"/>
           <p:nvPr/>
         </p:nvSpPr>
         <p:spPr>
           <a:xfrm>
-            <a:off x="548640" y="6309360"/>
-            <a:ext cx="11064240" cy="365760"/>
+            <a:off x="548640" y="6355080"/>
+            <a:ext cx="11064240" cy="347472"/>
           </a:xfrm>
           <a:prstGeom prst="rect">
             <a:avLst/>
@@ -2218,17 +2273,17 @@
               <a:buNone/>
             </a:pPr>
             <a:r>
-              <a:rPr lang="en-US" sz="1100" dirty="0">
-                <a:solidFill>
-                  <a:srgbClr val="8FA6B8"/>
-                </a:solidFill>
-                <a:latin typeface="Calibri" pitchFamily="34" charset="0"/>
-                <a:ea typeface="Calibri" pitchFamily="34" charset="-122"/>
-                <a:cs typeface="Calibri" pitchFamily="34" charset="-120"/>
-              </a:rPr>
-              <a:t>Sources: LBNL, 2024 US Data Center Energy Usage Report · Google Environmental Reports 2024–2026 · The Guardian (Jul 2023), Mongabay (Nov 2023), DCD on Uruguay</a:t>
-            </a:r>
-            <a:endParaRPr lang="en-US" sz="1100" dirty="0"/>
+              <a:rPr lang="en-US" sz="1050" dirty="0">
+                <a:solidFill>
+                  <a:srgbClr val="A9BCCB"/>
+                </a:solidFill>
+                <a:latin typeface="Calibri" pitchFamily="34" charset="0"/>
+                <a:ea typeface="Calibri" pitchFamily="34" charset="-122"/>
+                <a:cs typeface="Calibri" pitchFamily="34" charset="-120"/>
+              </a:rPr>
+              <a:t>Sources: LBNL 2024 US Data Center Energy Report · Google Environmental Reports 2024–26 · The Guardian 2023, Mongabay 2023  ·  Images: 3D illustrations made for this presentation</a:t>
+            </a:r>
+            <a:endParaRPr lang="en-US" sz="1050" dirty="0"/>
           </a:p>
         </p:txBody>
       </p:sp>
@@ -2245,9 +2300,16 @@
   <p:cSld name="Slide 2">
     <p:bg>
       <p:bgPr>
-        <a:solidFill>
-          <a:srgbClr val="FFFFFF"/>
-        </a:solidFill>
+        <a:blipFill dpi="0" rotWithShape="1">
+          <a:blip r:embed="rId1">
+            <a:lum/>
+          </a:blip>
+          <a:srcRect/>
+          <a:stretch>
+            <a:fillRect/>
+          </a:stretch>
+        </a:blipFill>
+        <a:effectLst/>
       </p:bgPr>
     </p:bg>
     <p:spTree>
@@ -2272,7 +2334,7 @@
         </p:nvSpPr>
         <p:spPr>
           <a:xfrm>
-            <a:off x="548640" y="457200"/>
+            <a:off x="548640" y="365760"/>
             <a:ext cx="11064240" cy="822960"/>
           </a:xfrm>
           <a:prstGeom prst="rect">
@@ -2289,9 +2351,9 @@
               <a:buNone/>
             </a:pPr>
             <a:r>
-              <a:rPr lang="en-US" sz="4000" dirty="0">
-                <a:solidFill>
-                  <a:srgbClr val="0E1B2A"/>
+              <a:rPr lang="en-US" sz="4000" b="1" dirty="0">
+                <a:solidFill>
+                  <a:srgbClr val="FFFFFF"/>
                 </a:solidFill>
                 <a:latin typeface="Cambria" pitchFamily="34" charset="0"/>
                 <a:ea typeface="Cambria" pitchFamily="34" charset="-122"/>
@@ -2305,46 +2367,14 @@
       </p:sp>
       <p:sp>
         <p:nvSpPr>
-          <p:cNvPr id="3" name="Shape 1"/>
-          <p:cNvSpPr/>
+          <p:cNvPr id="3" name="body"/>
+          <p:cNvSpPr txBox="1"/>
           <p:nvPr/>
         </p:nvSpPr>
         <p:spPr>
           <a:xfrm>
-            <a:off x="548640" y="1508760"/>
-            <a:ext cx="4983480" cy="4526280"/>
-          </a:xfrm>
-          <a:prstGeom prst="rect">
-            <a:avLst/>
-          </a:prstGeom>
-          <a:solidFill>
-            <a:srgbClr val="F1F4F6"/>
-          </a:solidFill>
-          <a:ln w="9525">
-            <a:solidFill>
-              <a:srgbClr val="F1F4F6"/>
-            </a:solidFill>
-            <a:prstDash val="solid"/>
-          </a:ln>
-          <a:effectLst>
-            <a:outerShdw sx="100000" sy="100000" kx="0" ky="0" algn="bl" rotWithShape="0" blurRad="254000" dist="63500" dir="5400000">
-              <a:srgbClr val="000000">
-                <a:alpha val="14000"/>
-              </a:srgbClr>
-            </a:outerShdw>
-          </a:effectLst>
-        </p:spPr>
-      </p:sp>
-      <p:sp>
-        <p:nvSpPr>
-          <p:cNvPr id="4" name="chart-title"/>
-          <p:cNvSpPr txBox="1"/>
-          <p:nvPr/>
-        </p:nvSpPr>
-        <p:spPr>
-          <a:xfrm>
-            <a:off x="822960" y="1691640"/>
-            <a:ext cx="4480560" cy="777240"/>
+            <a:off x="548640" y="1417320"/>
+            <a:ext cx="5943600" cy="4480560"/>
           </a:xfrm>
           <a:prstGeom prst="rect">
             <a:avLst/>
@@ -2356,51 +2386,251 @@
           <a:bodyPr wrap="square" lIns="0" tIns="0" rIns="0" bIns="0" rtlCol="0" anchor="t"/>
           <a:lstStyle/>
           <a:p>
-            <a:pPr indent="0" marL="0">
-              <a:buNone/>
-            </a:pPr>
-            <a:r>
-              <a:rPr lang="en-US" sz="2200" b="1" dirty="0">
-                <a:solidFill>
-                  <a:srgbClr val="0E1B2A"/>
-                </a:solidFill>
-                <a:latin typeface="Calibri" pitchFamily="34" charset="0"/>
-                <a:ea typeface="Calibri" pitchFamily="34" charset="-122"/>
-                <a:cs typeface="Calibri" pitchFamily="34" charset="-120"/>
-              </a:rPr>
-              <a:t>Requests are 18× what</a:t>
-            </a:r>
-            <a:endParaRPr lang="en-US" sz="2200" dirty="0"/>
-          </a:p>
-          <a:p>
-            <a:pPr indent="0" marL="0">
-              <a:buNone/>
-            </a:pPr>
-            <a:r>
-              <a:rPr lang="en-US" sz="2200" b="1" dirty="0">
-                <a:solidFill>
-                  <a:srgbClr val="0E1B2A"/>
-                </a:solidFill>
-                <a:latin typeface="Calibri" pitchFamily="34" charset="0"/>
-                <a:ea typeface="Calibri" pitchFamily="34" charset="-122"/>
-                <a:cs typeface="Calibri" pitchFamily="34" charset="-120"/>
-              </a:rPr>
-              <a:t>is already promised</a:t>
-            </a:r>
-            <a:endParaRPr lang="en-US" sz="2200" dirty="0"/>
+            <a:pPr marL="279400" indent="-279400">
+              <a:spcAft>
+                <a:spcPts val="1300"/>
+              </a:spcAft>
+              <a:buSzPct val="100000"/>
+              <a:buChar char="•"/>
+            </a:pPr>
+            <a:r>
+              <a:rPr lang="en-US" sz="2100" dirty="0">
+                <a:solidFill>
+                  <a:srgbClr val="E3EBF1"/>
+                </a:solidFill>
+                <a:latin typeface="Calibri" pitchFamily="34" charset="0"/>
+                <a:ea typeface="Calibri" pitchFamily="34" charset="-122"/>
+                <a:cs typeface="Calibri" pitchFamily="34" charset="-120"/>
+              </a:rPr>
+              <a:t>Most of our tap water is </a:t>
+            </a:r>
+            <a:r>
+              <a:rPr lang="en-US" sz="2100" b="1" dirty="0">
+                <a:solidFill>
+                  <a:srgbClr val="8FD3E8"/>
+                </a:solidFill>
+                <a:latin typeface="Calibri" pitchFamily="34" charset="0"/>
+                <a:ea typeface="Calibri" pitchFamily="34" charset="-122"/>
+                <a:cs typeface="Calibri" pitchFamily="34" charset="-120"/>
+              </a:rPr>
+              <a:t>desalinated</a:t>
+            </a:r>
+            <a:endParaRPr lang="en-US" sz="2100" dirty="0"/>
+          </a:p>
+          <a:p>
+            <a:pPr marL="279400" indent="-279400">
+              <a:spcAft>
+                <a:spcPts val="1300"/>
+              </a:spcAft>
+              <a:buSzPct val="100000"/>
+              <a:buChar char="•"/>
+            </a:pPr>
+            <a:r>
+              <a:rPr lang="en-US" sz="2100" dirty="0">
+                <a:solidFill>
+                  <a:srgbClr val="E3EBF1"/>
+                </a:solidFill>
+                <a:latin typeface="Calibri" pitchFamily="34" charset="0"/>
+                <a:ea typeface="Calibri" pitchFamily="34" charset="-122"/>
+                <a:cs typeface="Calibri" pitchFamily="34" charset="-120"/>
+              </a:rPr>
+              <a:t>Desalination needs </a:t>
+            </a:r>
+            <a:r>
+              <a:rPr lang="en-US" sz="2100" b="1" dirty="0">
+                <a:solidFill>
+                  <a:srgbClr val="FFFFFF"/>
+                </a:solidFill>
+                <a:latin typeface="Calibri" pitchFamily="34" charset="0"/>
+                <a:ea typeface="Calibri" pitchFamily="34" charset="-122"/>
+                <a:cs typeface="Calibri" pitchFamily="34" charset="-120"/>
+              </a:rPr>
+              <a:t>a lot of electricity</a:t>
+            </a:r>
+            <a:endParaRPr lang="en-US" sz="2100" dirty="0"/>
+          </a:p>
+          <a:p>
+            <a:pPr marL="279400" indent="-279400">
+              <a:spcAft>
+                <a:spcPts val="1300"/>
+              </a:spcAft>
+              <a:buSzPct val="100000"/>
+              <a:buChar char="•"/>
+            </a:pPr>
+            <a:r>
+              <a:rPr lang="en-US" sz="2100" dirty="0">
+                <a:solidFill>
+                  <a:srgbClr val="E3EBF1"/>
+                </a:solidFill>
+                <a:latin typeface="Calibri" pitchFamily="34" charset="0"/>
+                <a:ea typeface="Calibri" pitchFamily="34" charset="-122"/>
+                <a:cs typeface="Calibri" pitchFamily="34" charset="-120"/>
+              </a:rPr>
+              <a:t>Data centers requested </a:t>
+            </a:r>
+            <a:r>
+              <a:rPr lang="en-US" sz="2100" b="1" dirty="0">
+                <a:solidFill>
+                  <a:srgbClr val="F2A33A"/>
+                </a:solidFill>
+                <a:latin typeface="Calibri" pitchFamily="34" charset="0"/>
+                <a:ea typeface="Calibri" pitchFamily="34" charset="-122"/>
+                <a:cs typeface="Calibri" pitchFamily="34" charset="-120"/>
+              </a:rPr>
+              <a:t>27,000 MW</a:t>
+            </a:r>
+            <a:r>
+              <a:rPr lang="en-US" sz="2100" dirty="0">
+                <a:solidFill>
+                  <a:srgbClr val="E3EBF1"/>
+                </a:solidFill>
+                <a:latin typeface="Calibri" pitchFamily="34" charset="0"/>
+                <a:ea typeface="Calibri" pitchFamily="34" charset="-122"/>
+                <a:cs typeface="Calibri" pitchFamily="34" charset="-120"/>
+              </a:rPr>
+              <a:t> (≈3× average)</a:t>
+            </a:r>
+            <a:endParaRPr lang="en-US" sz="2100" dirty="0"/>
+          </a:p>
+          <a:p>
+            <a:pPr marL="279400" indent="-279400">
+              <a:spcAft>
+                <a:spcPts val="1300"/>
+              </a:spcAft>
+              <a:buSzPct val="100000"/>
+              <a:buChar char="•"/>
+            </a:pPr>
+            <a:r>
+              <a:rPr lang="en-US" sz="2100" b="1" dirty="0">
+                <a:solidFill>
+                  <a:srgbClr val="FFFFFF"/>
+                </a:solidFill>
+                <a:latin typeface="Calibri" pitchFamily="34" charset="0"/>
+                <a:ea typeface="Calibri" pitchFamily="34" charset="-122"/>
+                <a:cs typeface="Calibri" pitchFamily="34" charset="-120"/>
+              </a:rPr>
+              <a:t>July 2026: </a:t>
+            </a:r>
+            <a:r>
+              <a:rPr lang="en-US" sz="2100" dirty="0">
+                <a:solidFill>
+                  <a:srgbClr val="E3EBF1"/>
+                </a:solidFill>
+                <a:latin typeface="Calibri" pitchFamily="34" charset="0"/>
+                <a:ea typeface="Calibri" pitchFamily="34" charset="-122"/>
+                <a:cs typeface="Calibri" pitchFamily="34" charset="-120"/>
+              </a:rPr>
+              <a:t>regulator froze new connections</a:t>
+            </a:r>
+            <a:endParaRPr lang="en-US" sz="2100" dirty="0"/>
+          </a:p>
+          <a:p>
+            <a:pPr marL="279400" indent="-279400">
+              <a:spcAft>
+                <a:spcPts val="1300"/>
+              </a:spcAft>
+              <a:buSzPct val="100000"/>
+              <a:buChar char="•"/>
+            </a:pPr>
+            <a:r>
+              <a:rPr lang="en-US" sz="2100" b="1" dirty="0">
+                <a:solidFill>
+                  <a:srgbClr val="FFFFFF"/>
+                </a:solidFill>
+                <a:latin typeface="Calibri" pitchFamily="34" charset="0"/>
+                <a:ea typeface="Calibri" pitchFamily="34" charset="-122"/>
+                <a:cs typeface="Calibri" pitchFamily="34" charset="-120"/>
+              </a:rPr>
+              <a:t>Near us: </a:t>
+            </a:r>
+            <a:r>
+              <a:rPr lang="en-US" sz="2100" dirty="0">
+                <a:solidFill>
+                  <a:srgbClr val="E3EBF1"/>
+                </a:solidFill>
+                <a:latin typeface="Calibri" pitchFamily="34" charset="0"/>
+                <a:ea typeface="Calibri" pitchFamily="34" charset="-122"/>
+                <a:cs typeface="Calibri" pitchFamily="34" charset="-120"/>
+              </a:rPr>
+              <a:t>Kfar Yona, Netanya, Hadera projects</a:t>
+            </a:r>
+            <a:endParaRPr lang="en-US" sz="2100" dirty="0"/>
+          </a:p>
+          <a:p>
+            <a:pPr marL="279400" indent="-279400">
+              <a:spcAft>
+                <a:spcPts val="1300"/>
+              </a:spcAft>
+              <a:buSzPct val="100000"/>
+              <a:buChar char="•"/>
+            </a:pPr>
+            <a:r>
+              <a:rPr lang="en-US" sz="2100" b="1" dirty="0">
+                <a:solidFill>
+                  <a:srgbClr val="FFFFFF"/>
+                </a:solidFill>
+                <a:latin typeface="Calibri" pitchFamily="34" charset="0"/>
+                <a:ea typeface="Calibri" pitchFamily="34" charset="-122"/>
+                <a:cs typeface="Calibri" pitchFamily="34" charset="-120"/>
+              </a:rPr>
+              <a:t>2026 water shortage: </a:t>
+            </a:r>
+            <a:r>
+              <a:rPr lang="en-US" sz="2100" dirty="0">
+                <a:solidFill>
+                  <a:srgbClr val="E3EBF1"/>
+                </a:solidFill>
+                <a:latin typeface="Calibri" pitchFamily="34" charset="0"/>
+                <a:ea typeface="Calibri" pitchFamily="34" charset="-122"/>
+                <a:cs typeface="Calibri" pitchFamily="34" charset="-120"/>
+              </a:rPr>
+              <a:t>farms were cut first</a:t>
+            </a:r>
+            <a:endParaRPr lang="en-US" sz="2100" dirty="0"/>
           </a:p>
         </p:txBody>
       </p:sp>
       <p:sp>
         <p:nvSpPr>
-          <p:cNvPr id="5" name="caption-chart"/>
+          <p:cNvPr id="4" name="Shape 2"/>
+          <p:cNvSpPr/>
+          <p:nvPr/>
+        </p:nvSpPr>
+        <p:spPr>
+          <a:xfrm>
+            <a:off x="7406640" y="1280160"/>
+            <a:ext cx="4343400" cy="2560320"/>
+          </a:xfrm>
+          <a:prstGeom prst="roundRect">
+            <a:avLst>
+              <a:gd name="adj" fmla="val 4286"/>
+            </a:avLst>
+          </a:prstGeom>
+          <a:solidFill>
+            <a:srgbClr val="FFFFFF">
+              <a:alpha val="92000"/>
+            </a:srgbClr>
+          </a:solidFill>
+          <a:ln w="12700">
+            <a:solidFill>
+              <a:srgbClr val="FFFFFF">
+                <a:alpha val="0"/>
+              </a:srgbClr>
+            </a:solidFill>
+            <a:prstDash val="solid"/>
+          </a:ln>
+        </p:spPr>
+      </p:sp>
+      <p:sp>
+        <p:nvSpPr>
+          <p:cNvPr id="5" name="chart-title"/>
           <p:cNvSpPr txBox="1"/>
           <p:nvPr/>
         </p:nvSpPr>
         <p:spPr>
           <a:xfrm>
-            <a:off x="822960" y="2468880"/>
-            <a:ext cx="4480560" cy="274320"/>
+            <a:off x="7635240" y="1371600"/>
+            <a:ext cx="3931920" cy="658368"/>
           </a:xfrm>
           <a:prstGeom prst="rect">
             <a:avLst/>
@@ -2416,17 +2646,34 @@
               <a:buNone/>
             </a:pPr>
             <a:r>
-              <a:rPr lang="en-US" sz="1200" dirty="0">
-                <a:solidFill>
-                  <a:srgbClr val="5B6875"/>
-                </a:solidFill>
-                <a:latin typeface="Calibri" pitchFamily="34" charset="0"/>
-                <a:ea typeface="Calibri" pitchFamily="34" charset="-122"/>
-                <a:cs typeface="Calibri" pitchFamily="34" charset="-120"/>
-              </a:rPr>
-              <a:t>Data-center grid demand in Israel, megawatts (2026)</a:t>
-            </a:r>
-            <a:endParaRPr lang="en-US" sz="1200" dirty="0"/>
+              <a:rPr lang="en-US" sz="2000" b="1" dirty="0">
+                <a:solidFill>
+                  <a:srgbClr val="0E1B2A"/>
+                </a:solidFill>
+                <a:latin typeface="Calibri" pitchFamily="34" charset="0"/>
+                <a:ea typeface="Calibri" pitchFamily="34" charset="-122"/>
+                <a:cs typeface="Calibri" pitchFamily="34" charset="-120"/>
+              </a:rPr>
+              <a:t>Requests are 18× what</a:t>
+            </a:r>
+            <a:endParaRPr lang="en-US" sz="2000" dirty="0"/>
+          </a:p>
+          <a:p>
+            <a:pPr indent="0" marL="0">
+              <a:buNone/>
+            </a:pPr>
+            <a:r>
+              <a:rPr lang="en-US" sz="2000" b="1" dirty="0">
+                <a:solidFill>
+                  <a:srgbClr val="0E1B2A"/>
+                </a:solidFill>
+                <a:latin typeface="Calibri" pitchFamily="34" charset="0"/>
+                <a:ea typeface="Calibri" pitchFamily="34" charset="-122"/>
+                <a:cs typeface="Calibri" pitchFamily="34" charset="-120"/>
+              </a:rPr>
+              <a:t>is already promised</a:t>
+            </a:r>
+            <a:endParaRPr lang="en-US" sz="2000" dirty="0"/>
           </a:p>
         </p:txBody>
       </p:sp>
@@ -2437,289 +2684,25 @@
           <p:nvPr/>
         </p:nvGraphicFramePr>
         <p:xfrm>
-          <a:off x="685800" y="2743200"/>
-          <a:ext cx="4709160" cy="2788920"/>
+          <a:off x="7498080" y="2011680"/>
+          <a:ext cx="4206240" cy="1783080"/>
         </p:xfrm>
         <a:graphic xmlns:a="http://schemas.openxmlformats.org/drawingml/2006/main">
           <a:graphicData uri="http://schemas.openxmlformats.org/drawingml/2006/chart">
-            <c:chart xmlns:c="http://schemas.openxmlformats.org/drawingml/2006/chart" r:id="rId1"/>
+            <c:chart xmlns:c="http://schemas.openxmlformats.org/drawingml/2006/chart" r:id="rId2"/>
           </a:graphicData>
         </a:graphic>
       </p:graphicFrame>
       <p:sp>
         <p:nvSpPr>
-          <p:cNvPr id="7" name="caption-chart"/>
+          <p:cNvPr id="7" name="caption-sources"/>
           <p:cNvSpPr txBox="1"/>
           <p:nvPr/>
         </p:nvSpPr>
         <p:spPr>
           <a:xfrm>
-            <a:off x="822960" y="5532120"/>
-            <a:ext cx="4480560" cy="411480"/>
-          </a:xfrm>
-          <a:prstGeom prst="rect">
-            <a:avLst/>
-          </a:prstGeom>
-          <a:noFill/>
-          <a:ln/>
-        </p:spPr>
-        <p:txBody>
-          <a:bodyPr wrap="square" lIns="0" tIns="0" rIns="0" bIns="0" rtlCol="0" anchor="t"/>
-          <a:lstStyle/>
-          <a:p>
-            <a:pPr indent="0" marL="0">
-              <a:buNone/>
-            </a:pPr>
-            <a:r>
-              <a:rPr lang="en-US" sz="1200" dirty="0">
-                <a:solidFill>
-                  <a:srgbClr val="5B6875"/>
-                </a:solidFill>
-                <a:latin typeface="Calibri" pitchFamily="34" charset="0"/>
-                <a:ea typeface="Calibri" pitchFamily="34" charset="-122"/>
-                <a:cs typeface="Calibri" pitchFamily="34" charset="-120"/>
-              </a:rPr>
-              <a:t>Committed demand already uses the planned new supply to 2035</a:t>
-            </a:r>
-            <a:endParaRPr lang="en-US" sz="1200" dirty="0"/>
-          </a:p>
-        </p:txBody>
-      </p:sp>
-      <p:sp>
-        <p:nvSpPr>
-          <p:cNvPr id="8" name="body"/>
-          <p:cNvSpPr txBox="1"/>
-          <p:nvPr/>
-        </p:nvSpPr>
-        <p:spPr>
-          <a:xfrm>
-            <a:off x="5943600" y="1645920"/>
-            <a:ext cx="5715000" cy="4389120"/>
-          </a:xfrm>
-          <a:prstGeom prst="rect">
-            <a:avLst/>
-          </a:prstGeom>
-          <a:noFill/>
-          <a:ln/>
-        </p:spPr>
-        <p:txBody>
-          <a:bodyPr wrap="square" lIns="0" tIns="0" rIns="0" bIns="0" rtlCol="0" anchor="t"/>
-          <a:lstStyle/>
-          <a:p>
-            <a:pPr marL="279400" indent="-279400">
-              <a:spcAft>
-                <a:spcPts val="1300"/>
-              </a:spcAft>
-              <a:buSzPct val="100000"/>
-              <a:buChar char="•"/>
-            </a:pPr>
-            <a:r>
-              <a:rPr lang="en-US" sz="2100" dirty="0">
-                <a:solidFill>
-                  <a:srgbClr val="0E1B2A"/>
-                </a:solidFill>
-                <a:latin typeface="Calibri" pitchFamily="34" charset="0"/>
-                <a:ea typeface="Calibri" pitchFamily="34" charset="-122"/>
-                <a:cs typeface="Calibri" pitchFamily="34" charset="-120"/>
-              </a:rPr>
-              <a:t>Most of our tap water is </a:t>
-            </a:r>
-            <a:r>
-              <a:rPr lang="en-US" sz="2100" b="1" dirty="0">
-                <a:solidFill>
-                  <a:srgbClr val="0F6E84"/>
-                </a:solidFill>
-                <a:latin typeface="Calibri" pitchFamily="34" charset="0"/>
-                <a:ea typeface="Calibri" pitchFamily="34" charset="-122"/>
-                <a:cs typeface="Calibri" pitchFamily="34" charset="-120"/>
-              </a:rPr>
-              <a:t>desalinated</a:t>
-            </a:r>
-            <a:endParaRPr lang="en-US" sz="2100" dirty="0"/>
-          </a:p>
-          <a:p>
-            <a:pPr marL="279400" indent="-279400">
-              <a:spcAft>
-                <a:spcPts val="1300"/>
-              </a:spcAft>
-              <a:buSzPct val="100000"/>
-              <a:buChar char="•"/>
-            </a:pPr>
-            <a:r>
-              <a:rPr lang="en-US" sz="2100" dirty="0">
-                <a:solidFill>
-                  <a:srgbClr val="0E1B2A"/>
-                </a:solidFill>
-                <a:latin typeface="Calibri" pitchFamily="34" charset="0"/>
-                <a:ea typeface="Calibri" pitchFamily="34" charset="-122"/>
-                <a:cs typeface="Calibri" pitchFamily="34" charset="-120"/>
-              </a:rPr>
-              <a:t>Desalination needs </a:t>
-            </a:r>
-            <a:r>
-              <a:rPr lang="en-US" sz="2100" b="1" dirty="0">
-                <a:solidFill>
-                  <a:srgbClr val="0E1B2A"/>
-                </a:solidFill>
-                <a:latin typeface="Calibri" pitchFamily="34" charset="0"/>
-                <a:ea typeface="Calibri" pitchFamily="34" charset="-122"/>
-                <a:cs typeface="Calibri" pitchFamily="34" charset="-120"/>
-              </a:rPr>
-              <a:t>a lot of electricity</a:t>
-            </a:r>
-            <a:endParaRPr lang="en-US" sz="2100" dirty="0"/>
-          </a:p>
-          <a:p>
-            <a:pPr marL="279400" indent="-279400">
-              <a:spcAft>
-                <a:spcPts val="1300"/>
-              </a:spcAft>
-              <a:buSzPct val="100000"/>
-              <a:buChar char="•"/>
-            </a:pPr>
-            <a:r>
-              <a:rPr lang="en-US" sz="2100" dirty="0">
-                <a:solidFill>
-                  <a:srgbClr val="0E1B2A"/>
-                </a:solidFill>
-                <a:latin typeface="Calibri" pitchFamily="34" charset="0"/>
-                <a:ea typeface="Calibri" pitchFamily="34" charset="-122"/>
-                <a:cs typeface="Calibri" pitchFamily="34" charset="-120"/>
-              </a:rPr>
-              <a:t>Data centers requested </a:t>
-            </a:r>
-            <a:r>
-              <a:rPr lang="en-US" sz="2100" b="1" dirty="0">
-                <a:solidFill>
-                  <a:srgbClr val="A85A0C"/>
-                </a:solidFill>
-                <a:latin typeface="Calibri" pitchFamily="34" charset="0"/>
-                <a:ea typeface="Calibri" pitchFamily="34" charset="-122"/>
-                <a:cs typeface="Calibri" pitchFamily="34" charset="-120"/>
-              </a:rPr>
-              <a:t>27,000 MW</a:t>
-            </a:r>
-            <a:r>
-              <a:rPr lang="en-US" sz="2100" dirty="0">
-                <a:solidFill>
-                  <a:srgbClr val="0E1B2A"/>
-                </a:solidFill>
-                <a:latin typeface="Calibri" pitchFamily="34" charset="0"/>
-                <a:ea typeface="Calibri" pitchFamily="34" charset="-122"/>
-                <a:cs typeface="Calibri" pitchFamily="34" charset="-120"/>
-              </a:rPr>
-              <a:t> (≈3× average)</a:t>
-            </a:r>
-            <a:endParaRPr lang="en-US" sz="2100" dirty="0"/>
-          </a:p>
-          <a:p>
-            <a:pPr marL="279400" indent="-279400">
-              <a:spcAft>
-                <a:spcPts val="1300"/>
-              </a:spcAft>
-              <a:buSzPct val="100000"/>
-              <a:buChar char="•"/>
-            </a:pPr>
-            <a:r>
-              <a:rPr lang="en-US" sz="2100" b="1" dirty="0">
-                <a:solidFill>
-                  <a:srgbClr val="0E1B2A"/>
-                </a:solidFill>
-                <a:latin typeface="Calibri" pitchFamily="34" charset="0"/>
-                <a:ea typeface="Calibri" pitchFamily="34" charset="-122"/>
-                <a:cs typeface="Calibri" pitchFamily="34" charset="-120"/>
-              </a:rPr>
-              <a:t>July 2026: </a:t>
-            </a:r>
-            <a:r>
-              <a:rPr lang="en-US" sz="2100" dirty="0">
-                <a:solidFill>
-                  <a:srgbClr val="0E1B2A"/>
-                </a:solidFill>
-                <a:latin typeface="Calibri" pitchFamily="34" charset="0"/>
-                <a:ea typeface="Calibri" pitchFamily="34" charset="-122"/>
-                <a:cs typeface="Calibri" pitchFamily="34" charset="-120"/>
-              </a:rPr>
-              <a:t>regulator froze new connections</a:t>
-            </a:r>
-            <a:endParaRPr lang="en-US" sz="2100" dirty="0"/>
-          </a:p>
-          <a:p>
-            <a:pPr marL="279400" indent="-279400">
-              <a:spcAft>
-                <a:spcPts val="1300"/>
-              </a:spcAft>
-              <a:buSzPct val="100000"/>
-              <a:buChar char="•"/>
-            </a:pPr>
-            <a:r>
-              <a:rPr lang="en-US" sz="2100" b="1" dirty="0">
-                <a:solidFill>
-                  <a:srgbClr val="0E1B2A"/>
-                </a:solidFill>
-                <a:latin typeface="Calibri" pitchFamily="34" charset="0"/>
-                <a:ea typeface="Calibri" pitchFamily="34" charset="-122"/>
-                <a:cs typeface="Calibri" pitchFamily="34" charset="-120"/>
-              </a:rPr>
-              <a:t>Near us: </a:t>
-            </a:r>
-            <a:r>
-              <a:rPr lang="en-US" sz="2100" dirty="0">
-                <a:solidFill>
-                  <a:srgbClr val="0E1B2A"/>
-                </a:solidFill>
-                <a:latin typeface="Calibri" pitchFamily="34" charset="0"/>
-                <a:ea typeface="Calibri" pitchFamily="34" charset="-122"/>
-                <a:cs typeface="Calibri" pitchFamily="34" charset="-120"/>
-              </a:rPr>
-              <a:t>Kfar Yona, Netanya, Hadera projects</a:t>
-            </a:r>
-            <a:endParaRPr lang="en-US" sz="2100" dirty="0"/>
-          </a:p>
-          <a:p>
-            <a:pPr marL="279400" indent="-279400">
-              <a:spcAft>
-                <a:spcPts val="1300"/>
-              </a:spcAft>
-              <a:buSzPct val="100000"/>
-              <a:buChar char="•"/>
-            </a:pPr>
-            <a:r>
-              <a:rPr lang="en-US" sz="2100" b="1" dirty="0">
-                <a:solidFill>
-                  <a:srgbClr val="0E1B2A"/>
-                </a:solidFill>
-                <a:latin typeface="Calibri" pitchFamily="34" charset="0"/>
-                <a:ea typeface="Calibri" pitchFamily="34" charset="-122"/>
-                <a:cs typeface="Calibri" pitchFamily="34" charset="-120"/>
-              </a:rPr>
-              <a:t>2026 water shortage: </a:t>
-            </a:r>
-            <a:r>
-              <a:rPr lang="en-US" sz="2100" dirty="0">
-                <a:solidFill>
-                  <a:srgbClr val="0E1B2A"/>
-                </a:solidFill>
-                <a:latin typeface="Calibri" pitchFamily="34" charset="0"/>
-                <a:ea typeface="Calibri" pitchFamily="34" charset="-122"/>
-                <a:cs typeface="Calibri" pitchFamily="34" charset="-120"/>
-              </a:rPr>
-              <a:t>farms were cut first</a:t>
-            </a:r>
-            <a:endParaRPr lang="en-US" sz="2100" dirty="0"/>
-          </a:p>
-        </p:txBody>
-      </p:sp>
-      <p:sp>
-        <p:nvSpPr>
-          <p:cNvPr id="9" name="caption-sources"/>
-          <p:cNvSpPr txBox="1"/>
-          <p:nvPr/>
-        </p:nvSpPr>
-        <p:spPr>
-          <a:xfrm>
-            <a:off x="548640" y="6309360"/>
-            <a:ext cx="11064240" cy="365760"/>
+            <a:off x="548640" y="6355080"/>
+            <a:ext cx="11064240" cy="347472"/>
           </a:xfrm>
           <a:prstGeom prst="rect">
             <a:avLst/>
@@ -2735,17 +2718,17 @@
               <a:buNone/>
             </a:pPr>
             <a:r>
-              <a:rPr lang="en-US" sz="1100" dirty="0">
-                <a:solidFill>
-                  <a:srgbClr val="5B6875"/>
-                </a:solidFill>
-                <a:latin typeface="Calibri" pitchFamily="34" charset="0"/>
-                <a:ea typeface="Calibri" pitchFamily="34" charset="-122"/>
-                <a:cs typeface="Calibri" pitchFamily="34" charset="-120"/>
-              </a:rPr>
-              <a:t>Sources: Electricity Authority &amp; Noga via DCD, JNS, Ctech (Jul 2026) · State Comptroller (2024) · DCD, Globes, Ctech (local projects) · Times of Israel, CNN (Sep 2026)</a:t>
-            </a:r>
-            <a:endParaRPr lang="en-US" sz="1100" dirty="0"/>
+              <a:rPr lang="en-US" sz="1050" dirty="0">
+                <a:solidFill>
+                  <a:srgbClr val="A9BCCB"/>
+                </a:solidFill>
+                <a:latin typeface="Calibri" pitchFamily="34" charset="0"/>
+                <a:ea typeface="Calibri" pitchFamily="34" charset="-122"/>
+                <a:cs typeface="Calibri" pitchFamily="34" charset="-120"/>
+              </a:rPr>
+              <a:t>Sources: Electricity Authority &amp; Noga via DCD, JNS, Ctech (Jul 2026) · State Comptroller 2024 · DCD, Globes, Ctech · Times of Israel, CNN (Sep 2026)  ·  Images: 3D illustrations made for this presentation</a:t>
+            </a:r>
+            <a:endParaRPr lang="en-US" sz="1050" dirty="0"/>
           </a:p>
         </p:txBody>
       </p:sp>
@@ -2762,9 +2745,16 @@
   <p:cSld name="Slide 3">
     <p:bg>
       <p:bgPr>
-        <a:solidFill>
-          <a:srgbClr val="FFFFFF"/>
-        </a:solidFill>
+        <a:blipFill dpi="0" rotWithShape="1">
+          <a:blip r:embed="rId1">
+            <a:lum/>
+          </a:blip>
+          <a:srcRect/>
+          <a:stretch>
+            <a:fillRect/>
+          </a:stretch>
+        </a:blipFill>
+        <a:effectLst/>
       </p:bgPr>
     </p:bg>
     <p:spTree>
@@ -2783,89 +2773,14 @@
       </p:grpSpPr>
       <p:sp>
         <p:nvSpPr>
-          <p:cNvPr id="2" name="photo-frame"/>
-          <p:cNvSpPr/>
+          <p:cNvPr id="2" name="title"/>
+          <p:cNvSpPr txBox="1"/>
           <p:nvPr/>
         </p:nvSpPr>
         <p:spPr>
           <a:xfrm>
-            <a:off x="0" y="0"/>
-            <a:ext cx="4480560" cy="6858000"/>
-          </a:xfrm>
-          <a:prstGeom prst="rect">
-            <a:avLst/>
-          </a:prstGeom>
-          <a:solidFill>
-            <a:srgbClr val="D5DEE5"/>
-          </a:solidFill>
-          <a:ln w="12700">
-            <a:solidFill>
-              <a:srgbClr val="D5DEE5"/>
-            </a:solidFill>
-            <a:prstDash val="solid"/>
-          </a:ln>
-        </p:spPr>
-      </p:sp>
-      <p:sp>
-        <p:nvSpPr>
-          <p:cNvPr id="3" name="caption-photo"/>
-          <p:cNvSpPr txBox="1"/>
-          <p:nvPr/>
-        </p:nvSpPr>
-        <p:spPr>
-          <a:xfrm>
-            <a:off x="320040" y="6172200"/>
-            <a:ext cx="3840480" cy="411480"/>
-          </a:xfrm>
-          <a:prstGeom prst="rect">
-            <a:avLst/>
-          </a:prstGeom>
-          <a:noFill/>
-          <a:ln/>
-        </p:spPr>
-        <p:txBody>
-          <a:bodyPr wrap="square" lIns="0" tIns="0" rIns="0" bIns="0" rtlCol="0" anchor="b"/>
-          <a:lstStyle/>
-          <a:p>
-            <a:pPr indent="0" marL="0">
-              <a:buNone/>
-            </a:pPr>
-            <a:r>
-              <a:rPr lang="en-US" sz="1200" b="1" dirty="0">
-                <a:solidFill>
-                  <a:srgbClr val="3E4C59"/>
-                </a:solidFill>
-                <a:latin typeface="Calibri" pitchFamily="34" charset="0"/>
-                <a:ea typeface="Calibri" pitchFamily="34" charset="-122"/>
-                <a:cs typeface="Calibri" pitchFamily="34" charset="-120"/>
-              </a:rPr>
-              <a:t>Photo: </a:t>
-            </a:r>
-            <a:r>
-              <a:rPr lang="en-US" sz="1200" dirty="0">
-                <a:solidFill>
-                  <a:srgbClr val="3E4C59"/>
-                </a:solidFill>
-                <a:latin typeface="Calibri" pitchFamily="34" charset="0"/>
-                <a:ea typeface="Calibri" pitchFamily="34" charset="-122"/>
-                <a:cs typeface="Calibri" pitchFamily="34" charset="-120"/>
-              </a:rPr>
-              <a:t>community protest or public meeting (add a real photo)</a:t>
-            </a:r>
-            <a:endParaRPr lang="en-US" sz="1200" dirty="0"/>
-          </a:p>
-        </p:txBody>
-      </p:sp>
-      <p:sp>
-        <p:nvSpPr>
-          <p:cNvPr id="4" name="title"/>
-          <p:cNvSpPr txBox="1"/>
-          <p:nvPr/>
-        </p:nvSpPr>
-        <p:spPr>
-          <a:xfrm>
-            <a:off x="5074920" y="457200"/>
-            <a:ext cx="6583680" cy="822960"/>
+            <a:off x="548640" y="320040"/>
+            <a:ext cx="11064240" cy="822960"/>
           </a:xfrm>
           <a:prstGeom prst="rect">
             <a:avLst/>
@@ -2881,15 +2796,15 @@
               <a:buNone/>
             </a:pPr>
             <a:r>
-              <a:rPr lang="en-US" sz="4000" dirty="0">
-                <a:solidFill>
-                  <a:srgbClr val="0E1B2A"/>
+              <a:rPr lang="en-US" sz="4000" b="1" dirty="0">
+                <a:solidFill>
+                  <a:srgbClr val="FFFFFF"/>
                 </a:solidFill>
                 <a:latin typeface="Cambria" pitchFamily="34" charset="0"/>
                 <a:ea typeface="Cambria" pitchFamily="34" charset="-122"/>
                 <a:cs typeface="Cambria" pitchFamily="34" charset="-120"/>
               </a:rPr>
-              <a:t>Who Is Pushing Back?</a:t>
+              <a:t>Who Is Pushing Back? NGOs &amp; Laws</a:t>
             </a:r>
             <a:endParaRPr lang="en-US" sz="4000" dirty="0"/>
           </a:p>
@@ -2897,14 +2812,45 @@
       </p:sp>
       <p:sp>
         <p:nvSpPr>
-          <p:cNvPr id="5" name="kicker"/>
+          <p:cNvPr id="3" name="Shape 1"/>
+          <p:cNvSpPr/>
+          <p:nvPr/>
+        </p:nvSpPr>
+        <p:spPr>
+          <a:xfrm>
+            <a:off x="7360920" y="1280160"/>
+            <a:ext cx="4434840" cy="5440680"/>
+          </a:xfrm>
+          <a:prstGeom prst="roundRect">
+            <a:avLst>
+              <a:gd name="adj" fmla="val 2474"/>
+            </a:avLst>
+          </a:prstGeom>
+          <a:solidFill>
+            <a:srgbClr val="0B2239">
+              <a:alpha val="86000"/>
+            </a:srgbClr>
+          </a:solidFill>
+          <a:ln w="12700">
+            <a:solidFill>
+              <a:srgbClr val="0B2239">
+                <a:alpha val="0"/>
+              </a:srgbClr>
+            </a:solidFill>
+            <a:prstDash val="solid"/>
+          </a:ln>
+        </p:spPr>
+      </p:sp>
+      <p:sp>
+        <p:nvSpPr>
+          <p:cNvPr id="4" name="header"/>
           <p:cNvSpPr txBox="1"/>
           <p:nvPr/>
         </p:nvSpPr>
         <p:spPr>
           <a:xfrm>
-            <a:off x="5074920" y="1261872"/>
-            <a:ext cx="6583680" cy="411480"/>
+            <a:off x="7589520" y="1417320"/>
+            <a:ext cx="4023360" cy="777240"/>
           </a:xfrm>
           <a:prstGeom prst="rect">
             <a:avLst/>
@@ -2920,30 +2866,47 @@
               <a:buNone/>
             </a:pPr>
             <a:r>
-              <a:rPr lang="en-US" sz="2200" dirty="0">
-                <a:solidFill>
-                  <a:srgbClr val="0F6E84"/>
-                </a:solidFill>
-                <a:latin typeface="Calibri" pitchFamily="34" charset="0"/>
-                <a:ea typeface="Calibri" pitchFamily="34" charset="-122"/>
-                <a:cs typeface="Calibri" pitchFamily="34" charset="-120"/>
-              </a:rPr>
-              <a:t>NGOs &amp; laws</a:t>
-            </a:r>
-            <a:endParaRPr lang="en-US" sz="2200" dirty="0"/>
+              <a:rPr lang="en-US" sz="2600" b="1" dirty="0">
+                <a:solidFill>
+                  <a:srgbClr val="FFFFFF"/>
+                </a:solidFill>
+                <a:latin typeface="Cambria" pitchFamily="34" charset="0"/>
+                <a:ea typeface="Cambria" pitchFamily="34" charset="-122"/>
+                <a:cs typeface="Cambria" pitchFamily="34" charset="-120"/>
+              </a:rPr>
+              <a:t>NGO: SPNI</a:t>
+            </a:r>
+            <a:endParaRPr lang="en-US" sz="2600" dirty="0"/>
+          </a:p>
+          <a:p>
+            <a:pPr indent="0" marL="0">
+              <a:buNone/>
+            </a:pPr>
+            <a:r>
+              <a:rPr lang="en-US" sz="1300" dirty="0">
+                <a:solidFill>
+                  <a:srgbClr val="A9BCCB"/>
+                </a:solidFill>
+                <a:latin typeface="Calibri" pitchFamily="34" charset="0"/>
+                <a:ea typeface="Calibri" pitchFamily="34" charset="-122"/>
+                <a:cs typeface="Calibri" pitchFamily="34" charset="-120"/>
+              </a:rPr>
+              <a:t>Society for the Protection of Nature in Israel</a:t>
+            </a:r>
+            <a:endParaRPr lang="en-US" sz="2600" dirty="0"/>
           </a:p>
         </p:txBody>
       </p:sp>
       <p:sp>
         <p:nvSpPr>
-          <p:cNvPr id="6" name="header"/>
+          <p:cNvPr id="5" name="body"/>
           <p:cNvSpPr txBox="1"/>
           <p:nvPr/>
         </p:nvSpPr>
         <p:spPr>
           <a:xfrm>
-            <a:off x="5074920" y="1874520"/>
-            <a:ext cx="6583680" cy="777240"/>
+            <a:off x="7589520" y="2240280"/>
+            <a:ext cx="4069080" cy="1463040"/>
           </a:xfrm>
           <a:prstGeom prst="rect">
             <a:avLst/>
@@ -2955,38 +2918,85 @@
           <a:bodyPr wrap="square" lIns="0" tIns="0" rIns="0" bIns="0" rtlCol="0" anchor="t"/>
           <a:lstStyle/>
           <a:p>
+            <a:pPr marL="279400" indent="-279400">
+              <a:spcAft>
+                <a:spcPts val="800"/>
+              </a:spcAft>
+              <a:buSzPct val="100000"/>
+              <a:buChar char="•"/>
+            </a:pPr>
+            <a:r>
+              <a:rPr lang="en-US" sz="2000" dirty="0">
+                <a:solidFill>
+                  <a:srgbClr val="E3EBF1"/>
+                </a:solidFill>
+                <a:latin typeface="Calibri" pitchFamily="34" charset="0"/>
+                <a:ea typeface="Calibri" pitchFamily="34" charset="-122"/>
+                <a:cs typeface="Calibri" pitchFamily="34" charset="-120"/>
+              </a:rPr>
+              <a:t>Advocacy against the AI server-farm fast-track bill</a:t>
+            </a:r>
+            <a:endParaRPr lang="en-US" sz="2000" dirty="0"/>
+          </a:p>
+          <a:p>
+            <a:pPr marL="279400" indent="-279400">
+              <a:spcAft>
+                <a:spcPts val="800"/>
+              </a:spcAft>
+              <a:buSzPct val="100000"/>
+              <a:buChar char="•"/>
+            </a:pPr>
+            <a:r>
+              <a:rPr lang="en-US" sz="2000" dirty="0">
+                <a:solidFill>
+                  <a:srgbClr val="E3EBF1"/>
+                </a:solidFill>
+                <a:latin typeface="Calibri" pitchFamily="34" charset="0"/>
+                <a:ea typeface="Calibri" pitchFamily="34" charset="-122"/>
+                <a:cs typeface="Calibri" pitchFamily="34" charset="-120"/>
+              </a:rPr>
+              <a:t>The bill lets big farms skip local committees</a:t>
+            </a:r>
+            <a:endParaRPr lang="en-US" sz="2000" dirty="0"/>
+          </a:p>
+        </p:txBody>
+      </p:sp>
+      <p:sp>
+        <p:nvSpPr>
+          <p:cNvPr id="6" name="header"/>
+          <p:cNvSpPr txBox="1"/>
+          <p:nvPr/>
+        </p:nvSpPr>
+        <p:spPr>
+          <a:xfrm>
+            <a:off x="7589520" y="3749040"/>
+            <a:ext cx="4023360" cy="457200"/>
+          </a:xfrm>
+          <a:prstGeom prst="rect">
+            <a:avLst/>
+          </a:prstGeom>
+          <a:noFill/>
+          <a:ln/>
+        </p:spPr>
+        <p:txBody>
+          <a:bodyPr wrap="square" lIns="0" tIns="0" rIns="0" bIns="0" rtlCol="0" anchor="ctr"/>
+          <a:lstStyle/>
+          <a:p>
             <a:pPr indent="0" marL="0">
               <a:buNone/>
             </a:pPr>
             <a:r>
-              <a:rPr lang="en-US" sz="2600" dirty="0">
-                <a:solidFill>
-                  <a:srgbClr val="0E1B2A"/>
+              <a:rPr lang="en-US" sz="2400" b="1" dirty="0">
+                <a:solidFill>
+                  <a:srgbClr val="FFFFFF"/>
                 </a:solidFill>
                 <a:latin typeface="Cambria" pitchFamily="34" charset="0"/>
                 <a:ea typeface="Cambria" pitchFamily="34" charset="-122"/>
                 <a:cs typeface="Cambria" pitchFamily="34" charset="-120"/>
               </a:rPr>
-              <a:t>NGO: SPNI</a:t>
-            </a:r>
-            <a:endParaRPr lang="en-US" sz="2600" dirty="0"/>
-          </a:p>
-          <a:p>
-            <a:pPr indent="0" marL="0">
-              <a:buNone/>
-            </a:pPr>
-            <a:r>
-              <a:rPr lang="en-US" sz="1400" dirty="0">
-                <a:solidFill>
-                  <a:srgbClr val="5B6875"/>
-                </a:solidFill>
-                <a:latin typeface="Calibri" pitchFamily="34" charset="0"/>
-                <a:ea typeface="Calibri" pitchFamily="34" charset="-122"/>
-                <a:cs typeface="Calibri" pitchFamily="34" charset="-120"/>
-              </a:rPr>
-              <a:t>Society for the Protection of Nature in Israel</a:t>
-            </a:r>
-            <a:endParaRPr lang="en-US" sz="2600" dirty="0"/>
+              <a:t>Legislation &amp; regulation</a:t>
+            </a:r>
+            <a:endParaRPr lang="en-US" sz="2400" dirty="0"/>
           </a:p>
         </p:txBody>
       </p:sp>
@@ -2998,8 +3008,8 @@
         </p:nvSpPr>
         <p:spPr>
           <a:xfrm>
-            <a:off x="5074920" y="2697480"/>
-            <a:ext cx="6583680" cy="960120"/>
+            <a:off x="7589520" y="4251960"/>
+            <a:ext cx="4069080" cy="2011680"/>
           </a:xfrm>
           <a:prstGeom prst="rect">
             <a:avLst/>
@@ -3013,128 +3023,111 @@
           <a:p>
             <a:pPr marL="279400" indent="-279400">
               <a:spcAft>
-                <a:spcPts val="800"/>
+                <a:spcPts val="600"/>
               </a:spcAft>
               <a:buSzPct val="100000"/>
               <a:buChar char="•"/>
             </a:pPr>
             <a:r>
+              <a:rPr lang="en-US" sz="2000" b="1" dirty="0">
+                <a:solidFill>
+                  <a:srgbClr val="FFFFFF"/>
+                </a:solidFill>
+                <a:latin typeface="Calibri" pitchFamily="34" charset="0"/>
+                <a:ea typeface="Calibri" pitchFamily="34" charset="-122"/>
+                <a:cs typeface="Calibri" pitchFamily="34" charset="-120"/>
+              </a:rPr>
+              <a:t>EU (2023): </a:t>
+            </a:r>
+            <a:r>
               <a:rPr lang="en-US" sz="2000" dirty="0">
                 <a:solidFill>
-                  <a:srgbClr val="0E1B2A"/>
-                </a:solidFill>
-                <a:latin typeface="Calibri" pitchFamily="34" charset="0"/>
-                <a:ea typeface="Calibri" pitchFamily="34" charset="-122"/>
-                <a:cs typeface="Calibri" pitchFamily="34" charset="-120"/>
-              </a:rPr>
-              <a:t>Advocacy against the AI server-farm fast-track bill</a:t>
+                  <a:srgbClr val="E3EBF1"/>
+                </a:solidFill>
+                <a:latin typeface="Calibri" pitchFamily="34" charset="0"/>
+                <a:ea typeface="Calibri" pitchFamily="34" charset="-122"/>
+                <a:cs typeface="Calibri" pitchFamily="34" charset="-120"/>
+              </a:rPr>
+              <a:t>data centers must report water use</a:t>
             </a:r>
             <a:endParaRPr lang="en-US" sz="2000" dirty="0"/>
           </a:p>
           <a:p>
             <a:pPr marL="279400" indent="-279400">
               <a:spcAft>
-                <a:spcPts val="800"/>
+                <a:spcPts val="600"/>
               </a:spcAft>
               <a:buSzPct val="100000"/>
               <a:buChar char="•"/>
             </a:pPr>
             <a:r>
+              <a:rPr lang="en-US" sz="2000" b="1" dirty="0">
+                <a:solidFill>
+                  <a:srgbClr val="FFFFFF"/>
+                </a:solidFill>
+                <a:latin typeface="Calibri" pitchFamily="34" charset="0"/>
+                <a:ea typeface="Calibri" pitchFamily="34" charset="-122"/>
+                <a:cs typeface="Calibri" pitchFamily="34" charset="-120"/>
+              </a:rPr>
+              <a:t>Israel’s Water Law (1959): </a:t>
+            </a:r>
+            <a:r>
               <a:rPr lang="en-US" sz="2000" dirty="0">
                 <a:solidFill>
-                  <a:srgbClr val="0E1B2A"/>
-                </a:solidFill>
-                <a:latin typeface="Calibri" pitchFamily="34" charset="0"/>
-                <a:ea typeface="Calibri" pitchFamily="34" charset="-122"/>
-                <a:cs typeface="Calibri" pitchFamily="34" charset="-120"/>
-              </a:rPr>
-              <a:t>The bill lets big farms skip local committees</a:t>
+                  <a:srgbClr val="E3EBF1"/>
+                </a:solidFill>
+                <a:latin typeface="Calibri" pitchFamily="34" charset="0"/>
+                <a:ea typeface="Calibri" pitchFamily="34" charset="-122"/>
+                <a:cs typeface="Calibri" pitchFamily="34" charset="-120"/>
+              </a:rPr>
+              <a:t>water is public</a:t>
             </a:r>
             <a:endParaRPr lang="en-US" sz="2000" dirty="0"/>
           </a:p>
+          <a:p>
+            <a:pPr marL="279400" indent="-279400">
+              <a:spcAft>
+                <a:spcPts val="600"/>
+              </a:spcAft>
+              <a:buSzPct val="100000"/>
+              <a:buChar char="•"/>
+            </a:pPr>
+            <a:r>
+              <a:rPr lang="en-US" sz="2000" b="1" dirty="0">
+                <a:solidFill>
+                  <a:srgbClr val="FFFFFF"/>
+                </a:solidFill>
+                <a:latin typeface="Calibri" pitchFamily="34" charset="0"/>
+                <a:ea typeface="Calibri" pitchFamily="34" charset="-122"/>
+                <a:cs typeface="Calibri" pitchFamily="34" charset="-120"/>
+              </a:rPr>
+              <a:t>Israel: </a:t>
+            </a:r>
+            <a:r>
+              <a:rPr lang="en-US" sz="2000" dirty="0">
+                <a:solidFill>
+                  <a:srgbClr val="E3EBF1"/>
+                </a:solidFill>
+                <a:latin typeface="Calibri" pitchFamily="34" charset="0"/>
+                <a:ea typeface="Calibri" pitchFamily="34" charset="-122"/>
+                <a:cs typeface="Calibri" pitchFamily="34" charset="-120"/>
+              </a:rPr>
+              <a:t>no disclosure rule found</a:t>
+            </a:r>
+            <a:endParaRPr lang="en-US" sz="2000" dirty="0"/>
+          </a:p>
         </p:txBody>
       </p:sp>
       <p:sp>
         <p:nvSpPr>
-          <p:cNvPr id="8" name="Shape 6"/>
-          <p:cNvSpPr/>
+          <p:cNvPr id="8" name="caption-sources"/>
+          <p:cNvSpPr txBox="1"/>
           <p:nvPr/>
         </p:nvSpPr>
         <p:spPr>
           <a:xfrm>
-            <a:off x="4114800" y="3840480"/>
-            <a:ext cx="7543800" cy="2240280"/>
-          </a:xfrm>
-          <a:prstGeom prst="rect">
-            <a:avLst/>
-          </a:prstGeom>
-          <a:solidFill>
-            <a:srgbClr val="FFFFFF"/>
-          </a:solidFill>
-          <a:ln w="9525">
-            <a:solidFill>
-              <a:srgbClr val="DDE3E8"/>
-            </a:solidFill>
-            <a:prstDash val="solid"/>
-          </a:ln>
-          <a:effectLst>
-            <a:outerShdw sx="100000" sy="100000" kx="0" ky="0" algn="bl" rotWithShape="0" blurRad="254000" dist="63500" dir="5400000">
-              <a:srgbClr val="000000">
-                <a:alpha val="20000"/>
-              </a:srgbClr>
-            </a:outerShdw>
-          </a:effectLst>
-        </p:spPr>
-      </p:sp>
-      <p:sp>
-        <p:nvSpPr>
-          <p:cNvPr id="9" name="header"/>
-          <p:cNvSpPr txBox="1"/>
-          <p:nvPr/>
-        </p:nvSpPr>
-        <p:spPr>
-          <a:xfrm>
-            <a:off x="4434840" y="4005072"/>
-            <a:ext cx="6949440" cy="502920"/>
-          </a:xfrm>
-          <a:prstGeom prst="rect">
-            <a:avLst/>
-          </a:prstGeom>
-          <a:noFill/>
-          <a:ln/>
-        </p:spPr>
-        <p:txBody>
-          <a:bodyPr wrap="square" lIns="0" tIns="0" rIns="0" bIns="0" rtlCol="0" anchor="ctr"/>
-          <a:lstStyle/>
-          <a:p>
-            <a:pPr indent="0" marL="0">
-              <a:buNone/>
-            </a:pPr>
-            <a:r>
-              <a:rPr lang="en-US" sz="2600" dirty="0">
-                <a:solidFill>
-                  <a:srgbClr val="0E1B2A"/>
-                </a:solidFill>
-                <a:latin typeface="Cambria" pitchFamily="34" charset="0"/>
-                <a:ea typeface="Cambria" pitchFamily="34" charset="-122"/>
-                <a:cs typeface="Cambria" pitchFamily="34" charset="-120"/>
-              </a:rPr>
-              <a:t>Legislation &amp; regulation</a:t>
-            </a:r>
-            <a:endParaRPr lang="en-US" sz="2600" dirty="0"/>
-          </a:p>
-        </p:txBody>
-      </p:sp>
-      <p:sp>
-        <p:nvSpPr>
-          <p:cNvPr id="10" name="body"/>
-          <p:cNvSpPr txBox="1"/>
-          <p:nvPr/>
-        </p:nvSpPr>
-        <p:spPr>
-          <a:xfrm>
-            <a:off x="4434840" y="4572000"/>
-            <a:ext cx="6949440" cy="1417320"/>
+            <a:off x="7589520" y="6263640"/>
+            <a:ext cx="4069080" cy="411480"/>
           </a:xfrm>
           <a:prstGeom prst="rect">
             <a:avLst/>
@@ -3146,139 +3139,21 @@
           <a:bodyPr wrap="square" lIns="0" tIns="0" rIns="0" bIns="0" rtlCol="0" anchor="t"/>
           <a:lstStyle/>
           <a:p>
-            <a:pPr marL="279400" indent="-279400">
-              <a:spcAft>
-                <a:spcPts val="600"/>
-              </a:spcAft>
-              <a:buSzPct val="100000"/>
-              <a:buChar char="•"/>
-            </a:pPr>
-            <a:r>
-              <a:rPr lang="en-US" sz="2000" b="1" dirty="0">
-                <a:solidFill>
-                  <a:srgbClr val="0E1B2A"/>
-                </a:solidFill>
-                <a:latin typeface="Calibri" pitchFamily="34" charset="0"/>
-                <a:ea typeface="Calibri" pitchFamily="34" charset="-122"/>
-                <a:cs typeface="Calibri" pitchFamily="34" charset="-120"/>
-              </a:rPr>
-              <a:t>EU (2023): </a:t>
-            </a:r>
-            <a:r>
-              <a:rPr lang="en-US" sz="2000" dirty="0">
-                <a:solidFill>
-                  <a:srgbClr val="0E1B2A"/>
-                </a:solidFill>
-                <a:latin typeface="Calibri" pitchFamily="34" charset="0"/>
-                <a:ea typeface="Calibri" pitchFamily="34" charset="-122"/>
-                <a:cs typeface="Calibri" pitchFamily="34" charset="-120"/>
-              </a:rPr>
-              <a:t>data centers must report water use</a:t>
-            </a:r>
-            <a:endParaRPr lang="en-US" sz="2000" dirty="0"/>
-          </a:p>
-          <a:p>
-            <a:pPr marL="279400" indent="-279400">
-              <a:spcAft>
-                <a:spcPts val="600"/>
-              </a:spcAft>
-              <a:buSzPct val="100000"/>
-              <a:buChar char="•"/>
-            </a:pPr>
-            <a:r>
-              <a:rPr lang="en-US" sz="2000" b="1" dirty="0">
-                <a:solidFill>
-                  <a:srgbClr val="0E1B2A"/>
-                </a:solidFill>
-                <a:latin typeface="Calibri" pitchFamily="34" charset="0"/>
-                <a:ea typeface="Calibri" pitchFamily="34" charset="-122"/>
-                <a:cs typeface="Calibri" pitchFamily="34" charset="-120"/>
-              </a:rPr>
-              <a:t>Israel’s Water Law (1959): </a:t>
-            </a:r>
-            <a:r>
-              <a:rPr lang="en-US" sz="2000" dirty="0">
-                <a:solidFill>
-                  <a:srgbClr val="0E1B2A"/>
-                </a:solidFill>
-                <a:latin typeface="Calibri" pitchFamily="34" charset="0"/>
-                <a:ea typeface="Calibri" pitchFamily="34" charset="-122"/>
-                <a:cs typeface="Calibri" pitchFamily="34" charset="-120"/>
-              </a:rPr>
-              <a:t>water is public</a:t>
-            </a:r>
-            <a:endParaRPr lang="en-US" sz="2000" dirty="0"/>
-          </a:p>
-          <a:p>
-            <a:pPr marL="279400" indent="-279400">
-              <a:spcAft>
-                <a:spcPts val="600"/>
-              </a:spcAft>
-              <a:buSzPct val="100000"/>
-              <a:buChar char="•"/>
-            </a:pPr>
-            <a:r>
-              <a:rPr lang="en-US" sz="2000" b="1" dirty="0">
-                <a:solidFill>
-                  <a:srgbClr val="0E1B2A"/>
-                </a:solidFill>
-                <a:latin typeface="Calibri" pitchFamily="34" charset="0"/>
-                <a:ea typeface="Calibri" pitchFamily="34" charset="-122"/>
-                <a:cs typeface="Calibri" pitchFamily="34" charset="-120"/>
-              </a:rPr>
-              <a:t>Israel: </a:t>
-            </a:r>
-            <a:r>
-              <a:rPr lang="en-US" sz="2000" dirty="0">
-                <a:solidFill>
-                  <a:srgbClr val="0E1B2A"/>
-                </a:solidFill>
-                <a:latin typeface="Calibri" pitchFamily="34" charset="0"/>
-                <a:ea typeface="Calibri" pitchFamily="34" charset="-122"/>
-                <a:cs typeface="Calibri" pitchFamily="34" charset="-120"/>
-              </a:rPr>
-              <a:t>no disclosure rule found</a:t>
-            </a:r>
-            <a:endParaRPr lang="en-US" sz="2000" dirty="0"/>
-          </a:p>
-        </p:txBody>
-      </p:sp>
-      <p:sp>
-        <p:nvSpPr>
-          <p:cNvPr id="11" name="caption-sources"/>
-          <p:cNvSpPr txBox="1"/>
-          <p:nvPr/>
-        </p:nvSpPr>
-        <p:spPr>
-          <a:xfrm>
-            <a:off x="4846320" y="6309360"/>
-            <a:ext cx="6812280" cy="365760"/>
-          </a:xfrm>
-          <a:prstGeom prst="rect">
-            <a:avLst/>
-          </a:prstGeom>
-          <a:noFill/>
-          <a:ln/>
-        </p:spPr>
-        <p:txBody>
-          <a:bodyPr wrap="square" lIns="0" tIns="0" rIns="0" bIns="0" rtlCol="0" anchor="ctr"/>
-          <a:lstStyle/>
-          <a:p>
             <a:pPr indent="0" marL="0">
               <a:buNone/>
             </a:pPr>
             <a:r>
-              <a:rPr lang="en-US" sz="1100" dirty="0">
-                <a:solidFill>
-                  <a:srgbClr val="5B6875"/>
-                </a:solidFill>
-                <a:latin typeface="Calibri" pitchFamily="34" charset="0"/>
-                <a:ea typeface="Calibri" pitchFamily="34" charset="-122"/>
-                <a:cs typeface="Calibri" pitchFamily="34" charset="-120"/>
-              </a:rPr>
-              <a:t>Sources: Calcalist 2026 (SPNI) · Knesset bill, 1st reading 1 Jun 2026 · EU Dir. 2023/1791 Art. 12 · Water Law 1959</a:t>
-            </a:r>
-            <a:endParaRPr lang="en-US" sz="1100" dirty="0"/>
+              <a:rPr lang="en-US" sz="900" dirty="0">
+                <a:solidFill>
+                  <a:srgbClr val="A9BCCB"/>
+                </a:solidFill>
+                <a:latin typeface="Calibri" pitchFamily="34" charset="0"/>
+                <a:ea typeface="Calibri" pitchFamily="34" charset="-122"/>
+                <a:cs typeface="Calibri" pitchFamily="34" charset="-120"/>
+              </a:rPr>
+              <a:t>Sources: Calcalist 2026 (SPNI) · Knesset bill, 1st reading 1 Jun 2026 · EU Dir. 2023/1791 Art. 12 · Water Law 1959 · Images: 3D illustrations made for this presentation</a:t>
+            </a:r>
+            <a:endParaRPr lang="en-US" sz="900" dirty="0"/>
           </a:p>
         </p:txBody>
       </p:sp>
@@ -3295,9 +3170,16 @@
   <p:cSld name="Slide 4">
     <p:bg>
       <p:bgPr>
-        <a:solidFill>
-          <a:srgbClr val="F1F4F6"/>
-        </a:solidFill>
+        <a:blipFill dpi="0" rotWithShape="1">
+          <a:blip r:embed="rId1">
+            <a:lum/>
+          </a:blip>
+          <a:srcRect/>
+          <a:stretch>
+            <a:fillRect/>
+          </a:stretch>
+        </a:blipFill>
+        <a:effectLst/>
       </p:bgPr>
     </p:bg>
     <p:spTree>
@@ -3322,7 +3204,7 @@
         </p:nvSpPr>
         <p:spPr>
           <a:xfrm>
-            <a:off x="548640" y="457200"/>
+            <a:off x="548640" y="365760"/>
             <a:ext cx="11064240" cy="822960"/>
           </a:xfrm>
           <a:prstGeom prst="rect">
@@ -3339,7 +3221,7 @@
               <a:buNone/>
             </a:pPr>
             <a:r>
-              <a:rPr lang="en-US" sz="4000" dirty="0">
+              <a:rPr lang="en-US" sz="4200" b="1" dirty="0">
                 <a:solidFill>
                   <a:srgbClr val="0E1B2A"/>
                 </a:solidFill>
@@ -3347,22 +3229,53 @@
                 <a:ea typeface="Cambria" pitchFamily="34" charset="-122"/>
                 <a:cs typeface="Cambria" pitchFamily="34" charset="-120"/>
               </a:rPr>
-              <a:t>What Would We Do? Our Proposal</a:t>
-            </a:r>
-            <a:endParaRPr lang="en-US" sz="4000" dirty="0"/>
+              <a:t>Our Idea: Run AI Locally</a:t>
+            </a:r>
+            <a:endParaRPr lang="en-US" sz="4200" dirty="0"/>
           </a:p>
         </p:txBody>
       </p:sp>
       <p:sp>
         <p:nvSpPr>
-          <p:cNvPr id="3" name="header"/>
+          <p:cNvPr id="3" name="Shape 1"/>
+          <p:cNvSpPr/>
+          <p:nvPr/>
+        </p:nvSpPr>
+        <p:spPr>
+          <a:xfrm>
+            <a:off x="411480" y="1325880"/>
+            <a:ext cx="6355080" cy="3977640"/>
+          </a:xfrm>
+          <a:prstGeom prst="roundRect">
+            <a:avLst>
+              <a:gd name="adj" fmla="val 2759"/>
+            </a:avLst>
+          </a:prstGeom>
+          <a:solidFill>
+            <a:srgbClr val="0B2239">
+              <a:alpha val="88000"/>
+            </a:srgbClr>
+          </a:solidFill>
+          <a:ln w="12700">
+            <a:solidFill>
+              <a:srgbClr val="0B2239">
+                <a:alpha val="0"/>
+              </a:srgbClr>
+            </a:solidFill>
+            <a:prstDash val="solid"/>
+          </a:ln>
+        </p:spPr>
+      </p:sp>
+      <p:sp>
+        <p:nvSpPr>
+          <p:cNvPr id="4" name="header"/>
           <p:cNvSpPr txBox="1"/>
           <p:nvPr/>
         </p:nvSpPr>
         <p:spPr>
           <a:xfrm>
-            <a:off x="548640" y="1298448"/>
-            <a:ext cx="11064240" cy="457200"/>
+            <a:off x="685800" y="1508760"/>
+            <a:ext cx="5897880" cy="457200"/>
           </a:xfrm>
           <a:prstGeom prst="rect">
             <a:avLst/>
@@ -3378,73 +3291,190 @@
               <a:buNone/>
             </a:pPr>
             <a:r>
-              <a:rPr lang="en-US" sz="2400" b="1" dirty="0">
-                <a:solidFill>
-                  <a:srgbClr val="0F6E84"/>
-                </a:solidFill>
-                <a:latin typeface="Calibri" pitchFamily="34" charset="0"/>
-                <a:ea typeface="Calibri" pitchFamily="34" charset="-122"/>
-                <a:cs typeface="Calibri" pitchFamily="34" charset="-120"/>
-              </a:rPr>
-              <a:t>Policy reform: </a:t>
-            </a:r>
-            <a:r>
-              <a:rPr lang="en-US" sz="2400" dirty="0">
-                <a:solidFill>
-                  <a:srgbClr val="0E1B2A"/>
-                </a:solidFill>
-                <a:latin typeface="Calibri" pitchFamily="34" charset="0"/>
-                <a:ea typeface="Calibri" pitchFamily="34" charset="-122"/>
-                <a:cs typeface="Calibri" pitchFamily="34" charset="-120"/>
-              </a:rPr>
-              <a:t>the “Open Meter” Law</a:t>
-            </a:r>
-            <a:endParaRPr lang="en-US" sz="2400" dirty="0"/>
+              <a:rPr lang="en-US" sz="2200" b="1" dirty="0">
+                <a:solidFill>
+                  <a:srgbClr val="F2A33A"/>
+                </a:solidFill>
+                <a:latin typeface="Calibri" pitchFamily="34" charset="0"/>
+                <a:ea typeface="Calibri" pitchFamily="34" charset="-122"/>
+                <a:cs typeface="Calibri" pitchFamily="34" charset="-120"/>
+              </a:rPr>
+              <a:t>Make LLMs run on normal PCs and laptops</a:t>
+            </a:r>
+            <a:endParaRPr lang="en-US" sz="2200" dirty="0"/>
           </a:p>
         </p:txBody>
       </p:sp>
       <p:sp>
         <p:nvSpPr>
-          <p:cNvPr id="4" name="Shape 2"/>
-          <p:cNvSpPr/>
+          <p:cNvPr id="5" name="body"/>
+          <p:cNvSpPr txBox="1"/>
           <p:nvPr/>
         </p:nvSpPr>
         <p:spPr>
           <a:xfrm>
-            <a:off x="548640" y="1965960"/>
-            <a:ext cx="3566160" cy="2011680"/>
+            <a:off x="685800" y="2148840"/>
+            <a:ext cx="5897880" cy="3840480"/>
           </a:xfrm>
           <a:prstGeom prst="rect">
             <a:avLst/>
           </a:prstGeom>
-          <a:solidFill>
-            <a:srgbClr val="FFFFFF"/>
-          </a:solidFill>
-          <a:ln w="9525">
-            <a:solidFill>
-              <a:srgbClr val="DDE3E8"/>
-            </a:solidFill>
-            <a:prstDash val="solid"/>
-          </a:ln>
-          <a:effectLst>
-            <a:outerShdw sx="100000" sy="100000" kx="0" ky="0" algn="bl" rotWithShape="0" blurRad="254000" dist="63500" dir="5400000">
-              <a:srgbClr val="000000">
-                <a:alpha val="14000"/>
-              </a:srgbClr>
-            </a:outerShdw>
-          </a:effectLst>
+          <a:noFill/>
+          <a:ln/>
         </p:spPr>
-      </p:sp>
-      <p:sp>
-        <p:nvSpPr>
-          <p:cNvPr id="5" name="number"/>
+        <p:txBody>
+          <a:bodyPr wrap="square" lIns="0" tIns="0" rIns="0" bIns="0" rtlCol="0" anchor="t"/>
+          <a:lstStyle/>
+          <a:p>
+            <a:pPr marL="279400" indent="-279400">
+              <a:spcAft>
+                <a:spcPts val="1400"/>
+              </a:spcAft>
+              <a:buSzPct val="100000"/>
+              <a:buChar char="•"/>
+            </a:pPr>
+            <a:r>
+              <a:rPr lang="en-US" sz="2100" dirty="0">
+                <a:solidFill>
+                  <a:srgbClr val="E3EBF1"/>
+                </a:solidFill>
+                <a:latin typeface="Calibri" pitchFamily="34" charset="0"/>
+                <a:ea typeface="Calibri" pitchFamily="34" charset="-122"/>
+                <a:cs typeface="Calibri" pitchFamily="34" charset="-120"/>
+              </a:rPr>
+              <a:t>Companies make models </a:t>
+            </a:r>
+            <a:r>
+              <a:rPr lang="en-US" sz="2100" b="1" dirty="0">
+                <a:solidFill>
+                  <a:srgbClr val="FFFFFF"/>
+                </a:solidFill>
+                <a:latin typeface="Calibri" pitchFamily="34" charset="0"/>
+                <a:ea typeface="Calibri" pitchFamily="34" charset="-122"/>
+                <a:cs typeface="Calibri" pitchFamily="34" charset="-120"/>
+              </a:rPr>
+              <a:t>smaller and more efficient</a:t>
+            </a:r>
+            <a:endParaRPr lang="en-US" sz="2100" dirty="0"/>
+          </a:p>
+          <a:p>
+            <a:pPr marL="279400" indent="-279400">
+              <a:spcAft>
+                <a:spcPts val="1400"/>
+              </a:spcAft>
+              <a:buSzPct val="100000"/>
+              <a:buChar char="•"/>
+            </a:pPr>
+            <a:r>
+              <a:rPr lang="en-US" sz="2100" dirty="0">
+                <a:solidFill>
+                  <a:srgbClr val="E3EBF1"/>
+                </a:solidFill>
+                <a:latin typeface="Calibri" pitchFamily="34" charset="0"/>
+                <a:ea typeface="Calibri" pitchFamily="34" charset="-122"/>
+                <a:cs typeface="Calibri" pitchFamily="34" charset="-120"/>
+              </a:rPr>
+              <a:t>People download a model instead of the cloud</a:t>
+            </a:r>
+            <a:endParaRPr lang="en-US" sz="2100" dirty="0"/>
+          </a:p>
+          <a:p>
+            <a:pPr marL="279400" indent="-279400">
+              <a:spcAft>
+                <a:spcPts val="1400"/>
+              </a:spcAft>
+              <a:buSzPct val="100000"/>
+              <a:buChar char="•"/>
+            </a:pPr>
+            <a:r>
+              <a:rPr lang="en-US" sz="2100" b="1" dirty="0">
+                <a:solidFill>
+                  <a:srgbClr val="FFFFFF"/>
+                </a:solidFill>
+                <a:latin typeface="Calibri" pitchFamily="34" charset="0"/>
+                <a:ea typeface="Calibri" pitchFamily="34" charset="-122"/>
+                <a:cs typeface="Calibri" pitchFamily="34" charset="-120"/>
+              </a:rPr>
+              <a:t>How: </a:t>
+            </a:r>
+            <a:r>
+              <a:rPr lang="en-US" sz="2100" dirty="0">
+                <a:solidFill>
+                  <a:srgbClr val="E3EBF1"/>
+                </a:solidFill>
+                <a:latin typeface="Calibri" pitchFamily="34" charset="0"/>
+                <a:ea typeface="Calibri" pitchFamily="34" charset="-122"/>
+                <a:cs typeface="Calibri" pitchFamily="34" charset="-120"/>
+              </a:rPr>
+              <a:t>optimization, quantization, smaller models</a:t>
+            </a:r>
+            <a:endParaRPr lang="en-US" sz="2100" dirty="0"/>
+          </a:p>
+          <a:p>
+            <a:pPr marL="279400" indent="-279400">
+              <a:spcAft>
+                <a:spcPts val="1400"/>
+              </a:spcAft>
+              <a:buSzPct val="100000"/>
+              <a:buChar char="•"/>
+            </a:pPr>
+            <a:r>
+              <a:rPr lang="en-US" sz="2100" dirty="0">
+                <a:solidFill>
+                  <a:srgbClr val="E3EBF1"/>
+                </a:solidFill>
+                <a:latin typeface="Calibri" pitchFamily="34" charset="0"/>
+                <a:ea typeface="Calibri" pitchFamily="34" charset="-122"/>
+                <a:cs typeface="Calibri" pitchFamily="34" charset="-120"/>
+              </a:rPr>
+              <a:t>Better chips make local AI stronger</a:t>
+            </a:r>
+            <a:endParaRPr lang="en-US" sz="2100" dirty="0"/>
+          </a:p>
+          <a:p>
+            <a:pPr marL="279400" indent="-279400">
+              <a:spcAft>
+                <a:spcPts val="1400"/>
+              </a:spcAft>
+              <a:buSzPct val="100000"/>
+              <a:buChar char="•"/>
+            </a:pPr>
+            <a:r>
+              <a:rPr lang="en-US" sz="2100" b="1" dirty="0">
+                <a:solidFill>
+                  <a:srgbClr val="FFFFFF"/>
+                </a:solidFill>
+                <a:latin typeface="Calibri" pitchFamily="34" charset="0"/>
+                <a:ea typeface="Calibri" pitchFamily="34" charset="-122"/>
+                <a:cs typeface="Calibri" pitchFamily="34" charset="-120"/>
+              </a:rPr>
+              <a:t>Already real: </a:t>
+            </a:r>
+            <a:r>
+              <a:rPr lang="en-US" sz="2100" dirty="0">
+                <a:solidFill>
+                  <a:srgbClr val="E3EBF1"/>
+                </a:solidFill>
+                <a:latin typeface="Calibri" pitchFamily="34" charset="0"/>
+                <a:ea typeface="Calibri" pitchFamily="34" charset="-122"/>
+                <a:cs typeface="Calibri" pitchFamily="34" charset="-120"/>
+              </a:rPr>
+              <a:t>Phi-3 runs on a phone</a:t>
+            </a:r>
+            <a:endParaRPr lang="en-US" sz="2100" dirty="0"/>
+          </a:p>
+        </p:txBody>
+      </p:sp>
+      <p:sp>
+        <p:nvSpPr>
+          <p:cNvPr id="6" name="caption-sources"/>
           <p:cNvSpPr txBox="1"/>
           <p:nvPr/>
         </p:nvSpPr>
         <p:spPr>
           <a:xfrm>
-            <a:off x="822960" y="2057400"/>
-            <a:ext cx="914400" cy="777240"/>
+            <a:off x="548640" y="6355080"/>
+            <a:ext cx="11064240" cy="347472"/>
           </a:xfrm>
           <a:prstGeom prst="rect">
             <a:avLst/>
@@ -3460,517 +3490,17 @@
               <a:buNone/>
             </a:pPr>
             <a:r>
-              <a:rPr lang="en-US" sz="4800" dirty="0">
-                <a:solidFill>
-                  <a:srgbClr val="0F6E84"/>
-                </a:solidFill>
-                <a:latin typeface="Cambria" pitchFamily="34" charset="0"/>
-                <a:ea typeface="Cambria" pitchFamily="34" charset="-122"/>
-                <a:cs typeface="Cambria" pitchFamily="34" charset="-120"/>
-              </a:rPr>
-              <a:t>1</a:t>
-            </a:r>
-            <a:endParaRPr lang="en-US" sz="4800" dirty="0"/>
-          </a:p>
-        </p:txBody>
-      </p:sp>
-      <p:sp>
-        <p:nvSpPr>
-          <p:cNvPr id="6" name="body"/>
-          <p:cNvSpPr txBox="1"/>
-          <p:nvPr/>
-        </p:nvSpPr>
-        <p:spPr>
-          <a:xfrm>
-            <a:off x="822960" y="2880360"/>
-            <a:ext cx="3017520" cy="960120"/>
-          </a:xfrm>
-          <a:prstGeom prst="rect">
-            <a:avLst/>
-          </a:prstGeom>
-          <a:noFill/>
-          <a:ln/>
-        </p:spPr>
-        <p:txBody>
-          <a:bodyPr wrap="square" lIns="0" tIns="0" rIns="0" bIns="0" rtlCol="0" anchor="t"/>
-          <a:lstStyle/>
-          <a:p>
-            <a:pPr indent="0" marL="0">
-              <a:buNone/>
-            </a:pPr>
-            <a:r>
-              <a:rPr lang="en-US" sz="2100" dirty="0">
-                <a:solidFill>
-                  <a:srgbClr val="0E1B2A"/>
-                </a:solidFill>
-                <a:latin typeface="Calibri" pitchFamily="34" charset="0"/>
-                <a:ea typeface="Calibri" pitchFamily="34" charset="-122"/>
-                <a:cs typeface="Calibri" pitchFamily="34" charset="-120"/>
-              </a:rPr>
-              <a:t>Data centers publish yearly water and power use</a:t>
-            </a:r>
-            <a:endParaRPr lang="en-US" sz="2100" dirty="0"/>
-          </a:p>
-        </p:txBody>
-      </p:sp>
-      <p:sp>
-        <p:nvSpPr>
-          <p:cNvPr id="7" name="Shape 5"/>
-          <p:cNvSpPr/>
-          <p:nvPr/>
-        </p:nvSpPr>
-        <p:spPr>
-          <a:xfrm>
-            <a:off x="4315968" y="1965960"/>
-            <a:ext cx="3566160" cy="2011680"/>
-          </a:xfrm>
-          <a:prstGeom prst="rect">
-            <a:avLst/>
-          </a:prstGeom>
-          <a:solidFill>
-            <a:srgbClr val="FFFFFF"/>
-          </a:solidFill>
-          <a:ln w="9525">
-            <a:solidFill>
-              <a:srgbClr val="DDE3E8"/>
-            </a:solidFill>
-            <a:prstDash val="solid"/>
-          </a:ln>
-          <a:effectLst>
-            <a:outerShdw sx="100000" sy="100000" kx="0" ky="0" algn="bl" rotWithShape="0" blurRad="254000" dist="63500" dir="5400000">
-              <a:srgbClr val="000000">
-                <a:alpha val="14000"/>
-              </a:srgbClr>
-            </a:outerShdw>
-          </a:effectLst>
-        </p:spPr>
-      </p:sp>
-      <p:sp>
-        <p:nvSpPr>
-          <p:cNvPr id="8" name="number"/>
-          <p:cNvSpPr txBox="1"/>
-          <p:nvPr/>
-        </p:nvSpPr>
-        <p:spPr>
-          <a:xfrm>
-            <a:off x="4590288" y="2057400"/>
-            <a:ext cx="914400" cy="777240"/>
-          </a:xfrm>
-          <a:prstGeom prst="rect">
-            <a:avLst/>
-          </a:prstGeom>
-          <a:noFill/>
-          <a:ln/>
-        </p:spPr>
-        <p:txBody>
-          <a:bodyPr wrap="square" lIns="0" tIns="0" rIns="0" bIns="0" rtlCol="0" anchor="ctr"/>
-          <a:lstStyle/>
-          <a:p>
-            <a:pPr indent="0" marL="0">
-              <a:buNone/>
-            </a:pPr>
-            <a:r>
-              <a:rPr lang="en-US" sz="4800" dirty="0">
-                <a:solidFill>
-                  <a:srgbClr val="0F6E84"/>
-                </a:solidFill>
-                <a:latin typeface="Cambria" pitchFamily="34" charset="0"/>
-                <a:ea typeface="Cambria" pitchFamily="34" charset="-122"/>
-                <a:cs typeface="Cambria" pitchFamily="34" charset="-120"/>
-              </a:rPr>
-              <a:t>2</a:t>
-            </a:r>
-            <a:endParaRPr lang="en-US" sz="4800" dirty="0"/>
-          </a:p>
-        </p:txBody>
-      </p:sp>
-      <p:sp>
-        <p:nvSpPr>
-          <p:cNvPr id="9" name="body"/>
-          <p:cNvSpPr txBox="1"/>
-          <p:nvPr/>
-        </p:nvSpPr>
-        <p:spPr>
-          <a:xfrm>
-            <a:off x="4590288" y="2880360"/>
-            <a:ext cx="3017520" cy="960120"/>
-          </a:xfrm>
-          <a:prstGeom prst="rect">
-            <a:avLst/>
-          </a:prstGeom>
-          <a:noFill/>
-          <a:ln/>
-        </p:spPr>
-        <p:txBody>
-          <a:bodyPr wrap="square" lIns="0" tIns="0" rIns="0" bIns="0" rtlCol="0" anchor="t"/>
-          <a:lstStyle/>
-          <a:p>
-            <a:pPr indent="0" marL="0">
-              <a:buNone/>
-            </a:pPr>
-            <a:r>
-              <a:rPr lang="en-US" sz="2100" dirty="0">
-                <a:solidFill>
-                  <a:srgbClr val="0E1B2A"/>
-                </a:solidFill>
-                <a:latin typeface="Calibri" pitchFamily="34" charset="0"/>
-                <a:ea typeface="Calibri" pitchFamily="34" charset="-122"/>
-                <a:cs typeface="Calibri" pitchFamily="34" charset="-120"/>
-              </a:rPr>
-              <a:t>Local hearings stay, even on the fast track</a:t>
-            </a:r>
-            <a:endParaRPr lang="en-US" sz="2100" dirty="0"/>
-          </a:p>
-        </p:txBody>
-      </p:sp>
-      <p:sp>
-        <p:nvSpPr>
-          <p:cNvPr id="10" name="Shape 8"/>
-          <p:cNvSpPr/>
-          <p:nvPr/>
-        </p:nvSpPr>
-        <p:spPr>
-          <a:xfrm>
-            <a:off x="8083296" y="1965960"/>
-            <a:ext cx="3566160" cy="2011680"/>
-          </a:xfrm>
-          <a:prstGeom prst="rect">
-            <a:avLst/>
-          </a:prstGeom>
-          <a:solidFill>
-            <a:srgbClr val="FFFFFF"/>
-          </a:solidFill>
-          <a:ln w="9525">
-            <a:solidFill>
-              <a:srgbClr val="DDE3E8"/>
-            </a:solidFill>
-            <a:prstDash val="solid"/>
-          </a:ln>
-          <a:effectLst>
-            <a:outerShdw sx="100000" sy="100000" kx="0" ky="0" algn="bl" rotWithShape="0" blurRad="254000" dist="63500" dir="5400000">
-              <a:srgbClr val="000000">
-                <a:alpha val="14000"/>
-              </a:srgbClr>
-            </a:outerShdw>
-          </a:effectLst>
-        </p:spPr>
-      </p:sp>
-      <p:sp>
-        <p:nvSpPr>
-          <p:cNvPr id="11" name="number"/>
-          <p:cNvSpPr txBox="1"/>
-          <p:nvPr/>
-        </p:nvSpPr>
-        <p:spPr>
-          <a:xfrm>
-            <a:off x="8357616" y="2057400"/>
-            <a:ext cx="914400" cy="777240"/>
-          </a:xfrm>
-          <a:prstGeom prst="rect">
-            <a:avLst/>
-          </a:prstGeom>
-          <a:noFill/>
-          <a:ln/>
-        </p:spPr>
-        <p:txBody>
-          <a:bodyPr wrap="square" lIns="0" tIns="0" rIns="0" bIns="0" rtlCol="0" anchor="ctr"/>
-          <a:lstStyle/>
-          <a:p>
-            <a:pPr indent="0" marL="0">
-              <a:buNone/>
-            </a:pPr>
-            <a:r>
-              <a:rPr lang="en-US" sz="4800" dirty="0">
-                <a:solidFill>
-                  <a:srgbClr val="0F6E84"/>
-                </a:solidFill>
-                <a:latin typeface="Cambria" pitchFamily="34" charset="0"/>
-                <a:ea typeface="Cambria" pitchFamily="34" charset="-122"/>
-                <a:cs typeface="Cambria" pitchFamily="34" charset="-120"/>
-              </a:rPr>
-              <a:t>3</a:t>
-            </a:r>
-            <a:endParaRPr lang="en-US" sz="4800" dirty="0"/>
-          </a:p>
-        </p:txBody>
-      </p:sp>
-      <p:sp>
-        <p:nvSpPr>
-          <p:cNvPr id="12" name="body"/>
-          <p:cNvSpPr txBox="1"/>
-          <p:nvPr/>
-        </p:nvSpPr>
-        <p:spPr>
-          <a:xfrm>
-            <a:off x="8357616" y="2880360"/>
-            <a:ext cx="3017520" cy="960120"/>
-          </a:xfrm>
-          <a:prstGeom prst="rect">
-            <a:avLst/>
-          </a:prstGeom>
-          <a:noFill/>
-          <a:ln/>
-        </p:spPr>
-        <p:txBody>
-          <a:bodyPr wrap="square" lIns="0" tIns="0" rIns="0" bIns="0" rtlCol="0" anchor="t"/>
-          <a:lstStyle/>
-          <a:p>
-            <a:pPr indent="0" marL="0">
-              <a:buNone/>
-            </a:pPr>
-            <a:r>
-              <a:rPr lang="en-US" sz="2100" dirty="0">
-                <a:solidFill>
-                  <a:srgbClr val="0E1B2A"/>
-                </a:solidFill>
-                <a:latin typeface="Calibri" pitchFamily="34" charset="0"/>
-                <a:ea typeface="Calibri" pitchFamily="34" charset="-122"/>
-                <a:cs typeface="Calibri" pitchFamily="34" charset="-120"/>
-              </a:rPr>
-              <a:t>In shortages: homes and farms before servers</a:t>
-            </a:r>
-            <a:endParaRPr lang="en-US" sz="2100" dirty="0"/>
-          </a:p>
-        </p:txBody>
-      </p:sp>
-      <p:sp>
-        <p:nvSpPr>
-          <p:cNvPr id="13" name="body"/>
-          <p:cNvSpPr txBox="1"/>
-          <p:nvPr/>
-        </p:nvSpPr>
-        <p:spPr>
-          <a:xfrm>
-            <a:off x="548640" y="4114800"/>
-            <a:ext cx="11064240" cy="411480"/>
-          </a:xfrm>
-          <a:prstGeom prst="rect">
-            <a:avLst/>
-          </a:prstGeom>
-          <a:noFill/>
-          <a:ln/>
-        </p:spPr>
-        <p:txBody>
-          <a:bodyPr wrap="square" lIns="0" tIns="0" rIns="0" bIns="0" rtlCol="0" anchor="ctr"/>
-          <a:lstStyle/>
-          <a:p>
-            <a:pPr indent="0" marL="0">
-              <a:buNone/>
-            </a:pPr>
-            <a:r>
-              <a:rPr lang="en-US" sz="2100" i="1" dirty="0">
-                <a:solidFill>
-                  <a:srgbClr val="0F6E84"/>
-                </a:solidFill>
-                <a:latin typeface="Calibri" pitchFamily="34" charset="0"/>
-                <a:ea typeface="Calibri" pitchFamily="34" charset="-122"/>
-                <a:cs typeface="Calibri" pitchFamily="34" charset="-120"/>
-              </a:rPr>
-              <a:t>Aim: fair siting, no discrimination</a:t>
-            </a:r>
-            <a:endParaRPr lang="en-US" sz="2100" dirty="0"/>
-          </a:p>
-        </p:txBody>
-      </p:sp>
-      <p:sp>
-        <p:nvSpPr>
-          <p:cNvPr id="14" name="Shape 12"/>
-          <p:cNvSpPr/>
-          <p:nvPr/>
-        </p:nvSpPr>
-        <p:spPr>
-          <a:xfrm>
-            <a:off x="548640" y="4663440"/>
-            <a:ext cx="7333488" cy="1417320"/>
-          </a:xfrm>
-          <a:prstGeom prst="rect">
-            <a:avLst/>
-          </a:prstGeom>
-          <a:solidFill>
-            <a:srgbClr val="FFFFFF"/>
-          </a:solidFill>
-          <a:ln w="9525">
-            <a:solidFill>
-              <a:srgbClr val="DDE3E8"/>
-            </a:solidFill>
-            <a:prstDash val="solid"/>
-          </a:ln>
-          <a:effectLst>
-            <a:outerShdw sx="100000" sy="100000" kx="0" ky="0" algn="bl" rotWithShape="0" blurRad="254000" dist="63500" dir="5400000">
-              <a:srgbClr val="000000">
-                <a:alpha val="14000"/>
-              </a:srgbClr>
-            </a:outerShdw>
-          </a:effectLst>
-        </p:spPr>
-      </p:sp>
-      <p:sp>
-        <p:nvSpPr>
-          <p:cNvPr id="15" name="body"/>
-          <p:cNvSpPr txBox="1"/>
-          <p:nvPr/>
-        </p:nvSpPr>
-        <p:spPr>
-          <a:xfrm>
-            <a:off x="822960" y="4773168"/>
-            <a:ext cx="6858000" cy="1188720"/>
-          </a:xfrm>
-          <a:prstGeom prst="rect">
-            <a:avLst/>
-          </a:prstGeom>
-          <a:noFill/>
-          <a:ln/>
-        </p:spPr>
-        <p:txBody>
-          <a:bodyPr wrap="square" lIns="0" tIns="0" rIns="0" bIns="0" rtlCol="0" anchor="ctr"/>
-          <a:lstStyle/>
-          <a:p>
-            <a:pPr indent="0" marL="0">
-              <a:buNone/>
-            </a:pPr>
-            <a:r>
-              <a:rPr lang="en-US" sz="2400" dirty="0">
-                <a:solidFill>
-                  <a:srgbClr val="0E1B2A"/>
-                </a:solidFill>
-                <a:latin typeface="Cambria" pitchFamily="34" charset="0"/>
-                <a:ea typeface="Cambria" pitchFamily="34" charset="-122"/>
-                <a:cs typeface="Cambria" pitchFamily="34" charset="-120"/>
-              </a:rPr>
-              <a:t>Awareness idea: an “AI nutrition label”</a:t>
-            </a:r>
-            <a:endParaRPr lang="en-US" sz="2400" dirty="0"/>
-          </a:p>
-          <a:p>
-            <a:pPr indent="0" marL="0">
-              <a:buNone/>
-            </a:pPr>
-            <a:r>
-              <a:rPr lang="en-US" sz="2000" dirty="0">
-                <a:solidFill>
-                  <a:srgbClr val="0E1B2A"/>
-                </a:solidFill>
-                <a:latin typeface="Calibri" pitchFamily="34" charset="0"/>
-                <a:ea typeface="Calibri" pitchFamily="34" charset="-122"/>
-                <a:cs typeface="Calibri" pitchFamily="34" charset="-120"/>
-              </a:rPr>
-              <a:t>Posters showing each AI tool’s water and power</a:t>
-            </a:r>
-            <a:endParaRPr lang="en-US" sz="2400" dirty="0"/>
-          </a:p>
-        </p:txBody>
-      </p:sp>
-      <p:sp>
-        <p:nvSpPr>
-          <p:cNvPr id="16" name="photo-frame"/>
-          <p:cNvSpPr/>
-          <p:nvPr/>
-        </p:nvSpPr>
-        <p:spPr>
-          <a:xfrm>
-            <a:off x="8083296" y="4663440"/>
-            <a:ext cx="3566160" cy="1417320"/>
-          </a:xfrm>
-          <a:prstGeom prst="rect">
-            <a:avLst/>
-          </a:prstGeom>
-          <a:solidFill>
-            <a:srgbClr val="D5DEE5"/>
-          </a:solidFill>
-          <a:ln w="12700">
-            <a:solidFill>
-              <a:srgbClr val="D5DEE5"/>
-            </a:solidFill>
-            <a:prstDash val="solid"/>
-          </a:ln>
-        </p:spPr>
-      </p:sp>
-      <p:sp>
-        <p:nvSpPr>
-          <p:cNvPr id="17" name="caption-photo"/>
-          <p:cNvSpPr txBox="1"/>
-          <p:nvPr/>
-        </p:nvSpPr>
-        <p:spPr>
-          <a:xfrm>
-            <a:off x="8403336" y="5394960"/>
-            <a:ext cx="2926080" cy="411480"/>
-          </a:xfrm>
-          <a:prstGeom prst="rect">
-            <a:avLst/>
-          </a:prstGeom>
-          <a:noFill/>
-          <a:ln/>
-        </p:spPr>
-        <p:txBody>
-          <a:bodyPr wrap="square" lIns="0" tIns="0" rIns="0" bIns="0" rtlCol="0" anchor="b"/>
-          <a:lstStyle/>
-          <a:p>
-            <a:pPr indent="0" marL="0">
-              <a:buNone/>
-            </a:pPr>
-            <a:r>
-              <a:rPr lang="en-US" sz="1200" b="1" dirty="0">
-                <a:solidFill>
-                  <a:srgbClr val="3E4C59"/>
-                </a:solidFill>
-                <a:latin typeface="Calibri" pitchFamily="34" charset="0"/>
-                <a:ea typeface="Calibri" pitchFamily="34" charset="-122"/>
-                <a:cs typeface="Calibri" pitchFamily="34" charset="-120"/>
-              </a:rPr>
-              <a:t>Photo: </a:t>
-            </a:r>
-            <a:r>
-              <a:rPr lang="en-US" sz="1200" dirty="0">
-                <a:solidFill>
-                  <a:srgbClr val="3E4C59"/>
-                </a:solidFill>
-                <a:latin typeface="Calibri" pitchFamily="34" charset="0"/>
-                <a:ea typeface="Calibri" pitchFamily="34" charset="-122"/>
-                <a:cs typeface="Calibri" pitchFamily="34" charset="-120"/>
-              </a:rPr>
-              <a:t>town hall meeting (add a real photo)</a:t>
-            </a:r>
-            <a:endParaRPr lang="en-US" sz="1200" dirty="0"/>
-          </a:p>
-        </p:txBody>
-      </p:sp>
-      <p:sp>
-        <p:nvSpPr>
-          <p:cNvPr id="18" name="caption-sources"/>
-          <p:cNvSpPr txBox="1"/>
-          <p:nvPr/>
-        </p:nvSpPr>
-        <p:spPr>
-          <a:xfrm>
-            <a:off x="548640" y="6309360"/>
-            <a:ext cx="11064240" cy="365760"/>
-          </a:xfrm>
-          <a:prstGeom prst="rect">
-            <a:avLst/>
-          </a:prstGeom>
-          <a:noFill/>
-          <a:ln/>
-        </p:spPr>
-        <p:txBody>
-          <a:bodyPr wrap="square" lIns="0" tIns="0" rIns="0" bIns="0" rtlCol="0" anchor="ctr"/>
-          <a:lstStyle/>
-          <a:p>
-            <a:pPr indent="0" marL="0">
-              <a:buNone/>
-            </a:pPr>
-            <a:r>
-              <a:rPr lang="en-US" sz="1100" dirty="0">
-                <a:solidFill>
-                  <a:srgbClr val="5B6875"/>
-                </a:solidFill>
-                <a:latin typeface="Calibri" pitchFamily="34" charset="0"/>
-                <a:ea typeface="Calibri" pitchFamily="34" charset="-122"/>
-                <a:cs typeface="Calibri" pitchFamily="34" charset="-120"/>
-              </a:rPr>
-              <a:t>Our team’s proposal · Disclosure idea modeled on EU Energy Efficiency Directive 2023/1791, Art. 12</a:t>
-            </a:r>
-            <a:endParaRPr lang="en-US" sz="1100" dirty="0"/>
+              <a:rPr lang="en-US" sz="1050" dirty="0">
+                <a:solidFill>
+                  <a:srgbClr val="E6E0D8"/>
+                </a:solidFill>
+                <a:latin typeface="Calibri" pitchFamily="34" charset="0"/>
+                <a:ea typeface="Calibri" pitchFamily="34" charset="-122"/>
+                <a:cs typeface="Calibri" pitchFamily="34" charset="-120"/>
+              </a:rPr>
+              <a:t>Sources: Microsoft Phi-3 report (2024) · Meta Llama 3.2 (2024) · Dettmers et al., QLoRA (2023) · Microsoft Copilot+ PC (2024)  ·  Images: 3D illustrations made for this presentation</a:t>
+            </a:r>
+            <a:endParaRPr lang="en-US" sz="1050" dirty="0"/>
           </a:p>
         </p:txBody>
       </p:sp>
@@ -3987,9 +3517,16 @@
   <p:cSld name="Slide 5">
     <p:bg>
       <p:bgPr>
-        <a:solidFill>
-          <a:srgbClr val="0B2239"/>
-        </a:solidFill>
+        <a:blipFill dpi="0" rotWithShape="1">
+          <a:blip r:embed="rId1">
+            <a:lum/>
+          </a:blip>
+          <a:srcRect/>
+          <a:stretch>
+            <a:fillRect/>
+          </a:stretch>
+        </a:blipFill>
+        <a:effectLst/>
       </p:bgPr>
     </p:bg>
     <p:spTree>
@@ -4008,128 +3545,14 @@
       </p:grpSpPr>
       <p:sp>
         <p:nvSpPr>
-          <p:cNvPr id="2" name="photo-frame"/>
-          <p:cNvSpPr/>
+          <p:cNvPr id="2" name="title"/>
+          <p:cNvSpPr txBox="1"/>
           <p:nvPr/>
         </p:nvSpPr>
         <p:spPr>
           <a:xfrm>
-            <a:off x="6400800" y="0"/>
-            <a:ext cx="5790895" cy="6858000"/>
-          </a:xfrm>
-          <a:prstGeom prst="rect">
-            <a:avLst/>
-          </a:prstGeom>
-          <a:solidFill>
-            <a:srgbClr val="1C3A55"/>
-          </a:solidFill>
-          <a:ln w="12700">
-            <a:solidFill>
-              <a:srgbClr val="1C3A55"/>
-            </a:solidFill>
-            <a:prstDash val="solid"/>
-          </a:ln>
-        </p:spPr>
-      </p:sp>
-      <p:sp>
-        <p:nvSpPr>
-          <p:cNvPr id="3" name="caption-photo"/>
-          <p:cNvSpPr txBox="1"/>
-          <p:nvPr/>
-        </p:nvSpPr>
-        <p:spPr>
-          <a:xfrm>
-            <a:off x="6720840" y="6172200"/>
-            <a:ext cx="5150815" cy="411480"/>
-          </a:xfrm>
-          <a:prstGeom prst="rect">
-            <a:avLst/>
-          </a:prstGeom>
-          <a:noFill/>
-          <a:ln/>
-        </p:spPr>
-        <p:txBody>
-          <a:bodyPr wrap="square" lIns="0" tIns="0" rIns="0" bIns="0" rtlCol="0" anchor="b"/>
-          <a:lstStyle/>
-          <a:p>
-            <a:pPr indent="0" marL="0">
-              <a:buNone/>
-            </a:pPr>
-            <a:r>
-              <a:rPr lang="en-US" sz="1200" b="1" dirty="0">
-                <a:solidFill>
-                  <a:srgbClr val="8FA6B8"/>
-                </a:solidFill>
-                <a:latin typeface="Calibri" pitchFamily="34" charset="0"/>
-                <a:ea typeface="Calibri" pitchFamily="34" charset="-122"/>
-                <a:cs typeface="Calibri" pitchFamily="34" charset="-120"/>
-              </a:rPr>
-              <a:t>Photo: </a:t>
-            </a:r>
-            <a:r>
-              <a:rPr lang="en-US" sz="1200" dirty="0">
-                <a:solidFill>
-                  <a:srgbClr val="8FA6B8"/>
-                </a:solidFill>
-                <a:latin typeface="Calibri" pitchFamily="34" charset="0"/>
-                <a:ea typeface="Calibri" pitchFamily="34" charset="-122"/>
-                <a:cs typeface="Calibri" pitchFamily="34" charset="-120"/>
-              </a:rPr>
-              <a:t>farmland irrigation in the Sharon (add a real photo)</a:t>
-            </a:r>
-            <a:endParaRPr lang="en-US" sz="1200" dirty="0"/>
-          </a:p>
-        </p:txBody>
-      </p:sp>
-      <p:sp>
-        <p:nvSpPr>
-          <p:cNvPr id="4" name="title"/>
-          <p:cNvSpPr txBox="1"/>
-          <p:nvPr/>
-        </p:nvSpPr>
-        <p:spPr>
-          <a:xfrm>
-            <a:off x="548640" y="1005840"/>
-            <a:ext cx="5486400" cy="1554480"/>
-          </a:xfrm>
-          <a:prstGeom prst="rect">
-            <a:avLst/>
-          </a:prstGeom>
-          <a:noFill/>
-          <a:ln/>
-        </p:spPr>
-        <p:txBody>
-          <a:bodyPr wrap="square" lIns="0" tIns="0" rIns="0" bIns="0" rtlCol="0" anchor="b"/>
-          <a:lstStyle/>
-          <a:p>
-            <a:pPr indent="0" marL="0">
-              <a:buNone/>
-            </a:pPr>
-            <a:r>
-              <a:rPr lang="en-US" sz="4800" dirty="0">
-                <a:solidFill>
-                  <a:srgbClr val="FFFFFF"/>
-                </a:solidFill>
-                <a:latin typeface="Cambria" pitchFamily="34" charset="0"/>
-                <a:ea typeface="Cambria" pitchFamily="34" charset="-122"/>
-                <a:cs typeface="Cambria" pitchFamily="34" charset="-120"/>
-              </a:rPr>
-              <a:t>The cloud is not in the sky.</a:t>
-            </a:r>
-            <a:endParaRPr lang="en-US" sz="4800" dirty="0"/>
-          </a:p>
-        </p:txBody>
-      </p:sp>
-      <p:sp>
-        <p:nvSpPr>
-          <p:cNvPr id="5" name="title"/>
-          <p:cNvSpPr txBox="1"/>
-          <p:nvPr/>
-        </p:nvSpPr>
-        <p:spPr>
-          <a:xfrm>
-            <a:off x="548640" y="2697480"/>
-            <a:ext cx="5486400" cy="548640"/>
+            <a:off x="548640" y="365760"/>
+            <a:ext cx="6675120" cy="822960"/>
           </a:xfrm>
           <a:prstGeom prst="rect">
             <a:avLst/>
@@ -4145,30 +3568,30 @@
               <a:buNone/>
             </a:pPr>
             <a:r>
-              <a:rPr lang="en-US" sz="2800" i="1" dirty="0">
-                <a:solidFill>
-                  <a:srgbClr val="F2A33A"/>
+              <a:rPr lang="en-US" sz="3400" b="1" dirty="0">
+                <a:solidFill>
+                  <a:srgbClr val="FFFFFF"/>
                 </a:solidFill>
                 <a:latin typeface="Cambria" pitchFamily="34" charset="0"/>
                 <a:ea typeface="Cambria" pitchFamily="34" charset="-122"/>
                 <a:cs typeface="Cambria" pitchFamily="34" charset="-120"/>
               </a:rPr>
-              <a:t>It is next door, in the Sharon.</a:t>
-            </a:r>
-            <a:endParaRPr lang="en-US" sz="2800" dirty="0"/>
+              <a:t>What Would We Do? Our Plan</a:t>
+            </a:r>
+            <a:endParaRPr lang="en-US" sz="3400" dirty="0"/>
           </a:p>
         </p:txBody>
       </p:sp>
       <p:sp>
         <p:nvSpPr>
-          <p:cNvPr id="6" name="body"/>
+          <p:cNvPr id="3" name="header"/>
           <p:cNvSpPr txBox="1"/>
           <p:nvPr/>
         </p:nvSpPr>
         <p:spPr>
           <a:xfrm>
-            <a:off x="548640" y="3611880"/>
-            <a:ext cx="5486400" cy="868680"/>
+            <a:off x="548640" y="1188720"/>
+            <a:ext cx="6583680" cy="411480"/>
           </a:xfrm>
           <a:prstGeom prst="rect">
             <a:avLst/>
@@ -4184,47 +3607,61 @@
               <a:buNone/>
             </a:pPr>
             <a:r>
-              <a:rPr lang="en-US" sz="2400" dirty="0">
-                <a:solidFill>
-                  <a:srgbClr val="D3DEE6"/>
-                </a:solidFill>
-                <a:latin typeface="Calibri" pitchFamily="34" charset="0"/>
-                <a:ea typeface="Calibri" pitchFamily="34" charset="-122"/>
-                <a:cs typeface="Calibri" pitchFamily="34" charset="-120"/>
-              </a:rPr>
-              <a:t>Ask two questions:</a:t>
-            </a:r>
-            <a:endParaRPr lang="en-US" sz="2400" dirty="0"/>
-          </a:p>
-          <a:p>
-            <a:pPr indent="0" marL="0">
-              <a:buNone/>
-            </a:pPr>
-            <a:r>
-              <a:rPr lang="en-US" sz="2400" b="1" dirty="0">
-                <a:solidFill>
-                  <a:srgbClr val="FFFFFF"/>
-                </a:solidFill>
-                <a:latin typeface="Calibri" pitchFamily="34" charset="0"/>
-                <a:ea typeface="Calibri" pitchFamily="34" charset="-122"/>
-                <a:cs typeface="Calibri" pitchFamily="34" charset="-120"/>
-              </a:rPr>
-              <a:t>Who decides? Who pays?</a:t>
-            </a:r>
-            <a:endParaRPr lang="en-US" sz="2400" dirty="0"/>
+              <a:rPr lang="en-US" sz="2200" i="1" dirty="0">
+                <a:solidFill>
+                  <a:srgbClr val="F2A33A"/>
+                </a:solidFill>
+                <a:latin typeface="Calibri" pitchFamily="34" charset="0"/>
+                <a:ea typeface="Calibri" pitchFamily="34" charset="-122"/>
+                <a:cs typeface="Calibri" pitchFamily="34" charset="-120"/>
+              </a:rPr>
+              <a:t>A policy reform for AI sustainability</a:t>
+            </a:r>
+            <a:endParaRPr lang="en-US" sz="2200" dirty="0"/>
           </a:p>
         </p:txBody>
       </p:sp>
       <p:sp>
         <p:nvSpPr>
-          <p:cNvPr id="7" name="body"/>
+          <p:cNvPr id="4" name="Shape 2"/>
+          <p:cNvSpPr/>
+          <p:nvPr/>
+        </p:nvSpPr>
+        <p:spPr>
+          <a:xfrm>
+            <a:off x="411480" y="1783080"/>
+            <a:ext cx="6537960" cy="3657600"/>
+          </a:xfrm>
+          <a:prstGeom prst="roundRect">
+            <a:avLst>
+              <a:gd name="adj" fmla="val 3000"/>
+            </a:avLst>
+          </a:prstGeom>
+          <a:solidFill>
+            <a:srgbClr val="0B2239">
+              <a:alpha val="82000"/>
+            </a:srgbClr>
+          </a:solidFill>
+          <a:ln w="12700">
+            <a:solidFill>
+              <a:srgbClr val="0B2239">
+                <a:alpha val="0"/>
+              </a:srgbClr>
+            </a:solidFill>
+            <a:prstDash val="solid"/>
+          </a:ln>
+        </p:spPr>
+      </p:sp>
+      <p:sp>
+        <p:nvSpPr>
+          <p:cNvPr id="5" name="body"/>
           <p:cNvSpPr txBox="1"/>
           <p:nvPr/>
         </p:nvSpPr>
         <p:spPr>
           <a:xfrm>
-            <a:off x="548640" y="4663440"/>
-            <a:ext cx="5486400" cy="457200"/>
+            <a:off x="685800" y="1965960"/>
+            <a:ext cx="6126480" cy="1691640"/>
           </a:xfrm>
           <a:prstGeom prst="rect">
             <a:avLst/>
@@ -4236,22 +3673,16 @@
           <a:bodyPr wrap="square" lIns="0" tIns="0" rIns="0" bIns="0" rtlCol="0" anchor="t"/>
           <a:lstStyle/>
           <a:p>
-            <a:pPr indent="0" marL="0">
-              <a:buNone/>
-            </a:pPr>
-            <a:r>
-              <a:rPr lang="en-US" sz="2400" dirty="0">
-                <a:solidFill>
-                  <a:srgbClr val="D3DEE6"/>
-                </a:solidFill>
-                <a:latin typeface="Calibri" pitchFamily="34" charset="0"/>
-                <a:ea typeface="Calibri" pitchFamily="34" charset="-122"/>
-                <a:cs typeface="Calibri" pitchFamily="34" charset="-120"/>
-              </a:rPr>
-              <a:t>Real </a:t>
-            </a:r>
-            <a:r>
-              <a:rPr lang="en-US" sz="2400" b="1" dirty="0">
+            <a:pPr marL="342900" indent="-342900">
+              <a:spcAft>
+                <a:spcPts val="1200"/>
+              </a:spcAft>
+              <a:buSzPct val="100000"/>
+              <a:buFont typeface="+mj-lt"/>
+              <a:buAutoNum type="arabicPeriod" startAt="1"/>
+            </a:pPr>
+            <a:r>
+              <a:rPr lang="en-US" sz="2100" dirty="0">
                 <a:solidFill>
                   <a:srgbClr val="FFFFFF"/>
                 </a:solidFill>
@@ -4259,21 +3690,21 @@
                 <a:ea typeface="Calibri" pitchFamily="34" charset="-122"/>
                 <a:cs typeface="Calibri" pitchFamily="34" charset="-120"/>
               </a:rPr>
-              <a:t>sustainability</a:t>
-            </a:r>
-            <a:r>
-              <a:rPr lang="en-US" sz="2400" dirty="0">
-                <a:solidFill>
-                  <a:srgbClr val="D3DEE6"/>
-                </a:solidFill>
-                <a:latin typeface="Calibri" pitchFamily="34" charset="0"/>
-                <a:ea typeface="Calibri" pitchFamily="34" charset="-122"/>
-                <a:cs typeface="Calibri" pitchFamily="34" charset="-120"/>
-              </a:rPr>
-              <a:t> includes </a:t>
-            </a:r>
-            <a:r>
-              <a:rPr lang="en-US" sz="2400" b="1" dirty="0">
+              <a:t>Companies release local versions of their LLMs</a:t>
+            </a:r>
+            <a:endParaRPr lang="en-US" sz="2100" dirty="0"/>
+          </a:p>
+          <a:p>
+            <a:pPr marL="342900" indent="-342900">
+              <a:spcAft>
+                <a:spcPts val="1200"/>
+              </a:spcAft>
+              <a:buSzPct val="100000"/>
+              <a:buFont typeface="+mj-lt"/>
+              <a:buAutoNum type="arabicPeriod" startAt="1"/>
+            </a:pPr>
+            <a:r>
+              <a:rPr lang="en-US" sz="2100" dirty="0">
                 <a:solidFill>
                   <a:srgbClr val="FFFFFF"/>
                 </a:solidFill>
@@ -4281,22 +3712,44 @@
                 <a:ea typeface="Calibri" pitchFamily="34" charset="-122"/>
                 <a:cs typeface="Calibri" pitchFamily="34" charset="-120"/>
               </a:rPr>
-              <a:t>social justice</a:t>
-            </a:r>
-            <a:endParaRPr lang="en-US" sz="2400" dirty="0"/>
+              <a:t>Optimize models, not just make them bigger</a:t>
+            </a:r>
+            <a:endParaRPr lang="en-US" sz="2100" dirty="0"/>
+          </a:p>
+          <a:p>
+            <a:pPr marL="342900" indent="-342900">
+              <a:spcAft>
+                <a:spcPts val="1200"/>
+              </a:spcAft>
+              <a:buSzPct val="100000"/>
+              <a:buFont typeface="+mj-lt"/>
+              <a:buAutoNum type="arabicPeriod" startAt="1"/>
+            </a:pPr>
+            <a:r>
+              <a:rPr lang="en-US" sz="2100" dirty="0">
+                <a:solidFill>
+                  <a:srgbClr val="FFFFFF"/>
+                </a:solidFill>
+                <a:latin typeface="Calibri" pitchFamily="34" charset="0"/>
+                <a:ea typeface="Calibri" pitchFamily="34" charset="-122"/>
+                <a:cs typeface="Calibri" pitchFamily="34" charset="-120"/>
+              </a:rPr>
+              <a:t>Keep data centers for training and giant models</a:t>
+            </a:r>
+            <a:endParaRPr lang="en-US" sz="2100" dirty="0"/>
           </a:p>
         </p:txBody>
       </p:sp>
       <p:sp>
         <p:nvSpPr>
-          <p:cNvPr id="8" name="body"/>
+          <p:cNvPr id="6" name="body"/>
           <p:cNvSpPr txBox="1"/>
           <p:nvPr/>
         </p:nvSpPr>
         <p:spPr>
           <a:xfrm>
-            <a:off x="548640" y="5669280"/>
-            <a:ext cx="5486400" cy="457200"/>
+            <a:off x="685800" y="3840480"/>
+            <a:ext cx="6126480" cy="1463040"/>
           </a:xfrm>
           <a:prstGeom prst="rect">
             <a:avLst/>
@@ -4308,21 +3761,157 @@
           <a:bodyPr wrap="square" lIns="0" tIns="0" rIns="0" bIns="0" rtlCol="0" anchor="t"/>
           <a:lstStyle/>
           <a:p>
+            <a:pPr marL="279400" indent="-279400">
+              <a:spcAft>
+                <a:spcPts val="1200"/>
+              </a:spcAft>
+              <a:buSzPct val="100000"/>
+              <a:buChar char="•"/>
+            </a:pPr>
+            <a:r>
+              <a:rPr lang="en-US" sz="2100" b="1" dirty="0">
+                <a:solidFill>
+                  <a:srgbClr val="F2A33A"/>
+                </a:solidFill>
+                <a:latin typeface="Calibri" pitchFamily="34" charset="0"/>
+                <a:ea typeface="Calibri" pitchFamily="34" charset="-122"/>
+                <a:cs typeface="Calibri" pitchFamily="34" charset="-120"/>
+              </a:rPr>
+              <a:t>Could bring: </a:t>
+            </a:r>
+            <a:r>
+              <a:rPr lang="en-US" sz="2100" dirty="0">
+                <a:solidFill>
+                  <a:srgbClr val="E3EBF1"/>
+                </a:solidFill>
+                <a:latin typeface="Calibri" pitchFamily="34" charset="0"/>
+                <a:ea typeface="Calibri" pitchFamily="34" charset="-122"/>
+                <a:cs typeface="Calibri" pitchFamily="34" charset="-120"/>
+              </a:rPr>
+              <a:t>less water, less land, more privacy</a:t>
+            </a:r>
+            <a:endParaRPr lang="en-US" sz="2100" dirty="0"/>
+          </a:p>
+          <a:p>
+            <a:pPr marL="279400" indent="-279400">
+              <a:spcAft>
+                <a:spcPts val="1200"/>
+              </a:spcAft>
+              <a:buSzPct val="100000"/>
+              <a:buChar char="•"/>
+            </a:pPr>
+            <a:r>
+              <a:rPr lang="en-US" sz="2100" b="1" dirty="0">
+                <a:solidFill>
+                  <a:srgbClr val="F2A33A"/>
+                </a:solidFill>
+                <a:latin typeface="Calibri" pitchFamily="34" charset="0"/>
+                <a:ea typeface="Calibri" pitchFamily="34" charset="-122"/>
+                <a:cs typeface="Calibri" pitchFamily="34" charset="-120"/>
+              </a:rPr>
+              <a:t>Awareness idea: </a:t>
+            </a:r>
+            <a:r>
+              <a:rPr lang="en-US" sz="2100" dirty="0">
+                <a:solidFill>
+                  <a:srgbClr val="E3EBF1"/>
+                </a:solidFill>
+                <a:latin typeface="Calibri" pitchFamily="34" charset="0"/>
+                <a:ea typeface="Calibri" pitchFamily="34" charset="-122"/>
+                <a:cs typeface="Calibri" pitchFamily="34" charset="-120"/>
+              </a:rPr>
+              <a:t>an “AI label” for water, power</a:t>
+            </a:r>
+            <a:endParaRPr lang="en-US" sz="2100" dirty="0"/>
+          </a:p>
+        </p:txBody>
+      </p:sp>
+      <p:sp>
+        <p:nvSpPr>
+          <p:cNvPr id="7" name="quote"/>
+          <p:cNvSpPr txBox="1"/>
+          <p:nvPr/>
+        </p:nvSpPr>
+        <p:spPr>
+          <a:xfrm>
+            <a:off x="7315200" y="457200"/>
+            <a:ext cx="4434840" cy="2011680"/>
+          </a:xfrm>
+          <a:prstGeom prst="rect">
+            <a:avLst/>
+          </a:prstGeom>
+          <a:noFill/>
+          <a:ln/>
+        </p:spPr>
+        <p:txBody>
+          <a:bodyPr wrap="square" lIns="0" tIns="0" rIns="0" bIns="0" rtlCol="0" anchor="t"/>
+          <a:lstStyle/>
+          <a:p>
             <a:pPr indent="0" marL="0">
               <a:buNone/>
             </a:pPr>
             <a:r>
-              <a:rPr lang="en-US" sz="2000" dirty="0">
-                <a:solidFill>
-                  <a:srgbClr val="8FA6B8"/>
-                </a:solidFill>
-                <a:latin typeface="Calibri" pitchFamily="34" charset="0"/>
-                <a:ea typeface="Calibri" pitchFamily="34" charset="-122"/>
-                <a:cs typeface="Calibri" pitchFamily="34" charset="-120"/>
-              </a:rPr>
-              <a:t>Thank you! Questions?</a:t>
-            </a:r>
-            <a:endParaRPr lang="en-US" sz="2000" dirty="0"/>
+              <a:rPr lang="en-US" sz="2800" b="1" dirty="0">
+                <a:solidFill>
+                  <a:srgbClr val="FFFFFF"/>
+                </a:solidFill>
+                <a:latin typeface="Cambria" pitchFamily="34" charset="0"/>
+                <a:ea typeface="Cambria" pitchFamily="34" charset="-122"/>
+                <a:cs typeface="Cambria" pitchFamily="34" charset="-120"/>
+              </a:rPr>
+              <a:t>“Don’t just build bigger data centers. </a:t>
+            </a:r>
+            <a:r>
+              <a:rPr lang="en-US" sz="2800" b="1" dirty="0">
+                <a:solidFill>
+                  <a:srgbClr val="F2A33A"/>
+                </a:solidFill>
+                <a:latin typeface="Cambria" pitchFamily="34" charset="0"/>
+                <a:ea typeface="Cambria" pitchFamily="34" charset="-122"/>
+                <a:cs typeface="Cambria" pitchFamily="34" charset="-120"/>
+              </a:rPr>
+              <a:t>Make AI smarter and more efficient.”</a:t>
+            </a:r>
+            <a:endParaRPr lang="en-US" sz="2800" dirty="0"/>
+          </a:p>
+        </p:txBody>
+      </p:sp>
+      <p:sp>
+        <p:nvSpPr>
+          <p:cNvPr id="8" name="caption-sources"/>
+          <p:cNvSpPr txBox="1"/>
+          <p:nvPr/>
+        </p:nvSpPr>
+        <p:spPr>
+          <a:xfrm>
+            <a:off x="548640" y="6355080"/>
+            <a:ext cx="11064240" cy="347472"/>
+          </a:xfrm>
+          <a:prstGeom prst="rect">
+            <a:avLst/>
+          </a:prstGeom>
+          <a:noFill/>
+          <a:ln/>
+        </p:spPr>
+        <p:txBody>
+          <a:bodyPr wrap="square" lIns="0" tIns="0" rIns="0" bIns="0" rtlCol="0" anchor="ctr"/>
+          <a:lstStyle/>
+          <a:p>
+            <a:pPr indent="0" marL="0">
+              <a:buNone/>
+            </a:pPr>
+            <a:r>
+              <a:rPr lang="en-US" sz="1050" dirty="0">
+                <a:solidFill>
+                  <a:srgbClr val="A9BCCB"/>
+                </a:solidFill>
+                <a:latin typeface="Calibri" pitchFamily="34" charset="0"/>
+                <a:ea typeface="Calibri" pitchFamily="34" charset="-122"/>
+                <a:cs typeface="Calibri" pitchFamily="34" charset="-120"/>
+              </a:rPr>
+              <a:t>Our team’s plan · Sources for efficiency: Google 2025 (energy per prompt −33× in one year), Microsoft Phi-3 2024  ·  Images: 3D illustrations made for this presentation</a:t>
+            </a:r>
+            <a:endParaRPr lang="en-US" sz="1050" dirty="0"/>
           </a:p>
         </p:txBody>
       </p:sp>

</xml_diff>

<commit_message>
Use team's AI-generated protest and NPU images on Slides 3 and 5
Slide 3 now uses the team's drone-view protest image (one banner with
scrambled AI text blurred) with the text panel moved left so the crowd
and banners stay visible. Slide 5 uses the team's AI NPU chip image with
a narrower panel. Both slides are labelled as AI-generated illustrations.

Co-Authored-By: Claude Opus 5.5 <noreply@anthropic.com>
Claude-Session: https://claude.ai/code/session_01D1yfgr7znJrRSehnJ7HGe8
</commit_message>
<xml_diff>
--- a/ai-water-deck.pptx
+++ b/ai-water-deck.pptx
@@ -1240,7 +1240,7 @@
             <a:r>
               <a:rPr lang="en-US" dirty="0"/>
               <a:t>SLIDE 3 – talking points and sources
-- Background: a 3D illustration (not a real event) of residents protesting at the gate of a data center, seen from a drone.
+- Background: an AI-generated image made by our team; not a real event. It shows residents protesting at the gate of a data center, seen from a drone.
 - SPNI [S25]: publicly opposed the bill that makes AI server farms 'national infrastructure'. Warned of a 'destructive domino effect' on open land and energy security. Wants the status only for security, intelligence and academic use. Also active: Greenpeace Israel, Green Course.
 - The bill [S24]: Planning and Building Law amendment. AI server farms of 50 MW or more become 'national infrastructure'. They go to the National Infrastructure Committee and skip local and district committees and their objections. Passed first reading on 1 June 2026. FINAL PASSAGE UNVERIFIED: check before presenting.
 - Discrimination (required word): when big projects skip local committees, the people who live next door lose their voice. Critics say this is unfair and can become discrimination against small communities. We did not find proof that Israel targets poor areas on purpose.
@@ -1441,7 +1441,7 @@
 5. Data centers can still be used for extremely large models and training.
 Possible benefits: less need for new data centers; less land used for AI infrastructure; potentially less water needed for cooling; more AI can run directly on people's computers; more privacy and control for users.
 Our message: Don't just build bigger data centers. Make AI smarter and more efficient.
-Background: a 3D illustration of a small, efficient AI chip in focus, with a big data center blurred behind it.
+Background: an AI-generated image made by our team: a low-power AI chip (NPU) in front of rows of data-center servers. The chip's label and numbers are part of the illustration, not a real product.
 Awareness idea: an 'AI label' (like a food label) showing how much water and electricity an AI tool uses, with the source and year.
 Likely question: 'How do you make companies do this?' Answer: public pressure and awareness, plus reporting laws like the EU rule [S28], which make water and power use visible.
 Be honest: training still needs data centers, and local AI still uses electricity. The benefit comes from smaller, more efficient models.</a:t>
@@ -2818,17 +2818,17 @@
         </p:nvSpPr>
         <p:spPr>
           <a:xfrm>
-            <a:off x="7360920" y="1280160"/>
-            <a:ext cx="4434840" cy="5440680"/>
+            <a:off x="320040" y="1234440"/>
+            <a:ext cx="4206240" cy="5440680"/>
           </a:xfrm>
           <a:prstGeom prst="roundRect">
             <a:avLst>
-              <a:gd name="adj" fmla="val 2474"/>
+              <a:gd name="adj" fmla="val 2609"/>
             </a:avLst>
           </a:prstGeom>
           <a:solidFill>
             <a:srgbClr val="0B2239">
-              <a:alpha val="86000"/>
+              <a:alpha val="88000"/>
             </a:srgbClr>
           </a:solidFill>
           <a:ln w="12700">
@@ -2849,8 +2849,8 @@
         </p:nvSpPr>
         <p:spPr>
           <a:xfrm>
-            <a:off x="7589520" y="1417320"/>
-            <a:ext cx="4023360" cy="777240"/>
+            <a:off x="548640" y="1371600"/>
+            <a:ext cx="3794760" cy="777240"/>
           </a:xfrm>
           <a:prstGeom prst="rect">
             <a:avLst/>
@@ -2905,8 +2905,8 @@
         </p:nvSpPr>
         <p:spPr>
           <a:xfrm>
-            <a:off x="7589520" y="2240280"/>
-            <a:ext cx="4069080" cy="1463040"/>
+            <a:off x="548640" y="2194560"/>
+            <a:ext cx="3840480" cy="1508760"/>
           </a:xfrm>
           <a:prstGeom prst="rect">
             <a:avLst/>
@@ -2969,8 +2969,8 @@
         </p:nvSpPr>
         <p:spPr>
           <a:xfrm>
-            <a:off x="7589520" y="3749040"/>
-            <a:ext cx="4023360" cy="457200"/>
+            <a:off x="548640" y="3749040"/>
+            <a:ext cx="3794760" cy="457200"/>
           </a:xfrm>
           <a:prstGeom prst="rect">
             <a:avLst/>
@@ -2986,7 +2986,7 @@
               <a:buNone/>
             </a:pPr>
             <a:r>
-              <a:rPr lang="en-US" sz="2400" b="1" dirty="0">
+              <a:rPr lang="en-US" sz="2200" b="1" dirty="0">
                 <a:solidFill>
                   <a:srgbClr val="FFFFFF"/>
                 </a:solidFill>
@@ -2996,7 +2996,7 @@
               </a:rPr>
               <a:t>Legislation &amp; regulation</a:t>
             </a:r>
-            <a:endParaRPr lang="en-US" sz="2400" dirty="0"/>
+            <a:endParaRPr lang="en-US" sz="2200" dirty="0"/>
           </a:p>
         </p:txBody>
       </p:sp>
@@ -3008,8 +3008,8 @@
         </p:nvSpPr>
         <p:spPr>
           <a:xfrm>
-            <a:off x="7589520" y="4251960"/>
-            <a:ext cx="4069080" cy="2011680"/>
+            <a:off x="548640" y="4251960"/>
+            <a:ext cx="3840480" cy="1783080"/>
           </a:xfrm>
           <a:prstGeom prst="rect">
             <a:avLst/>
@@ -3126,8 +3126,8 @@
         </p:nvSpPr>
         <p:spPr>
           <a:xfrm>
-            <a:off x="7589520" y="6263640"/>
-            <a:ext cx="4069080" cy="411480"/>
+            <a:off x="548640" y="6108192"/>
+            <a:ext cx="3794760" cy="502920"/>
           </a:xfrm>
           <a:prstGeom prst="rect">
             <a:avLst/>
@@ -3151,7 +3151,7 @@
                 <a:ea typeface="Calibri" pitchFamily="34" charset="-122"/>
                 <a:cs typeface="Calibri" pitchFamily="34" charset="-120"/>
               </a:rPr>
-              <a:t>Sources: Calcalist 2026 (SPNI) · Knesset bill, 1st reading 1 Jun 2026 · EU Dir. 2023/1791 Art. 12 · Water Law 1959 · Images: 3D illustrations made for this presentation</a:t>
+              <a:t>Sources: Calcalist 2026 (SPNI) · Knesset bill, 1st reading 1 Jun 2026 · EU Dir. 2023/1791 Art. 12 · Water Law 1959 · Image: AI-generated illustration, not a real event</a:t>
             </a:r>
             <a:endParaRPr lang="en-US" sz="900" dirty="0"/>
           </a:p>
@@ -3629,17 +3629,17 @@
         </p:nvSpPr>
         <p:spPr>
           <a:xfrm>
-            <a:off x="411480" y="1783080"/>
-            <a:ext cx="6537960" cy="3657600"/>
+            <a:off x="365760" y="1737360"/>
+            <a:ext cx="4297680" cy="4434840"/>
           </a:xfrm>
           <a:prstGeom prst="roundRect">
             <a:avLst>
-              <a:gd name="adj" fmla="val 3000"/>
+              <a:gd name="adj" fmla="val 2553"/>
             </a:avLst>
           </a:prstGeom>
           <a:solidFill>
             <a:srgbClr val="0B2239">
-              <a:alpha val="82000"/>
+              <a:alpha val="86000"/>
             </a:srgbClr>
           </a:solidFill>
           <a:ln w="12700">
@@ -3660,8 +3660,8 @@
         </p:nvSpPr>
         <p:spPr>
           <a:xfrm>
-            <a:off x="685800" y="1965960"/>
-            <a:ext cx="6126480" cy="1691640"/>
+            <a:off x="566928" y="1874520"/>
+            <a:ext cx="3977640" cy="2331720"/>
           </a:xfrm>
           <a:prstGeom prst="rect">
             <a:avLst/>
@@ -3675,14 +3675,14 @@
           <a:p>
             <a:pPr marL="342900" indent="-342900">
               <a:spcAft>
-                <a:spcPts val="1200"/>
+                <a:spcPts val="1000"/>
               </a:spcAft>
               <a:buSzPct val="100000"/>
               <a:buFont typeface="+mj-lt"/>
               <a:buAutoNum type="arabicPeriod" startAt="1"/>
             </a:pPr>
             <a:r>
-              <a:rPr lang="en-US" sz="2100" dirty="0">
+              <a:rPr lang="en-US" sz="2000" dirty="0">
                 <a:solidFill>
                   <a:srgbClr val="FFFFFF"/>
                 </a:solidFill>
@@ -3692,19 +3692,19 @@
               </a:rPr>
               <a:t>Companies release local versions of their LLMs</a:t>
             </a:r>
-            <a:endParaRPr lang="en-US" sz="2100" dirty="0"/>
+            <a:endParaRPr lang="en-US" sz="2000" dirty="0"/>
           </a:p>
           <a:p>
             <a:pPr marL="342900" indent="-342900">
               <a:spcAft>
-                <a:spcPts val="1200"/>
+                <a:spcPts val="1000"/>
               </a:spcAft>
               <a:buSzPct val="100000"/>
               <a:buFont typeface="+mj-lt"/>
               <a:buAutoNum type="arabicPeriod" startAt="1"/>
             </a:pPr>
             <a:r>
-              <a:rPr lang="en-US" sz="2100" dirty="0">
+              <a:rPr lang="en-US" sz="2000" dirty="0">
                 <a:solidFill>
                   <a:srgbClr val="FFFFFF"/>
                 </a:solidFill>
@@ -3714,19 +3714,19 @@
               </a:rPr>
               <a:t>Optimize models, not just make them bigger</a:t>
             </a:r>
-            <a:endParaRPr lang="en-US" sz="2100" dirty="0"/>
+            <a:endParaRPr lang="en-US" sz="2000" dirty="0"/>
           </a:p>
           <a:p>
             <a:pPr marL="342900" indent="-342900">
               <a:spcAft>
-                <a:spcPts val="1200"/>
+                <a:spcPts val="1000"/>
               </a:spcAft>
               <a:buSzPct val="100000"/>
               <a:buFont typeface="+mj-lt"/>
               <a:buAutoNum type="arabicPeriod" startAt="1"/>
             </a:pPr>
             <a:r>
-              <a:rPr lang="en-US" sz="2100" dirty="0">
+              <a:rPr lang="en-US" sz="2000" dirty="0">
                 <a:solidFill>
                   <a:srgbClr val="FFFFFF"/>
                 </a:solidFill>
@@ -3736,7 +3736,7 @@
               </a:rPr>
               <a:t>Keep data centers for training and giant models</a:t>
             </a:r>
-            <a:endParaRPr lang="en-US" sz="2100" dirty="0"/>
+            <a:endParaRPr lang="en-US" sz="2000" dirty="0"/>
           </a:p>
         </p:txBody>
       </p:sp>
@@ -3748,8 +3748,8 @@
         </p:nvSpPr>
         <p:spPr>
           <a:xfrm>
-            <a:off x="685800" y="3840480"/>
-            <a:ext cx="6126480" cy="1463040"/>
+            <a:off x="566928" y="4297680"/>
+            <a:ext cx="3977640" cy="1783080"/>
           </a:xfrm>
           <a:prstGeom prst="rect">
             <a:avLst/>
@@ -3763,13 +3763,13 @@
           <a:p>
             <a:pPr marL="279400" indent="-279400">
               <a:spcAft>
-                <a:spcPts val="1200"/>
+                <a:spcPts val="1000"/>
               </a:spcAft>
               <a:buSzPct val="100000"/>
               <a:buChar char="•"/>
             </a:pPr>
             <a:r>
-              <a:rPr lang="en-US" sz="2100" b="1" dirty="0">
+              <a:rPr lang="en-US" sz="2000" b="1" dirty="0">
                 <a:solidFill>
                   <a:srgbClr val="F2A33A"/>
                 </a:solidFill>
@@ -3780,7 +3780,7 @@
               <a:t>Could bring: </a:t>
             </a:r>
             <a:r>
-              <a:rPr lang="en-US" sz="2100" dirty="0">
+              <a:rPr lang="en-US" sz="2000" dirty="0">
                 <a:solidFill>
                   <a:srgbClr val="E3EBF1"/>
                 </a:solidFill>
@@ -3790,18 +3790,18 @@
               </a:rPr>
               <a:t>less water, less land, more privacy</a:t>
             </a:r>
-            <a:endParaRPr lang="en-US" sz="2100" dirty="0"/>
+            <a:endParaRPr lang="en-US" sz="2000" dirty="0"/>
           </a:p>
           <a:p>
             <a:pPr marL="279400" indent="-279400">
               <a:spcAft>
-                <a:spcPts val="1200"/>
+                <a:spcPts val="1000"/>
               </a:spcAft>
               <a:buSzPct val="100000"/>
               <a:buChar char="•"/>
             </a:pPr>
             <a:r>
-              <a:rPr lang="en-US" sz="2100" b="1" dirty="0">
+              <a:rPr lang="en-US" sz="2000" b="1" dirty="0">
                 <a:solidFill>
                   <a:srgbClr val="F2A33A"/>
                 </a:solidFill>
@@ -3812,7 +3812,7 @@
               <a:t>Awareness idea: </a:t>
             </a:r>
             <a:r>
-              <a:rPr lang="en-US" sz="2100" dirty="0">
+              <a:rPr lang="en-US" sz="2000" dirty="0">
                 <a:solidFill>
                   <a:srgbClr val="E3EBF1"/>
                 </a:solidFill>
@@ -3822,7 +3822,7 @@
               </a:rPr>
               <a:t>an “AI label” for water, power</a:t>
             </a:r>
-            <a:endParaRPr lang="en-US" sz="2100" dirty="0"/>
+            <a:endParaRPr lang="en-US" sz="2000" dirty="0"/>
           </a:p>
         </p:txBody>
       </p:sp>
@@ -3834,8 +3834,8 @@
         </p:nvSpPr>
         <p:spPr>
           <a:xfrm>
-            <a:off x="7315200" y="457200"/>
-            <a:ext cx="4434840" cy="2011680"/>
+            <a:off x="6903720" y="365760"/>
+            <a:ext cx="4892040" cy="2011680"/>
           </a:xfrm>
           <a:prstGeom prst="rect">
             <a:avLst/>
@@ -3909,7 +3909,7 @@
                 <a:ea typeface="Calibri" pitchFamily="34" charset="-122"/>
                 <a:cs typeface="Calibri" pitchFamily="34" charset="-120"/>
               </a:rPr>
-              <a:t>Our team’s plan · Sources for efficiency: Google 2025 (energy per prompt −33× in one year), Microsoft Phi-3 2024  ·  Images: 3D illustrations made for this presentation</a:t>
+              <a:t>Our team’s plan · Sources for efficiency: Google 2025 (energy per prompt −33× in one year), Microsoft Phi-3 2024  ·  Image: AI-generated illustration</a:t>
             </a:r>
             <a:endParaRPr lang="en-US" sz="1050" dirty="0"/>
           </a:p>

</xml_diff>

<commit_message>
Use team's AI-generated server-hall image on Slide 1
Co-Authored-By: Claude Opus 5.5 <noreply@anthropic.com>
Claude-Session: https://claude.ai/code/session_01D1yfgr7znJrRSehnJ7HGe8
</commit_message>
<xml_diff>
--- a/ai-water-deck.pptx
+++ b/ai-water-deck.pptx
@@ -1049,7 +1049,7 @@
             <a:r>
               <a:rPr lang="en-US" dirty="0"/>
               <a:t>SLIDE 1 – talking points and sources (full script: speaker-notes.md)
-- Background: a 3D illustration of the inside of a data center (rows of server racks, cooling pipes).
+- Background: an AI-generated image made by our team of the inside of a data center (rows of server racks). Not a real place.
 - Data centers need water for cooling and electricity to run.
 - ON-SITE vs OFF-SITE [S1 LBNL 2024]: US data centers used 66 billion litres on-site in 2023 and about 800 billion litres off-site (water used by the power plants). 800 / 66 ≈ 12.
 - Google +70% [S6 Google Environmental Reports]: 6.4B gal = 24.2B L (2023); 8.1B gal = 30.7B L (2024); 10.9B gal = 41.3B L (2025). 41.3 / 24.2 = 1.71. Company-reported, all operations.
@@ -2281,7 +2281,7 @@
                 <a:ea typeface="Calibri" pitchFamily="34" charset="-122"/>
                 <a:cs typeface="Calibri" pitchFamily="34" charset="-120"/>
               </a:rPr>
-              <a:t>Sources: LBNL 2024 US Data Center Energy Report · Google Environmental Reports 2024–26 · The Guardian 2023, Mongabay 2023  ·  Images: 3D illustrations made for this presentation</a:t>
+              <a:t>Sources: LBNL 2024 US Data Center Energy Report · Google Environmental Reports 2024–26 · The Guardian 2023, Mongabay 2023  ·  Image: AI-generated illustration</a:t>
             </a:r>
             <a:endParaRPr lang="en-US" sz="1050" dirty="0"/>
           </a:p>

</xml_diff>

<commit_message>
Use campus photo on Slide 2; remove plant from Slide 4
Co-Authored-By: Claude Opus 5.5 <noreply@anthropic.com>
Claude-Session: https://claude.ai/code/session_01D1yfgr7znJrRSehnJ7HGe8
</commit_message>
<xml_diff>
--- a/ai-water-deck.pptx
+++ b/ai-water-deck.pptx
@@ -1143,7 +1143,7 @@
             <a:r>
               <a:rPr lang="en-US" dirty="0"/>
               <a:t>SLIDE 2 – talking points and sources
-- Background: a 3D illustration of Israel's coast at dusk. Sea, then a desalination plant, then power lines going inland to a lit data-center campus next to Sharon farm fields. It is an illustration, not a map.
+- Background: an example of a large data-center campus next to farmland, with its own electricity substation (left). It is NOT in Israel; it shows what these projects look like.
 - Chart: data-center grid demand in Israel, megawatts (2026). 1,500 MW already committed; 27,000 MW pending. 27,000 / 1,500 = 18.
 - Desalination share [S17]: sources disagree (State Comptroller 2024: 'about half'; Times of Israel 2026: over 80%). Say 'most', not a single number.
 - Desalination needs electricity [S16]: the State Comptroller (2024) names desalination AND data centers as drivers of 2030 electricity demand.
@@ -2726,7 +2726,7 @@
                 <a:ea typeface="Calibri" pitchFamily="34" charset="-122"/>
                 <a:cs typeface="Calibri" pitchFamily="34" charset="-120"/>
               </a:rPr>
-              <a:t>Sources: Electricity Authority &amp; Noga via DCD, JNS, Ctech (Jul 2026) · State Comptroller 2024 · DCD, Globes, Ctech · Times of Israel, CNN (Sep 2026)  ·  Images: 3D illustrations made for this presentation</a:t>
+              <a:t>Sources: Electricity Authority &amp; Noga via DCD, JNS, Ctech (Jul 2026) · State Comptroller 2024 · DCD, Globes, Ctech · Times of Israel, CNN (Sep 2026)  ·  Image: example data-center campus, not in Israel</a:t>
             </a:r>
             <a:endParaRPr lang="en-US" sz="1050" dirty="0"/>
           </a:p>

</xml_diff>

<commit_message>
Put speaker scripts in the slide notes; speaker notes as .txt
Each slide's notes now start with that speaker's script (Speaker B and C
split at the slide change), followed by the talking points and sources.
Notes are written as separate paragraphs so line breaks show in
PowerPoint. speaker-notes.md is replaced by a plain-text speaker-notes.txt.

Co-Authored-By: Claude Opus 5.5 <noreply@anthropic.com>
Claude-Session: https://claude.ai/code/session_01D1yfgr7znJrRSehnJ7HGe8
</commit_message>
<xml_diff>
--- a/ai-water-deck.pptx
+++ b/ai-water-deck.pptx
@@ -1047,16 +1047,126 @@
           <a:lstStyle/>
           <a:p>
             <a:r>
-              <a:rPr lang="en-US" dirty="0"/>
-              <a:t>SLIDE 1 – talking points and sources (full script: speaker-notes.md)
-- Background: an AI-generated image made by our team of the inside of a data center (rows of server racks). Not a real place.
-- Data centers need water for cooling and electricity to run.
-- ON-SITE vs OFF-SITE [S1 LBNL 2024]: US data centers used 66 billion litres on-site in 2023 and about 800 billion litres off-site (water used by the power plants). 800 / 66 ≈ 12.
-- Google +70% [S6 Google Environmental Reports]: 6.4B gal = 24.2B L (2023); 8.1B gal = 30.7B L (2024); 10.9B gal = 41.3B L (2025). 41.3 / 24.2 = 1.71. Company-reported, all operations.
-- Uruguay [S9]: 2023 drought, worst in 74 years. Montevideo tap water was mixed with salty water. Google's plan: about 7.6 million litres a day. Slogan: 'It's not drought, it's pillage.' Google made the project smaller and switched to air cooling.
-- Careful: 'one bottle of water per question' is a misreading. The study [S3] says 500 ml per about 10–50 answers.</a:t>
-            </a:r>
+              <a:rPr lang="en-US" b="1" dirty="0"/>
+              <a:t>SPEAKER A – SCRIPT (say this)</a:t>
+            </a:r>
+          </a:p>
+          <a:p>
             <a:endParaRPr lang="en-US" dirty="0"/>
+          </a:p>
+          <a:p>
+            <a:r>
+              <a:rPr lang="en-US" dirty="0"/>
+              <a:t>Hi everyone. Our topic today is AI's hidden thirst, and who pays for it.</a:t>
+            </a:r>
+          </a:p>
+          <a:p>
+            <a:endParaRPr lang="en-US" dirty="0"/>
+          </a:p>
+          <a:p>
+            <a:r>
+              <a:rPr lang="en-US" dirty="0"/>
+              <a:t>When you ask an AI chatbot a question, the work happens in huge buildings called data centers. Data centers need two things: electricity to run, and water to stay cool.</a:t>
+            </a:r>
+          </a:p>
+          <a:p>
+            <a:endParaRPr lang="en-US" dirty="0"/>
+          </a:p>
+          <a:p>
+            <a:r>
+              <a:rPr lang="en-US" dirty="0"/>
+              <a:t>There are two kinds of water use. On-site: inside the building, water evaporates to cool the servers. Off-site: the power plants that make the electricity also use water. A US government lab studied the year 2023. It found that the power plants used about twelve times more water than the data centers themselves.</a:t>
+            </a:r>
+          </a:p>
+          <a:p>
+            <a:endParaRPr lang="en-US" dirty="0"/>
+          </a:p>
+          <a:p>
+            <a:r>
+              <a:rPr lang="en-US" dirty="0"/>
+              <a:t>And it is growing fast. Look at our chart. Google's total water use went from 24 billion litres in 2023 to 41 billion in 2025. That is 70 percent more in two years.</a:t>
+            </a:r>
+          </a:p>
+          <a:p>
+            <a:endParaRPr lang="en-US" dirty="0"/>
+          </a:p>
+          <a:p>
+            <a:r>
+              <a:rPr lang="en-US" dirty="0"/>
+              <a:t>So this is a question of sustainability. But it is also a question of social justice. The benefits of AI go to people all over the world. The impact lands on the people who live near the data center.</a:t>
+            </a:r>
+          </a:p>
+          <a:p>
+            <a:endParaRPr lang="en-US" dirty="0"/>
+          </a:p>
+          <a:p>
+            <a:r>
+              <a:rPr lang="en-US" dirty="0"/>
+              <a:t>Here is an example. In 2023, Uruguay had its worst drought in 74 years. In the capital, Montevideo, the tap water turned salty. At the same time, Google planned a data center there. It would use about seven and a half million litres of water a day. People protested. After the protests, Google made the project smaller and changed to air cooling.</a:t>
+            </a:r>
+          </a:p>
+          <a:p>
+            <a:endParaRPr lang="en-US" dirty="0"/>
+          </a:p>
+          <a:p>
+            <a:r>
+              <a:rPr lang="en-US" b="1" dirty="0"/>
+              <a:t>HANDOFF -&gt; "Now [B] will show you what this looks like here in Israel."</a:t>
+            </a:r>
+          </a:p>
+          <a:p>
+            <a:endParaRPr lang="en-US" dirty="0"/>
+          </a:p>
+          <a:p>
+            <a:r>
+              <a:rPr lang="en-US" dirty="0"/>
+              <a:t>————————————————————</a:t>
+            </a:r>
+          </a:p>
+          <a:p>
+            <a:endParaRPr lang="en-US" dirty="0"/>
+          </a:p>
+          <a:p>
+            <a:r>
+              <a:rPr lang="en-US" b="1" dirty="0"/>
+              <a:t>SLIDE 1 – talking points and sources (full scripts and Q&amp;A: speaker-notes.txt)</a:t>
+            </a:r>
+          </a:p>
+          <a:p>
+            <a:r>
+              <a:rPr lang="en-US" dirty="0"/>
+              <a:t>- Background: an AI-generated image made by our team of the inside of a data center (rows of server racks). Not a real place.</a:t>
+            </a:r>
+          </a:p>
+          <a:p>
+            <a:r>
+              <a:rPr lang="en-US" dirty="0"/>
+              <a:t>- Data centers need water for cooling and electricity to run.</a:t>
+            </a:r>
+          </a:p>
+          <a:p>
+            <a:r>
+              <a:rPr lang="en-US" dirty="0"/>
+              <a:t>- ON-SITE vs OFF-SITE [S1 LBNL 2024]: US data centers used 66 billion litres on-site in 2023 and about 800 billion litres off-site (water used by the power plants). 800 / 66 ≈ 12.</a:t>
+            </a:r>
+          </a:p>
+          <a:p>
+            <a:r>
+              <a:rPr lang="en-US" dirty="0"/>
+              <a:t>- Google +70% [S6 Google Environmental Reports]: 6.4B gal = 24.2B L (2023); 8.1B gal = 30.7B L (2024); 10.9B gal = 41.3B L (2025). 41.3 / 24.2 = 1.71. Company-reported, all operations.</a:t>
+            </a:r>
+          </a:p>
+          <a:p>
+            <a:r>
+              <a:rPr lang="en-US" dirty="0"/>
+              <a:t>- Uruguay [S9]: 2023 drought, worst in 74 years. Montevideo tap water was mixed with salty water. Google's plan: about 7.6 million litres a day. Slogan: 'It's not drought, it's pillage.' Google made the project smaller and switched to air cooling.</a:t>
+            </a:r>
+          </a:p>
+          <a:p>
+            <a:r>
+              <a:rPr lang="en-US" dirty="0"/>
+              <a:t>- Careful: 'one bottle of water per question' is a misreading. The study [S3] says 500 ml per about 10–50 answers.</a:t>
+            </a:r>
           </a:p>
         </p:txBody>
       </p:sp>
@@ -1141,19 +1251,135 @@
           <a:lstStyle/>
           <a:p>
             <a:r>
-              <a:rPr lang="en-US" dirty="0"/>
-              <a:t>SLIDE 2 – talking points and sources
-- Background: an example of a large data-center campus next to farmland, with its own electricity substation (left). It is NOT in Israel; it shows what these projects look like.
-- Chart: data-center grid demand in Israel, megawatts (2026). 1,500 MW already committed; 27,000 MW pending. 27,000 / 1,500 = 18.
-- Desalination share [S17]: sources disagree (State Comptroller 2024: 'about half'; Times of Israel 2026: over 80%). Say 'most', not a single number.
-- Desalination needs electricity [S16]: the State Comptroller (2024) names desalination AND data centers as drivers of 2030 electricity demand.
-- 27,000 MW [S14, S15]: pending data-center requests to Noga, about 3 times Israel's average electricity use. 1,500 MW already committed uses up the planned new supply to 2035 (Ctech).
-- July 2026 freeze [S14]: the Electricity Authority stopped new data-center applications of 8 MW or more for 140 days from 21 July 2026 (until about early December).
-- Near us [S21, S22, S15]: MedOne, two underground data centers in Kfar Yona (next to Lev HaSharon, not inside it), first opens 2026. NED Alpha Campus in Netanya, 42 MW, early 2027. Mega Or asked for 1,111 MW at the old Alliance factory in Hadera.
-- Farms first [S18]: end of Aug 2026, algae shut 5 of 6 big desalination plants. The Water Authority told councils to cut farm and park irrigation. Ramat HaNegev farms lost fresh water completely. NOT caused by data centers. It shows who is cut first.
-- Unverified: water quotas for Lev HaSharon moshavim (no public figures found).</a:t>
-            </a:r>
+              <a:rPr lang="en-US" b="1" dirty="0"/>
+              <a:t>SPEAKER B – SCRIPT, part 1 of 2 (say this)</a:t>
+            </a:r>
+          </a:p>
+          <a:p>
             <a:endParaRPr lang="en-US" dirty="0"/>
+          </a:p>
+          <a:p>
+            <a:r>
+              <a:rPr lang="en-US" dirty="0"/>
+              <a:t>Thank you, [A]. Now let's look at Israel.</a:t>
+            </a:r>
+          </a:p>
+          <a:p>
+            <a:endParaRPr lang="en-US" dirty="0"/>
+          </a:p>
+          <a:p>
+            <a:r>
+              <a:rPr lang="en-US" dirty="0"/>
+              <a:t>Israel is different. Most of our tap water comes from the sea, through desalination. So here, the bigger problem is electricity. Desalination and data centers both need a lot of it.</a:t>
+            </a:r>
+          </a:p>
+          <a:p>
+            <a:endParaRPr lang="en-US" dirty="0"/>
+          </a:p>
+          <a:p>
+            <a:r>
+              <a:rPr lang="en-US" dirty="0"/>
+              <a:t>Look at the chart. Data centers were already promised 1,500 megawatts. That uses up all the new power planned until 2035. But new requests add up to 27,000 megawatts. That is eighteen times more, and about three times Israel's average use. So in July 2026, the Electricity Authority froze new requests for 140 days.</a:t>
+            </a:r>
+          </a:p>
+          <a:p>
+            <a:endParaRPr lang="en-US" dirty="0"/>
+          </a:p>
+          <a:p>
+            <a:r>
+              <a:rPr lang="en-US" dirty="0"/>
+              <a:t>And it is close to home: there are projects in Kfar Yona, Netanya and Hadera.</a:t>
+            </a:r>
+          </a:p>
+          <a:p>
+            <a:endParaRPr lang="en-US" dirty="0"/>
+          </a:p>
+          <a:p>
+            <a:r>
+              <a:rPr lang="en-US" dirty="0"/>
+              <a:t>In a shortage, who is cut first? In late August 2026, algae shut five of the six big desalination plants. Farms were cut first. Data centers did not cause this. But it shows who pays first.</a:t>
+            </a:r>
+          </a:p>
+          <a:p>
+            <a:endParaRPr lang="en-US" dirty="0"/>
+          </a:p>
+          <a:p>
+            <a:r>
+              <a:rPr lang="en-US" b="1" dirty="0"/>
+              <a:t>[CLICK -&gt; Slide 3]</a:t>
+            </a:r>
+          </a:p>
+          <a:p>
+            <a:endParaRPr lang="en-US" dirty="0"/>
+          </a:p>
+          <a:p>
+            <a:r>
+              <a:rPr lang="en-US" dirty="0"/>
+              <a:t>————————————————————</a:t>
+            </a:r>
+          </a:p>
+          <a:p>
+            <a:endParaRPr lang="en-US" dirty="0"/>
+          </a:p>
+          <a:p>
+            <a:r>
+              <a:rPr lang="en-US" b="1" dirty="0"/>
+              <a:t>SLIDE 2 – talking points and sources</a:t>
+            </a:r>
+          </a:p>
+          <a:p>
+            <a:r>
+              <a:rPr lang="en-US" dirty="0"/>
+              <a:t>- Background: an example of a large data-center campus next to farmland, with its own electricity substation (left). It is NOT in Israel; it shows what these projects look like.</a:t>
+            </a:r>
+          </a:p>
+          <a:p>
+            <a:r>
+              <a:rPr lang="en-US" dirty="0"/>
+              <a:t>- Chart: data-center grid demand in Israel, megawatts (2026). 1,500 MW already committed; 27,000 MW pending. 27,000 / 1,500 = 18.</a:t>
+            </a:r>
+          </a:p>
+          <a:p>
+            <a:r>
+              <a:rPr lang="en-US" dirty="0"/>
+              <a:t>- Desalination share [S17]: sources disagree (State Comptroller 2024: 'about half'; Times of Israel 2026: over 80%). Say 'most', not a single number.</a:t>
+            </a:r>
+          </a:p>
+          <a:p>
+            <a:r>
+              <a:rPr lang="en-US" dirty="0"/>
+              <a:t>- Desalination needs electricity [S16]: the State Comptroller (2024) names desalination AND data centers as drivers of 2030 electricity demand.</a:t>
+            </a:r>
+          </a:p>
+          <a:p>
+            <a:r>
+              <a:rPr lang="en-US" dirty="0"/>
+              <a:t>- 27,000 MW [S14, S15]: pending data-center requests to Noga, about 3 times Israel's average electricity use. 1,500 MW already committed uses up the planned new supply to 2035 (Ctech).</a:t>
+            </a:r>
+          </a:p>
+          <a:p>
+            <a:r>
+              <a:rPr lang="en-US" dirty="0"/>
+              <a:t>- July 2026 freeze [S14]: the Electricity Authority stopped new data-center applications of 8 MW or more for 140 days from 21 July 2026 (until about early December).</a:t>
+            </a:r>
+          </a:p>
+          <a:p>
+            <a:r>
+              <a:rPr lang="en-US" dirty="0"/>
+              <a:t>- Near us [S21, S22, S15]: MedOne, two underground data centers in Kfar Yona (next to Lev HaSharon, not inside it), first opens 2026. NED Alpha Campus in Netanya, 42 MW, early 2027. Mega Or asked for 1,111 MW at the old Alliance factory in Hadera.</a:t>
+            </a:r>
+          </a:p>
+          <a:p>
+            <a:r>
+              <a:rPr lang="en-US" dirty="0"/>
+              <a:t>- Farms first [S18]: end of Aug 2026, algae shut 5 of 6 big desalination plants. The Water Authority told councils to cut farm and park irrigation. Ramat HaNegev farms lost fresh water completely. NOT caused by data centers. It shows who is cut first.</a:t>
+            </a:r>
+          </a:p>
+          <a:p>
+            <a:r>
+              <a:rPr lang="en-US" dirty="0"/>
+              <a:t>- Unverified: water quotas for Lev HaSharon moshavim (no public figures found).</a:t>
+            </a:r>
           </a:p>
         </p:txBody>
       </p:sp>
@@ -1238,17 +1464,96 @@
           <a:lstStyle/>
           <a:p>
             <a:r>
-              <a:rPr lang="en-US" dirty="0"/>
-              <a:t>SLIDE 3 – talking points and sources
-- Background: an AI-generated image made by our team; not a real event. It shows residents protesting at the gate of a data center, seen from a drone.
-- SPNI [S25]: publicly opposed the bill that makes AI server farms 'national infrastructure'. Warned of a 'destructive domino effect' on open land and energy security. Wants the status only for security, intelligence and academic use. Also active: Greenpeace Israel, Green Course.
-- The bill [S24]: Planning and Building Law amendment. AI server farms of 50 MW or more become 'national infrastructure'. They go to the National Infrastructure Committee and skip local and district committees and their objections. Passed first reading on 1 June 2026. FINAL PASSAGE UNVERIFIED: check before presenting.
-- Discrimination (required word): when big projects skip local committees, the people who live next door lose their voice. Critics say this is unfair and can become discrimination against small communities. We did not find proof that Israel targets poor areas on purpose.
-- EU law [S28]: Energy Efficiency Directive (EU) 2023/1791, Article 12. Data centers with 500 kW or more of IT power must report energy and water use every year to an EU database.
-- Water Law [S27]: Water Law 5719-1959, section 1. Water sources in Israel are public property, controlled by the State, for the needs of the residents and the development of the country.
-- Gap: we found no Israeli rule that makes data centers publish their water or power use. Say 'we found no', not 'there is no'.</a:t>
-            </a:r>
+              <a:rPr lang="en-US" b="1" dirty="0"/>
+              <a:t>SPEAKER B – SCRIPT, part 2 of 2 (say this)</a:t>
+            </a:r>
+          </a:p>
+          <a:p>
             <a:endParaRPr lang="en-US" dirty="0"/>
+          </a:p>
+          <a:p>
+            <a:r>
+              <a:rPr lang="en-US" dirty="0"/>
+              <a:t>Who is pushing back? SPNI, the Society for the Protection of Nature in Israel, is an NGO. It does advocacy against a new bill. The bill would let big AI server farms skip local planning committees, so neighbors lose their chance to object. In our opinion, that can become discrimination against small communities.</a:t>
+            </a:r>
+          </a:p>
+          <a:p>
+            <a:endParaRPr lang="en-US" dirty="0"/>
+          </a:p>
+          <a:p>
+            <a:r>
+              <a:rPr lang="en-US" dirty="0"/>
+              <a:t>In Europe, 2023 legislation makes big data centers report their water and energy use every year. In Israel, the Water Law of 1959 says water sources are public property. But we found no Israeli regulation that makes data centers report their water use.</a:t>
+            </a:r>
+          </a:p>
+          <a:p>
+            <a:endParaRPr lang="en-US" dirty="0"/>
+          </a:p>
+          <a:p>
+            <a:r>
+              <a:rPr lang="en-US" b="1" dirty="0"/>
+              <a:t>HANDOFF -&gt; "Now [C] will tell you our idea."</a:t>
+            </a:r>
+          </a:p>
+          <a:p>
+            <a:endParaRPr lang="en-US" dirty="0"/>
+          </a:p>
+          <a:p>
+            <a:r>
+              <a:rPr lang="en-US" dirty="0"/>
+              <a:t>————————————————————</a:t>
+            </a:r>
+          </a:p>
+          <a:p>
+            <a:endParaRPr lang="en-US" dirty="0"/>
+          </a:p>
+          <a:p>
+            <a:r>
+              <a:rPr lang="en-US" b="1" dirty="0"/>
+              <a:t>SLIDE 3 – talking points and sources</a:t>
+            </a:r>
+          </a:p>
+          <a:p>
+            <a:r>
+              <a:rPr lang="en-US" dirty="0"/>
+              <a:t>- Background: an AI-generated image made by our team; not a real event. It shows residents protesting at the gate of a data center, seen from a drone.</a:t>
+            </a:r>
+          </a:p>
+          <a:p>
+            <a:r>
+              <a:rPr lang="en-US" dirty="0"/>
+              <a:t>- SPNI [S25]: publicly opposed the bill that makes AI server farms 'national infrastructure'. Warned of a 'destructive domino effect' on open land and energy security. Wants the status only for security, intelligence and academic use. Also active: Greenpeace Israel, Green Course.</a:t>
+            </a:r>
+          </a:p>
+          <a:p>
+            <a:r>
+              <a:rPr lang="en-US" dirty="0"/>
+              <a:t>- The bill [S24]: Planning and Building Law amendment. AI server farms of 50 MW or more become 'national infrastructure'. They go to the National Infrastructure Committee and skip local and district committees and their objections. Passed first reading on 1 June 2026. FINAL PASSAGE UNVERIFIED: check before presenting.</a:t>
+            </a:r>
+          </a:p>
+          <a:p>
+            <a:r>
+              <a:rPr lang="en-US" dirty="0"/>
+              <a:t>- Discrimination (required word): when big projects skip local committees, the people who live next door lose their voice. Critics say this is unfair and can become discrimination against small communities. We did not find proof that Israel targets poor areas on purpose.</a:t>
+            </a:r>
+          </a:p>
+          <a:p>
+            <a:r>
+              <a:rPr lang="en-US" dirty="0"/>
+              <a:t>- EU law [S28]: Energy Efficiency Directive (EU) 2023/1791, Article 12. Data centers with 500 kW or more of IT power must report energy and water use every year to an EU database.</a:t>
+            </a:r>
+          </a:p>
+          <a:p>
+            <a:r>
+              <a:rPr lang="en-US" dirty="0"/>
+              <a:t>- Water Law [S27]: Water Law 5719-1959, section 1. Water sources in Israel are public property, controlled by the State, for the needs of the residents and the development of the country.</a:t>
+            </a:r>
+          </a:p>
+          <a:p>
+            <a:r>
+              <a:rPr lang="en-US" dirty="0"/>
+              <a:t>- Gap: we found no Israeli rule that makes data centers publish their water or power use. Say 'we found no', not 'there is no'.</a:t>
+            </a:r>
           </a:p>
         </p:txBody>
       </p:sp>
@@ -1333,20 +1638,126 @@
           <a:lstStyle/>
           <a:p>
             <a:r>
-              <a:rPr lang="en-US" dirty="0"/>
-              <a:t>SLIDE 4 – our idea (Speaker C). Full original wording:
-Run AI Locally. Our idea is simple: Make LLMs able to run on normal PCs and laptops.
-- AI companies should optimize their models so they can run locally.
-- People could download an LLM instead of always connecting to a data center.
-- Companies should make models smaller and more efficient.
-- We can use: better optimization, quantization, smaller models, better computer chips.
-- As chips become more powerful, more AI could run locally.
-Instead of only building bigger data centers, make AI more efficient.
-Sources: [S29] Microsoft Phi-3 report (Apr 2024): a 3.8B model, about 1.8 GB at 4 bits, runs on an iPhone 14. [S30] Meta Llama 3.2 1B/3B (Sep 2024): built for phones and edge devices. [S31] QLoRA (2023): 4-bit quantization makes models much smaller. [S32] Copilot+ PCs (May 2024) have an AI chip (NPU) of 40+ TOPS to run AI locally.
-Background: a 3D illustration of a laptop running a small AI model offline.
-Be honest if asked: a laptop's electricity also comes from power plants. The big saving comes from smaller, optimized models doing less work (Google cut energy per prompt 33x in one year by optimizing [S4]).</a:t>
-            </a:r>
+              <a:rPr lang="en-US" b="1" dirty="0"/>
+              <a:t>SPEAKER C – SCRIPT, part 1 of 2 (say this)</a:t>
+            </a:r>
+          </a:p>
+          <a:p>
             <a:endParaRPr lang="en-US" dirty="0"/>
+          </a:p>
+          <a:p>
+            <a:r>
+              <a:rPr lang="en-US" dirty="0"/>
+              <a:t>Thanks, [B]. So what would we do?</a:t>
+            </a:r>
+          </a:p>
+          <a:p>
+            <a:endParaRPr lang="en-US" dirty="0"/>
+          </a:p>
+          <a:p>
+            <a:r>
+              <a:rPr lang="en-US" dirty="0"/>
+              <a:t>Our idea is simple: run AI locally. Today, most AI runs in huge data centers. We want large language models, the AI behind chatbots like ChatGPT, to run on normal laptops and PCs.</a:t>
+            </a:r>
+          </a:p>
+          <a:p>
+            <a:endParaRPr lang="en-US" dirty="0"/>
+          </a:p>
+          <a:p>
+            <a:r>
+              <a:rPr lang="en-US" dirty="0"/>
+              <a:t>How? Companies can make models smaller and more efficient. One method is quantization: it stores the model's numbers in a shorter form, so it needs much less memory. This is already real. Microsoft's small model, Phi-3, runs on a phone. And new laptops have special AI chips that make local AI stronger.</a:t>
+            </a:r>
+          </a:p>
+          <a:p>
+            <a:endParaRPr lang="en-US" dirty="0"/>
+          </a:p>
+          <a:p>
+            <a:r>
+              <a:rPr lang="en-US" b="1" dirty="0"/>
+              <a:t>[CLICK -&gt; Slide 5]</a:t>
+            </a:r>
+          </a:p>
+          <a:p>
+            <a:endParaRPr lang="en-US" dirty="0"/>
+          </a:p>
+          <a:p>
+            <a:r>
+              <a:rPr lang="en-US" dirty="0"/>
+              <a:t>————————————————————</a:t>
+            </a:r>
+          </a:p>
+          <a:p>
+            <a:endParaRPr lang="en-US" dirty="0"/>
+          </a:p>
+          <a:p>
+            <a:r>
+              <a:rPr lang="en-US" b="1" dirty="0"/>
+              <a:t>SLIDE 4 – our idea (Speaker C). Full original wording:</a:t>
+            </a:r>
+          </a:p>
+          <a:p>
+            <a:r>
+              <a:rPr lang="en-US" dirty="0"/>
+              <a:t>Run AI Locally. Our idea is simple: Make LLMs able to run on normal PCs and laptops.</a:t>
+            </a:r>
+          </a:p>
+          <a:p>
+            <a:r>
+              <a:rPr lang="en-US" dirty="0"/>
+              <a:t>- AI companies should optimize their models so they can run locally.</a:t>
+            </a:r>
+          </a:p>
+          <a:p>
+            <a:r>
+              <a:rPr lang="en-US" dirty="0"/>
+              <a:t>- People could download an LLM instead of always connecting to a data center.</a:t>
+            </a:r>
+          </a:p>
+          <a:p>
+            <a:r>
+              <a:rPr lang="en-US" dirty="0"/>
+              <a:t>- Companies should make models smaller and more efficient.</a:t>
+            </a:r>
+          </a:p>
+          <a:p>
+            <a:r>
+              <a:rPr lang="en-US" dirty="0"/>
+              <a:t>- We can use: better optimization, quantization, smaller models, better computer chips.</a:t>
+            </a:r>
+          </a:p>
+          <a:p>
+            <a:r>
+              <a:rPr lang="en-US" dirty="0"/>
+              <a:t>- As chips become more powerful, more AI could run locally.</a:t>
+            </a:r>
+          </a:p>
+          <a:p>
+            <a:r>
+              <a:rPr lang="en-US" dirty="0"/>
+              <a:t>Instead of only building bigger data centers, make AI more efficient.</a:t>
+            </a:r>
+          </a:p>
+          <a:p>
+            <a:endParaRPr lang="en-US" dirty="0"/>
+          </a:p>
+          <a:p>
+            <a:r>
+              <a:rPr lang="en-US" dirty="0"/>
+              <a:t>Sources: [S29] Microsoft Phi-3 report (Apr 2024): a 3.8B model, about 1.8 GB at 4 bits, runs on an iPhone 14. [S30] Meta Llama 3.2 1B/3B (Sep 2024): built for phones and edge devices. [S31] QLoRA (2023): 4-bit quantization makes models much smaller. [S32] Copilot+ PCs (May 2024) have an AI chip (NPU) of 40+ TOPS to run AI locally.</a:t>
+            </a:r>
+          </a:p>
+          <a:p>
+            <a:r>
+              <a:rPr lang="en-US" dirty="0"/>
+              <a:t>Background: a 3D illustration of a laptop running a small AI model offline.</a:t>
+            </a:r>
+          </a:p>
+          <a:p>
+            <a:r>
+              <a:rPr lang="en-US" dirty="0"/>
+              <a:t>Be honest if asked: a laptop's electricity also comes from power plants. The big saving comes from smaller, optimized models doing less work (Google cut energy per prompt 33x in one year by optimizing [S4]).</a:t>
+            </a:r>
           </a:p>
         </p:txBody>
       </p:sp>
@@ -1431,22 +1842,156 @@
           <a:lstStyle/>
           <a:p>
             <a:r>
-              <a:rPr lang="en-US" dirty="0"/>
-              <a:t>SLIDE 5 – our plan and message (Speaker C). Full original wording:
-What Would We Do? Our plan:
-1. AI companies should make local versions of their LLMs.
-2. These models should work on normal PCs and laptops whenever possible.
-3. Companies should focus on optimization instead of just making models bigger.
-4. New chips can gradually make local AI more powerful.
-5. Data centers can still be used for extremely large models and training.
-Possible benefits: less need for new data centers; less land used for AI infrastructure; potentially less water needed for cooling; more AI can run directly on people's computers; more privacy and control for users.
-Our message: Don't just build bigger data centers. Make AI smarter and more efficient.
-Background: an AI-generated image made by our team: a low-power AI chip (NPU) in front of rows of data-center servers. The chip's label and numbers are part of the illustration, not a real product.
-Awareness idea: an 'AI label' (like a food label) showing how much water and electricity an AI tool uses, with the source and year.
-Likely question: 'How do you make companies do this?' Answer: public pressure and awareness, plus reporting laws like the EU rule [S28], which make water and power use visible.
-Be honest: training still needs data centers, and local AI still uses electricity. The benefit comes from smaller, more efficient models.</a:t>
-            </a:r>
+              <a:rPr lang="en-US" b="1" dirty="0"/>
+              <a:t>SPEAKER C – SCRIPT, part 2 of 2 (say this)</a:t>
+            </a:r>
+          </a:p>
+          <a:p>
             <a:endParaRPr lang="en-US" dirty="0"/>
+          </a:p>
+          <a:p>
+            <a:r>
+              <a:rPr lang="en-US" dirty="0"/>
+              <a:t>So here is our plan. One: AI companies should release local versions of their models. Two: they should optimize their models, not just make them bigger. Three: data centers should stay for training and for the biggest models.</a:t>
+            </a:r>
+          </a:p>
+          <a:p>
+            <a:endParaRPr lang="en-US" dirty="0"/>
+          </a:p>
+          <a:p>
+            <a:r>
+              <a:rPr lang="en-US" dirty="0"/>
+              <a:t>This policy reform could mean fewer new data centers: less water, less land, and more privacy, because your data stays on your computer.</a:t>
+            </a:r>
+          </a:p>
+          <a:p>
+            <a:endParaRPr lang="en-US" dirty="0"/>
+          </a:p>
+          <a:p>
+            <a:r>
+              <a:rPr lang="en-US" dirty="0"/>
+              <a:t>To be honest, a laptop also uses electricity from power plants. The real saving comes from smaller, smarter models. Google says it cut the energy for each Gemini question by 33 times in one year, by making its systems more efficient.</a:t>
+            </a:r>
+          </a:p>
+          <a:p>
+            <a:endParaRPr lang="en-US" dirty="0"/>
+          </a:p>
+          <a:p>
+            <a:r>
+              <a:rPr lang="en-US" dirty="0"/>
+              <a:t>Our awareness idea is an "AI label", like a food label. It shows how much water and power an AI tool uses.</a:t>
+            </a:r>
+          </a:p>
+          <a:p>
+            <a:endParaRPr lang="en-US" dirty="0"/>
+          </a:p>
+          <a:p>
+            <a:r>
+              <a:rPr lang="en-US" dirty="0"/>
+              <a:t>This way, AI can keep growing without one community paying the price. So our message is: Don't just build bigger data centers. Make AI smarter and more efficient.</a:t>
+            </a:r>
+          </a:p>
+          <a:p>
+            <a:endParaRPr lang="en-US" dirty="0"/>
+          </a:p>
+          <a:p>
+            <a:r>
+              <a:rPr lang="en-US" dirty="0"/>
+              <a:t>Thank you. Any questions?</a:t>
+            </a:r>
+          </a:p>
+          <a:p>
+            <a:endParaRPr lang="en-US" dirty="0"/>
+          </a:p>
+          <a:p>
+            <a:r>
+              <a:rPr lang="en-US" dirty="0"/>
+              <a:t>————————————————————</a:t>
+            </a:r>
+          </a:p>
+          <a:p>
+            <a:endParaRPr lang="en-US" dirty="0"/>
+          </a:p>
+          <a:p>
+            <a:r>
+              <a:rPr lang="en-US" b="1" dirty="0"/>
+              <a:t>SLIDE 5 – our plan and message (Speaker C). Full original wording:</a:t>
+            </a:r>
+          </a:p>
+          <a:p>
+            <a:r>
+              <a:rPr lang="en-US" dirty="0"/>
+              <a:t>What Would We Do? Our plan:</a:t>
+            </a:r>
+          </a:p>
+          <a:p>
+            <a:r>
+              <a:rPr lang="en-US" dirty="0"/>
+              <a:t>1. AI companies should make local versions of their LLMs.</a:t>
+            </a:r>
+          </a:p>
+          <a:p>
+            <a:r>
+              <a:rPr lang="en-US" dirty="0"/>
+              <a:t>2. These models should work on normal PCs and laptops whenever possible.</a:t>
+            </a:r>
+          </a:p>
+          <a:p>
+            <a:r>
+              <a:rPr lang="en-US" dirty="0"/>
+              <a:t>3. Companies should focus on optimization instead of just making models bigger.</a:t>
+            </a:r>
+          </a:p>
+          <a:p>
+            <a:r>
+              <a:rPr lang="en-US" dirty="0"/>
+              <a:t>4. New chips can gradually make local AI more powerful.</a:t>
+            </a:r>
+          </a:p>
+          <a:p>
+            <a:r>
+              <a:rPr lang="en-US" dirty="0"/>
+              <a:t>5. Data centers can still be used for extremely large models and training.</a:t>
+            </a:r>
+          </a:p>
+          <a:p>
+            <a:r>
+              <a:rPr lang="en-US" dirty="0"/>
+              <a:t>Possible benefits: less need for new data centers; less land used for AI infrastructure; potentially less water needed for cooling; more AI can run directly on people's computers; more privacy and control for users.</a:t>
+            </a:r>
+          </a:p>
+          <a:p>
+            <a:r>
+              <a:rPr lang="en-US" dirty="0"/>
+              <a:t>Our message: Don't just build bigger data centers. Make AI smarter and more efficient.</a:t>
+            </a:r>
+          </a:p>
+          <a:p>
+            <a:endParaRPr lang="en-US" dirty="0"/>
+          </a:p>
+          <a:p>
+            <a:r>
+              <a:rPr lang="en-US" dirty="0"/>
+              <a:t>Background: an AI-generated image made by our team: a low-power AI chip (NPU) in front of rows of data-center servers. The chip's label and numbers are part of the illustration, not a real product.</a:t>
+            </a:r>
+          </a:p>
+          <a:p>
+            <a:r>
+              <a:rPr lang="en-US" dirty="0"/>
+              <a:t>Awareness idea: an 'AI label' (like a food label) showing how much water and electricity an AI tool uses, with the source and year.</a:t>
+            </a:r>
+          </a:p>
+          <a:p>
+            <a:r>
+              <a:rPr lang="en-US" dirty="0"/>
+              <a:t>Likely question: 'How do you make companies do this?' Answer: public pressure and awareness, plus reporting laws like the EU rule [S28], which make water and power use visible.</a:t>
+            </a:r>
+          </a:p>
+          <a:p>
+            <a:r>
+              <a:rPr lang="en-US" dirty="0"/>
+              <a:t>Be honest: training still needs data centers, and local AI still uses electricity. The benefit comes from smaller, more efficient models.</a:t>
+            </a:r>
           </a:p>
         </p:txBody>
       </p:sp>

</xml_diff>

<commit_message>
Add a title slide at the start
New Slide 1 with the title, name placeholders, and class and date
placeholders over a wider crop of the campus photo. The other slides move
to 2-6; the scripts, slide notes, source list and image files are
renumbered to match. Speaker A now opens on the title slide.

Co-Authored-By: Claude Opus 5.5 <noreply@anthropic.com>
Claude-Session: https://claude.ai/code/session_01D1yfgr7znJrRSehnJ7HGe8
</commit_message>
<xml_diff>
--- a/ai-water-deck.pptx
+++ b/ai-water-deck.pptx
@@ -10,9 +10,10 @@
     <p:sldId id="258" r:id="rId4"/>
     <p:sldId id="259" r:id="rId5"/>
     <p:sldId id="260" r:id="rId6"/>
+    <p:sldId id="261" r:id="rId7"/>
   </p:sldIdLst>
   <p:notesMasterIdLst>
-    <p:notesMasterId r:id="rId7"/>
+    <p:notesMasterId r:id="rId8"/>
   </p:notesMasterIdLst>
   <p:sldSz cx="12192000" cy="6858000"/>
   <p:notesSz cx="6858000" cy="12192000"/>
@@ -1048,7 +1049,7 @@
           <a:p>
             <a:r>
               <a:rPr lang="en-US" b="1" dirty="0"/>
-              <a:t>SPEAKER A – SCRIPT (say this)</a:t>
+              <a:t>SPEAKER A – SCRIPT, part 1 of 2 (say this)</a:t>
             </a:r>
           </a:p>
           <a:p>
@@ -1057,7 +1058,7 @@
           <a:p>
             <a:r>
               <a:rPr lang="en-US" dirty="0"/>
-              <a:t>Hi everyone. Our topic today is AI's hidden thirst, and who pays for it.</a:t>
+              <a:t>Hi everyone. We are [A], [B] and [C]. Our topic today is AI's hidden thirst, and who pays for it.</a:t>
             </a:r>
           </a:p>
           <a:p>
@@ -1065,8 +1066,8 @@
           </a:p>
           <a:p>
             <a:r>
-              <a:rPr lang="en-US" dirty="0"/>
-              <a:t>When you ask an AI chatbot a question, the work happens in huge buildings called data centers. Data centers need two things: electricity to run, and water to stay cool.</a:t>
+              <a:rPr lang="en-US" b="1" dirty="0"/>
+              <a:t>[CLICK -&gt; Slide 2]</a:t>
             </a:r>
           </a:p>
           <a:p>
@@ -1075,7 +1076,7 @@
           <a:p>
             <a:r>
               <a:rPr lang="en-US" dirty="0"/>
-              <a:t>There are two kinds of water use. On-site: inside the building, water evaporates to cool the servers. Off-site: the power plants that make the electricity also use water. A US government lab studied the year 2023. It found that the power plants used about twelve times more water than the data centers themselves.</a:t>
+              <a:t>————————————————————</a:t>
             </a:r>
           </a:p>
           <a:p>
@@ -1083,89 +1084,20 @@
           </a:p>
           <a:p>
             <a:r>
-              <a:rPr lang="en-US" dirty="0"/>
-              <a:t>And it is growing fast. Look at our chart. Google's total water use went from 24 billion litres in 2023 to 41 billion in 2025. That is 70 percent more in two years.</a:t>
-            </a:r>
-          </a:p>
-          <a:p>
-            <a:endParaRPr lang="en-US" dirty="0"/>
-          </a:p>
-          <a:p>
-            <a:r>
-              <a:rPr lang="en-US" dirty="0"/>
-              <a:t>So this is a question of sustainability. But it is also a question of social justice. The benefits of AI go to people all over the world. The impact lands on the people who live near the data center.</a:t>
-            </a:r>
-          </a:p>
-          <a:p>
-            <a:endParaRPr lang="en-US" dirty="0"/>
-          </a:p>
-          <a:p>
-            <a:r>
-              <a:rPr lang="en-US" dirty="0"/>
-              <a:t>Here is an example. In 2023, Uruguay had its worst drought in 74 years. In the capital, Montevideo, the tap water turned salty. At the same time, Google planned a data center there. It would use about seven and a half million litres of water a day. People protested. After the protests, Google made the project smaller and changed to air cooling.</a:t>
-            </a:r>
-          </a:p>
-          <a:p>
-            <a:endParaRPr lang="en-US" dirty="0"/>
-          </a:p>
-          <a:p>
-            <a:r>
               <a:rPr lang="en-US" b="1" dirty="0"/>
-              <a:t>HANDOFF -&gt; "Now [B] will show you what this looks like here in Israel."</a:t>
-            </a:r>
-          </a:p>
-          <a:p>
-            <a:endParaRPr lang="en-US" dirty="0"/>
-          </a:p>
-          <a:p>
-            <a:r>
-              <a:rPr lang="en-US" dirty="0"/>
-              <a:t>————————————————————</a:t>
-            </a:r>
-          </a:p>
-          <a:p>
-            <a:endParaRPr lang="en-US" dirty="0"/>
-          </a:p>
-          <a:p>
-            <a:r>
-              <a:rPr lang="en-US" b="1" dirty="0"/>
-              <a:t>SLIDE 1 – talking points and sources (full scripts and Q&amp;A: speaker-notes.txt)</a:t>
-            </a:r>
-          </a:p>
-          <a:p>
-            <a:r>
-              <a:rPr lang="en-US" dirty="0"/>
-              <a:t>- Background: an AI-generated image made by our team of the inside of a data center (rows of server racks). Not a real place.</a:t>
-            </a:r>
-          </a:p>
-          <a:p>
-            <a:r>
-              <a:rPr lang="en-US" dirty="0"/>
-              <a:t>- Data centers need water for cooling and electricity to run.</a:t>
-            </a:r>
-          </a:p>
-          <a:p>
-            <a:r>
-              <a:rPr lang="en-US" dirty="0"/>
-              <a:t>- ON-SITE vs OFF-SITE [S1 LBNL 2024]: US data centers used 66 billion litres on-site in 2023 and about 800 billion litres off-site (water used by the power plants). 800 / 66 ≈ 12.</a:t>
-            </a:r>
-          </a:p>
-          <a:p>
-            <a:r>
-              <a:rPr lang="en-US" dirty="0"/>
-              <a:t>- Google +70% [S6 Google Environmental Reports]: 6.4B gal = 24.2B L (2023); 8.1B gal = 30.7B L (2024); 10.9B gal = 41.3B L (2025). 41.3 / 24.2 = 1.71. Company-reported, all operations.</a:t>
-            </a:r>
-          </a:p>
-          <a:p>
-            <a:r>
-              <a:rPr lang="en-US" dirty="0"/>
-              <a:t>- Uruguay [S9]: 2023 drought, worst in 74 years. Montevideo tap water was mixed with salty water. Google's plan: about 7.6 million litres a day. Slogan: 'It's not drought, it's pillage.' Google made the project smaller and switched to air cooling.</a:t>
-            </a:r>
-          </a:p>
-          <a:p>
-            <a:r>
-              <a:rPr lang="en-US" dirty="0"/>
-              <a:t>- Careful: 'one bottle of water per question' is a misreading. The study [S3] says 500 ml per about 10–50 answers.</a:t>
+              <a:t>SLIDE 1 – title slide</a:t>
+            </a:r>
+          </a:p>
+          <a:p>
+            <a:r>
+              <a:rPr lang="en-US" dirty="0"/>
+              <a:t>- Before presenting: type your three names, your class and the date over the placeholders.</a:t>
+            </a:r>
+          </a:p>
+          <a:p>
+            <a:r>
+              <a:rPr lang="en-US" dirty="0"/>
+              <a:t>- Background: the same example data-center campus as Slide 3 (a wider crop with more sky). It is NOT in Israel.</a:t>
             </a:r>
           </a:p>
         </p:txBody>
@@ -1252,7 +1184,7 @@
           <a:p>
             <a:r>
               <a:rPr lang="en-US" b="1" dirty="0"/>
-              <a:t>SPEAKER B – SCRIPT, part 1 of 2 (say this)</a:t>
+              <a:t>SPEAKER A – SCRIPT, part 2 of 2 (say this)</a:t>
             </a:r>
           </a:p>
           <a:p>
@@ -1261,7 +1193,7 @@
           <a:p>
             <a:r>
               <a:rPr lang="en-US" dirty="0"/>
-              <a:t>Thank you, [A]. Now let's look at Israel.</a:t>
+              <a:t>When you ask an AI chatbot a question, the work happens in huge buildings called data centers. Data centers need two things: electricity to run, and water to stay cool.</a:t>
             </a:r>
           </a:p>
           <a:p>
@@ -1270,7 +1202,7 @@
           <a:p>
             <a:r>
               <a:rPr lang="en-US" dirty="0"/>
-              <a:t>Israel is different. Most of our tap water comes from the sea, through desalination. So here, the bigger problem is electricity. Desalination and data centers both need a lot of it.</a:t>
+              <a:t>There are two kinds of water use. On-site: inside the building, water evaporates to cool the servers. Off-site: the power plants that make the electricity also use water. A US government lab studied the year 2023. It found that the power plants used about twelve times more water than the data centers themselves.</a:t>
             </a:r>
           </a:p>
           <a:p>
@@ -1279,7 +1211,7 @@
           <a:p>
             <a:r>
               <a:rPr lang="en-US" dirty="0"/>
-              <a:t>Look at the chart. Data centers were already promised 1,500 megawatts. That uses up all the new power planned until 2035. But new requests add up to 27,000 megawatts. That is eighteen times more, and about three times Israel's average use. So in July 2026, the Electricity Authority froze new requests for 140 days.</a:t>
+              <a:t>And it is growing fast. Look at our chart. Google's total water use went from 24 billion litres in 2023 to 41 billion in 2025. That is 70 percent more in two years.</a:t>
             </a:r>
           </a:p>
           <a:p>
@@ -1288,7 +1220,7 @@
           <a:p>
             <a:r>
               <a:rPr lang="en-US" dirty="0"/>
-              <a:t>And it is close to home: there are projects in Kfar Yona, Netanya and Hadera.</a:t>
+              <a:t>So this is a question of sustainability. But it is also a question of social justice. The benefits of AI go to people all over the world. The impact lands on the people who live near the data center.</a:t>
             </a:r>
           </a:p>
           <a:p>
@@ -1297,7 +1229,7 @@
           <a:p>
             <a:r>
               <a:rPr lang="en-US" dirty="0"/>
-              <a:t>In a shortage, who is cut first? In late August 2026, algae shut five of the six big desalination plants. Farms were cut first. Data centers did not cause this. But it shows who pays first.</a:t>
+              <a:t>Here is an example. In 2023, Uruguay had its worst drought in 74 years. In the capital, Montevideo, the tap water turned salty. At the same time, Google planned a data center there. It would use about seven and a half million litres of water a day. People protested. After the protests, Google made the project smaller and changed to air cooling.</a:t>
             </a:r>
           </a:p>
           <a:p>
@@ -1306,7 +1238,7 @@
           <a:p>
             <a:r>
               <a:rPr lang="en-US" b="1" dirty="0"/>
-              <a:t>[CLICK -&gt; Slide 3]</a:t>
+              <a:t>HANDOFF -&gt; "Now [B] will show you what this looks like here in Israel."</a:t>
             </a:r>
           </a:p>
           <a:p>
@@ -1324,61 +1256,43 @@
           <a:p>
             <a:r>
               <a:rPr lang="en-US" b="1" dirty="0"/>
-              <a:t>SLIDE 2 – talking points and sources</a:t>
-            </a:r>
-          </a:p>
-          <a:p>
-            <a:r>
-              <a:rPr lang="en-US" dirty="0"/>
-              <a:t>- Background: an example of a large data-center campus next to farmland, with its own electricity substation (left). It is NOT in Israel; it shows what these projects look like.</a:t>
-            </a:r>
-          </a:p>
-          <a:p>
-            <a:r>
-              <a:rPr lang="en-US" dirty="0"/>
-              <a:t>- Chart: data-center grid demand in Israel, megawatts (2026). 1,500 MW already committed; 27,000 MW pending. 27,000 / 1,500 = 18.</a:t>
-            </a:r>
-          </a:p>
-          <a:p>
-            <a:r>
-              <a:rPr lang="en-US" dirty="0"/>
-              <a:t>- Desalination share [S17]: sources disagree (State Comptroller 2024: 'about half'; Times of Israel 2026: over 80%). Say 'most', not a single number.</a:t>
-            </a:r>
-          </a:p>
-          <a:p>
-            <a:r>
-              <a:rPr lang="en-US" dirty="0"/>
-              <a:t>- Desalination needs electricity [S16]: the State Comptroller (2024) names desalination AND data centers as drivers of 2030 electricity demand.</a:t>
-            </a:r>
-          </a:p>
-          <a:p>
-            <a:r>
-              <a:rPr lang="en-US" dirty="0"/>
-              <a:t>- 27,000 MW [S14, S15]: pending data-center requests to Noga, about 3 times Israel's average electricity use. 1,500 MW already committed uses up the planned new supply to 2035 (Ctech).</a:t>
-            </a:r>
-          </a:p>
-          <a:p>
-            <a:r>
-              <a:rPr lang="en-US" dirty="0"/>
-              <a:t>- July 2026 freeze [S14]: the Electricity Authority stopped new data-center applications of 8 MW or more for 140 days from 21 July 2026 (until about early December).</a:t>
-            </a:r>
-          </a:p>
-          <a:p>
-            <a:r>
-              <a:rPr lang="en-US" dirty="0"/>
-              <a:t>- Near us [S21, S22, S15]: MedOne, two underground data centers in Kfar Yona (next to Lev HaSharon, not inside it), first opens 2026. NED Alpha Campus in Netanya, 42 MW, early 2027. Mega Or asked for 1,111 MW at the old Alliance factory in Hadera.</a:t>
-            </a:r>
-          </a:p>
-          <a:p>
-            <a:r>
-              <a:rPr lang="en-US" dirty="0"/>
-              <a:t>- Farms first [S18]: end of Aug 2026, algae shut 5 of 6 big desalination plants. The Water Authority told councils to cut farm and park irrigation. Ramat HaNegev farms lost fresh water completely. NOT caused by data centers. It shows who is cut first.</a:t>
-            </a:r>
-          </a:p>
-          <a:p>
-            <a:r>
-              <a:rPr lang="en-US" dirty="0"/>
-              <a:t>- Unverified: water quotas for Lev HaSharon moshavim (no public figures found).</a:t>
+              <a:t>SLIDE 2 – talking points and sources (full scripts and Q&amp;A: speaker-notes.txt)</a:t>
+            </a:r>
+          </a:p>
+          <a:p>
+            <a:r>
+              <a:rPr lang="en-US" dirty="0"/>
+              <a:t>- Background: an AI-generated image made by our team of the inside of a data center (rows of server racks). Not a real place.</a:t>
+            </a:r>
+          </a:p>
+          <a:p>
+            <a:r>
+              <a:rPr lang="en-US" dirty="0"/>
+              <a:t>- Data centers need water for cooling and electricity to run.</a:t>
+            </a:r>
+          </a:p>
+          <a:p>
+            <a:r>
+              <a:rPr lang="en-US" dirty="0"/>
+              <a:t>- ON-SITE vs OFF-SITE [S1 LBNL 2024]: US data centers used 66 billion litres on-site in 2023 and about 800 billion litres off-site (water used by the power plants). 800 / 66 ≈ 12.</a:t>
+            </a:r>
+          </a:p>
+          <a:p>
+            <a:r>
+              <a:rPr lang="en-US" dirty="0"/>
+              <a:t>- Google +70% [S6 Google Environmental Reports]: 6.4B gal = 24.2B L (2023); 8.1B gal = 30.7B L (2024); 10.9B gal = 41.3B L (2025). 41.3 / 24.2 = 1.71. Company-reported, all operations.</a:t>
+            </a:r>
+          </a:p>
+          <a:p>
+            <a:r>
+              <a:rPr lang="en-US" dirty="0"/>
+              <a:t>- Uruguay [S9]: 2023 drought, worst in 74 years. Montevideo tap water was mixed with salty water. Google's plan: about 7.6 million litres a day. Slogan: 'It's not drought, it's pillage.' Google made the project smaller and switched to air cooling.</a:t>
+            </a:r>
+          </a:p>
+          <a:p>
+            <a:r>
+              <a:rPr lang="en-US" dirty="0"/>
+              <a:t>- Careful: 'one bottle of water per question' is a misreading. The study [S3] says 500 ml per about 10–50 answers.</a:t>
             </a:r>
           </a:p>
         </p:txBody>
@@ -1465,7 +1379,7 @@
           <a:p>
             <a:r>
               <a:rPr lang="en-US" b="1" dirty="0"/>
-              <a:t>SPEAKER B – SCRIPT, part 2 of 2 (say this)</a:t>
+              <a:t>SPEAKER B – SCRIPT, part 1 of 2 (say this)</a:t>
             </a:r>
           </a:p>
           <a:p>
@@ -1474,7 +1388,7 @@
           <a:p>
             <a:r>
               <a:rPr lang="en-US" dirty="0"/>
-              <a:t>Who is pushing back? SPNI, the Society for the Protection of Nature in Israel, is an NGO. It does advocacy against a new bill. The bill would let big AI server farms skip local planning committees, so neighbors lose their chance to object. In our opinion, that can become discrimination against small communities.</a:t>
+              <a:t>Thank you, [A]. Now let's look at Israel.</a:t>
             </a:r>
           </a:p>
           <a:p>
@@ -1483,7 +1397,7 @@
           <a:p>
             <a:r>
               <a:rPr lang="en-US" dirty="0"/>
-              <a:t>In Europe, 2023 legislation makes big data centers report their water and energy use every year. In Israel, the Water Law of 1959 says water sources are public property. But we found no Israeli regulation that makes data centers report their water use.</a:t>
+              <a:t>Israel is different. Most of our tap water comes from the sea, through desalination. So here, the bigger problem is electricity. Desalination and data centers both need a lot of it.</a:t>
             </a:r>
           </a:p>
           <a:p>
@@ -1491,8 +1405,35 @@
           </a:p>
           <a:p>
             <a:r>
+              <a:rPr lang="en-US" dirty="0"/>
+              <a:t>Look at the chart. Data centers were already promised 1,500 megawatts. That uses up all the new power planned until 2035. But new requests add up to 27,000 megawatts. That is eighteen times more, and about three times Israel's average use. So in July 2026, the Electricity Authority froze new requests for 140 days.</a:t>
+            </a:r>
+          </a:p>
+          <a:p>
+            <a:endParaRPr lang="en-US" dirty="0"/>
+          </a:p>
+          <a:p>
+            <a:r>
+              <a:rPr lang="en-US" dirty="0"/>
+              <a:t>And it is close to home: there are projects in Kfar Yona, Netanya and Hadera.</a:t>
+            </a:r>
+          </a:p>
+          <a:p>
+            <a:endParaRPr lang="en-US" dirty="0"/>
+          </a:p>
+          <a:p>
+            <a:r>
+              <a:rPr lang="en-US" dirty="0"/>
+              <a:t>In a shortage, who is cut first? In late August 2026, algae shut five of the six big desalination plants. Farms were cut first. Data centers did not cause this. But it shows who pays first.</a:t>
+            </a:r>
+          </a:p>
+          <a:p>
+            <a:endParaRPr lang="en-US" dirty="0"/>
+          </a:p>
+          <a:p>
+            <a:r>
               <a:rPr lang="en-US" b="1" dirty="0"/>
-              <a:t>HANDOFF -&gt; "Now [C] will tell you our idea."</a:t>
+              <a:t>[CLICK -&gt; Slide 4]</a:t>
             </a:r>
           </a:p>
           <a:p>
@@ -1516,43 +1457,55 @@
           <a:p>
             <a:r>
               <a:rPr lang="en-US" dirty="0"/>
-              <a:t>- Background: an AI-generated image made by our team; not a real event. It shows residents protesting at the gate of a data center, seen from a drone.</a:t>
-            </a:r>
-          </a:p>
-          <a:p>
-            <a:r>
-              <a:rPr lang="en-US" dirty="0"/>
-              <a:t>- SPNI [S25]: publicly opposed the bill that makes AI server farms 'national infrastructure'. Warned of a 'destructive domino effect' on open land and energy security. Wants the status only for security, intelligence and academic use. Also active: Greenpeace Israel, Green Course.</a:t>
-            </a:r>
-          </a:p>
-          <a:p>
-            <a:r>
-              <a:rPr lang="en-US" dirty="0"/>
-              <a:t>- The bill [S24]: Planning and Building Law amendment. AI server farms of 50 MW or more become 'national infrastructure'. They go to the National Infrastructure Committee and skip local and district committees and their objections. Passed first reading on 1 June 2026. FINAL PASSAGE UNVERIFIED: check before presenting.</a:t>
-            </a:r>
-          </a:p>
-          <a:p>
-            <a:r>
-              <a:rPr lang="en-US" dirty="0"/>
-              <a:t>- Discrimination (required word): when big projects skip local committees, the people who live next door lose their voice. Critics say this is unfair and can become discrimination against small communities. We did not find proof that Israel targets poor areas on purpose.</a:t>
-            </a:r>
-          </a:p>
-          <a:p>
-            <a:r>
-              <a:rPr lang="en-US" dirty="0"/>
-              <a:t>- EU law [S28]: Energy Efficiency Directive (EU) 2023/1791, Article 12. Data centers with 500 kW or more of IT power must report energy and water use every year to an EU database.</a:t>
-            </a:r>
-          </a:p>
-          <a:p>
-            <a:r>
-              <a:rPr lang="en-US" dirty="0"/>
-              <a:t>- Water Law [S27]: Water Law 5719-1959, section 1. Water sources in Israel are public property, controlled by the State, for the needs of the residents and the development of the country.</a:t>
-            </a:r>
-          </a:p>
-          <a:p>
-            <a:r>
-              <a:rPr lang="en-US" dirty="0"/>
-              <a:t>- Gap: we found no Israeli rule that makes data centers publish their water or power use. Say 'we found no', not 'there is no'.</a:t>
+              <a:t>- Background: an example of a large data-center campus next to farmland, with its own electricity substation (left). It is NOT in Israel; it shows what these projects look like.</a:t>
+            </a:r>
+          </a:p>
+          <a:p>
+            <a:r>
+              <a:rPr lang="en-US" dirty="0"/>
+              <a:t>- Chart: data-center grid demand in Israel, megawatts (2026). 1,500 MW already committed; 27,000 MW pending. 27,000 / 1,500 = 18.</a:t>
+            </a:r>
+          </a:p>
+          <a:p>
+            <a:r>
+              <a:rPr lang="en-US" dirty="0"/>
+              <a:t>- Desalination share [S17]: sources disagree (State Comptroller 2024: 'about half'; Times of Israel 2026: over 80%). Say 'most', not a single number.</a:t>
+            </a:r>
+          </a:p>
+          <a:p>
+            <a:r>
+              <a:rPr lang="en-US" dirty="0"/>
+              <a:t>- Desalination needs electricity [S16]: the State Comptroller (2024) names desalination AND data centers as drivers of 2030 electricity demand.</a:t>
+            </a:r>
+          </a:p>
+          <a:p>
+            <a:r>
+              <a:rPr lang="en-US" dirty="0"/>
+              <a:t>- 27,000 MW [S14, S15]: pending data-center requests to Noga, about 3 times Israel's average electricity use. 1,500 MW already committed uses up the planned new supply to 2035 (Ctech).</a:t>
+            </a:r>
+          </a:p>
+          <a:p>
+            <a:r>
+              <a:rPr lang="en-US" dirty="0"/>
+              <a:t>- July 2026 freeze [S14]: the Electricity Authority stopped new data-center applications of 8 MW or more for 140 days from 21 July 2026 (until about early December).</a:t>
+            </a:r>
+          </a:p>
+          <a:p>
+            <a:r>
+              <a:rPr lang="en-US" dirty="0"/>
+              <a:t>- Near us [S21, S22, S15]: MedOne, two underground data centers in Kfar Yona (next to Lev HaSharon, not inside it), first opens 2026. NED Alpha Campus in Netanya, 42 MW, early 2027. Mega Or asked for 1,111 MW at the old Alliance factory in Hadera.</a:t>
+            </a:r>
+          </a:p>
+          <a:p>
+            <a:r>
+              <a:rPr lang="en-US" dirty="0"/>
+              <a:t>- Farms first [S18]: end of Aug 2026, algae shut 5 of 6 big desalination plants. The Water Authority told councils to cut farm and park irrigation. Ramat HaNegev farms lost fresh water completely. NOT caused by data centers. It shows who is cut first.</a:t>
+            </a:r>
+          </a:p>
+          <a:p>
+            <a:r>
+              <a:rPr lang="en-US" dirty="0"/>
+              <a:t>- Unverified: water quotas for Lev HaSharon moshavim (no public figures found).</a:t>
             </a:r>
           </a:p>
         </p:txBody>
@@ -1639,7 +1592,7 @@
           <a:p>
             <a:r>
               <a:rPr lang="en-US" b="1" dirty="0"/>
-              <a:t>SPEAKER C – SCRIPT, part 1 of 2 (say this)</a:t>
+              <a:t>SPEAKER B – SCRIPT, part 2 of 2 (say this)</a:t>
             </a:r>
           </a:p>
           <a:p>
@@ -1648,7 +1601,7 @@
           <a:p>
             <a:r>
               <a:rPr lang="en-US" dirty="0"/>
-              <a:t>Thanks, [B]. So what would we do?</a:t>
+              <a:t>Who is pushing back? SPNI, the Society for the Protection of Nature in Israel, is an NGO. It does advocacy against a new bill. The bill would let big AI server farms skip local planning committees, so neighbors lose their chance to object. In our opinion, that can become discrimination against small communities.</a:t>
             </a:r>
           </a:p>
           <a:p>
@@ -1657,7 +1610,7 @@
           <a:p>
             <a:r>
               <a:rPr lang="en-US" dirty="0"/>
-              <a:t>Our idea is simple: run AI locally. Today, most AI runs in huge data centers. We want large language models, the AI behind chatbots like ChatGPT, to run on normal laptops and PCs.</a:t>
+              <a:t>In Europe, 2023 legislation makes big data centers report their water and energy use every year. In Israel, the Water Law of 1959 says water sources are public property. But we found no Israeli regulation that makes data centers report their water use.</a:t>
             </a:r>
           </a:p>
           <a:p>
@@ -1665,8 +1618,8 @@
           </a:p>
           <a:p>
             <a:r>
-              <a:rPr lang="en-US" dirty="0"/>
-              <a:t>How? Companies can make models smaller and more efficient. One method is quantization: it stores the model's numbers in a shorter form, so it needs much less memory. This is already real. Microsoft's small model, Phi-3, runs on a phone. And new laptops have special AI chips that make local AI stronger.</a:t>
+              <a:rPr lang="en-US" b="1" dirty="0"/>
+              <a:t>HANDOFF -&gt; "Now [C] will tell you our idea."</a:t>
             </a:r>
           </a:p>
           <a:p>
@@ -1674,89 +1627,59 @@
           </a:p>
           <a:p>
             <a:r>
+              <a:rPr lang="en-US" dirty="0"/>
+              <a:t>————————————————————</a:t>
+            </a:r>
+          </a:p>
+          <a:p>
+            <a:endParaRPr lang="en-US" dirty="0"/>
+          </a:p>
+          <a:p>
+            <a:r>
               <a:rPr lang="en-US" b="1" dirty="0"/>
-              <a:t>[CLICK -&gt; Slide 5]</a:t>
-            </a:r>
-          </a:p>
-          <a:p>
-            <a:endParaRPr lang="en-US" dirty="0"/>
-          </a:p>
-          <a:p>
-            <a:r>
-              <a:rPr lang="en-US" dirty="0"/>
-              <a:t>————————————————————</a:t>
-            </a:r>
-          </a:p>
-          <a:p>
-            <a:endParaRPr lang="en-US" dirty="0"/>
-          </a:p>
-          <a:p>
-            <a:r>
-              <a:rPr lang="en-US" b="1" dirty="0"/>
-              <a:t>SLIDE 4 – our idea (Speaker C). Full original wording:</a:t>
-            </a:r>
-          </a:p>
-          <a:p>
-            <a:r>
-              <a:rPr lang="en-US" dirty="0"/>
-              <a:t>Run AI Locally. Our idea is simple: Make LLMs able to run on normal PCs and laptops.</a:t>
-            </a:r>
-          </a:p>
-          <a:p>
-            <a:r>
-              <a:rPr lang="en-US" dirty="0"/>
-              <a:t>- AI companies should optimize their models so they can run locally.</a:t>
-            </a:r>
-          </a:p>
-          <a:p>
-            <a:r>
-              <a:rPr lang="en-US" dirty="0"/>
-              <a:t>- People could download an LLM instead of always connecting to a data center.</a:t>
-            </a:r>
-          </a:p>
-          <a:p>
-            <a:r>
-              <a:rPr lang="en-US" dirty="0"/>
-              <a:t>- Companies should make models smaller and more efficient.</a:t>
-            </a:r>
-          </a:p>
-          <a:p>
-            <a:r>
-              <a:rPr lang="en-US" dirty="0"/>
-              <a:t>- We can use: better optimization, quantization, smaller models, better computer chips.</a:t>
-            </a:r>
-          </a:p>
-          <a:p>
-            <a:r>
-              <a:rPr lang="en-US" dirty="0"/>
-              <a:t>- As chips become more powerful, more AI could run locally.</a:t>
-            </a:r>
-          </a:p>
-          <a:p>
-            <a:r>
-              <a:rPr lang="en-US" dirty="0"/>
-              <a:t>Instead of only building bigger data centers, make AI more efficient.</a:t>
-            </a:r>
-          </a:p>
-          <a:p>
-            <a:endParaRPr lang="en-US" dirty="0"/>
-          </a:p>
-          <a:p>
-            <a:r>
-              <a:rPr lang="en-US" dirty="0"/>
-              <a:t>Sources: [S29] Microsoft Phi-3 report (Apr 2024): a 3.8B model, about 1.8 GB at 4 bits, runs on an iPhone 14. [S30] Meta Llama 3.2 1B/3B (Sep 2024): built for phones and edge devices. [S31] QLoRA (2023): 4-bit quantization makes models much smaller. [S32] Copilot+ PCs (May 2024) have an AI chip (NPU) of 40+ TOPS to run AI locally.</a:t>
-            </a:r>
-          </a:p>
-          <a:p>
-            <a:r>
-              <a:rPr lang="en-US" dirty="0"/>
-              <a:t>Background: a 3D illustration of a laptop running a small AI model offline.</a:t>
-            </a:r>
-          </a:p>
-          <a:p>
-            <a:r>
-              <a:rPr lang="en-US" dirty="0"/>
-              <a:t>Be honest if asked: a laptop's electricity also comes from power plants. The big saving comes from smaller, optimized models doing less work (Google cut energy per prompt 33x in one year by optimizing [S4]).</a:t>
+              <a:t>SLIDE 4 – talking points and sources</a:t>
+            </a:r>
+          </a:p>
+          <a:p>
+            <a:r>
+              <a:rPr lang="en-US" dirty="0"/>
+              <a:t>- Background: an AI-generated image made by our team; not a real event. It shows residents protesting at the gate of a data center, seen from a drone.</a:t>
+            </a:r>
+          </a:p>
+          <a:p>
+            <a:r>
+              <a:rPr lang="en-US" dirty="0"/>
+              <a:t>- SPNI [S25]: publicly opposed the bill that makes AI server farms 'national infrastructure'. Warned of a 'destructive domino effect' on open land and energy security. Wants the status only for security, intelligence and academic use. Also active: Greenpeace Israel, Green Course.</a:t>
+            </a:r>
+          </a:p>
+          <a:p>
+            <a:r>
+              <a:rPr lang="en-US" dirty="0"/>
+              <a:t>- The bill [S24]: Planning and Building Law amendment. AI server farms of 50 MW or more become 'national infrastructure'. They go to the National Infrastructure Committee and skip local and district committees and their objections. Passed first reading on 1 June 2026. FINAL PASSAGE UNVERIFIED: check before presenting.</a:t>
+            </a:r>
+          </a:p>
+          <a:p>
+            <a:r>
+              <a:rPr lang="en-US" dirty="0"/>
+              <a:t>- Discrimination (required word): when big projects skip local committees, the people who live next door lose their voice. Critics say this is unfair and can become discrimination against small communities. We did not find proof that Israel targets poor areas on purpose.</a:t>
+            </a:r>
+          </a:p>
+          <a:p>
+            <a:r>
+              <a:rPr lang="en-US" dirty="0"/>
+              <a:t>- EU law [S28]: Energy Efficiency Directive (EU) 2023/1791, Article 12. Data centers with 500 kW or more of IT power must report energy and water use every year to an EU database.</a:t>
+            </a:r>
+          </a:p>
+          <a:p>
+            <a:r>
+              <a:rPr lang="en-US" dirty="0"/>
+              <a:t>- Water Law [S27]: Water Law 5719-1959, section 1. Water sources in Israel are public property, controlled by the State, for the needs of the residents and the development of the country.</a:t>
+            </a:r>
+          </a:p>
+          <a:p>
+            <a:r>
+              <a:rPr lang="en-US" dirty="0"/>
+              <a:t>- Gap: we found no Israeli rule that makes data centers publish their water or power use. Say 'we found no', not 'there is no'.</a:t>
             </a:r>
           </a:p>
         </p:txBody>
@@ -1843,7 +1766,7 @@
           <a:p>
             <a:r>
               <a:rPr lang="en-US" b="1" dirty="0"/>
-              <a:t>SPEAKER C – SCRIPT, part 2 of 2 (say this)</a:t>
+              <a:t>SPEAKER C – SCRIPT, part 1 of 2 (say this)</a:t>
             </a:r>
           </a:p>
           <a:p>
@@ -1852,7 +1775,7 @@
           <a:p>
             <a:r>
               <a:rPr lang="en-US" dirty="0"/>
-              <a:t>So here is our plan. One: AI companies should release local versions of their models. Two: they should optimize their models, not just make them bigger. Three: data centers should stay for training and for the biggest models.</a:t>
+              <a:t>Thanks, [B]. So what would we do?</a:t>
             </a:r>
           </a:p>
           <a:p>
@@ -1861,7 +1784,7 @@
           <a:p>
             <a:r>
               <a:rPr lang="en-US" dirty="0"/>
-              <a:t>This policy reform could mean fewer new data centers: less water, less land, and more privacy, because your data stays on your computer.</a:t>
+              <a:t>Our idea is simple: run AI locally. Today, most AI runs in huge data centers. We want large language models, the AI behind chatbots like ChatGPT, to run on normal laptops and PCs.</a:t>
             </a:r>
           </a:p>
           <a:p>
@@ -1870,7 +1793,7 @@
           <a:p>
             <a:r>
               <a:rPr lang="en-US" dirty="0"/>
-              <a:t>To be honest, a laptop also uses electricity from power plants. The real saving comes from smaller, smarter models. Google says it cut the energy for each Gemini question by 33 times in one year, by making its systems more efficient.</a:t>
+              <a:t>How? Companies can make models smaller and more efficient. One method is quantization: it stores the model's numbers in a shorter form, so it needs much less memory. This is already real. Microsoft's small model, Phi-3, runs on a phone. And new laptops have special AI chips that make local AI stronger.</a:t>
             </a:r>
           </a:p>
           <a:p>
@@ -1878,8 +1801,8 @@
           </a:p>
           <a:p>
             <a:r>
-              <a:rPr lang="en-US" dirty="0"/>
-              <a:t>Our awareness idea is an "AI label", like a food label. It shows how much water and power an AI tool uses.</a:t>
+              <a:rPr lang="en-US" b="1" dirty="0"/>
+              <a:t>[CLICK -&gt; Slide 6]</a:t>
             </a:r>
           </a:p>
           <a:p>
@@ -1888,7 +1811,7 @@
           <a:p>
             <a:r>
               <a:rPr lang="en-US" dirty="0"/>
-              <a:t>This way, AI can keep growing without one community paying the price. So our message is: Don't just build bigger data centers. Make AI smarter and more efficient.</a:t>
+              <a:t>————————————————————</a:t>
             </a:r>
           </a:p>
           <a:p>
@@ -1896,8 +1819,50 @@
           </a:p>
           <a:p>
             <a:r>
-              <a:rPr lang="en-US" dirty="0"/>
-              <a:t>Thank you. Any questions?</a:t>
+              <a:rPr lang="en-US" b="1" dirty="0"/>
+              <a:t>SLIDE 5 – our idea (Speaker C). Full original wording:</a:t>
+            </a:r>
+          </a:p>
+          <a:p>
+            <a:r>
+              <a:rPr lang="en-US" dirty="0"/>
+              <a:t>Run AI Locally. Our idea is simple: Make LLMs able to run on normal PCs and laptops.</a:t>
+            </a:r>
+          </a:p>
+          <a:p>
+            <a:r>
+              <a:rPr lang="en-US" dirty="0"/>
+              <a:t>- AI companies should optimize their models so they can run locally.</a:t>
+            </a:r>
+          </a:p>
+          <a:p>
+            <a:r>
+              <a:rPr lang="en-US" dirty="0"/>
+              <a:t>- People could download an LLM instead of always connecting to a data center.</a:t>
+            </a:r>
+          </a:p>
+          <a:p>
+            <a:r>
+              <a:rPr lang="en-US" dirty="0"/>
+              <a:t>- Companies should make models smaller and more efficient.</a:t>
+            </a:r>
+          </a:p>
+          <a:p>
+            <a:r>
+              <a:rPr lang="en-US" dirty="0"/>
+              <a:t>- We can use: better optimization, quantization, smaller models, better computer chips.</a:t>
+            </a:r>
+          </a:p>
+          <a:p>
+            <a:r>
+              <a:rPr lang="en-US" dirty="0"/>
+              <a:t>- As chips become more powerful, more AI could run locally.</a:t>
+            </a:r>
+          </a:p>
+          <a:p>
+            <a:r>
+              <a:rPr lang="en-US" dirty="0"/>
+              <a:t>Instead of only building bigger data centers, make AI more efficient.</a:t>
             </a:r>
           </a:p>
           <a:p>
@@ -1906,91 +1871,19 @@
           <a:p>
             <a:r>
               <a:rPr lang="en-US" dirty="0"/>
-              <a:t>————————————————————</a:t>
-            </a:r>
-          </a:p>
-          <a:p>
-            <a:endParaRPr lang="en-US" dirty="0"/>
-          </a:p>
-          <a:p>
-            <a:r>
-              <a:rPr lang="en-US" b="1" dirty="0"/>
-              <a:t>SLIDE 5 – our plan and message (Speaker C). Full original wording:</a:t>
-            </a:r>
-          </a:p>
-          <a:p>
-            <a:r>
-              <a:rPr lang="en-US" dirty="0"/>
-              <a:t>What Would We Do? Our plan:</a:t>
-            </a:r>
-          </a:p>
-          <a:p>
-            <a:r>
-              <a:rPr lang="en-US" dirty="0"/>
-              <a:t>1. AI companies should make local versions of their LLMs.</a:t>
-            </a:r>
-          </a:p>
-          <a:p>
-            <a:r>
-              <a:rPr lang="en-US" dirty="0"/>
-              <a:t>2. These models should work on normal PCs and laptops whenever possible.</a:t>
-            </a:r>
-          </a:p>
-          <a:p>
-            <a:r>
-              <a:rPr lang="en-US" dirty="0"/>
-              <a:t>3. Companies should focus on optimization instead of just making models bigger.</a:t>
-            </a:r>
-          </a:p>
-          <a:p>
-            <a:r>
-              <a:rPr lang="en-US" dirty="0"/>
-              <a:t>4. New chips can gradually make local AI more powerful.</a:t>
-            </a:r>
-          </a:p>
-          <a:p>
-            <a:r>
-              <a:rPr lang="en-US" dirty="0"/>
-              <a:t>5. Data centers can still be used for extremely large models and training.</a:t>
-            </a:r>
-          </a:p>
-          <a:p>
-            <a:r>
-              <a:rPr lang="en-US" dirty="0"/>
-              <a:t>Possible benefits: less need for new data centers; less land used for AI infrastructure; potentially less water needed for cooling; more AI can run directly on people's computers; more privacy and control for users.</a:t>
-            </a:r>
-          </a:p>
-          <a:p>
-            <a:r>
-              <a:rPr lang="en-US" dirty="0"/>
-              <a:t>Our message: Don't just build bigger data centers. Make AI smarter and more efficient.</a:t>
-            </a:r>
-          </a:p>
-          <a:p>
-            <a:endParaRPr lang="en-US" dirty="0"/>
-          </a:p>
-          <a:p>
-            <a:r>
-              <a:rPr lang="en-US" dirty="0"/>
-              <a:t>Background: an AI-generated image made by our team: a low-power AI chip (NPU) in front of rows of data-center servers. The chip's label and numbers are part of the illustration, not a real product.</a:t>
-            </a:r>
-          </a:p>
-          <a:p>
-            <a:r>
-              <a:rPr lang="en-US" dirty="0"/>
-              <a:t>Awareness idea: an 'AI label' (like a food label) showing how much water and electricity an AI tool uses, with the source and year.</a:t>
-            </a:r>
-          </a:p>
-          <a:p>
-            <a:r>
-              <a:rPr lang="en-US" dirty="0"/>
-              <a:t>Likely question: 'How do you make companies do this?' Answer: public pressure and awareness, plus reporting laws like the EU rule [S28], which make water and power use visible.</a:t>
-            </a:r>
-          </a:p>
-          <a:p>
-            <a:r>
-              <a:rPr lang="en-US" dirty="0"/>
-              <a:t>Be honest: training still needs data centers, and local AI still uses electricity. The benefit comes from smaller, more efficient models.</a:t>
+              <a:t>Sources: [S29] Microsoft Phi-3 report (Apr 2024): a 3.8B model, about 1.8 GB at 4 bits, runs on an iPhone 14. [S30] Meta Llama 3.2 1B/3B (Sep 2024): built for phones and edge devices. [S31] QLoRA (2023): 4-bit quantization makes models much smaller. [S32] Copilot+ PCs (May 2024) have an AI chip (NPU) of 40+ TOPS to run AI locally.</a:t>
+            </a:r>
+          </a:p>
+          <a:p>
+            <a:r>
+              <a:rPr lang="en-US" dirty="0"/>
+              <a:t>Background: a 3D illustration of a laptop running a small AI model offline.</a:t>
+            </a:r>
+          </a:p>
+          <a:p>
+            <a:r>
+              <a:rPr lang="en-US" dirty="0"/>
+              <a:t>Be honest if asked: a laptop's electricity also comes from power plants. The big saving comes from smaller, optimized models doing less work (Google cut energy per prompt 33x in one year by optimizing [S4]).</a:t>
             </a:r>
           </a:p>
         </p:txBody>
@@ -2013,6 +1906,240 @@
             <a:fld id="{F7021451-1387-4CA6-816F-3879F97B5CBC}" type="slidenum">
               <a:rPr lang="en-US"/>
               <a:t>5</a:t>
+            </a:fld>
+            <a:endParaRPr lang="en-US"/>
+          </a:p>
+        </p:txBody>
+      </p:sp>
+    </p:spTree>
+    <p:extLst>
+      <p:ext uri="{BB962C8B-B14F-4D97-AF65-F5344CB8AC3E}">
+        <p14:creationId xmlns:p14="http://schemas.microsoft.com/office/powerpoint/2010/main" val="1024086991"/>
+      </p:ext>
+    </p:extLst>
+  </p:cSld>
+  <p:clrMapOvr>
+    <a:masterClrMapping/>
+  </p:clrMapOvr>
+</p:notes>
+</file>
+
+<file path=ppt/notesSlides/notesSlide6.xml><?xml version="1.0" encoding="utf-8"?>
+<p:notes xmlns:a="http://schemas.openxmlformats.org/drawingml/2006/main" xmlns:r="http://schemas.openxmlformats.org/officeDocument/2006/relationships" xmlns:p="http://schemas.openxmlformats.org/presentationml/2006/main">
+  <p:cSld>
+    <p:spTree>
+      <p:nvGrpSpPr>
+        <p:cNvPr id="1" name=""/>
+        <p:cNvGrpSpPr/>
+        <p:nvPr/>
+      </p:nvGrpSpPr>
+      <p:grpSpPr>
+        <a:xfrm>
+          <a:off x="0" y="0"/>
+          <a:ext cx="0" cy="0"/>
+          <a:chOff x="0" y="0"/>
+          <a:chExt cx="0" cy="0"/>
+        </a:xfrm>
+      </p:grpSpPr>
+      <p:sp>
+        <p:nvSpPr>
+          <p:cNvPr id="2" name="Slide Image Placeholder 1"/>
+          <p:cNvSpPr>
+            <a:spLocks noGrp="1" noRot="1" noChangeAspect="1"/>
+          </p:cNvSpPr>
+          <p:nvPr>
+            <p:ph type="sldImg"/>
+          </p:nvPr>
+        </p:nvSpPr>
+        <p:spPr/>
+      </p:sp>
+      <p:sp>
+        <p:nvSpPr>
+          <p:cNvPr id="3" name="Notes Placeholder 2"/>
+          <p:cNvSpPr>
+            <a:spLocks noGrp="1"/>
+          </p:cNvSpPr>
+          <p:nvPr>
+            <p:ph type="body" idx="1"/>
+          </p:nvPr>
+        </p:nvSpPr>
+        <p:spPr/>
+        <p:txBody>
+          <a:bodyPr/>
+          <a:lstStyle/>
+          <a:p>
+            <a:r>
+              <a:rPr lang="en-US" b="1" dirty="0"/>
+              <a:t>SPEAKER C – SCRIPT, part 2 of 2 (say this)</a:t>
+            </a:r>
+          </a:p>
+          <a:p>
+            <a:endParaRPr lang="en-US" dirty="0"/>
+          </a:p>
+          <a:p>
+            <a:r>
+              <a:rPr lang="en-US" dirty="0"/>
+              <a:t>So here is our plan. One: AI companies should release local versions of their models. Two: they should optimize their models, not just make them bigger. Three: data centers should stay for training and for the biggest models.</a:t>
+            </a:r>
+          </a:p>
+          <a:p>
+            <a:endParaRPr lang="en-US" dirty="0"/>
+          </a:p>
+          <a:p>
+            <a:r>
+              <a:rPr lang="en-US" dirty="0"/>
+              <a:t>This policy reform could mean fewer new data centers: less water, less land, and more privacy, because your data stays on your computer.</a:t>
+            </a:r>
+          </a:p>
+          <a:p>
+            <a:endParaRPr lang="en-US" dirty="0"/>
+          </a:p>
+          <a:p>
+            <a:r>
+              <a:rPr lang="en-US" dirty="0"/>
+              <a:t>To be honest, a laptop also uses electricity from power plants. The real saving comes from smaller, smarter models. Google says it cut the energy for each Gemini question by 33 times in one year, by making its systems more efficient.</a:t>
+            </a:r>
+          </a:p>
+          <a:p>
+            <a:endParaRPr lang="en-US" dirty="0"/>
+          </a:p>
+          <a:p>
+            <a:r>
+              <a:rPr lang="en-US" dirty="0"/>
+              <a:t>Our awareness idea is an "AI label", like a food label. It shows how much water and power an AI tool uses.</a:t>
+            </a:r>
+          </a:p>
+          <a:p>
+            <a:endParaRPr lang="en-US" dirty="0"/>
+          </a:p>
+          <a:p>
+            <a:r>
+              <a:rPr lang="en-US" dirty="0"/>
+              <a:t>This way, AI can keep growing without one community paying the price. So our message is: Don't just build bigger data centers. Make AI smarter and more efficient.</a:t>
+            </a:r>
+          </a:p>
+          <a:p>
+            <a:endParaRPr lang="en-US" dirty="0"/>
+          </a:p>
+          <a:p>
+            <a:r>
+              <a:rPr lang="en-US" dirty="0"/>
+              <a:t>Thank you. Any questions?</a:t>
+            </a:r>
+          </a:p>
+          <a:p>
+            <a:endParaRPr lang="en-US" dirty="0"/>
+          </a:p>
+          <a:p>
+            <a:r>
+              <a:rPr lang="en-US" dirty="0"/>
+              <a:t>————————————————————</a:t>
+            </a:r>
+          </a:p>
+          <a:p>
+            <a:endParaRPr lang="en-US" dirty="0"/>
+          </a:p>
+          <a:p>
+            <a:r>
+              <a:rPr lang="en-US" b="1" dirty="0"/>
+              <a:t>SLIDE 6 – our plan and message (Speaker C). Full original wording:</a:t>
+            </a:r>
+          </a:p>
+          <a:p>
+            <a:r>
+              <a:rPr lang="en-US" dirty="0"/>
+              <a:t>What Would We Do? Our plan:</a:t>
+            </a:r>
+          </a:p>
+          <a:p>
+            <a:r>
+              <a:rPr lang="en-US" dirty="0"/>
+              <a:t>1. AI companies should make local versions of their LLMs.</a:t>
+            </a:r>
+          </a:p>
+          <a:p>
+            <a:r>
+              <a:rPr lang="en-US" dirty="0"/>
+              <a:t>2. These models should work on normal PCs and laptops whenever possible.</a:t>
+            </a:r>
+          </a:p>
+          <a:p>
+            <a:r>
+              <a:rPr lang="en-US" dirty="0"/>
+              <a:t>3. Companies should focus on optimization instead of just making models bigger.</a:t>
+            </a:r>
+          </a:p>
+          <a:p>
+            <a:r>
+              <a:rPr lang="en-US" dirty="0"/>
+              <a:t>4. New chips can gradually make local AI more powerful.</a:t>
+            </a:r>
+          </a:p>
+          <a:p>
+            <a:r>
+              <a:rPr lang="en-US" dirty="0"/>
+              <a:t>5. Data centers can still be used for extremely large models and training.</a:t>
+            </a:r>
+          </a:p>
+          <a:p>
+            <a:r>
+              <a:rPr lang="en-US" dirty="0"/>
+              <a:t>Possible benefits: less need for new data centers; less land used for AI infrastructure; potentially less water needed for cooling; more AI can run directly on people's computers; more privacy and control for users.</a:t>
+            </a:r>
+          </a:p>
+          <a:p>
+            <a:r>
+              <a:rPr lang="en-US" dirty="0"/>
+              <a:t>Our message: Don't just build bigger data centers. Make AI smarter and more efficient.</a:t>
+            </a:r>
+          </a:p>
+          <a:p>
+            <a:endParaRPr lang="en-US" dirty="0"/>
+          </a:p>
+          <a:p>
+            <a:r>
+              <a:rPr lang="en-US" dirty="0"/>
+              <a:t>Background: an AI-generated image made by our team: a low-power AI chip (NPU) in front of rows of data-center servers. The chip's label and numbers are part of the illustration, not a real product.</a:t>
+            </a:r>
+          </a:p>
+          <a:p>
+            <a:r>
+              <a:rPr lang="en-US" dirty="0"/>
+              <a:t>Awareness idea: an 'AI label' (like a food label) showing how much water and electricity an AI tool uses, with the source and year.</a:t>
+            </a:r>
+          </a:p>
+          <a:p>
+            <a:r>
+              <a:rPr lang="en-US" dirty="0"/>
+              <a:t>Likely question: 'How do you make companies do this?' Answer: public pressure and awareness, plus reporting laws like the EU rule [S28], which make water and power use visible.</a:t>
+            </a:r>
+          </a:p>
+          <a:p>
+            <a:r>
+              <a:rPr lang="en-US" dirty="0"/>
+              <a:t>Be honest: training still needs data centers, and local AI still uses electricity. The benefit comes from smaller, more efficient models.</a:t>
+            </a:r>
+          </a:p>
+        </p:txBody>
+      </p:sp>
+      <p:sp>
+        <p:nvSpPr>
+          <p:cNvPr id="4" name="Slide Number Placeholder 3"/>
+          <p:cNvSpPr>
+            <a:spLocks noGrp="1"/>
+          </p:cNvSpPr>
+          <p:nvPr>
+            <p:ph type="sldNum" sz="quarter" idx="10"/>
+          </p:nvPr>
+        </p:nvSpPr>
+        <p:spPr/>
+        <p:txBody>
+          <a:bodyPr/>
+          <a:lstStyle/>
+          <a:p>
+            <a:fld id="{F7021451-1387-4CA6-816F-3879F97B5CBC}" type="slidenum">
+              <a:rPr lang="en-US"/>
+              <a:t>6</a:t>
             </a:fld>
             <a:endParaRPr lang="en-US"/>
           </a:p>
@@ -2377,24 +2504,31 @@
         </p:nvSpPr>
         <p:spPr>
           <a:xfrm>
-            <a:off x="548640" y="411480"/>
-            <a:ext cx="11064240" cy="868680"/>
+            <a:off x="640080" y="1463040"/>
+            <a:ext cx="8686800" cy="2468880"/>
           </a:xfrm>
           <a:prstGeom prst="rect">
             <a:avLst/>
           </a:prstGeom>
           <a:noFill/>
           <a:ln/>
+          <a:effectLst>
+            <a:outerShdw sx="100000" sy="100000" kx="0" ky="0" algn="bl" rotWithShape="0" blurRad="101600" dist="25400" dir="5400000">
+              <a:srgbClr val="000000">
+                <a:alpha val="55000"/>
+              </a:srgbClr>
+            </a:outerShdw>
+          </a:effectLst>
         </p:spPr>
         <p:txBody>
-          <a:bodyPr wrap="square" lIns="0" tIns="0" rIns="0" bIns="0" rtlCol="0" anchor="ctr"/>
+          <a:bodyPr wrap="square" lIns="0" tIns="0" rIns="0" bIns="0" rtlCol="0" anchor="b"/>
           <a:lstStyle/>
           <a:p>
             <a:pPr indent="0" marL="0">
               <a:buNone/>
             </a:pPr>
             <a:r>
-              <a:rPr lang="en-US" sz="4600" b="1" dirty="0">
+              <a:rPr lang="en-US" sz="6000" b="1" dirty="0">
                 <a:solidFill>
                   <a:srgbClr val="FFFFFF"/>
                 </a:solidFill>
@@ -2402,28 +2536,77 @@
                 <a:ea typeface="Cambria" pitchFamily="34" charset="-122"/>
                 <a:cs typeface="Cambria" pitchFamily="34" charset="-120"/>
               </a:rPr>
-              <a:t>AI’s Hidden Thirst: Who Pays?</a:t>
-            </a:r>
-            <a:endParaRPr lang="en-US" sz="4600" dirty="0"/>
+              <a:t>AI’s Hidden Thirst:</a:t>
+            </a:r>
+            <a:endParaRPr lang="en-US" sz="6000" dirty="0"/>
+          </a:p>
+          <a:p>
+            <a:pPr indent="0" marL="0">
+              <a:buNone/>
+            </a:pPr>
+            <a:r>
+              <a:rPr lang="en-US" sz="6000" b="1" dirty="0">
+                <a:solidFill>
+                  <a:srgbClr val="F2A33A"/>
+                </a:solidFill>
+                <a:latin typeface="Cambria" pitchFamily="34" charset="0"/>
+                <a:ea typeface="Cambria" pitchFamily="34" charset="-122"/>
+                <a:cs typeface="Cambria" pitchFamily="34" charset="-120"/>
+              </a:rPr>
+              <a:t>Who Pays?</a:t>
+            </a:r>
+            <a:endParaRPr lang="en-US" sz="6000" dirty="0"/>
           </a:p>
         </p:txBody>
       </p:sp>
       <p:sp>
         <p:nvSpPr>
-          <p:cNvPr id="3" name="kicker"/>
+          <p:cNvPr id="3" name="Shape 1"/>
+          <p:cNvSpPr/>
+          <p:nvPr/>
+        </p:nvSpPr>
+        <p:spPr>
+          <a:xfrm>
+            <a:off x="676656" y="4160520"/>
+            <a:ext cx="1463040" cy="64008"/>
+          </a:xfrm>
+          <a:prstGeom prst="rect">
+            <a:avLst/>
+          </a:prstGeom>
+          <a:solidFill>
+            <a:srgbClr val="F2A33A"/>
+          </a:solidFill>
+          <a:ln w="12700">
+            <a:solidFill>
+              <a:srgbClr val="F2A33A"/>
+            </a:solidFill>
+            <a:prstDash val="solid"/>
+          </a:ln>
+        </p:spPr>
+      </p:sp>
+      <p:sp>
+        <p:nvSpPr>
+          <p:cNvPr id="4" name="names"/>
           <p:cNvSpPr txBox="1"/>
           <p:nvPr/>
         </p:nvSpPr>
         <p:spPr>
           <a:xfrm>
-            <a:off x="548640" y="1298448"/>
-            <a:ext cx="11064240" cy="457200"/>
+            <a:off x="640080" y="4434840"/>
+            <a:ext cx="8686800" cy="502920"/>
           </a:xfrm>
           <a:prstGeom prst="rect">
             <a:avLst/>
           </a:prstGeom>
           <a:noFill/>
           <a:ln/>
+          <a:effectLst>
+            <a:outerShdw sx="100000" sy="100000" kx="0" ky="0" algn="bl" rotWithShape="0" blurRad="1290320000" dist="322580000" dir="324000000000">
+              <a:srgbClr val="000000">
+                <a:alpha val="5500000000"/>
+              </a:srgbClr>
+            </a:outerShdw>
+          </a:effectLst>
         </p:spPr>
         <p:txBody>
           <a:bodyPr wrap="square" lIns="0" tIns="0" rIns="0" bIns="0" rtlCol="0" anchor="t"/>
@@ -2433,369 +2616,69 @@
               <a:buNone/>
             </a:pPr>
             <a:r>
-              <a:rPr lang="en-US" sz="2200" i="1" dirty="0">
-                <a:solidFill>
-                  <a:srgbClr val="F2A33A"/>
-                </a:solidFill>
-                <a:latin typeface="Calibri" pitchFamily="34" charset="0"/>
-                <a:ea typeface="Calibri" pitchFamily="34" charset="-122"/>
-                <a:cs typeface="Calibri" pitchFamily="34" charset="-120"/>
-              </a:rPr>
-              <a:t>A social justice question: who carries AI’s impact?</a:t>
-            </a:r>
-            <a:endParaRPr lang="en-US" sz="2200" dirty="0"/>
+              <a:rPr lang="en-US" sz="2600" b="1" dirty="0">
+                <a:solidFill>
+                  <a:srgbClr val="FFFFFF"/>
+                </a:solidFill>
+                <a:latin typeface="Calibri" pitchFamily="34" charset="0"/>
+                <a:ea typeface="Calibri" pitchFamily="34" charset="-122"/>
+                <a:cs typeface="Calibri" pitchFamily="34" charset="-120"/>
+              </a:rPr>
+              <a:t>[Name A]  ·  [Name B]  ·  [Name C]</a:t>
+            </a:r>
+            <a:endParaRPr lang="en-US" sz="2600" dirty="0"/>
           </a:p>
         </p:txBody>
       </p:sp>
       <p:sp>
         <p:nvSpPr>
-          <p:cNvPr id="4" name="body"/>
+          <p:cNvPr id="5" name="class-date"/>
           <p:cNvSpPr txBox="1"/>
           <p:nvPr/>
         </p:nvSpPr>
         <p:spPr>
           <a:xfrm>
-            <a:off x="548640" y="2148840"/>
-            <a:ext cx="6035040" cy="3931920"/>
+            <a:off x="640080" y="4983480"/>
+            <a:ext cx="8686800" cy="457200"/>
           </a:xfrm>
           <a:prstGeom prst="rect">
             <a:avLst/>
           </a:prstGeom>
           <a:noFill/>
           <a:ln/>
+          <a:effectLst>
+            <a:outerShdw sx="100000" sy="100000" kx="0" ky="0" algn="bl" rotWithShape="0" blurRad="16387064000000" dist="4096766000000" dir="19440000000000000">
+              <a:srgbClr val="000000">
+                <a:alpha val="550000000000000"/>
+              </a:srgbClr>
+            </a:outerShdw>
+          </a:effectLst>
         </p:spPr>
         <p:txBody>
           <a:bodyPr wrap="square" lIns="0" tIns="0" rIns="0" bIns="0" rtlCol="0" anchor="t"/>
           <a:lstStyle/>
           <a:p>
-            <a:pPr marL="279400" indent="-279400">
-              <a:spcAft>
-                <a:spcPts val="1600"/>
-              </a:spcAft>
-              <a:buSzPct val="100000"/>
-              <a:buChar char="•"/>
-            </a:pPr>
-            <a:r>
-              <a:rPr lang="en-US" sz="2200" dirty="0">
-                <a:solidFill>
-                  <a:srgbClr val="E3EBF1"/>
-                </a:solidFill>
-                <a:latin typeface="Calibri" pitchFamily="34" charset="0"/>
-                <a:ea typeface="Calibri" pitchFamily="34" charset="-122"/>
-                <a:cs typeface="Calibri" pitchFamily="34" charset="-120"/>
-              </a:rPr>
-              <a:t>AI data centers run on water </a:t>
-            </a:r>
-            <a:r>
-              <a:rPr lang="en-US" sz="2200" b="1" dirty="0">
-                <a:solidFill>
-                  <a:srgbClr val="F2A33A"/>
-                </a:solidFill>
-                <a:latin typeface="Calibri" pitchFamily="34" charset="0"/>
-                <a:ea typeface="Calibri" pitchFamily="34" charset="-122"/>
-                <a:cs typeface="Calibri" pitchFamily="34" charset="-120"/>
-              </a:rPr>
-              <a:t>and</a:t>
-            </a:r>
-            <a:r>
-              <a:rPr lang="en-US" sz="2200" dirty="0">
-                <a:solidFill>
-                  <a:srgbClr val="E3EBF1"/>
-                </a:solidFill>
-                <a:latin typeface="Calibri" pitchFamily="34" charset="0"/>
-                <a:ea typeface="Calibri" pitchFamily="34" charset="-122"/>
-                <a:cs typeface="Calibri" pitchFamily="34" charset="-120"/>
-              </a:rPr>
-              <a:t> power</a:t>
-            </a:r>
-            <a:endParaRPr lang="en-US" sz="2200" dirty="0"/>
-          </a:p>
-          <a:p>
-            <a:pPr marL="279400" indent="-279400">
-              <a:spcAft>
-                <a:spcPts val="1600"/>
-              </a:spcAft>
-              <a:buSzPct val="100000"/>
-              <a:buChar char="•"/>
-            </a:pPr>
-            <a:r>
-              <a:rPr lang="en-US" sz="2200" b="1" dirty="0">
-                <a:solidFill>
-                  <a:srgbClr val="FFFFFF"/>
-                </a:solidFill>
-                <a:latin typeface="Calibri" pitchFamily="34" charset="0"/>
-                <a:ea typeface="Calibri" pitchFamily="34" charset="-122"/>
-                <a:cs typeface="Calibri" pitchFamily="34" charset="-120"/>
-              </a:rPr>
-              <a:t>On-site: </a:t>
-            </a:r>
-            <a:r>
-              <a:rPr lang="en-US" sz="2200" dirty="0">
-                <a:solidFill>
-                  <a:srgbClr val="E3EBF1"/>
-                </a:solidFill>
-                <a:latin typeface="Calibri" pitchFamily="34" charset="0"/>
-                <a:ea typeface="Calibri" pitchFamily="34" charset="-122"/>
-                <a:cs typeface="Calibri" pitchFamily="34" charset="-120"/>
-              </a:rPr>
-              <a:t>water evaporates to cool servers</a:t>
-            </a:r>
-            <a:endParaRPr lang="en-US" sz="2200" dirty="0"/>
-          </a:p>
-          <a:p>
-            <a:pPr marL="279400" indent="-279400">
-              <a:spcAft>
-                <a:spcPts val="1600"/>
-              </a:spcAft>
-              <a:buSzPct val="100000"/>
-              <a:buChar char="•"/>
-            </a:pPr>
-            <a:r>
-              <a:rPr lang="en-US" sz="2200" b="1" dirty="0">
-                <a:solidFill>
-                  <a:srgbClr val="FFFFFF"/>
-                </a:solidFill>
-                <a:latin typeface="Calibri" pitchFamily="34" charset="0"/>
-                <a:ea typeface="Calibri" pitchFamily="34" charset="-122"/>
-                <a:cs typeface="Calibri" pitchFamily="34" charset="-120"/>
-              </a:rPr>
-              <a:t>Off-site: </a:t>
-            </a:r>
-            <a:r>
-              <a:rPr lang="en-US" sz="2200" dirty="0">
-                <a:solidFill>
-                  <a:srgbClr val="E3EBF1"/>
-                </a:solidFill>
-                <a:latin typeface="Calibri" pitchFamily="34" charset="0"/>
-                <a:ea typeface="Calibri" pitchFamily="34" charset="-122"/>
-                <a:cs typeface="Calibri" pitchFamily="34" charset="-120"/>
-              </a:rPr>
-              <a:t>US power plants use about </a:t>
-            </a:r>
-            <a:r>
-              <a:rPr lang="en-US" sz="2200" b="1" dirty="0">
-                <a:solidFill>
-                  <a:srgbClr val="F2A33A"/>
-                </a:solidFill>
-                <a:latin typeface="Calibri" pitchFamily="34" charset="0"/>
-                <a:ea typeface="Calibri" pitchFamily="34" charset="-122"/>
-                <a:cs typeface="Calibri" pitchFamily="34" charset="-120"/>
-              </a:rPr>
-              <a:t>12× more</a:t>
-            </a:r>
-            <a:endParaRPr lang="en-US" sz="2200" dirty="0"/>
-          </a:p>
-          <a:p>
-            <a:pPr marL="279400" indent="-279400">
-              <a:spcAft>
-                <a:spcPts val="1600"/>
-              </a:spcAft>
-              <a:buSzPct val="100000"/>
-              <a:buChar char="•"/>
-            </a:pPr>
-            <a:r>
-              <a:rPr lang="en-US" sz="2200" b="1" dirty="0">
-                <a:solidFill>
-                  <a:srgbClr val="FFFFFF"/>
-                </a:solidFill>
-                <a:latin typeface="Calibri" pitchFamily="34" charset="0"/>
-                <a:ea typeface="Calibri" pitchFamily="34" charset="-122"/>
-                <a:cs typeface="Calibri" pitchFamily="34" charset="-120"/>
-              </a:rPr>
-              <a:t>Uruguay 2023: </a:t>
-            </a:r>
-            <a:r>
-              <a:rPr lang="en-US" sz="2200" dirty="0">
-                <a:solidFill>
-                  <a:srgbClr val="E3EBF1"/>
-                </a:solidFill>
-                <a:latin typeface="Calibri" pitchFamily="34" charset="0"/>
-                <a:ea typeface="Calibri" pitchFamily="34" charset="-122"/>
-                <a:cs typeface="Calibri" pitchFamily="34" charset="-120"/>
-              </a:rPr>
-              <a:t>drought, salty tap water, protests</a:t>
-            </a:r>
-            <a:endParaRPr lang="en-US" sz="2200" dirty="0"/>
-          </a:p>
-          <a:p>
-            <a:pPr marL="279400" indent="-279400">
-              <a:spcAft>
-                <a:spcPts val="1600"/>
-              </a:spcAft>
-              <a:buSzPct val="100000"/>
-              <a:buChar char="•"/>
-            </a:pPr>
-            <a:r>
-              <a:rPr lang="en-US" sz="2200" b="1" dirty="0">
-                <a:solidFill>
-                  <a:srgbClr val="FFFFFF"/>
-                </a:solidFill>
-                <a:latin typeface="Calibri" pitchFamily="34" charset="0"/>
-                <a:ea typeface="Calibri" pitchFamily="34" charset="-122"/>
-                <a:cs typeface="Calibri" pitchFamily="34" charset="-120"/>
-              </a:rPr>
-              <a:t>Result: </a:t>
-            </a:r>
-            <a:r>
-              <a:rPr lang="en-US" sz="2200" dirty="0">
-                <a:solidFill>
-                  <a:srgbClr val="E3EBF1"/>
-                </a:solidFill>
-                <a:latin typeface="Calibri" pitchFamily="34" charset="0"/>
-                <a:ea typeface="Calibri" pitchFamily="34" charset="-122"/>
-                <a:cs typeface="Calibri" pitchFamily="34" charset="-120"/>
-              </a:rPr>
-              <a:t>Google switched its plan to air cooling</a:t>
-            </a:r>
-            <a:endParaRPr lang="en-US" sz="2200" dirty="0"/>
-          </a:p>
-        </p:txBody>
-      </p:sp>
-      <p:sp>
-        <p:nvSpPr>
-          <p:cNvPr id="5" name="Shape 3"/>
-          <p:cNvSpPr/>
-          <p:nvPr/>
-        </p:nvSpPr>
-        <p:spPr>
-          <a:xfrm>
-            <a:off x="7543800" y="2011680"/>
-            <a:ext cx="4206240" cy="4069080"/>
-          </a:xfrm>
-          <a:prstGeom prst="roundRect">
-            <a:avLst>
-              <a:gd name="adj" fmla="val 2697"/>
-            </a:avLst>
-          </a:prstGeom>
-          <a:solidFill>
-            <a:srgbClr val="FFFFFF">
-              <a:alpha val="92000"/>
-            </a:srgbClr>
-          </a:solidFill>
-          <a:ln w="12700">
-            <a:solidFill>
-              <a:srgbClr val="FFFFFF">
-                <a:alpha val="0"/>
-              </a:srgbClr>
-            </a:solidFill>
-            <a:prstDash val="solid"/>
-          </a:ln>
-        </p:spPr>
-      </p:sp>
-      <p:sp>
-        <p:nvSpPr>
-          <p:cNvPr id="6" name="chart-title"/>
-          <p:cNvSpPr txBox="1"/>
-          <p:nvPr/>
-        </p:nvSpPr>
-        <p:spPr>
-          <a:xfrm>
-            <a:off x="7772400" y="2148840"/>
-            <a:ext cx="3749040" cy="777240"/>
-          </a:xfrm>
-          <a:prstGeom prst="rect">
-            <a:avLst/>
-          </a:prstGeom>
-          <a:noFill/>
-          <a:ln/>
-        </p:spPr>
-        <p:txBody>
-          <a:bodyPr wrap="square" lIns="0" tIns="0" rIns="0" bIns="0" rtlCol="0" anchor="t"/>
-          <a:lstStyle/>
-          <a:p>
             <a:pPr indent="0" marL="0">
               <a:buNone/>
             </a:pPr>
             <a:r>
-              <a:rPr lang="en-US" sz="2100" b="1" dirty="0">
-                <a:solidFill>
-                  <a:srgbClr val="0E1B2A"/>
-                </a:solidFill>
-                <a:latin typeface="Calibri" pitchFamily="34" charset="0"/>
-                <a:ea typeface="Calibri" pitchFamily="34" charset="-122"/>
-                <a:cs typeface="Calibri" pitchFamily="34" charset="-120"/>
-              </a:rPr>
-              <a:t>Google’s water use rose 70%</a:t>
-            </a:r>
-            <a:endParaRPr lang="en-US" sz="2100" dirty="0"/>
-          </a:p>
-          <a:p>
-            <a:pPr indent="0" marL="0">
-              <a:buNone/>
-            </a:pPr>
-            <a:r>
-              <a:rPr lang="en-US" sz="2100" b="1" dirty="0">
-                <a:solidFill>
-                  <a:srgbClr val="0E1B2A"/>
-                </a:solidFill>
-                <a:latin typeface="Calibri" pitchFamily="34" charset="0"/>
-                <a:ea typeface="Calibri" pitchFamily="34" charset="-122"/>
-                <a:cs typeface="Calibri" pitchFamily="34" charset="-120"/>
-              </a:rPr>
-              <a:t>in two years</a:t>
-            </a:r>
-            <a:endParaRPr lang="en-US" sz="2100" dirty="0"/>
+              <a:rPr lang="en-US" sz="2200" dirty="0">
+                <a:solidFill>
+                  <a:srgbClr val="E3EBF1"/>
+                </a:solidFill>
+                <a:latin typeface="Calibri" pitchFamily="34" charset="0"/>
+                <a:ea typeface="Calibri" pitchFamily="34" charset="-122"/>
+                <a:cs typeface="Calibri" pitchFamily="34" charset="-120"/>
+              </a:rPr>
+              <a:t>English class  ·  [Class]  ·  [Date]</a:t>
+            </a:r>
+            <a:endParaRPr lang="en-US" sz="2200" dirty="0"/>
           </a:p>
         </p:txBody>
       </p:sp>
       <p:sp>
         <p:nvSpPr>
-          <p:cNvPr id="7" name="caption-chart"/>
-          <p:cNvSpPr txBox="1"/>
-          <p:nvPr/>
-        </p:nvSpPr>
-        <p:spPr>
-          <a:xfrm>
-            <a:off x="7772400" y="2926080"/>
-            <a:ext cx="3749040" cy="274320"/>
-          </a:xfrm>
-          <a:prstGeom prst="rect">
-            <a:avLst/>
-          </a:prstGeom>
-          <a:noFill/>
-          <a:ln/>
-        </p:spPr>
-        <p:txBody>
-          <a:bodyPr wrap="square" lIns="0" tIns="0" rIns="0" bIns="0" rtlCol="0" anchor="t"/>
-          <a:lstStyle/>
-          <a:p>
-            <a:pPr indent="0" marL="0">
-              <a:buNone/>
-            </a:pPr>
-            <a:r>
-              <a:rPr lang="en-US" sz="1100" dirty="0">
-                <a:solidFill>
-                  <a:srgbClr val="4A5A68"/>
-                </a:solidFill>
-                <a:latin typeface="Calibri" pitchFamily="34" charset="0"/>
-                <a:ea typeface="Calibri" pitchFamily="34" charset="-122"/>
-                <a:cs typeface="Calibri" pitchFamily="34" charset="-120"/>
-              </a:rPr>
-              <a:t>Billion litres · all Google operations · company-reported</a:t>
-            </a:r>
-            <a:endParaRPr lang="en-US" sz="1100" dirty="0"/>
-          </a:p>
-        </p:txBody>
-      </p:sp>
-      <p:graphicFrame>
-        <p:nvGraphicFramePr>
-          <p:cNvPr id="8" name="Chart 0" descr=""/>
-          <p:cNvGraphicFramePr/>
-          <p:nvPr/>
-        </p:nvGraphicFramePr>
-        <p:xfrm>
-          <a:off x="7635240" y="3154680"/>
-          <a:ext cx="4023360" cy="2834640"/>
-        </p:xfrm>
-        <a:graphic xmlns:a="http://schemas.openxmlformats.org/drawingml/2006/main">
-          <a:graphicData uri="http://schemas.openxmlformats.org/drawingml/2006/chart">
-            <c:chart xmlns:c="http://schemas.openxmlformats.org/drawingml/2006/chart" r:id="rId2"/>
-          </a:graphicData>
-        </a:graphic>
-      </p:graphicFrame>
-      <p:sp>
-        <p:nvSpPr>
-          <p:cNvPr id="9" name="caption-sources"/>
+          <p:cNvPr id="6" name="caption-sources"/>
           <p:cNvSpPr txBox="1"/>
           <p:nvPr/>
         </p:nvSpPr>
@@ -2826,7 +2709,7 @@
                 <a:ea typeface="Calibri" pitchFamily="34" charset="-122"/>
                 <a:cs typeface="Calibri" pitchFamily="34" charset="-120"/>
               </a:rPr>
-              <a:t>Sources: LBNL 2024 US Data Center Energy Report · Google Environmental Reports 2024–26 · The Guardian 2023, Mongabay 2023  ·  Image: AI-generated illustration</a:t>
+              <a:t>Image: example data-center campus, not in Israel</a:t>
             </a:r>
             <a:endParaRPr lang="en-US" sz="1050" dirty="0"/>
           </a:p>
@@ -2879,8 +2762,8 @@
         </p:nvSpPr>
         <p:spPr>
           <a:xfrm>
-            <a:off x="548640" y="365760"/>
-            <a:ext cx="11064240" cy="822960"/>
+            <a:off x="548640" y="411480"/>
+            <a:ext cx="11064240" cy="868680"/>
           </a:xfrm>
           <a:prstGeom prst="rect">
             <a:avLst/>
@@ -2896,7 +2779,7 @@
               <a:buNone/>
             </a:pPr>
             <a:r>
-              <a:rPr lang="en-US" sz="4000" b="1" dirty="0">
+              <a:rPr lang="en-US" sz="4600" b="1" dirty="0">
                 <a:solidFill>
                   <a:srgbClr val="FFFFFF"/>
                 </a:solidFill>
@@ -2904,22 +2787,22 @@
                 <a:ea typeface="Cambria" pitchFamily="34" charset="-122"/>
                 <a:cs typeface="Cambria" pitchFamily="34" charset="-120"/>
               </a:rPr>
-              <a:t>Israel &amp; Lev HaSharon: The Power Problem</a:t>
-            </a:r>
-            <a:endParaRPr lang="en-US" sz="4000" dirty="0"/>
+              <a:t>AI’s Hidden Thirst: Who Pays?</a:t>
+            </a:r>
+            <a:endParaRPr lang="en-US" sz="4600" dirty="0"/>
           </a:p>
         </p:txBody>
       </p:sp>
       <p:sp>
         <p:nvSpPr>
-          <p:cNvPr id="3" name="body"/>
+          <p:cNvPr id="3" name="kicker"/>
           <p:cNvSpPr txBox="1"/>
           <p:nvPr/>
         </p:nvSpPr>
         <p:spPr>
           <a:xfrm>
-            <a:off x="548640" y="1417320"/>
-            <a:ext cx="5943600" cy="4480560"/>
+            <a:off x="548640" y="1298448"/>
+            <a:ext cx="11064240" cy="457200"/>
           </a:xfrm>
           <a:prstGeom prst="rect">
             <a:avLst/>
@@ -2931,15 +2814,54 @@
           <a:bodyPr wrap="square" lIns="0" tIns="0" rIns="0" bIns="0" rtlCol="0" anchor="t"/>
           <a:lstStyle/>
           <a:p>
+            <a:pPr indent="0" marL="0">
+              <a:buNone/>
+            </a:pPr>
+            <a:r>
+              <a:rPr lang="en-US" sz="2200" i="1" dirty="0">
+                <a:solidFill>
+                  <a:srgbClr val="F2A33A"/>
+                </a:solidFill>
+                <a:latin typeface="Calibri" pitchFamily="34" charset="0"/>
+                <a:ea typeface="Calibri" pitchFamily="34" charset="-122"/>
+                <a:cs typeface="Calibri" pitchFamily="34" charset="-120"/>
+              </a:rPr>
+              <a:t>A social justice question: who carries AI’s impact?</a:t>
+            </a:r>
+            <a:endParaRPr lang="en-US" sz="2200" dirty="0"/>
+          </a:p>
+        </p:txBody>
+      </p:sp>
+      <p:sp>
+        <p:nvSpPr>
+          <p:cNvPr id="4" name="body"/>
+          <p:cNvSpPr txBox="1"/>
+          <p:nvPr/>
+        </p:nvSpPr>
+        <p:spPr>
+          <a:xfrm>
+            <a:off x="548640" y="2148840"/>
+            <a:ext cx="6035040" cy="3931920"/>
+          </a:xfrm>
+          <a:prstGeom prst="rect">
+            <a:avLst/>
+          </a:prstGeom>
+          <a:noFill/>
+          <a:ln/>
+        </p:spPr>
+        <p:txBody>
+          <a:bodyPr wrap="square" lIns="0" tIns="0" rIns="0" bIns="0" rtlCol="0" anchor="t"/>
+          <a:lstStyle/>
+          <a:p>
             <a:pPr marL="279400" indent="-279400">
               <a:spcAft>
-                <a:spcPts val="1300"/>
+                <a:spcPts val="1600"/>
               </a:spcAft>
               <a:buSzPct val="100000"/>
               <a:buChar char="•"/>
             </a:pPr>
             <a:r>
-              <a:rPr lang="en-US" sz="2100" dirty="0">
+              <a:rPr lang="en-US" sz="2200" dirty="0">
                 <a:solidFill>
                   <a:srgbClr val="E3EBF1"/>
                 </a:solidFill>
@@ -2947,31 +2869,53 @@
                 <a:ea typeface="Calibri" pitchFamily="34" charset="-122"/>
                 <a:cs typeface="Calibri" pitchFamily="34" charset="-120"/>
               </a:rPr>
-              <a:t>Most of our tap water is </a:t>
-            </a:r>
-            <a:r>
-              <a:rPr lang="en-US" sz="2100" b="1" dirty="0">
-                <a:solidFill>
-                  <a:srgbClr val="8FD3E8"/>
-                </a:solidFill>
-                <a:latin typeface="Calibri" pitchFamily="34" charset="0"/>
-                <a:ea typeface="Calibri" pitchFamily="34" charset="-122"/>
-                <a:cs typeface="Calibri" pitchFamily="34" charset="-120"/>
-              </a:rPr>
-              <a:t>desalinated</a:t>
-            </a:r>
-            <a:endParaRPr lang="en-US" sz="2100" dirty="0"/>
+              <a:t>AI data centers run on water </a:t>
+            </a:r>
+            <a:r>
+              <a:rPr lang="en-US" sz="2200" b="1" dirty="0">
+                <a:solidFill>
+                  <a:srgbClr val="F2A33A"/>
+                </a:solidFill>
+                <a:latin typeface="Calibri" pitchFamily="34" charset="0"/>
+                <a:ea typeface="Calibri" pitchFamily="34" charset="-122"/>
+                <a:cs typeface="Calibri" pitchFamily="34" charset="-120"/>
+              </a:rPr>
+              <a:t>and</a:t>
+            </a:r>
+            <a:r>
+              <a:rPr lang="en-US" sz="2200" dirty="0">
+                <a:solidFill>
+                  <a:srgbClr val="E3EBF1"/>
+                </a:solidFill>
+                <a:latin typeface="Calibri" pitchFamily="34" charset="0"/>
+                <a:ea typeface="Calibri" pitchFamily="34" charset="-122"/>
+                <a:cs typeface="Calibri" pitchFamily="34" charset="-120"/>
+              </a:rPr>
+              <a:t> power</a:t>
+            </a:r>
+            <a:endParaRPr lang="en-US" sz="2200" dirty="0"/>
           </a:p>
           <a:p>
             <a:pPr marL="279400" indent="-279400">
               <a:spcAft>
-                <a:spcPts val="1300"/>
+                <a:spcPts val="1600"/>
               </a:spcAft>
               <a:buSzPct val="100000"/>
               <a:buChar char="•"/>
             </a:pPr>
             <a:r>
-              <a:rPr lang="en-US" sz="2100" dirty="0">
+              <a:rPr lang="en-US" sz="2200" b="1" dirty="0">
+                <a:solidFill>
+                  <a:srgbClr val="FFFFFF"/>
+                </a:solidFill>
+                <a:latin typeface="Calibri" pitchFamily="34" charset="0"/>
+                <a:ea typeface="Calibri" pitchFamily="34" charset="-122"/>
+                <a:cs typeface="Calibri" pitchFamily="34" charset="-120"/>
+              </a:rPr>
+              <a:t>On-site: </a:t>
+            </a:r>
+            <a:r>
+              <a:rPr lang="en-US" sz="2200" dirty="0">
                 <a:solidFill>
                   <a:srgbClr val="E3EBF1"/>
                 </a:solidFill>
@@ -2979,31 +2923,31 @@
                 <a:ea typeface="Calibri" pitchFamily="34" charset="-122"/>
                 <a:cs typeface="Calibri" pitchFamily="34" charset="-120"/>
               </a:rPr>
-              <a:t>Desalination needs </a:t>
-            </a:r>
-            <a:r>
-              <a:rPr lang="en-US" sz="2100" b="1" dirty="0">
-                <a:solidFill>
-                  <a:srgbClr val="FFFFFF"/>
-                </a:solidFill>
-                <a:latin typeface="Calibri" pitchFamily="34" charset="0"/>
-                <a:ea typeface="Calibri" pitchFamily="34" charset="-122"/>
-                <a:cs typeface="Calibri" pitchFamily="34" charset="-120"/>
-              </a:rPr>
-              <a:t>a lot of electricity</a:t>
-            </a:r>
-            <a:endParaRPr lang="en-US" sz="2100" dirty="0"/>
+              <a:t>water evaporates to cool servers</a:t>
+            </a:r>
+            <a:endParaRPr lang="en-US" sz="2200" dirty="0"/>
           </a:p>
           <a:p>
             <a:pPr marL="279400" indent="-279400">
               <a:spcAft>
-                <a:spcPts val="1300"/>
+                <a:spcPts val="1600"/>
               </a:spcAft>
               <a:buSzPct val="100000"/>
               <a:buChar char="•"/>
             </a:pPr>
             <a:r>
-              <a:rPr lang="en-US" sz="2100" dirty="0">
+              <a:rPr lang="en-US" sz="2200" b="1" dirty="0">
+                <a:solidFill>
+                  <a:srgbClr val="FFFFFF"/>
+                </a:solidFill>
+                <a:latin typeface="Calibri" pitchFamily="34" charset="0"/>
+                <a:ea typeface="Calibri" pitchFamily="34" charset="-122"/>
+                <a:cs typeface="Calibri" pitchFamily="34" charset="-120"/>
+              </a:rPr>
+              <a:t>Off-site: </a:t>
+            </a:r>
+            <a:r>
+              <a:rPr lang="en-US" sz="2200" dirty="0">
                 <a:solidFill>
                   <a:srgbClr val="E3EBF1"/>
                 </a:solidFill>
@@ -3011,10 +2955,10 @@
                 <a:ea typeface="Calibri" pitchFamily="34" charset="-122"/>
                 <a:cs typeface="Calibri" pitchFamily="34" charset="-120"/>
               </a:rPr>
-              <a:t>Data centers requested </a:t>
-            </a:r>
-            <a:r>
-              <a:rPr lang="en-US" sz="2100" b="1" dirty="0">
+              <a:t>US power plants use about </a:t>
+            </a:r>
+            <a:r>
+              <a:rPr lang="en-US" sz="2200" b="1" dirty="0">
                 <a:solidFill>
                   <a:srgbClr val="F2A33A"/>
                 </a:solidFill>
@@ -3022,31 +2966,20 @@
                 <a:ea typeface="Calibri" pitchFamily="34" charset="-122"/>
                 <a:cs typeface="Calibri" pitchFamily="34" charset="-120"/>
               </a:rPr>
-              <a:t>27,000 MW</a:t>
-            </a:r>
-            <a:r>
-              <a:rPr lang="en-US" sz="2100" dirty="0">
-                <a:solidFill>
-                  <a:srgbClr val="E3EBF1"/>
-                </a:solidFill>
-                <a:latin typeface="Calibri" pitchFamily="34" charset="0"/>
-                <a:ea typeface="Calibri" pitchFamily="34" charset="-122"/>
-                <a:cs typeface="Calibri" pitchFamily="34" charset="-120"/>
-              </a:rPr>
-              <a:t> (≈3× average)</a:t>
-            </a:r>
-            <a:endParaRPr lang="en-US" sz="2100" dirty="0"/>
+              <a:t>12× more</a:t>
+            </a:r>
+            <a:endParaRPr lang="en-US" sz="2200" dirty="0"/>
           </a:p>
           <a:p>
             <a:pPr marL="279400" indent="-279400">
               <a:spcAft>
-                <a:spcPts val="1300"/>
+                <a:spcPts val="1600"/>
               </a:spcAft>
               <a:buSzPct val="100000"/>
               <a:buChar char="•"/>
             </a:pPr>
             <a:r>
-              <a:rPr lang="en-US" sz="2100" b="1" dirty="0">
+              <a:rPr lang="en-US" sz="2200" b="1" dirty="0">
                 <a:solidFill>
                   <a:srgbClr val="FFFFFF"/>
                 </a:solidFill>
@@ -3054,10 +2987,10 @@
                 <a:ea typeface="Calibri" pitchFamily="34" charset="-122"/>
                 <a:cs typeface="Calibri" pitchFamily="34" charset="-120"/>
               </a:rPr>
-              <a:t>July 2026: </a:t>
-            </a:r>
-            <a:r>
-              <a:rPr lang="en-US" sz="2100" dirty="0">
+              <a:t>Uruguay 2023: </a:t>
+            </a:r>
+            <a:r>
+              <a:rPr lang="en-US" sz="2200" dirty="0">
                 <a:solidFill>
                   <a:srgbClr val="E3EBF1"/>
                 </a:solidFill>
@@ -3065,20 +2998,20 @@
                 <a:ea typeface="Calibri" pitchFamily="34" charset="-122"/>
                 <a:cs typeface="Calibri" pitchFamily="34" charset="-120"/>
               </a:rPr>
-              <a:t>regulator froze new connections</a:t>
-            </a:r>
-            <a:endParaRPr lang="en-US" sz="2100" dirty="0"/>
+              <a:t>drought, salty tap water, protests</a:t>
+            </a:r>
+            <a:endParaRPr lang="en-US" sz="2200" dirty="0"/>
           </a:p>
           <a:p>
             <a:pPr marL="279400" indent="-279400">
               <a:spcAft>
-                <a:spcPts val="1300"/>
+                <a:spcPts val="1600"/>
               </a:spcAft>
               <a:buSzPct val="100000"/>
               <a:buChar char="•"/>
             </a:pPr>
             <a:r>
-              <a:rPr lang="en-US" sz="2100" b="1" dirty="0">
+              <a:rPr lang="en-US" sz="2200" b="1" dirty="0">
                 <a:solidFill>
                   <a:srgbClr val="FFFFFF"/>
                 </a:solidFill>
@@ -3086,10 +3019,10 @@
                 <a:ea typeface="Calibri" pitchFamily="34" charset="-122"/>
                 <a:cs typeface="Calibri" pitchFamily="34" charset="-120"/>
               </a:rPr>
-              <a:t>Near us: </a:t>
-            </a:r>
-            <a:r>
-              <a:rPr lang="en-US" sz="2100" dirty="0">
+              <a:t>Result: </a:t>
+            </a:r>
+            <a:r>
+              <a:rPr lang="en-US" sz="2200" dirty="0">
                 <a:solidFill>
                   <a:srgbClr val="E3EBF1"/>
                 </a:solidFill>
@@ -3097,58 +3030,26 @@
                 <a:ea typeface="Calibri" pitchFamily="34" charset="-122"/>
                 <a:cs typeface="Calibri" pitchFamily="34" charset="-120"/>
               </a:rPr>
-              <a:t>Kfar Yona, Netanya, Hadera projects</a:t>
-            </a:r>
-            <a:endParaRPr lang="en-US" sz="2100" dirty="0"/>
-          </a:p>
-          <a:p>
-            <a:pPr marL="279400" indent="-279400">
-              <a:spcAft>
-                <a:spcPts val="1300"/>
-              </a:spcAft>
-              <a:buSzPct val="100000"/>
-              <a:buChar char="•"/>
-            </a:pPr>
-            <a:r>
-              <a:rPr lang="en-US" sz="2100" b="1" dirty="0">
-                <a:solidFill>
-                  <a:srgbClr val="FFFFFF"/>
-                </a:solidFill>
-                <a:latin typeface="Calibri" pitchFamily="34" charset="0"/>
-                <a:ea typeface="Calibri" pitchFamily="34" charset="-122"/>
-                <a:cs typeface="Calibri" pitchFamily="34" charset="-120"/>
-              </a:rPr>
-              <a:t>2026 water shortage: </a:t>
-            </a:r>
-            <a:r>
-              <a:rPr lang="en-US" sz="2100" dirty="0">
-                <a:solidFill>
-                  <a:srgbClr val="E3EBF1"/>
-                </a:solidFill>
-                <a:latin typeface="Calibri" pitchFamily="34" charset="0"/>
-                <a:ea typeface="Calibri" pitchFamily="34" charset="-122"/>
-                <a:cs typeface="Calibri" pitchFamily="34" charset="-120"/>
-              </a:rPr>
-              <a:t>farms were cut first</a:t>
-            </a:r>
-            <a:endParaRPr lang="en-US" sz="2100" dirty="0"/>
+              <a:t>Google switched its plan to air cooling</a:t>
+            </a:r>
+            <a:endParaRPr lang="en-US" sz="2200" dirty="0"/>
           </a:p>
         </p:txBody>
       </p:sp>
       <p:sp>
         <p:nvSpPr>
-          <p:cNvPr id="4" name="Shape 2"/>
+          <p:cNvPr id="5" name="Shape 3"/>
           <p:cNvSpPr/>
           <p:nvPr/>
         </p:nvSpPr>
         <p:spPr>
           <a:xfrm>
-            <a:off x="7406640" y="1280160"/>
-            <a:ext cx="4343400" cy="2560320"/>
+            <a:off x="7543800" y="2011680"/>
+            <a:ext cx="4206240" cy="4069080"/>
           </a:xfrm>
           <a:prstGeom prst="roundRect">
             <a:avLst>
-              <a:gd name="adj" fmla="val 4286"/>
+              <a:gd name="adj" fmla="val 2697"/>
             </a:avLst>
           </a:prstGeom>
           <a:solidFill>
@@ -3168,14 +3069,14 @@
       </p:sp>
       <p:sp>
         <p:nvSpPr>
-          <p:cNvPr id="5" name="chart-title"/>
+          <p:cNvPr id="6" name="chart-title"/>
           <p:cNvSpPr txBox="1"/>
           <p:nvPr/>
         </p:nvSpPr>
         <p:spPr>
           <a:xfrm>
-            <a:off x="7635240" y="1371600"/>
-            <a:ext cx="3931920" cy="658368"/>
+            <a:off x="7772400" y="2148840"/>
+            <a:ext cx="3749040" cy="777240"/>
           </a:xfrm>
           <a:prstGeom prst="rect">
             <a:avLst/>
@@ -3191,7 +3092,7 @@
               <a:buNone/>
             </a:pPr>
             <a:r>
-              <a:rPr lang="en-US" sz="2000" b="1" dirty="0">
+              <a:rPr lang="en-US" sz="2100" b="1" dirty="0">
                 <a:solidFill>
                   <a:srgbClr val="0E1B2A"/>
                 </a:solidFill>
@@ -3199,16 +3100,16 @@
                 <a:ea typeface="Calibri" pitchFamily="34" charset="-122"/>
                 <a:cs typeface="Calibri" pitchFamily="34" charset="-120"/>
               </a:rPr>
-              <a:t>Requests are 18× what</a:t>
-            </a:r>
-            <a:endParaRPr lang="en-US" sz="2000" dirty="0"/>
+              <a:t>Google’s water use rose 70%</a:t>
+            </a:r>
+            <a:endParaRPr lang="en-US" sz="2100" dirty="0"/>
           </a:p>
           <a:p>
             <a:pPr indent="0" marL="0">
               <a:buNone/>
             </a:pPr>
             <a:r>
-              <a:rPr lang="en-US" sz="2000" b="1" dirty="0">
+              <a:rPr lang="en-US" sz="2100" b="1" dirty="0">
                 <a:solidFill>
                   <a:srgbClr val="0E1B2A"/>
                 </a:solidFill>
@@ -3216,21 +3117,60 @@
                 <a:ea typeface="Calibri" pitchFamily="34" charset="-122"/>
                 <a:cs typeface="Calibri" pitchFamily="34" charset="-120"/>
               </a:rPr>
-              <a:t>is already promised</a:t>
-            </a:r>
-            <a:endParaRPr lang="en-US" sz="2000" dirty="0"/>
+              <a:t>in two years</a:t>
+            </a:r>
+            <a:endParaRPr lang="en-US" sz="2100" dirty="0"/>
+          </a:p>
+        </p:txBody>
+      </p:sp>
+      <p:sp>
+        <p:nvSpPr>
+          <p:cNvPr id="7" name="caption-chart"/>
+          <p:cNvSpPr txBox="1"/>
+          <p:nvPr/>
+        </p:nvSpPr>
+        <p:spPr>
+          <a:xfrm>
+            <a:off x="7772400" y="2926080"/>
+            <a:ext cx="3749040" cy="274320"/>
+          </a:xfrm>
+          <a:prstGeom prst="rect">
+            <a:avLst/>
+          </a:prstGeom>
+          <a:noFill/>
+          <a:ln/>
+        </p:spPr>
+        <p:txBody>
+          <a:bodyPr wrap="square" lIns="0" tIns="0" rIns="0" bIns="0" rtlCol="0" anchor="t"/>
+          <a:lstStyle/>
+          <a:p>
+            <a:pPr indent="0" marL="0">
+              <a:buNone/>
+            </a:pPr>
+            <a:r>
+              <a:rPr lang="en-US" sz="1100" dirty="0">
+                <a:solidFill>
+                  <a:srgbClr val="4A5A68"/>
+                </a:solidFill>
+                <a:latin typeface="Calibri" pitchFamily="34" charset="0"/>
+                <a:ea typeface="Calibri" pitchFamily="34" charset="-122"/>
+                <a:cs typeface="Calibri" pitchFamily="34" charset="-120"/>
+              </a:rPr>
+              <a:t>Billion litres · all Google operations · company-reported</a:t>
+            </a:r>
+            <a:endParaRPr lang="en-US" sz="1100" dirty="0"/>
           </a:p>
         </p:txBody>
       </p:sp>
       <p:graphicFrame>
         <p:nvGraphicFramePr>
-          <p:cNvPr id="6" name="Chart 0" descr=""/>
+          <p:cNvPr id="8" name="Chart 0" descr=""/>
           <p:cNvGraphicFramePr/>
           <p:nvPr/>
         </p:nvGraphicFramePr>
         <p:xfrm>
-          <a:off x="7498080" y="2011680"/>
-          <a:ext cx="4206240" cy="1783080"/>
+          <a:off x="7635240" y="3154680"/>
+          <a:ext cx="4023360" cy="2834640"/>
         </p:xfrm>
         <a:graphic xmlns:a="http://schemas.openxmlformats.org/drawingml/2006/main">
           <a:graphicData uri="http://schemas.openxmlformats.org/drawingml/2006/chart">
@@ -3240,7 +3180,7 @@
       </p:graphicFrame>
       <p:sp>
         <p:nvSpPr>
-          <p:cNvPr id="7" name="caption-sources"/>
+          <p:cNvPr id="9" name="caption-sources"/>
           <p:cNvSpPr txBox="1"/>
           <p:nvPr/>
         </p:nvSpPr>
@@ -3271,7 +3211,7 @@
                 <a:ea typeface="Calibri" pitchFamily="34" charset="-122"/>
                 <a:cs typeface="Calibri" pitchFamily="34" charset="-120"/>
               </a:rPr>
-              <a:t>Sources: Electricity Authority &amp; Noga via DCD, JNS, Ctech (Jul 2026) · State Comptroller 2024 · DCD, Globes, Ctech · Times of Israel, CNN (Sep 2026)  ·  Image: example data-center campus, not in Israel</a:t>
+              <a:t>Sources: LBNL 2024 US Data Center Energy Report · Google Environmental Reports 2024–26 · The Guardian 2023, Mongabay 2023  ·  Image: AI-generated illustration</a:t>
             </a:r>
             <a:endParaRPr lang="en-US" sz="1050" dirty="0"/>
           </a:p>
@@ -3324,7 +3264,7 @@
         </p:nvSpPr>
         <p:spPr>
           <a:xfrm>
-            <a:off x="548640" y="320040"/>
+            <a:off x="548640" y="365760"/>
             <a:ext cx="11064240" cy="822960"/>
           </a:xfrm>
           <a:prstGeom prst="rect">
@@ -3349,7 +3289,7 @@
                 <a:ea typeface="Cambria" pitchFamily="34" charset="-122"/>
                 <a:cs typeface="Cambria" pitchFamily="34" charset="-120"/>
               </a:rPr>
-              <a:t>Who Is Pushing Back? NGOs &amp; Laws</a:t>
+              <a:t>Israel &amp; Lev HaSharon: The Power Problem</a:t>
             </a:r>
             <a:endParaRPr lang="en-US" sz="4000" dirty="0"/>
           </a:p>
@@ -3357,45 +3297,14 @@
       </p:sp>
       <p:sp>
         <p:nvSpPr>
-          <p:cNvPr id="3" name="Shape 1"/>
-          <p:cNvSpPr/>
+          <p:cNvPr id="3" name="body"/>
+          <p:cNvSpPr txBox="1"/>
           <p:nvPr/>
         </p:nvSpPr>
         <p:spPr>
           <a:xfrm>
-            <a:off x="320040" y="1234440"/>
-            <a:ext cx="4206240" cy="5440680"/>
-          </a:xfrm>
-          <a:prstGeom prst="roundRect">
-            <a:avLst>
-              <a:gd name="adj" fmla="val 2609"/>
-            </a:avLst>
-          </a:prstGeom>
-          <a:solidFill>
-            <a:srgbClr val="0B2239">
-              <a:alpha val="88000"/>
-            </a:srgbClr>
-          </a:solidFill>
-          <a:ln w="12700">
-            <a:solidFill>
-              <a:srgbClr val="0B2239">
-                <a:alpha val="0"/>
-              </a:srgbClr>
-            </a:solidFill>
-            <a:prstDash val="solid"/>
-          </a:ln>
-        </p:spPr>
-      </p:sp>
-      <p:sp>
-        <p:nvSpPr>
-          <p:cNvPr id="4" name="header"/>
-          <p:cNvSpPr txBox="1"/>
-          <p:nvPr/>
-        </p:nvSpPr>
-        <p:spPr>
-          <a:xfrm>
-            <a:off x="548640" y="1371600"/>
-            <a:ext cx="3794760" cy="777240"/>
+            <a:off x="548640" y="1417320"/>
+            <a:ext cx="5943600" cy="4480560"/>
           </a:xfrm>
           <a:prstGeom prst="rect">
             <a:avLst/>
@@ -3407,51 +3316,251 @@
           <a:bodyPr wrap="square" lIns="0" tIns="0" rIns="0" bIns="0" rtlCol="0" anchor="t"/>
           <a:lstStyle/>
           <a:p>
-            <a:pPr indent="0" marL="0">
-              <a:buNone/>
-            </a:pPr>
-            <a:r>
-              <a:rPr lang="en-US" sz="2600" b="1" dirty="0">
+            <a:pPr marL="279400" indent="-279400">
+              <a:spcAft>
+                <a:spcPts val="1300"/>
+              </a:spcAft>
+              <a:buSzPct val="100000"/>
+              <a:buChar char="•"/>
+            </a:pPr>
+            <a:r>
+              <a:rPr lang="en-US" sz="2100" dirty="0">
+                <a:solidFill>
+                  <a:srgbClr val="E3EBF1"/>
+                </a:solidFill>
+                <a:latin typeface="Calibri" pitchFamily="34" charset="0"/>
+                <a:ea typeface="Calibri" pitchFamily="34" charset="-122"/>
+                <a:cs typeface="Calibri" pitchFamily="34" charset="-120"/>
+              </a:rPr>
+              <a:t>Most of our tap water is </a:t>
+            </a:r>
+            <a:r>
+              <a:rPr lang="en-US" sz="2100" b="1" dirty="0">
+                <a:solidFill>
+                  <a:srgbClr val="8FD3E8"/>
+                </a:solidFill>
+                <a:latin typeface="Calibri" pitchFamily="34" charset="0"/>
+                <a:ea typeface="Calibri" pitchFamily="34" charset="-122"/>
+                <a:cs typeface="Calibri" pitchFamily="34" charset="-120"/>
+              </a:rPr>
+              <a:t>desalinated</a:t>
+            </a:r>
+            <a:endParaRPr lang="en-US" sz="2100" dirty="0"/>
+          </a:p>
+          <a:p>
+            <a:pPr marL="279400" indent="-279400">
+              <a:spcAft>
+                <a:spcPts val="1300"/>
+              </a:spcAft>
+              <a:buSzPct val="100000"/>
+              <a:buChar char="•"/>
+            </a:pPr>
+            <a:r>
+              <a:rPr lang="en-US" sz="2100" dirty="0">
+                <a:solidFill>
+                  <a:srgbClr val="E3EBF1"/>
+                </a:solidFill>
+                <a:latin typeface="Calibri" pitchFamily="34" charset="0"/>
+                <a:ea typeface="Calibri" pitchFamily="34" charset="-122"/>
+                <a:cs typeface="Calibri" pitchFamily="34" charset="-120"/>
+              </a:rPr>
+              <a:t>Desalination needs </a:t>
+            </a:r>
+            <a:r>
+              <a:rPr lang="en-US" sz="2100" b="1" dirty="0">
                 <a:solidFill>
                   <a:srgbClr val="FFFFFF"/>
                 </a:solidFill>
-                <a:latin typeface="Cambria" pitchFamily="34" charset="0"/>
-                <a:ea typeface="Cambria" pitchFamily="34" charset="-122"/>
-                <a:cs typeface="Cambria" pitchFamily="34" charset="-120"/>
-              </a:rPr>
-              <a:t>NGO: SPNI</a:t>
-            </a:r>
-            <a:endParaRPr lang="en-US" sz="2600" dirty="0"/>
-          </a:p>
-          <a:p>
-            <a:pPr indent="0" marL="0">
-              <a:buNone/>
-            </a:pPr>
-            <a:r>
-              <a:rPr lang="en-US" sz="1300" dirty="0">
-                <a:solidFill>
-                  <a:srgbClr val="A9BCCB"/>
-                </a:solidFill>
-                <a:latin typeface="Calibri" pitchFamily="34" charset="0"/>
-                <a:ea typeface="Calibri" pitchFamily="34" charset="-122"/>
-                <a:cs typeface="Calibri" pitchFamily="34" charset="-120"/>
-              </a:rPr>
-              <a:t>Society for the Protection of Nature in Israel</a:t>
-            </a:r>
-            <a:endParaRPr lang="en-US" sz="2600" dirty="0"/>
+                <a:latin typeface="Calibri" pitchFamily="34" charset="0"/>
+                <a:ea typeface="Calibri" pitchFamily="34" charset="-122"/>
+                <a:cs typeface="Calibri" pitchFamily="34" charset="-120"/>
+              </a:rPr>
+              <a:t>a lot of electricity</a:t>
+            </a:r>
+            <a:endParaRPr lang="en-US" sz="2100" dirty="0"/>
+          </a:p>
+          <a:p>
+            <a:pPr marL="279400" indent="-279400">
+              <a:spcAft>
+                <a:spcPts val="1300"/>
+              </a:spcAft>
+              <a:buSzPct val="100000"/>
+              <a:buChar char="•"/>
+            </a:pPr>
+            <a:r>
+              <a:rPr lang="en-US" sz="2100" dirty="0">
+                <a:solidFill>
+                  <a:srgbClr val="E3EBF1"/>
+                </a:solidFill>
+                <a:latin typeface="Calibri" pitchFamily="34" charset="0"/>
+                <a:ea typeface="Calibri" pitchFamily="34" charset="-122"/>
+                <a:cs typeface="Calibri" pitchFamily="34" charset="-120"/>
+              </a:rPr>
+              <a:t>Data centers requested </a:t>
+            </a:r>
+            <a:r>
+              <a:rPr lang="en-US" sz="2100" b="1" dirty="0">
+                <a:solidFill>
+                  <a:srgbClr val="F2A33A"/>
+                </a:solidFill>
+                <a:latin typeface="Calibri" pitchFamily="34" charset="0"/>
+                <a:ea typeface="Calibri" pitchFamily="34" charset="-122"/>
+                <a:cs typeface="Calibri" pitchFamily="34" charset="-120"/>
+              </a:rPr>
+              <a:t>27,000 MW</a:t>
+            </a:r>
+            <a:r>
+              <a:rPr lang="en-US" sz="2100" dirty="0">
+                <a:solidFill>
+                  <a:srgbClr val="E3EBF1"/>
+                </a:solidFill>
+                <a:latin typeface="Calibri" pitchFamily="34" charset="0"/>
+                <a:ea typeface="Calibri" pitchFamily="34" charset="-122"/>
+                <a:cs typeface="Calibri" pitchFamily="34" charset="-120"/>
+              </a:rPr>
+              <a:t> (≈3× average)</a:t>
+            </a:r>
+            <a:endParaRPr lang="en-US" sz="2100" dirty="0"/>
+          </a:p>
+          <a:p>
+            <a:pPr marL="279400" indent="-279400">
+              <a:spcAft>
+                <a:spcPts val="1300"/>
+              </a:spcAft>
+              <a:buSzPct val="100000"/>
+              <a:buChar char="•"/>
+            </a:pPr>
+            <a:r>
+              <a:rPr lang="en-US" sz="2100" b="1" dirty="0">
+                <a:solidFill>
+                  <a:srgbClr val="FFFFFF"/>
+                </a:solidFill>
+                <a:latin typeface="Calibri" pitchFamily="34" charset="0"/>
+                <a:ea typeface="Calibri" pitchFamily="34" charset="-122"/>
+                <a:cs typeface="Calibri" pitchFamily="34" charset="-120"/>
+              </a:rPr>
+              <a:t>July 2026: </a:t>
+            </a:r>
+            <a:r>
+              <a:rPr lang="en-US" sz="2100" dirty="0">
+                <a:solidFill>
+                  <a:srgbClr val="E3EBF1"/>
+                </a:solidFill>
+                <a:latin typeface="Calibri" pitchFamily="34" charset="0"/>
+                <a:ea typeface="Calibri" pitchFamily="34" charset="-122"/>
+                <a:cs typeface="Calibri" pitchFamily="34" charset="-120"/>
+              </a:rPr>
+              <a:t>regulator froze new connections</a:t>
+            </a:r>
+            <a:endParaRPr lang="en-US" sz="2100" dirty="0"/>
+          </a:p>
+          <a:p>
+            <a:pPr marL="279400" indent="-279400">
+              <a:spcAft>
+                <a:spcPts val="1300"/>
+              </a:spcAft>
+              <a:buSzPct val="100000"/>
+              <a:buChar char="•"/>
+            </a:pPr>
+            <a:r>
+              <a:rPr lang="en-US" sz="2100" b="1" dirty="0">
+                <a:solidFill>
+                  <a:srgbClr val="FFFFFF"/>
+                </a:solidFill>
+                <a:latin typeface="Calibri" pitchFamily="34" charset="0"/>
+                <a:ea typeface="Calibri" pitchFamily="34" charset="-122"/>
+                <a:cs typeface="Calibri" pitchFamily="34" charset="-120"/>
+              </a:rPr>
+              <a:t>Near us: </a:t>
+            </a:r>
+            <a:r>
+              <a:rPr lang="en-US" sz="2100" dirty="0">
+                <a:solidFill>
+                  <a:srgbClr val="E3EBF1"/>
+                </a:solidFill>
+                <a:latin typeface="Calibri" pitchFamily="34" charset="0"/>
+                <a:ea typeface="Calibri" pitchFamily="34" charset="-122"/>
+                <a:cs typeface="Calibri" pitchFamily="34" charset="-120"/>
+              </a:rPr>
+              <a:t>Kfar Yona, Netanya, Hadera projects</a:t>
+            </a:r>
+            <a:endParaRPr lang="en-US" sz="2100" dirty="0"/>
+          </a:p>
+          <a:p>
+            <a:pPr marL="279400" indent="-279400">
+              <a:spcAft>
+                <a:spcPts val="1300"/>
+              </a:spcAft>
+              <a:buSzPct val="100000"/>
+              <a:buChar char="•"/>
+            </a:pPr>
+            <a:r>
+              <a:rPr lang="en-US" sz="2100" b="1" dirty="0">
+                <a:solidFill>
+                  <a:srgbClr val="FFFFFF"/>
+                </a:solidFill>
+                <a:latin typeface="Calibri" pitchFamily="34" charset="0"/>
+                <a:ea typeface="Calibri" pitchFamily="34" charset="-122"/>
+                <a:cs typeface="Calibri" pitchFamily="34" charset="-120"/>
+              </a:rPr>
+              <a:t>2026 water shortage: </a:t>
+            </a:r>
+            <a:r>
+              <a:rPr lang="en-US" sz="2100" dirty="0">
+                <a:solidFill>
+                  <a:srgbClr val="E3EBF1"/>
+                </a:solidFill>
+                <a:latin typeface="Calibri" pitchFamily="34" charset="0"/>
+                <a:ea typeface="Calibri" pitchFamily="34" charset="-122"/>
+                <a:cs typeface="Calibri" pitchFamily="34" charset="-120"/>
+              </a:rPr>
+              <a:t>farms were cut first</a:t>
+            </a:r>
+            <a:endParaRPr lang="en-US" sz="2100" dirty="0"/>
           </a:p>
         </p:txBody>
       </p:sp>
       <p:sp>
         <p:nvSpPr>
-          <p:cNvPr id="5" name="body"/>
+          <p:cNvPr id="4" name="Shape 2"/>
+          <p:cNvSpPr/>
+          <p:nvPr/>
+        </p:nvSpPr>
+        <p:spPr>
+          <a:xfrm>
+            <a:off x="7406640" y="1280160"/>
+            <a:ext cx="4343400" cy="2560320"/>
+          </a:xfrm>
+          <a:prstGeom prst="roundRect">
+            <a:avLst>
+              <a:gd name="adj" fmla="val 4286"/>
+            </a:avLst>
+          </a:prstGeom>
+          <a:solidFill>
+            <a:srgbClr val="FFFFFF">
+              <a:alpha val="92000"/>
+            </a:srgbClr>
+          </a:solidFill>
+          <a:ln w="12700">
+            <a:solidFill>
+              <a:srgbClr val="FFFFFF">
+                <a:alpha val="0"/>
+              </a:srgbClr>
+            </a:solidFill>
+            <a:prstDash val="solid"/>
+          </a:ln>
+        </p:spPr>
+      </p:sp>
+      <p:sp>
+        <p:nvSpPr>
+          <p:cNvPr id="5" name="chart-title"/>
           <p:cNvSpPr txBox="1"/>
           <p:nvPr/>
         </p:nvSpPr>
         <p:spPr>
           <a:xfrm>
-            <a:off x="548640" y="2194560"/>
-            <a:ext cx="3840480" cy="1508760"/>
+            <a:off x="7635240" y="1371600"/>
+            <a:ext cx="3931920" cy="658368"/>
           </a:xfrm>
           <a:prstGeom prst="rect">
             <a:avLst/>
@@ -3463,59 +3572,67 @@
           <a:bodyPr wrap="square" lIns="0" tIns="0" rIns="0" bIns="0" rtlCol="0" anchor="t"/>
           <a:lstStyle/>
           <a:p>
-            <a:pPr marL="279400" indent="-279400">
-              <a:spcAft>
-                <a:spcPts val="800"/>
-              </a:spcAft>
-              <a:buSzPct val="100000"/>
-              <a:buChar char="•"/>
-            </a:pPr>
-            <a:r>
-              <a:rPr lang="en-US" sz="2000" dirty="0">
-                <a:solidFill>
-                  <a:srgbClr val="E3EBF1"/>
-                </a:solidFill>
-                <a:latin typeface="Calibri" pitchFamily="34" charset="0"/>
-                <a:ea typeface="Calibri" pitchFamily="34" charset="-122"/>
-                <a:cs typeface="Calibri" pitchFamily="34" charset="-120"/>
-              </a:rPr>
-              <a:t>Advocacy against the AI server-farm fast-track bill</a:t>
+            <a:pPr indent="0" marL="0">
+              <a:buNone/>
+            </a:pPr>
+            <a:r>
+              <a:rPr lang="en-US" sz="2000" b="1" dirty="0">
+                <a:solidFill>
+                  <a:srgbClr val="0E1B2A"/>
+                </a:solidFill>
+                <a:latin typeface="Calibri" pitchFamily="34" charset="0"/>
+                <a:ea typeface="Calibri" pitchFamily="34" charset="-122"/>
+                <a:cs typeface="Calibri" pitchFamily="34" charset="-120"/>
+              </a:rPr>
+              <a:t>Requests are 18× what</a:t>
             </a:r>
             <a:endParaRPr lang="en-US" sz="2000" dirty="0"/>
           </a:p>
           <a:p>
-            <a:pPr marL="279400" indent="-279400">
-              <a:spcAft>
-                <a:spcPts val="800"/>
-              </a:spcAft>
-              <a:buSzPct val="100000"/>
-              <a:buChar char="•"/>
-            </a:pPr>
-            <a:r>
-              <a:rPr lang="en-US" sz="2000" dirty="0">
-                <a:solidFill>
-                  <a:srgbClr val="E3EBF1"/>
-                </a:solidFill>
-                <a:latin typeface="Calibri" pitchFamily="34" charset="0"/>
-                <a:ea typeface="Calibri" pitchFamily="34" charset="-122"/>
-                <a:cs typeface="Calibri" pitchFamily="34" charset="-120"/>
-              </a:rPr>
-              <a:t>The bill lets big farms skip local committees</a:t>
+            <a:pPr indent="0" marL="0">
+              <a:buNone/>
+            </a:pPr>
+            <a:r>
+              <a:rPr lang="en-US" sz="2000" b="1" dirty="0">
+                <a:solidFill>
+                  <a:srgbClr val="0E1B2A"/>
+                </a:solidFill>
+                <a:latin typeface="Calibri" pitchFamily="34" charset="0"/>
+                <a:ea typeface="Calibri" pitchFamily="34" charset="-122"/>
+                <a:cs typeface="Calibri" pitchFamily="34" charset="-120"/>
+              </a:rPr>
+              <a:t>is already promised</a:t>
             </a:r>
             <a:endParaRPr lang="en-US" sz="2000" dirty="0"/>
           </a:p>
         </p:txBody>
       </p:sp>
-      <p:sp>
-        <p:nvSpPr>
-          <p:cNvPr id="6" name="header"/>
+      <p:graphicFrame>
+        <p:nvGraphicFramePr>
+          <p:cNvPr id="6" name="Chart 0" descr=""/>
+          <p:cNvGraphicFramePr/>
+          <p:nvPr/>
+        </p:nvGraphicFramePr>
+        <p:xfrm>
+          <a:off x="7498080" y="2011680"/>
+          <a:ext cx="4206240" cy="1783080"/>
+        </p:xfrm>
+        <a:graphic xmlns:a="http://schemas.openxmlformats.org/drawingml/2006/main">
+          <a:graphicData uri="http://schemas.openxmlformats.org/drawingml/2006/chart">
+            <c:chart xmlns:c="http://schemas.openxmlformats.org/drawingml/2006/chart" r:id="rId2"/>
+          </a:graphicData>
+        </a:graphic>
+      </p:graphicFrame>
+      <p:sp>
+        <p:nvSpPr>
+          <p:cNvPr id="7" name="caption-sources"/>
           <p:cNvSpPr txBox="1"/>
           <p:nvPr/>
         </p:nvSpPr>
         <p:spPr>
           <a:xfrm>
-            <a:off x="548640" y="3749040"/>
-            <a:ext cx="3794760" cy="457200"/>
+            <a:off x="548640" y="6355080"/>
+            <a:ext cx="11064240" cy="347472"/>
           </a:xfrm>
           <a:prstGeom prst="rect">
             <a:avLst/>
@@ -3531,164 +3648,7 @@
               <a:buNone/>
             </a:pPr>
             <a:r>
-              <a:rPr lang="en-US" sz="2200" b="1" dirty="0">
-                <a:solidFill>
-                  <a:srgbClr val="FFFFFF"/>
-                </a:solidFill>
-                <a:latin typeface="Cambria" pitchFamily="34" charset="0"/>
-                <a:ea typeface="Cambria" pitchFamily="34" charset="-122"/>
-                <a:cs typeface="Cambria" pitchFamily="34" charset="-120"/>
-              </a:rPr>
-              <a:t>Legislation &amp; regulation</a:t>
-            </a:r>
-            <a:endParaRPr lang="en-US" sz="2200" dirty="0"/>
-          </a:p>
-        </p:txBody>
-      </p:sp>
-      <p:sp>
-        <p:nvSpPr>
-          <p:cNvPr id="7" name="body"/>
-          <p:cNvSpPr txBox="1"/>
-          <p:nvPr/>
-        </p:nvSpPr>
-        <p:spPr>
-          <a:xfrm>
-            <a:off x="548640" y="4251960"/>
-            <a:ext cx="3840480" cy="1783080"/>
-          </a:xfrm>
-          <a:prstGeom prst="rect">
-            <a:avLst/>
-          </a:prstGeom>
-          <a:noFill/>
-          <a:ln/>
-        </p:spPr>
-        <p:txBody>
-          <a:bodyPr wrap="square" lIns="0" tIns="0" rIns="0" bIns="0" rtlCol="0" anchor="t"/>
-          <a:lstStyle/>
-          <a:p>
-            <a:pPr marL="279400" indent="-279400">
-              <a:spcAft>
-                <a:spcPts val="600"/>
-              </a:spcAft>
-              <a:buSzPct val="100000"/>
-              <a:buChar char="•"/>
-            </a:pPr>
-            <a:r>
-              <a:rPr lang="en-US" sz="2000" b="1" dirty="0">
-                <a:solidFill>
-                  <a:srgbClr val="FFFFFF"/>
-                </a:solidFill>
-                <a:latin typeface="Calibri" pitchFamily="34" charset="0"/>
-                <a:ea typeface="Calibri" pitchFamily="34" charset="-122"/>
-                <a:cs typeface="Calibri" pitchFamily="34" charset="-120"/>
-              </a:rPr>
-              <a:t>EU (2023): </a:t>
-            </a:r>
-            <a:r>
-              <a:rPr lang="en-US" sz="2000" dirty="0">
-                <a:solidFill>
-                  <a:srgbClr val="E3EBF1"/>
-                </a:solidFill>
-                <a:latin typeface="Calibri" pitchFamily="34" charset="0"/>
-                <a:ea typeface="Calibri" pitchFamily="34" charset="-122"/>
-                <a:cs typeface="Calibri" pitchFamily="34" charset="-120"/>
-              </a:rPr>
-              <a:t>data centers must report water use</a:t>
-            </a:r>
-            <a:endParaRPr lang="en-US" sz="2000" dirty="0"/>
-          </a:p>
-          <a:p>
-            <a:pPr marL="279400" indent="-279400">
-              <a:spcAft>
-                <a:spcPts val="600"/>
-              </a:spcAft>
-              <a:buSzPct val="100000"/>
-              <a:buChar char="•"/>
-            </a:pPr>
-            <a:r>
-              <a:rPr lang="en-US" sz="2000" b="1" dirty="0">
-                <a:solidFill>
-                  <a:srgbClr val="FFFFFF"/>
-                </a:solidFill>
-                <a:latin typeface="Calibri" pitchFamily="34" charset="0"/>
-                <a:ea typeface="Calibri" pitchFamily="34" charset="-122"/>
-                <a:cs typeface="Calibri" pitchFamily="34" charset="-120"/>
-              </a:rPr>
-              <a:t>Israel’s Water Law (1959): </a:t>
-            </a:r>
-            <a:r>
-              <a:rPr lang="en-US" sz="2000" dirty="0">
-                <a:solidFill>
-                  <a:srgbClr val="E3EBF1"/>
-                </a:solidFill>
-                <a:latin typeface="Calibri" pitchFamily="34" charset="0"/>
-                <a:ea typeface="Calibri" pitchFamily="34" charset="-122"/>
-                <a:cs typeface="Calibri" pitchFamily="34" charset="-120"/>
-              </a:rPr>
-              <a:t>water is public</a:t>
-            </a:r>
-            <a:endParaRPr lang="en-US" sz="2000" dirty="0"/>
-          </a:p>
-          <a:p>
-            <a:pPr marL="279400" indent="-279400">
-              <a:spcAft>
-                <a:spcPts val="600"/>
-              </a:spcAft>
-              <a:buSzPct val="100000"/>
-              <a:buChar char="•"/>
-            </a:pPr>
-            <a:r>
-              <a:rPr lang="en-US" sz="2000" b="1" dirty="0">
-                <a:solidFill>
-                  <a:srgbClr val="FFFFFF"/>
-                </a:solidFill>
-                <a:latin typeface="Calibri" pitchFamily="34" charset="0"/>
-                <a:ea typeface="Calibri" pitchFamily="34" charset="-122"/>
-                <a:cs typeface="Calibri" pitchFamily="34" charset="-120"/>
-              </a:rPr>
-              <a:t>Israel: </a:t>
-            </a:r>
-            <a:r>
-              <a:rPr lang="en-US" sz="2000" dirty="0">
-                <a:solidFill>
-                  <a:srgbClr val="E3EBF1"/>
-                </a:solidFill>
-                <a:latin typeface="Calibri" pitchFamily="34" charset="0"/>
-                <a:ea typeface="Calibri" pitchFamily="34" charset="-122"/>
-                <a:cs typeface="Calibri" pitchFamily="34" charset="-120"/>
-              </a:rPr>
-              <a:t>no disclosure rule found</a:t>
-            </a:r>
-            <a:endParaRPr lang="en-US" sz="2000" dirty="0"/>
-          </a:p>
-        </p:txBody>
-      </p:sp>
-      <p:sp>
-        <p:nvSpPr>
-          <p:cNvPr id="8" name="caption-sources"/>
-          <p:cNvSpPr txBox="1"/>
-          <p:nvPr/>
-        </p:nvSpPr>
-        <p:spPr>
-          <a:xfrm>
-            <a:off x="548640" y="6108192"/>
-            <a:ext cx="3794760" cy="502920"/>
-          </a:xfrm>
-          <a:prstGeom prst="rect">
-            <a:avLst/>
-          </a:prstGeom>
-          <a:noFill/>
-          <a:ln/>
-        </p:spPr>
-        <p:txBody>
-          <a:bodyPr wrap="square" lIns="0" tIns="0" rIns="0" bIns="0" rtlCol="0" anchor="t"/>
-          <a:lstStyle/>
-          <a:p>
-            <a:pPr indent="0" marL="0">
-              <a:buNone/>
-            </a:pPr>
-            <a:r>
-              <a:rPr lang="en-US" sz="900" dirty="0">
+              <a:rPr lang="en-US" sz="1050" dirty="0">
                 <a:solidFill>
                   <a:srgbClr val="A9BCCB"/>
                 </a:solidFill>
@@ -3696,9 +3656,9 @@
                 <a:ea typeface="Calibri" pitchFamily="34" charset="-122"/>
                 <a:cs typeface="Calibri" pitchFamily="34" charset="-120"/>
               </a:rPr>
-              <a:t>Sources: Calcalist 2026 (SPNI) · Knesset bill, 1st reading 1 Jun 2026 · EU Dir. 2023/1791 Art. 12 · Water Law 1959 · Image: AI-generated illustration, not a real event</a:t>
-            </a:r>
-            <a:endParaRPr lang="en-US" sz="900" dirty="0"/>
+              <a:t>Sources: Electricity Authority &amp; Noga via DCD, JNS, Ctech (Jul 2026) · State Comptroller 2024 · DCD, Globes, Ctech · Times of Israel, CNN (Sep 2026)  ·  Image: example data-center campus, not in Israel</a:t>
+            </a:r>
+            <a:endParaRPr lang="en-US" sz="1050" dirty="0"/>
           </a:p>
         </p:txBody>
       </p:sp>
@@ -3749,6 +3709,431 @@
         </p:nvSpPr>
         <p:spPr>
           <a:xfrm>
+            <a:off x="548640" y="320040"/>
+            <a:ext cx="11064240" cy="822960"/>
+          </a:xfrm>
+          <a:prstGeom prst="rect">
+            <a:avLst/>
+          </a:prstGeom>
+          <a:noFill/>
+          <a:ln/>
+        </p:spPr>
+        <p:txBody>
+          <a:bodyPr wrap="square" lIns="0" tIns="0" rIns="0" bIns="0" rtlCol="0" anchor="ctr"/>
+          <a:lstStyle/>
+          <a:p>
+            <a:pPr indent="0" marL="0">
+              <a:buNone/>
+            </a:pPr>
+            <a:r>
+              <a:rPr lang="en-US" sz="4000" b="1" dirty="0">
+                <a:solidFill>
+                  <a:srgbClr val="FFFFFF"/>
+                </a:solidFill>
+                <a:latin typeface="Cambria" pitchFamily="34" charset="0"/>
+                <a:ea typeface="Cambria" pitchFamily="34" charset="-122"/>
+                <a:cs typeface="Cambria" pitchFamily="34" charset="-120"/>
+              </a:rPr>
+              <a:t>Who Is Pushing Back? NGOs &amp; Laws</a:t>
+            </a:r>
+            <a:endParaRPr lang="en-US" sz="4000" dirty="0"/>
+          </a:p>
+        </p:txBody>
+      </p:sp>
+      <p:sp>
+        <p:nvSpPr>
+          <p:cNvPr id="3" name="Shape 1"/>
+          <p:cNvSpPr/>
+          <p:nvPr/>
+        </p:nvSpPr>
+        <p:spPr>
+          <a:xfrm>
+            <a:off x="320040" y="1234440"/>
+            <a:ext cx="4206240" cy="5440680"/>
+          </a:xfrm>
+          <a:prstGeom prst="roundRect">
+            <a:avLst>
+              <a:gd name="adj" fmla="val 2609"/>
+            </a:avLst>
+          </a:prstGeom>
+          <a:solidFill>
+            <a:srgbClr val="0B2239">
+              <a:alpha val="88000"/>
+            </a:srgbClr>
+          </a:solidFill>
+          <a:ln w="12700">
+            <a:solidFill>
+              <a:srgbClr val="0B2239">
+                <a:alpha val="0"/>
+              </a:srgbClr>
+            </a:solidFill>
+            <a:prstDash val="solid"/>
+          </a:ln>
+        </p:spPr>
+      </p:sp>
+      <p:sp>
+        <p:nvSpPr>
+          <p:cNvPr id="4" name="header"/>
+          <p:cNvSpPr txBox="1"/>
+          <p:nvPr/>
+        </p:nvSpPr>
+        <p:spPr>
+          <a:xfrm>
+            <a:off x="548640" y="1371600"/>
+            <a:ext cx="3794760" cy="777240"/>
+          </a:xfrm>
+          <a:prstGeom prst="rect">
+            <a:avLst/>
+          </a:prstGeom>
+          <a:noFill/>
+          <a:ln/>
+        </p:spPr>
+        <p:txBody>
+          <a:bodyPr wrap="square" lIns="0" tIns="0" rIns="0" bIns="0" rtlCol="0" anchor="t"/>
+          <a:lstStyle/>
+          <a:p>
+            <a:pPr indent="0" marL="0">
+              <a:buNone/>
+            </a:pPr>
+            <a:r>
+              <a:rPr lang="en-US" sz="2600" b="1" dirty="0">
+                <a:solidFill>
+                  <a:srgbClr val="FFFFFF"/>
+                </a:solidFill>
+                <a:latin typeface="Cambria" pitchFamily="34" charset="0"/>
+                <a:ea typeface="Cambria" pitchFamily="34" charset="-122"/>
+                <a:cs typeface="Cambria" pitchFamily="34" charset="-120"/>
+              </a:rPr>
+              <a:t>NGO: SPNI</a:t>
+            </a:r>
+            <a:endParaRPr lang="en-US" sz="2600" dirty="0"/>
+          </a:p>
+          <a:p>
+            <a:pPr indent="0" marL="0">
+              <a:buNone/>
+            </a:pPr>
+            <a:r>
+              <a:rPr lang="en-US" sz="1300" dirty="0">
+                <a:solidFill>
+                  <a:srgbClr val="A9BCCB"/>
+                </a:solidFill>
+                <a:latin typeface="Calibri" pitchFamily="34" charset="0"/>
+                <a:ea typeface="Calibri" pitchFamily="34" charset="-122"/>
+                <a:cs typeface="Calibri" pitchFamily="34" charset="-120"/>
+              </a:rPr>
+              <a:t>Society for the Protection of Nature in Israel</a:t>
+            </a:r>
+            <a:endParaRPr lang="en-US" sz="2600" dirty="0"/>
+          </a:p>
+        </p:txBody>
+      </p:sp>
+      <p:sp>
+        <p:nvSpPr>
+          <p:cNvPr id="5" name="body"/>
+          <p:cNvSpPr txBox="1"/>
+          <p:nvPr/>
+        </p:nvSpPr>
+        <p:spPr>
+          <a:xfrm>
+            <a:off x="548640" y="2194560"/>
+            <a:ext cx="3840480" cy="1508760"/>
+          </a:xfrm>
+          <a:prstGeom prst="rect">
+            <a:avLst/>
+          </a:prstGeom>
+          <a:noFill/>
+          <a:ln/>
+        </p:spPr>
+        <p:txBody>
+          <a:bodyPr wrap="square" lIns="0" tIns="0" rIns="0" bIns="0" rtlCol="0" anchor="t"/>
+          <a:lstStyle/>
+          <a:p>
+            <a:pPr marL="279400" indent="-279400">
+              <a:spcAft>
+                <a:spcPts val="800"/>
+              </a:spcAft>
+              <a:buSzPct val="100000"/>
+              <a:buChar char="•"/>
+            </a:pPr>
+            <a:r>
+              <a:rPr lang="en-US" sz="2000" dirty="0">
+                <a:solidFill>
+                  <a:srgbClr val="E3EBF1"/>
+                </a:solidFill>
+                <a:latin typeface="Calibri" pitchFamily="34" charset="0"/>
+                <a:ea typeface="Calibri" pitchFamily="34" charset="-122"/>
+                <a:cs typeface="Calibri" pitchFamily="34" charset="-120"/>
+              </a:rPr>
+              <a:t>Advocacy against the AI server-farm fast-track bill</a:t>
+            </a:r>
+            <a:endParaRPr lang="en-US" sz="2000" dirty="0"/>
+          </a:p>
+          <a:p>
+            <a:pPr marL="279400" indent="-279400">
+              <a:spcAft>
+                <a:spcPts val="800"/>
+              </a:spcAft>
+              <a:buSzPct val="100000"/>
+              <a:buChar char="•"/>
+            </a:pPr>
+            <a:r>
+              <a:rPr lang="en-US" sz="2000" dirty="0">
+                <a:solidFill>
+                  <a:srgbClr val="E3EBF1"/>
+                </a:solidFill>
+                <a:latin typeface="Calibri" pitchFamily="34" charset="0"/>
+                <a:ea typeface="Calibri" pitchFamily="34" charset="-122"/>
+                <a:cs typeface="Calibri" pitchFamily="34" charset="-120"/>
+              </a:rPr>
+              <a:t>The bill lets big farms skip local committees</a:t>
+            </a:r>
+            <a:endParaRPr lang="en-US" sz="2000" dirty="0"/>
+          </a:p>
+        </p:txBody>
+      </p:sp>
+      <p:sp>
+        <p:nvSpPr>
+          <p:cNvPr id="6" name="header"/>
+          <p:cNvSpPr txBox="1"/>
+          <p:nvPr/>
+        </p:nvSpPr>
+        <p:spPr>
+          <a:xfrm>
+            <a:off x="548640" y="3749040"/>
+            <a:ext cx="3794760" cy="457200"/>
+          </a:xfrm>
+          <a:prstGeom prst="rect">
+            <a:avLst/>
+          </a:prstGeom>
+          <a:noFill/>
+          <a:ln/>
+        </p:spPr>
+        <p:txBody>
+          <a:bodyPr wrap="square" lIns="0" tIns="0" rIns="0" bIns="0" rtlCol="0" anchor="ctr"/>
+          <a:lstStyle/>
+          <a:p>
+            <a:pPr indent="0" marL="0">
+              <a:buNone/>
+            </a:pPr>
+            <a:r>
+              <a:rPr lang="en-US" sz="2200" b="1" dirty="0">
+                <a:solidFill>
+                  <a:srgbClr val="FFFFFF"/>
+                </a:solidFill>
+                <a:latin typeface="Cambria" pitchFamily="34" charset="0"/>
+                <a:ea typeface="Cambria" pitchFamily="34" charset="-122"/>
+                <a:cs typeface="Cambria" pitchFamily="34" charset="-120"/>
+              </a:rPr>
+              <a:t>Legislation &amp; regulation</a:t>
+            </a:r>
+            <a:endParaRPr lang="en-US" sz="2200" dirty="0"/>
+          </a:p>
+        </p:txBody>
+      </p:sp>
+      <p:sp>
+        <p:nvSpPr>
+          <p:cNvPr id="7" name="body"/>
+          <p:cNvSpPr txBox="1"/>
+          <p:nvPr/>
+        </p:nvSpPr>
+        <p:spPr>
+          <a:xfrm>
+            <a:off x="548640" y="4251960"/>
+            <a:ext cx="3840480" cy="1783080"/>
+          </a:xfrm>
+          <a:prstGeom prst="rect">
+            <a:avLst/>
+          </a:prstGeom>
+          <a:noFill/>
+          <a:ln/>
+        </p:spPr>
+        <p:txBody>
+          <a:bodyPr wrap="square" lIns="0" tIns="0" rIns="0" bIns="0" rtlCol="0" anchor="t"/>
+          <a:lstStyle/>
+          <a:p>
+            <a:pPr marL="279400" indent="-279400">
+              <a:spcAft>
+                <a:spcPts val="600"/>
+              </a:spcAft>
+              <a:buSzPct val="100000"/>
+              <a:buChar char="•"/>
+            </a:pPr>
+            <a:r>
+              <a:rPr lang="en-US" sz="2000" b="1" dirty="0">
+                <a:solidFill>
+                  <a:srgbClr val="FFFFFF"/>
+                </a:solidFill>
+                <a:latin typeface="Calibri" pitchFamily="34" charset="0"/>
+                <a:ea typeface="Calibri" pitchFamily="34" charset="-122"/>
+                <a:cs typeface="Calibri" pitchFamily="34" charset="-120"/>
+              </a:rPr>
+              <a:t>EU (2023): </a:t>
+            </a:r>
+            <a:r>
+              <a:rPr lang="en-US" sz="2000" dirty="0">
+                <a:solidFill>
+                  <a:srgbClr val="E3EBF1"/>
+                </a:solidFill>
+                <a:latin typeface="Calibri" pitchFamily="34" charset="0"/>
+                <a:ea typeface="Calibri" pitchFamily="34" charset="-122"/>
+                <a:cs typeface="Calibri" pitchFamily="34" charset="-120"/>
+              </a:rPr>
+              <a:t>data centers must report water use</a:t>
+            </a:r>
+            <a:endParaRPr lang="en-US" sz="2000" dirty="0"/>
+          </a:p>
+          <a:p>
+            <a:pPr marL="279400" indent="-279400">
+              <a:spcAft>
+                <a:spcPts val="600"/>
+              </a:spcAft>
+              <a:buSzPct val="100000"/>
+              <a:buChar char="•"/>
+            </a:pPr>
+            <a:r>
+              <a:rPr lang="en-US" sz="2000" b="1" dirty="0">
+                <a:solidFill>
+                  <a:srgbClr val="FFFFFF"/>
+                </a:solidFill>
+                <a:latin typeface="Calibri" pitchFamily="34" charset="0"/>
+                <a:ea typeface="Calibri" pitchFamily="34" charset="-122"/>
+                <a:cs typeface="Calibri" pitchFamily="34" charset="-120"/>
+              </a:rPr>
+              <a:t>Israel’s Water Law (1959): </a:t>
+            </a:r>
+            <a:r>
+              <a:rPr lang="en-US" sz="2000" dirty="0">
+                <a:solidFill>
+                  <a:srgbClr val="E3EBF1"/>
+                </a:solidFill>
+                <a:latin typeface="Calibri" pitchFamily="34" charset="0"/>
+                <a:ea typeface="Calibri" pitchFamily="34" charset="-122"/>
+                <a:cs typeface="Calibri" pitchFamily="34" charset="-120"/>
+              </a:rPr>
+              <a:t>water is public</a:t>
+            </a:r>
+            <a:endParaRPr lang="en-US" sz="2000" dirty="0"/>
+          </a:p>
+          <a:p>
+            <a:pPr marL="279400" indent="-279400">
+              <a:spcAft>
+                <a:spcPts val="600"/>
+              </a:spcAft>
+              <a:buSzPct val="100000"/>
+              <a:buChar char="•"/>
+            </a:pPr>
+            <a:r>
+              <a:rPr lang="en-US" sz="2000" b="1" dirty="0">
+                <a:solidFill>
+                  <a:srgbClr val="FFFFFF"/>
+                </a:solidFill>
+                <a:latin typeface="Calibri" pitchFamily="34" charset="0"/>
+                <a:ea typeface="Calibri" pitchFamily="34" charset="-122"/>
+                <a:cs typeface="Calibri" pitchFamily="34" charset="-120"/>
+              </a:rPr>
+              <a:t>Israel: </a:t>
+            </a:r>
+            <a:r>
+              <a:rPr lang="en-US" sz="2000" dirty="0">
+                <a:solidFill>
+                  <a:srgbClr val="E3EBF1"/>
+                </a:solidFill>
+                <a:latin typeface="Calibri" pitchFamily="34" charset="0"/>
+                <a:ea typeface="Calibri" pitchFamily="34" charset="-122"/>
+                <a:cs typeface="Calibri" pitchFamily="34" charset="-120"/>
+              </a:rPr>
+              <a:t>no disclosure rule found</a:t>
+            </a:r>
+            <a:endParaRPr lang="en-US" sz="2000" dirty="0"/>
+          </a:p>
+        </p:txBody>
+      </p:sp>
+      <p:sp>
+        <p:nvSpPr>
+          <p:cNvPr id="8" name="caption-sources"/>
+          <p:cNvSpPr txBox="1"/>
+          <p:nvPr/>
+        </p:nvSpPr>
+        <p:spPr>
+          <a:xfrm>
+            <a:off x="548640" y="6108192"/>
+            <a:ext cx="3794760" cy="502920"/>
+          </a:xfrm>
+          <a:prstGeom prst="rect">
+            <a:avLst/>
+          </a:prstGeom>
+          <a:noFill/>
+          <a:ln/>
+        </p:spPr>
+        <p:txBody>
+          <a:bodyPr wrap="square" lIns="0" tIns="0" rIns="0" bIns="0" rtlCol="0" anchor="t"/>
+          <a:lstStyle/>
+          <a:p>
+            <a:pPr indent="0" marL="0">
+              <a:buNone/>
+            </a:pPr>
+            <a:r>
+              <a:rPr lang="en-US" sz="900" dirty="0">
+                <a:solidFill>
+                  <a:srgbClr val="A9BCCB"/>
+                </a:solidFill>
+                <a:latin typeface="Calibri" pitchFamily="34" charset="0"/>
+                <a:ea typeface="Calibri" pitchFamily="34" charset="-122"/>
+                <a:cs typeface="Calibri" pitchFamily="34" charset="-120"/>
+              </a:rPr>
+              <a:t>Sources: Calcalist 2026 (SPNI) · Knesset bill, 1st reading 1 Jun 2026 · EU Dir. 2023/1791 Art. 12 · Water Law 1959 · Image: AI-generated illustration, not a real event</a:t>
+            </a:r>
+            <a:endParaRPr lang="en-US" sz="900" dirty="0"/>
+          </a:p>
+        </p:txBody>
+      </p:sp>
+    </p:spTree>
+  </p:cSld>
+  <p:clrMapOvr>
+    <a:masterClrMapping/>
+  </p:clrMapOvr>
+</p:sld>
+</file>
+
+<file path=ppt/slides/slide5.xml><?xml version="1.0" encoding="utf-8"?>
+<p:sld xmlns:a="http://schemas.openxmlformats.org/drawingml/2006/main" xmlns:r="http://schemas.openxmlformats.org/officeDocument/2006/relationships" xmlns:p="http://schemas.openxmlformats.org/presentationml/2006/main">
+  <p:cSld name="Slide 5">
+    <p:bg>
+      <p:bgPr>
+        <a:blipFill dpi="0" rotWithShape="1">
+          <a:blip r:embed="rId1">
+            <a:lum/>
+          </a:blip>
+          <a:srcRect/>
+          <a:stretch>
+            <a:fillRect/>
+          </a:stretch>
+        </a:blipFill>
+        <a:effectLst/>
+      </p:bgPr>
+    </p:bg>
+    <p:spTree>
+      <p:nvGrpSpPr>
+        <p:cNvPr id="1" name=""/>
+        <p:cNvGrpSpPr/>
+        <p:nvPr/>
+      </p:nvGrpSpPr>
+      <p:grpSpPr>
+        <a:xfrm>
+          <a:off x="0" y="0"/>
+          <a:ext cx="0" cy="0"/>
+          <a:chOff x="0" y="0"/>
+          <a:chExt cx="0" cy="0"/>
+        </a:xfrm>
+      </p:grpSpPr>
+      <p:sp>
+        <p:nvSpPr>
+          <p:cNvPr id="2" name="title"/>
+          <p:cNvSpPr txBox="1"/>
+          <p:nvPr/>
+        </p:nvSpPr>
+        <p:spPr>
+          <a:xfrm>
             <a:off x="548640" y="365760"/>
             <a:ext cx="11064240" cy="822960"/>
           </a:xfrm>
@@ -4057,9 +4442,9 @@
 </p:sld>
 </file>
 
-<file path=ppt/slides/slide5.xml><?xml version="1.0" encoding="utf-8"?>
+<file path=ppt/slides/slide6.xml><?xml version="1.0" encoding="utf-8"?>
 <p:sld xmlns:a="http://schemas.openxmlformats.org/drawingml/2006/main" xmlns:r="http://schemas.openxmlformats.org/officeDocument/2006/relationships" xmlns:p="http://schemas.openxmlformats.org/presentationml/2006/main">
-  <p:cSld name="Slide 5">
+  <p:cSld name="Slide 6">
     <p:bg>
       <p:bgPr>
         <a:blipFill dpi="0" rotWithShape="1">

</xml_diff>

<commit_message>
Fix title-slide shadows that stopped PowerPoint opening the deck
The three title-slide text boxes shared one shadow options object, which
pptxgenjs converts in place, so the second and third got out-of-range
values (alpha 5,500,000,000 and more). Each box now gets its own copy.

Co-Authored-By: Claude Opus 5.5 <noreply@anthropic.com>
Claude-Session: https://claude.ai/code/session_01D1yfgr7znJrRSehnJ7HGe8
</commit_message>
<xml_diff>
--- a/ai-water-deck.pptx
+++ b/ai-water-deck.pptx
@@ -2601,9 +2601,9 @@
           <a:noFill/>
           <a:ln/>
           <a:effectLst>
-            <a:outerShdw sx="100000" sy="100000" kx="0" ky="0" algn="bl" rotWithShape="0" blurRad="1290320000" dist="322580000" dir="324000000000">
+            <a:outerShdw sx="100000" sy="100000" kx="0" ky="0" algn="bl" rotWithShape="0" blurRad="101600" dist="25400" dir="5400000">
               <a:srgbClr val="000000">
-                <a:alpha val="5500000000"/>
+                <a:alpha val="55000"/>
               </a:srgbClr>
             </a:outerShdw>
           </a:effectLst>
@@ -2647,9 +2647,9 @@
           <a:noFill/>
           <a:ln/>
           <a:effectLst>
-            <a:outerShdw sx="100000" sy="100000" kx="0" ky="0" algn="bl" rotWithShape="0" blurRad="16387064000000" dist="4096766000000" dir="19440000000000000">
+            <a:outerShdw sx="100000" sy="100000" kx="0" ky="0" algn="bl" rotWithShape="0" blurRad="101600" dist="25400" dir="5400000">
               <a:srgbClr val="000000">
-                <a:alpha val="550000000000000"/>
+                <a:alpha val="55000"/>
               </a:srgbClr>
             </a:outerShdw>
           </a:effectLst>

</xml_diff>

<commit_message>
New title background; remove source lists and image labels
Slide 1 uses the team's forest data-center picture, with the title over
the trees at the top and the names at the bottom. The source footers and
image labels are gone from all slides, sources.md is deleted, and the
source tags are removed from the slide notes and speaker-notes.txt.

Co-Authored-By: Claude Opus 5.5 <noreply@anthropic.com>
Claude-Session: https://claude.ai/code/session_01D1yfgr7znJrRSehnJ7HGe8
</commit_message>
<xml_diff>
--- a/ai-water-deck.pptx
+++ b/ai-water-deck.pptx
@@ -1097,7 +1097,13 @@
           <a:p>
             <a:r>
               <a:rPr lang="en-US" dirty="0"/>
-              <a:t>- Background: the same example data-center campus as Slide 3 (a wider crop with more sky). It is NOT in Israel.</a:t>
+              <a:t>- Background: an AI-generated image made by our team: a data center in a forest, with solar panels on the roofs and steam from cooling towers (right). Not a real place.</a:t>
+            </a:r>
+          </a:p>
+          <a:p>
+            <a:r>
+              <a:rPr lang="en-US" dirty="0"/>
+              <a:t>- If asked about the steam: it shows water evaporating to cool the servers. That is the on-site water use we explain on Slide 2.</a:t>
             </a:r>
           </a:p>
         </p:txBody>
@@ -1256,7 +1262,7 @@
           <a:p>
             <a:r>
               <a:rPr lang="en-US" b="1" dirty="0"/>
-              <a:t>SLIDE 2 – talking points and sources (full scripts and Q&amp;A: speaker-notes.txt)</a:t>
+              <a:t>SLIDE 2 – talking points (full scripts and Q&amp;A: speaker-notes.txt)</a:t>
             </a:r>
           </a:p>
           <a:p>
@@ -1274,25 +1280,25 @@
           <a:p>
             <a:r>
               <a:rPr lang="en-US" dirty="0"/>
-              <a:t>- ON-SITE vs OFF-SITE [S1 LBNL 2024]: US data centers used 66 billion litres on-site in 2023 and about 800 billion litres off-site (water used by the power plants). 800 / 66 ≈ 12.</a:t>
-            </a:r>
-          </a:p>
-          <a:p>
-            <a:r>
-              <a:rPr lang="en-US" dirty="0"/>
-              <a:t>- Google +70% [S6 Google Environmental Reports]: 6.4B gal = 24.2B L (2023); 8.1B gal = 30.7B L (2024); 10.9B gal = 41.3B L (2025). 41.3 / 24.2 = 1.71. Company-reported, all operations.</a:t>
-            </a:r>
-          </a:p>
-          <a:p>
-            <a:r>
-              <a:rPr lang="en-US" dirty="0"/>
-              <a:t>- Uruguay [S9]: 2023 drought, worst in 74 years. Montevideo tap water was mixed with salty water. Google's plan: about 7.6 million litres a day. Slogan: 'It's not drought, it's pillage.' Google made the project smaller and switched to air cooling.</a:t>
-            </a:r>
-          </a:p>
-          <a:p>
-            <a:r>
-              <a:rPr lang="en-US" dirty="0"/>
-              <a:t>- Careful: 'one bottle of water per question' is a misreading. The study [S3] says 500 ml per about 10–50 answers.</a:t>
+              <a:t>- ON-SITE vs OFF-SITE: US data centers used 66 billion litres on-site in 2023 and about 800 billion litres off-site (water used by the power plants). 800 / 66 ≈ 12.</a:t>
+            </a:r>
+          </a:p>
+          <a:p>
+            <a:r>
+              <a:rPr lang="en-US" dirty="0"/>
+              <a:t>- Google +70%: 6.4B gal = 24.2B L (2023); 8.1B gal = 30.7B L (2024); 10.9B gal = 41.3B L (2025). 41.3 / 24.2 = 1.71. Company-reported, all operations.</a:t>
+            </a:r>
+          </a:p>
+          <a:p>
+            <a:r>
+              <a:rPr lang="en-US" dirty="0"/>
+              <a:t>- Uruguay: 2023 drought, worst in 74 years. Montevideo tap water was mixed with salty water. Google's plan: about 7.6 million litres a day. Slogan: 'It's not drought, it's pillage.' Google made the project smaller and switched to air cooling.</a:t>
+            </a:r>
+          </a:p>
+          <a:p>
+            <a:r>
+              <a:rPr lang="en-US" dirty="0"/>
+              <a:t>- Careful: 'one bottle of water per question' is a misreading. The study says 500 ml per about 10–50 answers.</a:t>
             </a:r>
           </a:p>
         </p:txBody>
@@ -1451,7 +1457,7 @@
           <a:p>
             <a:r>
               <a:rPr lang="en-US" b="1" dirty="0"/>
-              <a:t>SLIDE 3 – talking points and sources</a:t>
+              <a:t>SLIDE 3 – talking points</a:t>
             </a:r>
           </a:p>
           <a:p>
@@ -1469,37 +1475,37 @@
           <a:p>
             <a:r>
               <a:rPr lang="en-US" dirty="0"/>
-              <a:t>- Desalination share [S17]: sources disagree (State Comptroller 2024: 'about half'; Times of Israel 2026: over 80%). Say 'most', not a single number.</a:t>
-            </a:r>
-          </a:p>
-          <a:p>
-            <a:r>
-              <a:rPr lang="en-US" dirty="0"/>
-              <a:t>- Desalination needs electricity [S16]: the State Comptroller (2024) names desalination AND data centers as drivers of 2030 electricity demand.</a:t>
-            </a:r>
-          </a:p>
-          <a:p>
-            <a:r>
-              <a:rPr lang="en-US" dirty="0"/>
-              <a:t>- 27,000 MW [S14, S15]: pending data-center requests to Noga, about 3 times Israel's average electricity use. 1,500 MW already committed uses up the planned new supply to 2035 (Ctech).</a:t>
-            </a:r>
-          </a:p>
-          <a:p>
-            <a:r>
-              <a:rPr lang="en-US" dirty="0"/>
-              <a:t>- July 2026 freeze [S14]: the Electricity Authority stopped new data-center applications of 8 MW or more for 140 days from 21 July 2026 (until about early December).</a:t>
-            </a:r>
-          </a:p>
-          <a:p>
-            <a:r>
-              <a:rPr lang="en-US" dirty="0"/>
-              <a:t>- Near us [S21, S22, S15]: MedOne, two underground data centers in Kfar Yona (next to Lev HaSharon, not inside it), first opens 2026. NED Alpha Campus in Netanya, 42 MW, early 2027. Mega Or asked for 1,111 MW at the old Alliance factory in Hadera.</a:t>
-            </a:r>
-          </a:p>
-          <a:p>
-            <a:r>
-              <a:rPr lang="en-US" dirty="0"/>
-              <a:t>- Farms first [S18]: end of Aug 2026, algae shut 5 of 6 big desalination plants. The Water Authority told councils to cut farm and park irrigation. Ramat HaNegev farms lost fresh water completely. NOT caused by data centers. It shows who is cut first.</a:t>
+              <a:t>- Desalination share: sources disagree (State Comptroller 2024: 'about half'; Times of Israel 2026: over 80%). Say 'most', not a single number.</a:t>
+            </a:r>
+          </a:p>
+          <a:p>
+            <a:r>
+              <a:rPr lang="en-US" dirty="0"/>
+              <a:t>- Desalination needs electricity: the State Comptroller (2024) names desalination AND data centers as drivers of 2030 electricity demand.</a:t>
+            </a:r>
+          </a:p>
+          <a:p>
+            <a:r>
+              <a:rPr lang="en-US" dirty="0"/>
+              <a:t>- 27,000 MW: pending data-center requests to Noga, about 3 times Israel's average electricity use. 1,500 MW already committed uses up the planned new supply to 2035 (Ctech).</a:t>
+            </a:r>
+          </a:p>
+          <a:p>
+            <a:r>
+              <a:rPr lang="en-US" dirty="0"/>
+              <a:t>- July 2026 freeze: the Electricity Authority stopped new data-center applications of 8 MW or more for 140 days from 21 July 2026 (until about early December).</a:t>
+            </a:r>
+          </a:p>
+          <a:p>
+            <a:r>
+              <a:rPr lang="en-US" dirty="0"/>
+              <a:t>- Near us: MedOne, two underground data centers in Kfar Yona (next to Lev HaSharon, not inside it), first opens 2026. NED Alpha Campus in Netanya, 42 MW, early 2027. Mega Or asked for 1,111 MW at the old Alliance factory in Hadera.</a:t>
+            </a:r>
+          </a:p>
+          <a:p>
+            <a:r>
+              <a:rPr lang="en-US" dirty="0"/>
+              <a:t>- Farms first: end of Aug 2026, algae shut 5 of 6 big desalination plants. The Water Authority told councils to cut farm and park irrigation. Ramat HaNegev farms lost fresh water completely. NOT caused by data centers. It shows who is cut first.</a:t>
             </a:r>
           </a:p>
           <a:p>
@@ -1637,7 +1643,7 @@
           <a:p>
             <a:r>
               <a:rPr lang="en-US" b="1" dirty="0"/>
-              <a:t>SLIDE 4 – talking points and sources</a:t>
+              <a:t>SLIDE 4 – talking points</a:t>
             </a:r>
           </a:p>
           <a:p>
@@ -1649,13 +1655,13 @@
           <a:p>
             <a:r>
               <a:rPr lang="en-US" dirty="0"/>
-              <a:t>- SPNI [S25]: publicly opposed the bill that makes AI server farms 'national infrastructure'. Warned of a 'destructive domino effect' on open land and energy security. Wants the status only for security, intelligence and academic use. Also active: Greenpeace Israel, Green Course.</a:t>
-            </a:r>
-          </a:p>
-          <a:p>
-            <a:r>
-              <a:rPr lang="en-US" dirty="0"/>
-              <a:t>- The bill [S24]: Planning and Building Law amendment. AI server farms of 50 MW or more become 'national infrastructure'. They go to the National Infrastructure Committee and skip local and district committees and their objections. Passed first reading on 1 June 2026. FINAL PASSAGE UNVERIFIED: check before presenting.</a:t>
+              <a:t>- SPNI: publicly opposed the bill that makes AI server farms 'national infrastructure'. Warned of a 'destructive domino effect' on open land and energy security. Wants the status only for security, intelligence and academic use. Also active: Greenpeace Israel, Green Course.</a:t>
+            </a:r>
+          </a:p>
+          <a:p>
+            <a:r>
+              <a:rPr lang="en-US" dirty="0"/>
+              <a:t>- The bill: Planning and Building Law amendment. AI server farms of 50 MW or more become 'national infrastructure'. They go to the National Infrastructure Committee and skip local and district committees and their objections. Passed first reading on 1 June 2026. FINAL PASSAGE UNVERIFIED: check before presenting.</a:t>
             </a:r>
           </a:p>
           <a:p>
@@ -1667,13 +1673,13 @@
           <a:p>
             <a:r>
               <a:rPr lang="en-US" dirty="0"/>
-              <a:t>- EU law [S28]: Energy Efficiency Directive (EU) 2023/1791, Article 12. Data centers with 500 kW or more of IT power must report energy and water use every year to an EU database.</a:t>
-            </a:r>
-          </a:p>
-          <a:p>
-            <a:r>
-              <a:rPr lang="en-US" dirty="0"/>
-              <a:t>- Water Law [S27]: Water Law 5719-1959, section 1. Water sources in Israel are public property, controlled by the State, for the needs of the residents and the development of the country.</a:t>
+              <a:t>- EU law: Energy Efficiency Directive (EU) 2023/1791, Article 12. Data centers with 500 kW or more of IT power must report energy and water use every year to an EU database.</a:t>
+            </a:r>
+          </a:p>
+          <a:p>
+            <a:r>
+              <a:rPr lang="en-US" dirty="0"/>
+              <a:t>- Water Law: Water Law 5719-1959, section 1. Water sources in Israel are public property, controlled by the State, for the needs of the residents and the development of the country.</a:t>
             </a:r>
           </a:p>
           <a:p>
@@ -1871,7 +1877,7 @@
           <a:p>
             <a:r>
               <a:rPr lang="en-US" dirty="0"/>
-              <a:t>Sources: [S29] Microsoft Phi-3 report (Apr 2024): a 3.8B model, about 1.8 GB at 4 bits, runs on an iPhone 14. [S30] Meta Llama 3.2 1B/3B (Sep 2024): built for phones and edge devices. [S31] QLoRA (2023): 4-bit quantization makes models much smaller. [S32] Copilot+ PCs (May 2024) have an AI chip (NPU) of 40+ TOPS to run AI locally.</a:t>
+              <a:t>Facts: Microsoft Phi-3 report (Apr 2024): a 3.8B model, about 1.8 GB at 4 bits, runs on an iPhone 14. Meta Llama 3.2 1B/3B (Sep 2024): built for phones and edge devices. QLoRA (2023): 4-bit quantization makes models much smaller. Copilot+ PCs (May 2024) have an AI chip (NPU) of 40+ TOPS to run AI locally.</a:t>
             </a:r>
           </a:p>
           <a:p>
@@ -1883,7 +1889,7 @@
           <a:p>
             <a:r>
               <a:rPr lang="en-US" dirty="0"/>
-              <a:t>Be honest if asked: a laptop's electricity also comes from power plants. The big saving comes from smaller, optimized models doing less work (Google cut energy per prompt 33x in one year by optimizing [S4]).</a:t>
+              <a:t>Be honest if asked: a laptop's electricity also comes from power plants. The big saving comes from smaller, optimized models doing less work (Google cut energy per prompt 33x in one year by optimizing).</a:t>
             </a:r>
           </a:p>
         </p:txBody>
@@ -2111,7 +2117,7 @@
           <a:p>
             <a:r>
               <a:rPr lang="en-US" dirty="0"/>
-              <a:t>Likely question: 'How do you make companies do this?' Answer: public pressure and awareness, plus reporting laws like the EU rule [S28], which make water and power use visible.</a:t>
+              <a:t>Likely question: 'How do you make companies do this?' Answer: public pressure and awareness, plus reporting laws like the EU rule, which make water and power use visible.</a:t>
             </a:r>
           </a:p>
           <a:p>
@@ -2504,8 +2510,8 @@
         </p:nvSpPr>
         <p:spPr>
           <a:xfrm>
-            <a:off x="640080" y="1463040"/>
-            <a:ext cx="8686800" cy="2468880"/>
+            <a:off x="640080" y="411480"/>
+            <a:ext cx="8686800" cy="2148840"/>
           </a:xfrm>
           <a:prstGeom prst="rect">
             <a:avLst/>
@@ -2521,7 +2527,7 @@
           </a:effectLst>
         </p:spPr>
         <p:txBody>
-          <a:bodyPr wrap="square" lIns="0" tIns="0" rIns="0" bIns="0" rtlCol="0" anchor="b"/>
+          <a:bodyPr wrap="square" lIns="0" tIns="0" rIns="0" bIns="0" rtlCol="0" anchor="t"/>
           <a:lstStyle/>
           <a:p>
             <a:pPr indent="0" marL="0">
@@ -2567,7 +2573,7 @@
         </p:nvSpPr>
         <p:spPr>
           <a:xfrm>
-            <a:off x="676656" y="4160520"/>
+            <a:off x="676656" y="5230368"/>
             <a:ext cx="1463040" cy="64008"/>
           </a:xfrm>
           <a:prstGeom prst="rect">
@@ -2592,7 +2598,7 @@
         </p:nvSpPr>
         <p:spPr>
           <a:xfrm>
-            <a:off x="640080" y="4434840"/>
+            <a:off x="640080" y="5394960"/>
             <a:ext cx="8686800" cy="502920"/>
           </a:xfrm>
           <a:prstGeom prst="rect">
@@ -2638,7 +2644,7 @@
         </p:nvSpPr>
         <p:spPr>
           <a:xfrm>
-            <a:off x="640080" y="4983480"/>
+            <a:off x="640080" y="5943600"/>
             <a:ext cx="8686800" cy="457200"/>
           </a:xfrm>
           <a:prstGeom prst="rect">
@@ -2673,45 +2679,6 @@
               <a:t>English class  ·  [Class]  ·  [Date]</a:t>
             </a:r>
             <a:endParaRPr lang="en-US" sz="2200" dirty="0"/>
-          </a:p>
-        </p:txBody>
-      </p:sp>
-      <p:sp>
-        <p:nvSpPr>
-          <p:cNvPr id="6" name="caption-sources"/>
-          <p:cNvSpPr txBox="1"/>
-          <p:nvPr/>
-        </p:nvSpPr>
-        <p:spPr>
-          <a:xfrm>
-            <a:off x="548640" y="6355080"/>
-            <a:ext cx="11064240" cy="347472"/>
-          </a:xfrm>
-          <a:prstGeom prst="rect">
-            <a:avLst/>
-          </a:prstGeom>
-          <a:noFill/>
-          <a:ln/>
-        </p:spPr>
-        <p:txBody>
-          <a:bodyPr wrap="square" lIns="0" tIns="0" rIns="0" bIns="0" rtlCol="0" anchor="ctr"/>
-          <a:lstStyle/>
-          <a:p>
-            <a:pPr indent="0" marL="0">
-              <a:buNone/>
-            </a:pPr>
-            <a:r>
-              <a:rPr lang="en-US" sz="1050" dirty="0">
-                <a:solidFill>
-                  <a:srgbClr val="A9BCCB"/>
-                </a:solidFill>
-                <a:latin typeface="Calibri" pitchFamily="34" charset="0"/>
-                <a:ea typeface="Calibri" pitchFamily="34" charset="-122"/>
-                <a:cs typeface="Calibri" pitchFamily="34" charset="-120"/>
-              </a:rPr>
-              <a:t>Image: example data-center campus, not in Israel</a:t>
-            </a:r>
-            <a:endParaRPr lang="en-US" sz="1050" dirty="0"/>
           </a:p>
         </p:txBody>
       </p:sp>
@@ -3178,45 +3145,6 @@
           </a:graphicData>
         </a:graphic>
       </p:graphicFrame>
-      <p:sp>
-        <p:nvSpPr>
-          <p:cNvPr id="9" name="caption-sources"/>
-          <p:cNvSpPr txBox="1"/>
-          <p:nvPr/>
-        </p:nvSpPr>
-        <p:spPr>
-          <a:xfrm>
-            <a:off x="548640" y="6355080"/>
-            <a:ext cx="11064240" cy="347472"/>
-          </a:xfrm>
-          <a:prstGeom prst="rect">
-            <a:avLst/>
-          </a:prstGeom>
-          <a:noFill/>
-          <a:ln/>
-        </p:spPr>
-        <p:txBody>
-          <a:bodyPr wrap="square" lIns="0" tIns="0" rIns="0" bIns="0" rtlCol="0" anchor="ctr"/>
-          <a:lstStyle/>
-          <a:p>
-            <a:pPr indent="0" marL="0">
-              <a:buNone/>
-            </a:pPr>
-            <a:r>
-              <a:rPr lang="en-US" sz="1050" dirty="0">
-                <a:solidFill>
-                  <a:srgbClr val="A9BCCB"/>
-                </a:solidFill>
-                <a:latin typeface="Calibri" pitchFamily="34" charset="0"/>
-                <a:ea typeface="Calibri" pitchFamily="34" charset="-122"/>
-                <a:cs typeface="Calibri" pitchFamily="34" charset="-120"/>
-              </a:rPr>
-              <a:t>Sources: LBNL 2024 US Data Center Energy Report · Google Environmental Reports 2024–26 · The Guardian 2023, Mongabay 2023  ·  Image: AI-generated illustration</a:t>
-            </a:r>
-            <a:endParaRPr lang="en-US" sz="1050" dirty="0"/>
-          </a:p>
-        </p:txBody>
-      </p:sp>
     </p:spTree>
   </p:cSld>
   <p:clrMapOvr>
@@ -3623,45 +3551,6 @@
           </a:graphicData>
         </a:graphic>
       </p:graphicFrame>
-      <p:sp>
-        <p:nvSpPr>
-          <p:cNvPr id="7" name="caption-sources"/>
-          <p:cNvSpPr txBox="1"/>
-          <p:nvPr/>
-        </p:nvSpPr>
-        <p:spPr>
-          <a:xfrm>
-            <a:off x="548640" y="6355080"/>
-            <a:ext cx="11064240" cy="347472"/>
-          </a:xfrm>
-          <a:prstGeom prst="rect">
-            <a:avLst/>
-          </a:prstGeom>
-          <a:noFill/>
-          <a:ln/>
-        </p:spPr>
-        <p:txBody>
-          <a:bodyPr wrap="square" lIns="0" tIns="0" rIns="0" bIns="0" rtlCol="0" anchor="ctr"/>
-          <a:lstStyle/>
-          <a:p>
-            <a:pPr indent="0" marL="0">
-              <a:buNone/>
-            </a:pPr>
-            <a:r>
-              <a:rPr lang="en-US" sz="1050" dirty="0">
-                <a:solidFill>
-                  <a:srgbClr val="A9BCCB"/>
-                </a:solidFill>
-                <a:latin typeface="Calibri" pitchFamily="34" charset="0"/>
-                <a:ea typeface="Calibri" pitchFamily="34" charset="-122"/>
-                <a:cs typeface="Calibri" pitchFamily="34" charset="-120"/>
-              </a:rPr>
-              <a:t>Sources: Electricity Authority &amp; Noga via DCD, JNS, Ctech (Jul 2026) · State Comptroller 2024 · DCD, Globes, Ctech · Times of Israel, CNN (Sep 2026)  ·  Image: example data-center campus, not in Israel</a:t>
-            </a:r>
-            <a:endParaRPr lang="en-US" sz="1050" dirty="0"/>
-          </a:p>
-        </p:txBody>
-      </p:sp>
     </p:spTree>
   </p:cSld>
   <p:clrMapOvr>
@@ -3749,7 +3638,7 @@
         <p:spPr>
           <a:xfrm>
             <a:off x="320040" y="1234440"/>
-            <a:ext cx="4206240" cy="5440680"/>
+            <a:ext cx="4206240" cy="4983480"/>
           </a:xfrm>
           <a:prstGeom prst="roundRect">
             <a:avLst>
@@ -4045,45 +3934,6 @@
               <a:t>no disclosure rule found</a:t>
             </a:r>
             <a:endParaRPr lang="en-US" sz="2000" dirty="0"/>
-          </a:p>
-        </p:txBody>
-      </p:sp>
-      <p:sp>
-        <p:nvSpPr>
-          <p:cNvPr id="8" name="caption-sources"/>
-          <p:cNvSpPr txBox="1"/>
-          <p:nvPr/>
-        </p:nvSpPr>
-        <p:spPr>
-          <a:xfrm>
-            <a:off x="548640" y="6108192"/>
-            <a:ext cx="3794760" cy="502920"/>
-          </a:xfrm>
-          <a:prstGeom prst="rect">
-            <a:avLst/>
-          </a:prstGeom>
-          <a:noFill/>
-          <a:ln/>
-        </p:spPr>
-        <p:txBody>
-          <a:bodyPr wrap="square" lIns="0" tIns="0" rIns="0" bIns="0" rtlCol="0" anchor="t"/>
-          <a:lstStyle/>
-          <a:p>
-            <a:pPr indent="0" marL="0">
-              <a:buNone/>
-            </a:pPr>
-            <a:r>
-              <a:rPr lang="en-US" sz="900" dirty="0">
-                <a:solidFill>
-                  <a:srgbClr val="A9BCCB"/>
-                </a:solidFill>
-                <a:latin typeface="Calibri" pitchFamily="34" charset="0"/>
-                <a:ea typeface="Calibri" pitchFamily="34" charset="-122"/>
-                <a:cs typeface="Calibri" pitchFamily="34" charset="-120"/>
-              </a:rPr>
-              <a:t>Sources: Calcalist 2026 (SPNI) · Knesset bill, 1st reading 1 Jun 2026 · EU Dir. 2023/1791 Art. 12 · Water Law 1959 · Image: AI-generated illustration, not a real event</a:t>
-            </a:r>
-            <a:endParaRPr lang="en-US" sz="900" dirty="0"/>
           </a:p>
         </p:txBody>
       </p:sp>
@@ -4395,45 +4245,6 @@
           </a:p>
         </p:txBody>
       </p:sp>
-      <p:sp>
-        <p:nvSpPr>
-          <p:cNvPr id="6" name="caption-sources"/>
-          <p:cNvSpPr txBox="1"/>
-          <p:nvPr/>
-        </p:nvSpPr>
-        <p:spPr>
-          <a:xfrm>
-            <a:off x="548640" y="6355080"/>
-            <a:ext cx="11064240" cy="347472"/>
-          </a:xfrm>
-          <a:prstGeom prst="rect">
-            <a:avLst/>
-          </a:prstGeom>
-          <a:noFill/>
-          <a:ln/>
-        </p:spPr>
-        <p:txBody>
-          <a:bodyPr wrap="square" lIns="0" tIns="0" rIns="0" bIns="0" rtlCol="0" anchor="ctr"/>
-          <a:lstStyle/>
-          <a:p>
-            <a:pPr indent="0" marL="0">
-              <a:buNone/>
-            </a:pPr>
-            <a:r>
-              <a:rPr lang="en-US" sz="1050" dirty="0">
-                <a:solidFill>
-                  <a:srgbClr val="E6E0D8"/>
-                </a:solidFill>
-                <a:latin typeface="Calibri" pitchFamily="34" charset="0"/>
-                <a:ea typeface="Calibri" pitchFamily="34" charset="-122"/>
-                <a:cs typeface="Calibri" pitchFamily="34" charset="-120"/>
-              </a:rPr>
-              <a:t>Sources: Microsoft Phi-3 report (2024) · Meta Llama 3.2 (2024) · Dettmers et al., QLoRA (2023) · Microsoft Copilot+ PC (2024)  ·  Images: 3D illustrations made for this presentation</a:t>
-            </a:r>
-            <a:endParaRPr lang="en-US" sz="1050" dirty="0"/>
-          </a:p>
-        </p:txBody>
-      </p:sp>
     </p:spTree>
   </p:cSld>
   <p:clrMapOvr>
@@ -4803,45 +4614,6 @@
               <a:t>Make AI smarter and more efficient.”</a:t>
             </a:r>
             <a:endParaRPr lang="en-US" sz="2800" dirty="0"/>
-          </a:p>
-        </p:txBody>
-      </p:sp>
-      <p:sp>
-        <p:nvSpPr>
-          <p:cNvPr id="8" name="caption-sources"/>
-          <p:cNvSpPr txBox="1"/>
-          <p:nvPr/>
-        </p:nvSpPr>
-        <p:spPr>
-          <a:xfrm>
-            <a:off x="548640" y="6355080"/>
-            <a:ext cx="11064240" cy="347472"/>
-          </a:xfrm>
-          <a:prstGeom prst="rect">
-            <a:avLst/>
-          </a:prstGeom>
-          <a:noFill/>
-          <a:ln/>
-        </p:spPr>
-        <p:txBody>
-          <a:bodyPr wrap="square" lIns="0" tIns="0" rIns="0" bIns="0" rtlCol="0" anchor="ctr"/>
-          <a:lstStyle/>
-          <a:p>
-            <a:pPr indent="0" marL="0">
-              <a:buNone/>
-            </a:pPr>
-            <a:r>
-              <a:rPr lang="en-US" sz="1050" dirty="0">
-                <a:solidFill>
-                  <a:srgbClr val="A9BCCB"/>
-                </a:solidFill>
-                <a:latin typeface="Calibri" pitchFamily="34" charset="0"/>
-                <a:ea typeface="Calibri" pitchFamily="34" charset="-122"/>
-                <a:cs typeface="Calibri" pitchFamily="34" charset="-120"/>
-              </a:rPr>
-              <a:t>Our team’s plan · Sources for efficiency: Google 2025 (energy per prompt −33× in one year), Microsoft Phi-3 2024  ·  Image: AI-generated illustration</a:t>
-            </a:r>
-            <a:endParaRPr lang="en-US" sz="1050" dirty="0"/>
           </a:p>
         </p:txBody>
       </p:sp>

</xml_diff>

<commit_message>
Replace the Phi-3 example with a UGREEN HomeAgent HA100 slide
ai-water-deck-canva.pptx is the team's Canva export with Slide 5 redrawn
without the Phi-3 bullet and a new editable Slide 6 on the UGREEN
HomeAgent HA100 (announced at IFA 2026, ships early 2027). Speaker C's
script now covers Slides 5-7 (249 words) and the slide notes match. The
generated ai-water-deck.pptx gets the same two changes.

Co-Authored-By: Claude Opus 5.5 <noreply@anthropic.com>
Claude-Session: https://claude.ai/code/session_01D1yfgr7znJrRSehnJ7HGe8
</commit_message>
<xml_diff>
--- a/ai-water-deck.pptx
+++ b/ai-water-deck.pptx
@@ -11,9 +11,10 @@
     <p:sldId id="259" r:id="rId5"/>
     <p:sldId id="260" r:id="rId6"/>
     <p:sldId id="261" r:id="rId7"/>
+    <p:sldId id="262" r:id="rId8"/>
   </p:sldIdLst>
   <p:notesMasterIdLst>
-    <p:notesMasterId r:id="rId8"/>
+    <p:notesMasterId r:id="rId9"/>
   </p:notesMasterIdLst>
   <p:sldSz cx="12192000" cy="6858000"/>
   <p:notesSz cx="6858000" cy="12192000"/>
@@ -1772,7 +1773,7 @@
           <a:p>
             <a:r>
               <a:rPr lang="en-US" b="1" dirty="0"/>
-              <a:t>SPEAKER C – SCRIPT, part 1 of 2 (say this)</a:t>
+              <a:t>SPEAKER C – SCRIPT, part 1 of 3 (say this)</a:t>
             </a:r>
           </a:p>
           <a:p>
@@ -1790,7 +1791,7 @@
           <a:p>
             <a:r>
               <a:rPr lang="en-US" dirty="0"/>
-              <a:t>Our idea is simple: run AI locally. Today, most AI runs in huge data centers. We want large language models, the AI behind chatbots like ChatGPT, to run on normal laptops and PCs.</a:t>
+              <a:t>Our idea is simple: run AI locally. We want large language models, the AI behind chatbots like ChatGPT, to run on normal laptops and PCs.</a:t>
             </a:r>
           </a:p>
           <a:p>
@@ -1799,7 +1800,7 @@
           <a:p>
             <a:r>
               <a:rPr lang="en-US" dirty="0"/>
-              <a:t>How? Companies can make models smaller and more efficient. One method is quantization: it stores the model's numbers in a shorter form, so it needs much less memory. This is already real. Microsoft's small model, Phi-3, runs on a phone. And new laptops have special AI chips that make local AI stronger.</a:t>
+              <a:t>How? Companies can make models smaller and more efficient. One method is quantization: it stores the model's numbers in a shorter form, so it needs much less memory. And new laptops have special AI chips that make local AI stronger.</a:t>
             </a:r>
           </a:p>
           <a:p>
@@ -1877,13 +1878,19 @@
           <a:p>
             <a:r>
               <a:rPr lang="en-US" dirty="0"/>
-              <a:t>Facts: Microsoft Phi-3 report (Apr 2024): a 3.8B model, about 1.8 GB at 4 bits, runs on an iPhone 14. Meta Llama 3.2 1B/3B (Sep 2024): built for phones and edge devices. QLoRA (2023): 4-bit quantization makes models much smaller. Copilot+ PCs (May 2024) have an AI chip (NPU) of 40+ TOPS to run AI locally.</a:t>
+              <a:t>Facts: Meta Llama 3.2 1B/3B (Sep 2024): built for phones and edge devices. QLoRA (2023): 4-bit quantization makes models much smaller. Copilot+ PCs (May 2024) have an AI chip (NPU) of 40+ TOPS to run AI locally.</a:t>
             </a:r>
           </a:p>
           <a:p>
             <a:r>
               <a:rPr lang="en-US" dirty="0"/>
               <a:t>Background: a 3D illustration of a laptop running a small AI model offline.</a:t>
+            </a:r>
+          </a:p>
+          <a:p>
+            <a:r>
+              <a:rPr lang="en-US" dirty="0"/>
+              <a:t>The real-world example (UGREEN HomeAgent HA100) is on the next slide.</a:t>
             </a:r>
           </a:p>
           <a:p>
@@ -1976,7 +1983,7 @@
           <a:p>
             <a:r>
               <a:rPr lang="en-US" b="1" dirty="0"/>
-              <a:t>SPEAKER C – SCRIPT, part 2 of 2 (say this)</a:t>
+              <a:t>SPEAKER C – SCRIPT, part 2 of 3 (say this)</a:t>
             </a:r>
           </a:p>
           <a:p>
@@ -1985,7 +1992,7 @@
           <a:p>
             <a:r>
               <a:rPr lang="en-US" dirty="0"/>
-              <a:t>So here is our plan. One: AI companies should release local versions of their models. Two: they should optimize their models, not just make them bigger. Three: data centers should stay for training and for the biggest models.</a:t>
+              <a:t>A real example: at IFA 2026, UGREEN showed the HomeAgent HA100, an AI box for your home. Its assistant runs an open AI model, Qwen3, at home, not in a data center. Your camera videos stay on your own drives. It should ship in early 2027.</a:t>
             </a:r>
           </a:p>
           <a:p>
@@ -1993,8 +2000,8 @@
           </a:p>
           <a:p>
             <a:r>
-              <a:rPr lang="en-US" dirty="0"/>
-              <a:t>This policy reform could mean fewer new data centers: less water, less land, and more privacy, because your data stays on your computer.</a:t>
+              <a:rPr lang="en-US" b="1" dirty="0"/>
+              <a:t>[CLICK -&gt; Slide 7]</a:t>
             </a:r>
           </a:p>
           <a:p>
@@ -2003,7 +2010,7 @@
           <a:p>
             <a:r>
               <a:rPr lang="en-US" dirty="0"/>
-              <a:t>To be honest, a laptop also uses electricity from power plants. The real saving comes from smaller, smarter models. Google says it cut the energy for each Gemini question by 33 times in one year, by making its systems more efficient.</a:t>
+              <a:t>————————————————————</a:t>
             </a:r>
           </a:p>
           <a:p>
@@ -2011,119 +2018,38 @@
           </a:p>
           <a:p>
             <a:r>
-              <a:rPr lang="en-US" dirty="0"/>
-              <a:t>Our awareness idea is an "AI label", like a food label. It shows how much water and power an AI tool uses.</a:t>
-            </a:r>
-          </a:p>
-          <a:p>
-            <a:endParaRPr lang="en-US" dirty="0"/>
-          </a:p>
-          <a:p>
-            <a:r>
-              <a:rPr lang="en-US" dirty="0"/>
-              <a:t>This way, AI can keep growing without one community paying the price. So our message is: Don't just build bigger data centers. Make AI smarter and more efficient.</a:t>
-            </a:r>
-          </a:p>
-          <a:p>
-            <a:endParaRPr lang="en-US" dirty="0"/>
-          </a:p>
-          <a:p>
-            <a:r>
-              <a:rPr lang="en-US" dirty="0"/>
-              <a:t>Thank you. Any questions?</a:t>
-            </a:r>
-          </a:p>
-          <a:p>
-            <a:endParaRPr lang="en-US" dirty="0"/>
-          </a:p>
-          <a:p>
-            <a:r>
-              <a:rPr lang="en-US" dirty="0"/>
-              <a:t>————————————————————</a:t>
-            </a:r>
-          </a:p>
-          <a:p>
-            <a:endParaRPr lang="en-US" dirty="0"/>
-          </a:p>
-          <a:p>
-            <a:r>
               <a:rPr lang="en-US" b="1" dirty="0"/>
-              <a:t>SLIDE 6 – our plan and message (Speaker C). Full original wording:</a:t>
-            </a:r>
-          </a:p>
-          <a:p>
-            <a:r>
-              <a:rPr lang="en-US" dirty="0"/>
-              <a:t>What Would We Do? Our plan:</a:t>
-            </a:r>
-          </a:p>
-          <a:p>
-            <a:r>
-              <a:rPr lang="en-US" dirty="0"/>
-              <a:t>1. AI companies should make local versions of their LLMs.</a:t>
-            </a:r>
-          </a:p>
-          <a:p>
-            <a:r>
-              <a:rPr lang="en-US" dirty="0"/>
-              <a:t>2. These models should work on normal PCs and laptops whenever possible.</a:t>
-            </a:r>
-          </a:p>
-          <a:p>
-            <a:r>
-              <a:rPr lang="en-US" dirty="0"/>
-              <a:t>3. Companies should focus on optimization instead of just making models bigger.</a:t>
-            </a:r>
-          </a:p>
-          <a:p>
-            <a:r>
-              <a:rPr lang="en-US" dirty="0"/>
-              <a:t>4. New chips can gradually make local AI more powerful.</a:t>
-            </a:r>
-          </a:p>
-          <a:p>
-            <a:r>
-              <a:rPr lang="en-US" dirty="0"/>
-              <a:t>5. Data centers can still be used for extremely large models and training.</a:t>
-            </a:r>
-          </a:p>
-          <a:p>
-            <a:r>
-              <a:rPr lang="en-US" dirty="0"/>
-              <a:t>Possible benefits: less need for new data centers; less land used for AI infrastructure; potentially less water needed for cooling; more AI can run directly on people's computers; more privacy and control for users.</a:t>
-            </a:r>
-          </a:p>
-          <a:p>
-            <a:r>
-              <a:rPr lang="en-US" dirty="0"/>
-              <a:t>Our message: Don't just build bigger data centers. Make AI smarter and more efficient.</a:t>
-            </a:r>
-          </a:p>
-          <a:p>
-            <a:endParaRPr lang="en-US" dirty="0"/>
-          </a:p>
-          <a:p>
-            <a:r>
-              <a:rPr lang="en-US" dirty="0"/>
-              <a:t>Background: an AI-generated image made by our team: a low-power AI chip (NPU) in front of rows of data-center servers. The chip's label and numbers are part of the illustration, not a real product.</a:t>
-            </a:r>
-          </a:p>
-          <a:p>
-            <a:r>
-              <a:rPr lang="en-US" dirty="0"/>
-              <a:t>Awareness idea: an 'AI label' (like a food label) showing how much water and electricity an AI tool uses, with the source and year.</a:t>
-            </a:r>
-          </a:p>
-          <a:p>
-            <a:r>
-              <a:rPr lang="en-US" dirty="0"/>
-              <a:t>Likely question: 'How do you make companies do this?' Answer: public pressure and awareness, plus reporting laws like the EU rule, which make water and power use visible.</a:t>
-            </a:r>
-          </a:p>
-          <a:p>
-            <a:r>
-              <a:rPr lang="en-US" dirty="0"/>
-              <a:t>Be honest: training still needs data centers, and local AI still uses electricity. The benefit comes from smaller, more efficient models.</a:t>
+              <a:t>SLIDE 6 – real example (Speaker C)</a:t>
+            </a:r>
+          </a:p>
+          <a:p>
+            <a:r>
+              <a:rPr lang="en-US" dirty="0"/>
+              <a:t>- UGREEN HomeAgent HA100: a local-AI home hub shown at IFA 2026 (September 2026). Its assistant, Uliya, uses Qwen3, an open AI model from Alibaba, running on the hub itself. Cloud models such as ChatGPT are optional.</a:t>
+            </a:r>
+          </a:p>
+          <a:p>
+            <a:r>
+              <a:rPr lang="en-US" dirty="0"/>
+              <a:t>- It recognises people, vehicles, pets and packages in camera video, writes event summaries, and lets you search recorded video by keyword. Video is stored on the hub's own drives, with no monthly storage fee.</a:t>
+            </a:r>
+          </a:p>
+          <a:p>
+            <a:r>
+              <a:rPr lang="en-US" dirty="0"/>
+              <a:t>- Not on sale yet: Kickstarter campaign from 27 October 2026; shipping from late January 2027 at the earliest.</a:t>
+            </a:r>
+          </a:p>
+          <a:p>
+            <a:r>
+              <a:rPr lang="en-US" dirty="0"/>
+              <a:t>- Be honest if asked: UGREEN says sign-in, remote access, phone notifications, software updates and optional services still need the internet. Reports disagree on its price and AI speed, so we give no numbers.</a:t>
+            </a:r>
+          </a:p>
+          <a:p>
+            <a:r>
+              <a:rPr lang="en-US" dirty="0"/>
+              <a:t>- Background: the laptop scene from Slide 5, blurred. It is not a picture of the HA100.</a:t>
             </a:r>
           </a:p>
         </p:txBody>
@@ -2146,6 +2072,240 @@
             <a:fld id="{F7021451-1387-4CA6-816F-3879F97B5CBC}" type="slidenum">
               <a:rPr lang="en-US"/>
               <a:t>6</a:t>
+            </a:fld>
+            <a:endParaRPr lang="en-US"/>
+          </a:p>
+        </p:txBody>
+      </p:sp>
+    </p:spTree>
+    <p:extLst>
+      <p:ext uri="{BB962C8B-B14F-4D97-AF65-F5344CB8AC3E}">
+        <p14:creationId xmlns:p14="http://schemas.microsoft.com/office/powerpoint/2010/main" val="1024086991"/>
+      </p:ext>
+    </p:extLst>
+  </p:cSld>
+  <p:clrMapOvr>
+    <a:masterClrMapping/>
+  </p:clrMapOvr>
+</p:notes>
+</file>
+
+<file path=ppt/notesSlides/notesSlide7.xml><?xml version="1.0" encoding="utf-8"?>
+<p:notes xmlns:a="http://schemas.openxmlformats.org/drawingml/2006/main" xmlns:r="http://schemas.openxmlformats.org/officeDocument/2006/relationships" xmlns:p="http://schemas.openxmlformats.org/presentationml/2006/main">
+  <p:cSld>
+    <p:spTree>
+      <p:nvGrpSpPr>
+        <p:cNvPr id="1" name=""/>
+        <p:cNvGrpSpPr/>
+        <p:nvPr/>
+      </p:nvGrpSpPr>
+      <p:grpSpPr>
+        <a:xfrm>
+          <a:off x="0" y="0"/>
+          <a:ext cx="0" cy="0"/>
+          <a:chOff x="0" y="0"/>
+          <a:chExt cx="0" cy="0"/>
+        </a:xfrm>
+      </p:grpSpPr>
+      <p:sp>
+        <p:nvSpPr>
+          <p:cNvPr id="2" name="Slide Image Placeholder 1"/>
+          <p:cNvSpPr>
+            <a:spLocks noGrp="1" noRot="1" noChangeAspect="1"/>
+          </p:cNvSpPr>
+          <p:nvPr>
+            <p:ph type="sldImg"/>
+          </p:nvPr>
+        </p:nvSpPr>
+        <p:spPr/>
+      </p:sp>
+      <p:sp>
+        <p:nvSpPr>
+          <p:cNvPr id="3" name="Notes Placeholder 2"/>
+          <p:cNvSpPr>
+            <a:spLocks noGrp="1"/>
+          </p:cNvSpPr>
+          <p:nvPr>
+            <p:ph type="body" idx="1"/>
+          </p:nvPr>
+        </p:nvSpPr>
+        <p:spPr/>
+        <p:txBody>
+          <a:bodyPr/>
+          <a:lstStyle/>
+          <a:p>
+            <a:r>
+              <a:rPr lang="en-US" b="1" dirty="0"/>
+              <a:t>SPEAKER C – SCRIPT, part 3 of 3 (say this)</a:t>
+            </a:r>
+          </a:p>
+          <a:p>
+            <a:endParaRPr lang="en-US" dirty="0"/>
+          </a:p>
+          <a:p>
+            <a:r>
+              <a:rPr lang="en-US" dirty="0"/>
+              <a:t>Here is our plan. One: AI companies should release local versions of their models. Two: they should optimize their models, not just make them bigger. Three: data centers should stay for training and for the biggest models.</a:t>
+            </a:r>
+          </a:p>
+          <a:p>
+            <a:endParaRPr lang="en-US" dirty="0"/>
+          </a:p>
+          <a:p>
+            <a:r>
+              <a:rPr lang="en-US" dirty="0"/>
+              <a:t>This policy reform could mean fewer new data centers: less water, less land, and more privacy, because your data stays on your computer.</a:t>
+            </a:r>
+          </a:p>
+          <a:p>
+            <a:endParaRPr lang="en-US" dirty="0"/>
+          </a:p>
+          <a:p>
+            <a:r>
+              <a:rPr lang="en-US" dirty="0"/>
+              <a:t>To be honest, a laptop also uses power-plant electricity. The real saving comes from smaller, smarter models.</a:t>
+            </a:r>
+          </a:p>
+          <a:p>
+            <a:endParaRPr lang="en-US" dirty="0"/>
+          </a:p>
+          <a:p>
+            <a:r>
+              <a:rPr lang="en-US" dirty="0"/>
+              <a:t>Our awareness idea is an "AI label", like a food label. It shows how much water and power an AI tool uses.</a:t>
+            </a:r>
+          </a:p>
+          <a:p>
+            <a:endParaRPr lang="en-US" dirty="0"/>
+          </a:p>
+          <a:p>
+            <a:r>
+              <a:rPr lang="en-US" dirty="0"/>
+              <a:t>This way, AI can keep growing without one community paying the price. So our message is: Don't just build bigger data centers. Make AI smarter and more efficient.</a:t>
+            </a:r>
+          </a:p>
+          <a:p>
+            <a:endParaRPr lang="en-US" dirty="0"/>
+          </a:p>
+          <a:p>
+            <a:r>
+              <a:rPr lang="en-US" dirty="0"/>
+              <a:t>Thank you. Any questions?</a:t>
+            </a:r>
+          </a:p>
+          <a:p>
+            <a:endParaRPr lang="en-US" dirty="0"/>
+          </a:p>
+          <a:p>
+            <a:r>
+              <a:rPr lang="en-US" dirty="0"/>
+              <a:t>————————————————————</a:t>
+            </a:r>
+          </a:p>
+          <a:p>
+            <a:endParaRPr lang="en-US" dirty="0"/>
+          </a:p>
+          <a:p>
+            <a:r>
+              <a:rPr lang="en-US" b="1" dirty="0"/>
+              <a:t>SLIDE 7 – our plan and message (Speaker C). Full original wording:</a:t>
+            </a:r>
+          </a:p>
+          <a:p>
+            <a:r>
+              <a:rPr lang="en-US" dirty="0"/>
+              <a:t>What Would We Do? Our plan:</a:t>
+            </a:r>
+          </a:p>
+          <a:p>
+            <a:r>
+              <a:rPr lang="en-US" dirty="0"/>
+              <a:t>1. AI companies should make local versions of their LLMs.</a:t>
+            </a:r>
+          </a:p>
+          <a:p>
+            <a:r>
+              <a:rPr lang="en-US" dirty="0"/>
+              <a:t>2. These models should work on normal PCs and laptops whenever possible.</a:t>
+            </a:r>
+          </a:p>
+          <a:p>
+            <a:r>
+              <a:rPr lang="en-US" dirty="0"/>
+              <a:t>3. Companies should focus on optimization instead of just making models bigger.</a:t>
+            </a:r>
+          </a:p>
+          <a:p>
+            <a:r>
+              <a:rPr lang="en-US" dirty="0"/>
+              <a:t>4. New chips can gradually make local AI more powerful.</a:t>
+            </a:r>
+          </a:p>
+          <a:p>
+            <a:r>
+              <a:rPr lang="en-US" dirty="0"/>
+              <a:t>5. Data centers can still be used for extremely large models and training.</a:t>
+            </a:r>
+          </a:p>
+          <a:p>
+            <a:r>
+              <a:rPr lang="en-US" dirty="0"/>
+              <a:t>Possible benefits: less need for new data centers; less land used for AI infrastructure; potentially less water needed for cooling; more AI can run directly on people's computers; more privacy and control for users.</a:t>
+            </a:r>
+          </a:p>
+          <a:p>
+            <a:r>
+              <a:rPr lang="en-US" dirty="0"/>
+              <a:t>Our message: Don't just build bigger data centers. Make AI smarter and more efficient.</a:t>
+            </a:r>
+          </a:p>
+          <a:p>
+            <a:endParaRPr lang="en-US" dirty="0"/>
+          </a:p>
+          <a:p>
+            <a:r>
+              <a:rPr lang="en-US" dirty="0"/>
+              <a:t>Background: an AI-generated image made by our team: a low-power AI chip (NPU) in front of rows of data-center servers. The chip's label and numbers are part of the illustration, not a real product.</a:t>
+            </a:r>
+          </a:p>
+          <a:p>
+            <a:r>
+              <a:rPr lang="en-US" dirty="0"/>
+              <a:t>Awareness idea: an 'AI label' (like a food label) showing how much water and electricity an AI tool uses, with the source and year.</a:t>
+            </a:r>
+          </a:p>
+          <a:p>
+            <a:r>
+              <a:rPr lang="en-US" dirty="0"/>
+              <a:t>Likely question: 'How do you make companies do this?' Answer: public pressure and awareness, plus reporting laws like the EU rule, which make water and power use visible.</a:t>
+            </a:r>
+          </a:p>
+          <a:p>
+            <a:r>
+              <a:rPr lang="en-US" dirty="0"/>
+              <a:t>Be honest: training still needs data centers, and local AI still uses electricity. The benefit comes from smaller, more efficient models.</a:t>
+            </a:r>
+          </a:p>
+        </p:txBody>
+      </p:sp>
+      <p:sp>
+        <p:nvSpPr>
+          <p:cNvPr id="4" name="Slide Number Placeholder 3"/>
+          <p:cNvSpPr>
+            <a:spLocks noGrp="1"/>
+          </p:cNvSpPr>
+          <p:nvPr>
+            <p:ph type="sldNum" sz="quarter" idx="10"/>
+          </p:nvPr>
+        </p:nvSpPr>
+        <p:spPr/>
+        <p:txBody>
+          <a:bodyPr/>
+          <a:lstStyle/>
+          <a:p>
+            <a:fld id="{F7021451-1387-4CA6-816F-3879F97B5CBC}" type="slidenum">
+              <a:rPr lang="en-US"/>
+              <a:t>7</a:t>
             </a:fld>
             <a:endParaRPr lang="en-US"/>
           </a:p>
@@ -4024,11 +4184,11 @@
         <p:spPr>
           <a:xfrm>
             <a:off x="411480" y="1325880"/>
-            <a:ext cx="6355080" cy="3977640"/>
+            <a:ext cx="6355080" cy="3566160"/>
           </a:xfrm>
           <a:prstGeom prst="roundRect">
             <a:avLst>
-              <a:gd name="adj" fmla="val 2759"/>
+              <a:gd name="adj" fmla="val 3077"/>
             </a:avLst>
           </a:prstGeom>
           <a:solidFill>
@@ -4094,7 +4254,7 @@
         <p:spPr>
           <a:xfrm>
             <a:off x="685800" y="2148840"/>
-            <a:ext cx="5897880" cy="3840480"/>
+            <a:ext cx="5897880" cy="2651760"/>
           </a:xfrm>
           <a:prstGeom prst="rect">
             <a:avLst/>
@@ -4208,38 +4368,6 @@
                 <a:cs typeface="Calibri" pitchFamily="34" charset="-120"/>
               </a:rPr>
               <a:t>Better chips make local AI stronger</a:t>
-            </a:r>
-            <a:endParaRPr lang="en-US" sz="2100" dirty="0"/>
-          </a:p>
-          <a:p>
-            <a:pPr marL="279400" indent="-279400">
-              <a:spcAft>
-                <a:spcPts val="1400"/>
-              </a:spcAft>
-              <a:buSzPct val="100000"/>
-              <a:buChar char="•"/>
-            </a:pPr>
-            <a:r>
-              <a:rPr lang="en-US" sz="2100" b="1" dirty="0">
-                <a:solidFill>
-                  <a:srgbClr val="FFFFFF"/>
-                </a:solidFill>
-                <a:latin typeface="Calibri" pitchFamily="34" charset="0"/>
-                <a:ea typeface="Calibri" pitchFamily="34" charset="-122"/>
-                <a:cs typeface="Calibri" pitchFamily="34" charset="-120"/>
-              </a:rPr>
-              <a:t>Already real: </a:t>
-            </a:r>
-            <a:r>
-              <a:rPr lang="en-US" sz="2100" dirty="0">
-                <a:solidFill>
-                  <a:srgbClr val="E3EBF1"/>
-                </a:solidFill>
-                <a:latin typeface="Calibri" pitchFamily="34" charset="0"/>
-                <a:ea typeface="Calibri" pitchFamily="34" charset="-122"/>
-                <a:cs typeface="Calibri" pitchFamily="34" charset="-120"/>
-              </a:rPr>
-              <a:t>Phi-3 runs on a phone</a:t>
             </a:r>
             <a:endParaRPr lang="en-US" sz="2100" dirty="0"/>
           </a:p>
@@ -4256,6 +4384,357 @@
 <file path=ppt/slides/slide6.xml><?xml version="1.0" encoding="utf-8"?>
 <p:sld xmlns:a="http://schemas.openxmlformats.org/drawingml/2006/main" xmlns:r="http://schemas.openxmlformats.org/officeDocument/2006/relationships" xmlns:p="http://schemas.openxmlformats.org/presentationml/2006/main">
   <p:cSld name="Slide 6">
+    <p:bg>
+      <p:bgPr>
+        <a:blipFill dpi="0" rotWithShape="1">
+          <a:blip r:embed="rId1">
+            <a:lum/>
+          </a:blip>
+          <a:srcRect/>
+          <a:stretch>
+            <a:fillRect/>
+          </a:stretch>
+        </a:blipFill>
+        <a:effectLst/>
+      </p:bgPr>
+    </p:bg>
+    <p:spTree>
+      <p:nvGrpSpPr>
+        <p:cNvPr id="1" name=""/>
+        <p:cNvGrpSpPr/>
+        <p:nvPr/>
+      </p:nvGrpSpPr>
+      <p:grpSpPr>
+        <a:xfrm>
+          <a:off x="0" y="0"/>
+          <a:ext cx="0" cy="0"/>
+          <a:chOff x="0" y="0"/>
+          <a:chExt cx="0" cy="0"/>
+        </a:xfrm>
+      </p:grpSpPr>
+      <p:sp>
+        <p:nvSpPr>
+          <p:cNvPr id="2" name="title"/>
+          <p:cNvSpPr txBox="1"/>
+          <p:nvPr/>
+        </p:nvSpPr>
+        <p:spPr>
+          <a:xfrm>
+            <a:off x="548640" y="365760"/>
+            <a:ext cx="11064240" cy="822960"/>
+          </a:xfrm>
+          <a:prstGeom prst="rect">
+            <a:avLst/>
+          </a:prstGeom>
+          <a:noFill/>
+          <a:ln/>
+        </p:spPr>
+        <p:txBody>
+          <a:bodyPr wrap="square" lIns="0" tIns="0" rIns="0" bIns="0" rtlCol="0" anchor="ctr"/>
+          <a:lstStyle/>
+          <a:p>
+            <a:pPr indent="0" marL="0">
+              <a:buNone/>
+            </a:pPr>
+            <a:r>
+              <a:rPr lang="en-US" sz="4000" b="1" dirty="0">
+                <a:solidFill>
+                  <a:srgbClr val="FFFFFF"/>
+                </a:solidFill>
+                <a:latin typeface="Cambria" pitchFamily="34" charset="0"/>
+                <a:ea typeface="Cambria" pitchFamily="34" charset="-122"/>
+                <a:cs typeface="Cambria" pitchFamily="34" charset="-120"/>
+              </a:rPr>
+              <a:t>Real Example: UGREEN HomeAgent HA100</a:t>
+            </a:r>
+            <a:endParaRPr lang="en-US" sz="4000" dirty="0"/>
+          </a:p>
+        </p:txBody>
+      </p:sp>
+      <p:sp>
+        <p:nvSpPr>
+          <p:cNvPr id="3" name="kicker"/>
+          <p:cNvSpPr txBox="1"/>
+          <p:nvPr/>
+        </p:nvSpPr>
+        <p:spPr>
+          <a:xfrm>
+            <a:off x="548640" y="1188720"/>
+            <a:ext cx="11064240" cy="457200"/>
+          </a:xfrm>
+          <a:prstGeom prst="rect">
+            <a:avLst/>
+          </a:prstGeom>
+          <a:noFill/>
+          <a:ln/>
+        </p:spPr>
+        <p:txBody>
+          <a:bodyPr wrap="square" lIns="0" tIns="0" rIns="0" bIns="0" rtlCol="0" anchor="t"/>
+          <a:lstStyle/>
+          <a:p>
+            <a:pPr indent="0" marL="0">
+              <a:buNone/>
+            </a:pPr>
+            <a:r>
+              <a:rPr lang="en-US" sz="2200" i="1" dirty="0">
+                <a:solidFill>
+                  <a:srgbClr val="F2A33A"/>
+                </a:solidFill>
+                <a:latin typeface="Calibri" pitchFamily="34" charset="0"/>
+                <a:ea typeface="Calibri" pitchFamily="34" charset="-122"/>
+                <a:cs typeface="Calibri" pitchFamily="34" charset="-120"/>
+              </a:rPr>
+              <a:t>Announced at IFA 2026  ·  ships early 2027</a:t>
+            </a:r>
+            <a:endParaRPr lang="en-US" sz="2200" dirty="0"/>
+          </a:p>
+        </p:txBody>
+      </p:sp>
+      <p:sp>
+        <p:nvSpPr>
+          <p:cNvPr id="4" name="Shape 2"/>
+          <p:cNvSpPr/>
+          <p:nvPr/>
+        </p:nvSpPr>
+        <p:spPr>
+          <a:xfrm>
+            <a:off x="411480" y="1828800"/>
+            <a:ext cx="7040880" cy="3520440"/>
+          </a:xfrm>
+          <a:prstGeom prst="roundRect">
+            <a:avLst>
+              <a:gd name="adj" fmla="val 3117"/>
+            </a:avLst>
+          </a:prstGeom>
+          <a:solidFill>
+            <a:srgbClr val="0B2239">
+              <a:alpha val="88000"/>
+            </a:srgbClr>
+          </a:solidFill>
+          <a:ln w="12700">
+            <a:solidFill>
+              <a:srgbClr val="0B2239">
+                <a:alpha val="0"/>
+              </a:srgbClr>
+            </a:solidFill>
+            <a:prstDash val="solid"/>
+          </a:ln>
+        </p:spPr>
+      </p:sp>
+      <p:sp>
+        <p:nvSpPr>
+          <p:cNvPr id="5" name="body"/>
+          <p:cNvSpPr txBox="1"/>
+          <p:nvPr/>
+        </p:nvSpPr>
+        <p:spPr>
+          <a:xfrm>
+            <a:off x="685800" y="2103120"/>
+            <a:ext cx="6583680" cy="3108960"/>
+          </a:xfrm>
+          <a:prstGeom prst="rect">
+            <a:avLst/>
+          </a:prstGeom>
+          <a:noFill/>
+          <a:ln/>
+        </p:spPr>
+        <p:txBody>
+          <a:bodyPr wrap="square" lIns="0" tIns="0" rIns="0" bIns="0" rtlCol="0" anchor="t"/>
+          <a:lstStyle/>
+          <a:p>
+            <a:pPr marL="279400" indent="-279400">
+              <a:spcAft>
+                <a:spcPts val="1600"/>
+              </a:spcAft>
+              <a:buSzPct val="100000"/>
+              <a:buChar char="•"/>
+            </a:pPr>
+            <a:r>
+              <a:rPr lang="en-US" sz="2100" dirty="0">
+                <a:solidFill>
+                  <a:srgbClr val="E3EBF1"/>
+                </a:solidFill>
+                <a:latin typeface="Calibri" pitchFamily="34" charset="0"/>
+                <a:ea typeface="Calibri" pitchFamily="34" charset="-122"/>
+                <a:cs typeface="Calibri" pitchFamily="34" charset="-120"/>
+              </a:rPr>
+              <a:t>A home AI hub, </a:t>
+            </a:r>
+            <a:r>
+              <a:rPr lang="en-US" sz="2100" b="1" dirty="0">
+                <a:solidFill>
+                  <a:srgbClr val="FFFFFF"/>
+                </a:solidFill>
+                <a:latin typeface="Calibri" pitchFamily="34" charset="0"/>
+                <a:ea typeface="Calibri" pitchFamily="34" charset="-122"/>
+                <a:cs typeface="Calibri" pitchFamily="34" charset="-120"/>
+              </a:rPr>
+              <a:t>not a cloud server</a:t>
+            </a:r>
+            <a:endParaRPr lang="en-US" sz="2100" dirty="0"/>
+          </a:p>
+          <a:p>
+            <a:pPr marL="279400" indent="-279400">
+              <a:spcAft>
+                <a:spcPts val="1600"/>
+              </a:spcAft>
+              <a:buSzPct val="100000"/>
+              <a:buChar char="•"/>
+            </a:pPr>
+            <a:r>
+              <a:rPr lang="en-US" sz="2100" dirty="0">
+                <a:solidFill>
+                  <a:srgbClr val="E3EBF1"/>
+                </a:solidFill>
+                <a:latin typeface="Calibri" pitchFamily="34" charset="0"/>
+                <a:ea typeface="Calibri" pitchFamily="34" charset="-122"/>
+                <a:cs typeface="Calibri" pitchFamily="34" charset="-120"/>
+              </a:rPr>
+              <a:t>Its assistant runs the </a:t>
+            </a:r>
+            <a:r>
+              <a:rPr lang="en-US" sz="2100" b="1" dirty="0">
+                <a:solidFill>
+                  <a:srgbClr val="F2A33A"/>
+                </a:solidFill>
+                <a:latin typeface="Calibri" pitchFamily="34" charset="0"/>
+                <a:ea typeface="Calibri" pitchFamily="34" charset="-122"/>
+                <a:cs typeface="Calibri" pitchFamily="34" charset="-120"/>
+              </a:rPr>
+              <a:t>Qwen3</a:t>
+            </a:r>
+            <a:r>
+              <a:rPr lang="en-US" sz="2100" dirty="0">
+                <a:solidFill>
+                  <a:srgbClr val="E3EBF1"/>
+                </a:solidFill>
+                <a:latin typeface="Calibri" pitchFamily="34" charset="0"/>
+                <a:ea typeface="Calibri" pitchFamily="34" charset="-122"/>
+                <a:cs typeface="Calibri" pitchFamily="34" charset="-120"/>
+              </a:rPr>
+              <a:t> model at home</a:t>
+            </a:r>
+            <a:endParaRPr lang="en-US" sz="2100" dirty="0"/>
+          </a:p>
+          <a:p>
+            <a:pPr marL="279400" indent="-279400">
+              <a:spcAft>
+                <a:spcPts val="1600"/>
+              </a:spcAft>
+              <a:buSzPct val="100000"/>
+              <a:buChar char="•"/>
+            </a:pPr>
+            <a:r>
+              <a:rPr lang="en-US" sz="2100" dirty="0">
+                <a:solidFill>
+                  <a:srgbClr val="E3EBF1"/>
+                </a:solidFill>
+                <a:latin typeface="Calibri" pitchFamily="34" charset="0"/>
+                <a:ea typeface="Calibri" pitchFamily="34" charset="-122"/>
+                <a:cs typeface="Calibri" pitchFamily="34" charset="-120"/>
+              </a:rPr>
+              <a:t>Spots people, pets, cars and packages</a:t>
+            </a:r>
+            <a:endParaRPr lang="en-US" sz="2100" dirty="0"/>
+          </a:p>
+          <a:p>
+            <a:pPr marL="279400" indent="-279400">
+              <a:spcAft>
+                <a:spcPts val="1600"/>
+              </a:spcAft>
+              <a:buSzPct val="100000"/>
+              <a:buChar char="•"/>
+            </a:pPr>
+            <a:r>
+              <a:rPr lang="en-US" sz="2100" dirty="0">
+                <a:solidFill>
+                  <a:srgbClr val="E3EBF1"/>
+                </a:solidFill>
+                <a:latin typeface="Calibri" pitchFamily="34" charset="0"/>
+                <a:ea typeface="Calibri" pitchFamily="34" charset="-122"/>
+                <a:cs typeface="Calibri" pitchFamily="34" charset="-120"/>
+              </a:rPr>
+              <a:t>Search your camera videos by keyword</a:t>
+            </a:r>
+            <a:endParaRPr lang="en-US" sz="2100" dirty="0"/>
+          </a:p>
+          <a:p>
+            <a:pPr marL="279400" indent="-279400">
+              <a:spcAft>
+                <a:spcPts val="1600"/>
+              </a:spcAft>
+              <a:buSzPct val="100000"/>
+              <a:buChar char="•"/>
+            </a:pPr>
+            <a:r>
+              <a:rPr lang="en-US" sz="2100" dirty="0">
+                <a:solidFill>
+                  <a:srgbClr val="E3EBF1"/>
+                </a:solidFill>
+                <a:latin typeface="Calibri" pitchFamily="34" charset="0"/>
+                <a:ea typeface="Calibri" pitchFamily="34" charset="-122"/>
+                <a:cs typeface="Calibri" pitchFamily="34" charset="-120"/>
+              </a:rPr>
+              <a:t>Your videos stay on </a:t>
+            </a:r>
+            <a:r>
+              <a:rPr lang="en-US" sz="2100" b="1" dirty="0">
+                <a:solidFill>
+                  <a:srgbClr val="FFFFFF"/>
+                </a:solidFill>
+                <a:latin typeface="Calibri" pitchFamily="34" charset="0"/>
+                <a:ea typeface="Calibri" pitchFamily="34" charset="-122"/>
+                <a:cs typeface="Calibri" pitchFamily="34" charset="-120"/>
+              </a:rPr>
+              <a:t>your own drives</a:t>
+            </a:r>
+            <a:endParaRPr lang="en-US" sz="2100" dirty="0"/>
+          </a:p>
+          <a:p>
+            <a:pPr marL="279400" indent="-279400">
+              <a:spcAft>
+                <a:spcPts val="1600"/>
+              </a:spcAft>
+              <a:buSzPct val="100000"/>
+              <a:buChar char="•"/>
+            </a:pPr>
+            <a:r>
+              <a:rPr lang="en-US" sz="2100" b="1" dirty="0">
+                <a:solidFill>
+                  <a:srgbClr val="F2A33A"/>
+                </a:solidFill>
+                <a:latin typeface="Calibri" pitchFamily="34" charset="0"/>
+                <a:ea typeface="Calibri" pitchFamily="34" charset="-122"/>
+                <a:cs typeface="Calibri" pitchFamily="34" charset="-120"/>
+              </a:rPr>
+              <a:t>Honest: </a:t>
+            </a:r>
+            <a:r>
+              <a:rPr lang="en-US" sz="2100" dirty="0">
+                <a:solidFill>
+                  <a:srgbClr val="E3EBF1"/>
+                </a:solidFill>
+                <a:latin typeface="Calibri" pitchFamily="34" charset="0"/>
+                <a:ea typeface="Calibri" pitchFamily="34" charset="-122"/>
+                <a:cs typeface="Calibri" pitchFamily="34" charset="-120"/>
+              </a:rPr>
+              <a:t>some features still need the internet</a:t>
+            </a:r>
+            <a:endParaRPr lang="en-US" sz="2100" dirty="0"/>
+          </a:p>
+        </p:txBody>
+      </p:sp>
+    </p:spTree>
+  </p:cSld>
+  <p:clrMapOvr>
+    <a:masterClrMapping/>
+  </p:clrMapOvr>
+</p:sld>
+</file>
+
+<file path=ppt/slides/slide7.xml><?xml version="1.0" encoding="utf-8"?>
+<p:sld xmlns:a="http://schemas.openxmlformats.org/drawingml/2006/main" xmlns:r="http://schemas.openxmlformats.org/officeDocument/2006/relationships" xmlns:p="http://schemas.openxmlformats.org/presentationml/2006/main">
+  <p:cSld name="Slide 7">
     <p:bg>
       <p:bgPr>
         <a:blipFill dpi="0" rotWithShape="1">

</xml_diff>